<commit_message>
Completar revisión solicitada por el tutor
</commit_message>
<xml_diff>
--- a/Presentacion_defensa_TFG.pptx
+++ b/Presentacion_defensa_TFG.pptx
@@ -203,7 +203,7 @@
             </a:lvl1pPr>
           </a:lstStyle>
           <a:p>
-            <a:fld id="{EC1CC0BC-828B-4403-AF76-D0BDC1F191C1}" type="datetimeFigureOut">
+            <a:fld id="{7CC186FB-0339-42DD-8219-60C2673475E3}" type="datetimeFigureOut">
               <a:rPr lang="es-ES" smtClean="0"/>
               <a:t>30/08/2026</a:t>
             </a:fld>
@@ -361,7 +361,7 @@
             </a:lvl1pPr>
           </a:lstStyle>
           <a:p>
-            <a:fld id="{62FD20D0-E940-4D78-9233-EDB8C890ED70}" type="slidenum">
+            <a:fld id="{3CB51BCC-4392-4008-A116-89654DD6F7E1}" type="slidenum">
               <a:rPr lang="es-ES" smtClean="0"/>
               <a:t>‹Nº›</a:t>
             </a:fld>
@@ -372,7 +372,7 @@
     </p:spTree>
     <p:extLst>
       <p:ext uri="{BB962C8B-B14F-4D97-AF65-F5344CB8AC3E}">
-        <p14:creationId xmlns:p14="http://schemas.microsoft.com/office/powerpoint/2010/main" val="2096879160"/>
+        <p14:creationId xmlns:p14="http://schemas.microsoft.com/office/powerpoint/2010/main" val="2646070627"/>
       </p:ext>
     </p:extLst>
   </p:cSld>
@@ -541,7 +541,7 @@
           <a:bodyPr/>
           <a:lstStyle/>
           <a:p>
-            <a:fld id="{62FD20D0-E940-4D78-9233-EDB8C890ED70}" type="slidenum">
+            <a:fld id="{3CB51BCC-4392-4008-A116-89654DD6F7E1}" type="slidenum">
               <a:rPr lang="es-ES" smtClean="0"/>
               <a:t>1</a:t>
             </a:fld>
@@ -552,7 +552,7 @@
     </p:spTree>
     <p:extLst>
       <p:ext uri="{BB962C8B-B14F-4D97-AF65-F5344CB8AC3E}">
-        <p14:creationId xmlns:p14="http://schemas.microsoft.com/office/powerpoint/2010/main" val="1799262356"/>
+        <p14:creationId xmlns:p14="http://schemas.microsoft.com/office/powerpoint/2010/main" val="2231447491"/>
       </p:ext>
     </p:extLst>
   </p:cSld>
@@ -632,7 +632,7 @@
           <a:bodyPr/>
           <a:lstStyle/>
           <a:p>
-            <a:fld id="{62FD20D0-E940-4D78-9233-EDB8C890ED70}" type="slidenum">
+            <a:fld id="{3CB51BCC-4392-4008-A116-89654DD6F7E1}" type="slidenum">
               <a:rPr lang="es-ES" smtClean="0"/>
               <a:t>10</a:t>
             </a:fld>
@@ -643,7 +643,7 @@
     </p:spTree>
     <p:extLst>
       <p:ext uri="{BB962C8B-B14F-4D97-AF65-F5344CB8AC3E}">
-        <p14:creationId xmlns:p14="http://schemas.microsoft.com/office/powerpoint/2010/main" val="3229460935"/>
+        <p14:creationId xmlns:p14="http://schemas.microsoft.com/office/powerpoint/2010/main" val="472512179"/>
       </p:ext>
     </p:extLst>
   </p:cSld>
@@ -724,7 +724,7 @@
           <a:bodyPr/>
           <a:lstStyle/>
           <a:p>
-            <a:fld id="{62FD20D0-E940-4D78-9233-EDB8C890ED70}" type="slidenum">
+            <a:fld id="{3CB51BCC-4392-4008-A116-89654DD6F7E1}" type="slidenum">
               <a:rPr lang="es-ES" smtClean="0"/>
               <a:t>11</a:t>
             </a:fld>
@@ -735,7 +735,7 @@
     </p:spTree>
     <p:extLst>
       <p:ext uri="{BB962C8B-B14F-4D97-AF65-F5344CB8AC3E}">
-        <p14:creationId xmlns:p14="http://schemas.microsoft.com/office/powerpoint/2010/main" val="1263996119"/>
+        <p14:creationId xmlns:p14="http://schemas.microsoft.com/office/powerpoint/2010/main" val="210158520"/>
       </p:ext>
     </p:extLst>
   </p:cSld>
@@ -816,7 +816,7 @@
           <a:bodyPr/>
           <a:lstStyle/>
           <a:p>
-            <a:fld id="{62FD20D0-E940-4D78-9233-EDB8C890ED70}" type="slidenum">
+            <a:fld id="{3CB51BCC-4392-4008-A116-89654DD6F7E1}" type="slidenum">
               <a:rPr lang="es-ES" smtClean="0"/>
               <a:t>12</a:t>
             </a:fld>
@@ -827,7 +827,7 @@
     </p:spTree>
     <p:extLst>
       <p:ext uri="{BB962C8B-B14F-4D97-AF65-F5344CB8AC3E}">
-        <p14:creationId xmlns:p14="http://schemas.microsoft.com/office/powerpoint/2010/main" val="3839223418"/>
+        <p14:creationId xmlns:p14="http://schemas.microsoft.com/office/powerpoint/2010/main" val="226154271"/>
       </p:ext>
     </p:extLst>
   </p:cSld>
@@ -907,7 +907,7 @@
           <a:bodyPr/>
           <a:lstStyle/>
           <a:p>
-            <a:fld id="{62FD20D0-E940-4D78-9233-EDB8C890ED70}" type="slidenum">
+            <a:fld id="{3CB51BCC-4392-4008-A116-89654DD6F7E1}" type="slidenum">
               <a:rPr lang="es-ES" smtClean="0"/>
               <a:t>13</a:t>
             </a:fld>
@@ -918,7 +918,7 @@
     </p:spTree>
     <p:extLst>
       <p:ext uri="{BB962C8B-B14F-4D97-AF65-F5344CB8AC3E}">
-        <p14:creationId xmlns:p14="http://schemas.microsoft.com/office/powerpoint/2010/main" val="3126957935"/>
+        <p14:creationId xmlns:p14="http://schemas.microsoft.com/office/powerpoint/2010/main" val="391412948"/>
       </p:ext>
     </p:extLst>
   </p:cSld>
@@ -998,7 +998,7 @@
           <a:bodyPr/>
           <a:lstStyle/>
           <a:p>
-            <a:fld id="{62FD20D0-E940-4D78-9233-EDB8C890ED70}" type="slidenum">
+            <a:fld id="{3CB51BCC-4392-4008-A116-89654DD6F7E1}" type="slidenum">
               <a:rPr lang="es-ES" smtClean="0"/>
               <a:t>14</a:t>
             </a:fld>
@@ -1009,7 +1009,7 @@
     </p:spTree>
     <p:extLst>
       <p:ext uri="{BB962C8B-B14F-4D97-AF65-F5344CB8AC3E}">
-        <p14:creationId xmlns:p14="http://schemas.microsoft.com/office/powerpoint/2010/main" val="1508752304"/>
+        <p14:creationId xmlns:p14="http://schemas.microsoft.com/office/powerpoint/2010/main" val="3423900029"/>
       </p:ext>
     </p:extLst>
   </p:cSld>
@@ -1088,7 +1088,7 @@
           <a:bodyPr/>
           <a:lstStyle/>
           <a:p>
-            <a:fld id="{62FD20D0-E940-4D78-9233-EDB8C890ED70}" type="slidenum">
+            <a:fld id="{3CB51BCC-4392-4008-A116-89654DD6F7E1}" type="slidenum">
               <a:rPr lang="es-ES" smtClean="0"/>
               <a:t>2</a:t>
             </a:fld>
@@ -1099,7 +1099,7 @@
     </p:spTree>
     <p:extLst>
       <p:ext uri="{BB962C8B-B14F-4D97-AF65-F5344CB8AC3E}">
-        <p14:creationId xmlns:p14="http://schemas.microsoft.com/office/powerpoint/2010/main" val="3010338617"/>
+        <p14:creationId xmlns:p14="http://schemas.microsoft.com/office/powerpoint/2010/main" val="4033252132"/>
       </p:ext>
     </p:extLst>
   </p:cSld>
@@ -1179,7 +1179,7 @@
           <a:bodyPr/>
           <a:lstStyle/>
           <a:p>
-            <a:fld id="{62FD20D0-E940-4D78-9233-EDB8C890ED70}" type="slidenum">
+            <a:fld id="{3CB51BCC-4392-4008-A116-89654DD6F7E1}" type="slidenum">
               <a:rPr lang="es-ES" smtClean="0"/>
               <a:t>3</a:t>
             </a:fld>
@@ -1190,7 +1190,7 @@
     </p:spTree>
     <p:extLst>
       <p:ext uri="{BB962C8B-B14F-4D97-AF65-F5344CB8AC3E}">
-        <p14:creationId xmlns:p14="http://schemas.microsoft.com/office/powerpoint/2010/main" val="2818384676"/>
+        <p14:creationId xmlns:p14="http://schemas.microsoft.com/office/powerpoint/2010/main" val="2701454281"/>
       </p:ext>
     </p:extLst>
   </p:cSld>
@@ -1270,7 +1270,7 @@
           <a:bodyPr/>
           <a:lstStyle/>
           <a:p>
-            <a:fld id="{62FD20D0-E940-4D78-9233-EDB8C890ED70}" type="slidenum">
+            <a:fld id="{3CB51BCC-4392-4008-A116-89654DD6F7E1}" type="slidenum">
               <a:rPr lang="es-ES" smtClean="0"/>
               <a:t>4</a:t>
             </a:fld>
@@ -1281,7 +1281,7 @@
     </p:spTree>
     <p:extLst>
       <p:ext uri="{BB962C8B-B14F-4D97-AF65-F5344CB8AC3E}">
-        <p14:creationId xmlns:p14="http://schemas.microsoft.com/office/powerpoint/2010/main" val="1221159697"/>
+        <p14:creationId xmlns:p14="http://schemas.microsoft.com/office/powerpoint/2010/main" val="3859119265"/>
       </p:ext>
     </p:extLst>
   </p:cSld>
@@ -1361,7 +1361,7 @@
           <a:bodyPr/>
           <a:lstStyle/>
           <a:p>
-            <a:fld id="{62FD20D0-E940-4D78-9233-EDB8C890ED70}" type="slidenum">
+            <a:fld id="{3CB51BCC-4392-4008-A116-89654DD6F7E1}" type="slidenum">
               <a:rPr lang="es-ES" smtClean="0"/>
               <a:t>5</a:t>
             </a:fld>
@@ -1372,7 +1372,7 @@
     </p:spTree>
     <p:extLst>
       <p:ext uri="{BB962C8B-B14F-4D97-AF65-F5344CB8AC3E}">
-        <p14:creationId xmlns:p14="http://schemas.microsoft.com/office/powerpoint/2010/main" val="311985354"/>
+        <p14:creationId xmlns:p14="http://schemas.microsoft.com/office/powerpoint/2010/main" val="415083141"/>
       </p:ext>
     </p:extLst>
   </p:cSld>
@@ -1452,7 +1452,7 @@
           <a:bodyPr/>
           <a:lstStyle/>
           <a:p>
-            <a:fld id="{62FD20D0-E940-4D78-9233-EDB8C890ED70}" type="slidenum">
+            <a:fld id="{3CB51BCC-4392-4008-A116-89654DD6F7E1}" type="slidenum">
               <a:rPr lang="es-ES" smtClean="0"/>
               <a:t>6</a:t>
             </a:fld>
@@ -1463,7 +1463,7 @@
     </p:spTree>
     <p:extLst>
       <p:ext uri="{BB962C8B-B14F-4D97-AF65-F5344CB8AC3E}">
-        <p14:creationId xmlns:p14="http://schemas.microsoft.com/office/powerpoint/2010/main" val="3428473666"/>
+        <p14:creationId xmlns:p14="http://schemas.microsoft.com/office/powerpoint/2010/main" val="3410577185"/>
       </p:ext>
     </p:extLst>
   </p:cSld>
@@ -1543,7 +1543,7 @@
           <a:bodyPr/>
           <a:lstStyle/>
           <a:p>
-            <a:fld id="{62FD20D0-E940-4D78-9233-EDB8C890ED70}" type="slidenum">
+            <a:fld id="{3CB51BCC-4392-4008-A116-89654DD6F7E1}" type="slidenum">
               <a:rPr lang="es-ES" smtClean="0"/>
               <a:t>7</a:t>
             </a:fld>
@@ -1554,7 +1554,7 @@
     </p:spTree>
     <p:extLst>
       <p:ext uri="{BB962C8B-B14F-4D97-AF65-F5344CB8AC3E}">
-        <p14:creationId xmlns:p14="http://schemas.microsoft.com/office/powerpoint/2010/main" val="2378713241"/>
+        <p14:creationId xmlns:p14="http://schemas.microsoft.com/office/powerpoint/2010/main" val="777135102"/>
       </p:ext>
     </p:extLst>
   </p:cSld>
@@ -1610,7 +1610,7 @@
           <a:p>
             <a:r>
               <a:rPr lang="es-ES"/>
-              <a:t>Relacionar cada tecnología con una decisión, no enumerar herramientas. Diferenciar los controles ya implementados de los controles necesarios para producción.
+              <a:t>Relacionar cada tecnología con una decisión, no enumerar herramientas. Aclarar que SPF, DKIM y DMARC se interpretan desde las cabeceras recibidas: no hay consultas DNS ni validación criptográfica. Diferenciar los controles ya implementados de los controles necesarios para producción.
 [Sources]
 - TFG.txt: herramientas, seguridad y privacidad.
 - README.md: Configuración y Alcance.
@@ -1634,7 +1634,7 @@
           <a:bodyPr/>
           <a:lstStyle/>
           <a:p>
-            <a:fld id="{62FD20D0-E940-4D78-9233-EDB8C890ED70}" type="slidenum">
+            <a:fld id="{3CB51BCC-4392-4008-A116-89654DD6F7E1}" type="slidenum">
               <a:rPr lang="es-ES" smtClean="0"/>
               <a:t>8</a:t>
             </a:fld>
@@ -1645,7 +1645,7 @@
     </p:spTree>
     <p:extLst>
       <p:ext uri="{BB962C8B-B14F-4D97-AF65-F5344CB8AC3E}">
-        <p14:creationId xmlns:p14="http://schemas.microsoft.com/office/powerpoint/2010/main" val="667265033"/>
+        <p14:creationId xmlns:p14="http://schemas.microsoft.com/office/powerpoint/2010/main" val="3068410174"/>
       </p:ext>
     </p:extLst>
   </p:cSld>
@@ -1701,8 +1701,9 @@
           <a:p>
             <a:r>
               <a:rPr lang="es-ES"/>
-              <a:t>Subrayar la separación entre calibración y evaluación. DIFrauD es un diagnóstico útil, pero no una validación independiente concluyente por posible solapamiento y falta de MIME completo.
+              <a:t>Los artefactos declaran 1.298 muestras ES y 164.971 EN. Subrayar que no se usó una división 70/30 inventada: entrenamiento, calibración de 40 casos y evaluación de 16 EML cumplen funciones separadas. DIFrauD es un diagnóstico útil, pero no una validación independiente concluyente por posible solapamiento y falta de MIME completo.
 [Sources]
+- TFG.txt: diseño experimental y datasets.
 - EVALUATION_REPORT.md.
 - EXTERNAL_EVALUATION_REPORT.md.
 - evaluation/README.md.
@@ -1726,7 +1727,7 @@
           <a:bodyPr/>
           <a:lstStyle/>
           <a:p>
-            <a:fld id="{62FD20D0-E940-4D78-9233-EDB8C890ED70}" type="slidenum">
+            <a:fld id="{3CB51BCC-4392-4008-A116-89654DD6F7E1}" type="slidenum">
               <a:rPr lang="es-ES" smtClean="0"/>
               <a:t>9</a:t>
             </a:fld>
@@ -1737,7 +1738,7 @@
     </p:spTree>
     <p:extLst>
       <p:ext uri="{BB962C8B-B14F-4D97-AF65-F5344CB8AC3E}">
-        <p14:creationId xmlns:p14="http://schemas.microsoft.com/office/powerpoint/2010/main" val="2332126483"/>
+        <p14:creationId xmlns:p14="http://schemas.microsoft.com/office/powerpoint/2010/main" val="1684516329"/>
       </p:ext>
     </p:extLst>
   </p:cSld>
@@ -1769,7 +1770,7 @@
           <p:cNvPr id="2" name="Título 1">
             <a:extLst>
               <a:ext uri="{FF2B5EF4-FFF2-40B4-BE49-F238E27FC236}">
-                <a16:creationId xmlns:a16="http://schemas.microsoft.com/office/drawing/2014/main" id="{6A2535E9-EFC2-3B97-8881-3F2C01791A8D}"/>
+                <a16:creationId xmlns:a16="http://schemas.microsoft.com/office/drawing/2014/main" id="{684083F0-58B1-AF58-FFBA-6315538A5474}"/>
               </a:ext>
             </a:extLst>
           </p:cNvPr>
@@ -1806,7 +1807,7 @@
           <p:cNvPr id="3" name="Subtítulo 2">
             <a:extLst>
               <a:ext uri="{FF2B5EF4-FFF2-40B4-BE49-F238E27FC236}">
-                <a16:creationId xmlns:a16="http://schemas.microsoft.com/office/drawing/2014/main" id="{EFAE3B26-A6DF-7A04-EA95-78277D67838B}"/>
+                <a16:creationId xmlns:a16="http://schemas.microsoft.com/office/drawing/2014/main" id="{0C3E214F-C515-104D-689E-733ACCF318EA}"/>
               </a:ext>
             </a:extLst>
           </p:cNvPr>
@@ -1876,7 +1877,7 @@
           <p:cNvPr id="4" name="Marcador de fecha 3">
             <a:extLst>
               <a:ext uri="{FF2B5EF4-FFF2-40B4-BE49-F238E27FC236}">
-                <a16:creationId xmlns:a16="http://schemas.microsoft.com/office/drawing/2014/main" id="{4FB99020-A05C-AC0A-1306-4D2654F3814E}"/>
+                <a16:creationId xmlns:a16="http://schemas.microsoft.com/office/drawing/2014/main" id="{F8A350AA-DB93-C75E-FA09-A88E7B6EC48A}"/>
               </a:ext>
             </a:extLst>
           </p:cNvPr>
@@ -1892,7 +1893,7 @@
           <a:bodyPr/>
           <a:lstStyle/>
           <a:p>
-            <a:fld id="{2240CE9B-84DE-4934-B0C9-67879BB15753}" type="datetimeFigureOut">
+            <a:fld id="{0C062895-02B9-4539-8A29-6999C3E43A53}" type="datetimeFigureOut">
               <a:rPr lang="es-ES" smtClean="0"/>
               <a:t>30/08/2026</a:t>
             </a:fld>
@@ -1905,7 +1906,7 @@
           <p:cNvPr id="5" name="Marcador de pie de página 4">
             <a:extLst>
               <a:ext uri="{FF2B5EF4-FFF2-40B4-BE49-F238E27FC236}">
-                <a16:creationId xmlns:a16="http://schemas.microsoft.com/office/drawing/2014/main" id="{0CE15150-6CCA-FE77-BDA6-E1F2E2A67214}"/>
+                <a16:creationId xmlns:a16="http://schemas.microsoft.com/office/drawing/2014/main" id="{A0946EE0-1C36-643A-EB8A-C4C2BAD1D397}"/>
               </a:ext>
             </a:extLst>
           </p:cNvPr>
@@ -1930,7 +1931,7 @@
           <p:cNvPr id="6" name="Marcador de número de diapositiva 5">
             <a:extLst>
               <a:ext uri="{FF2B5EF4-FFF2-40B4-BE49-F238E27FC236}">
-                <a16:creationId xmlns:a16="http://schemas.microsoft.com/office/drawing/2014/main" id="{65A1B84F-282D-7891-9A67-5DDB6232761A}"/>
+                <a16:creationId xmlns:a16="http://schemas.microsoft.com/office/drawing/2014/main" id="{499A4340-8280-9DCB-296D-3C4226CA8908}"/>
               </a:ext>
             </a:extLst>
           </p:cNvPr>
@@ -1946,7 +1947,7 @@
           <a:bodyPr/>
           <a:lstStyle/>
           <a:p>
-            <a:fld id="{2196C22A-0490-4AE3-AAE1-554C1C44C303}" type="slidenum">
+            <a:fld id="{32D2AD85-226A-431D-94CD-1256CC25EA7B}" type="slidenum">
               <a:rPr lang="es-ES" smtClean="0"/>
               <a:t>‹Nº›</a:t>
             </a:fld>
@@ -1957,7 +1958,7 @@
     </p:spTree>
     <p:extLst>
       <p:ext uri="{BB962C8B-B14F-4D97-AF65-F5344CB8AC3E}">
-        <p14:creationId xmlns:p14="http://schemas.microsoft.com/office/powerpoint/2010/main" val="2161167493"/>
+        <p14:creationId xmlns:p14="http://schemas.microsoft.com/office/powerpoint/2010/main" val="264273332"/>
       </p:ext>
     </p:extLst>
   </p:cSld>
@@ -1989,7 +1990,7 @@
           <p:cNvPr id="2" name="Título 1">
             <a:extLst>
               <a:ext uri="{FF2B5EF4-FFF2-40B4-BE49-F238E27FC236}">
-                <a16:creationId xmlns:a16="http://schemas.microsoft.com/office/drawing/2014/main" id="{0E842DD8-9F13-5ED6-1575-3EC163184A93}"/>
+                <a16:creationId xmlns:a16="http://schemas.microsoft.com/office/drawing/2014/main" id="{A00621D1-190C-7076-FC55-B77F92436087}"/>
               </a:ext>
             </a:extLst>
           </p:cNvPr>
@@ -2017,7 +2018,7 @@
           <p:cNvPr id="3" name="Marcador de texto vertical 2">
             <a:extLst>
               <a:ext uri="{FF2B5EF4-FFF2-40B4-BE49-F238E27FC236}">
-                <a16:creationId xmlns:a16="http://schemas.microsoft.com/office/drawing/2014/main" id="{5ACA41DA-ABBD-57D9-D6BF-0DA2C5444356}"/>
+                <a16:creationId xmlns:a16="http://schemas.microsoft.com/office/drawing/2014/main" id="{099DDC5B-9311-AAFC-6CAC-E04AE542017A}"/>
               </a:ext>
             </a:extLst>
           </p:cNvPr>
@@ -2074,7 +2075,7 @@
           <p:cNvPr id="4" name="Marcador de fecha 3">
             <a:extLst>
               <a:ext uri="{FF2B5EF4-FFF2-40B4-BE49-F238E27FC236}">
-                <a16:creationId xmlns:a16="http://schemas.microsoft.com/office/drawing/2014/main" id="{7D3EA3E1-3393-4CA4-F565-00FD546D80D0}"/>
+                <a16:creationId xmlns:a16="http://schemas.microsoft.com/office/drawing/2014/main" id="{89ABAE14-E204-D319-1106-0253858B900C}"/>
               </a:ext>
             </a:extLst>
           </p:cNvPr>
@@ -2090,7 +2091,7 @@
           <a:bodyPr/>
           <a:lstStyle/>
           <a:p>
-            <a:fld id="{2240CE9B-84DE-4934-B0C9-67879BB15753}" type="datetimeFigureOut">
+            <a:fld id="{0C062895-02B9-4539-8A29-6999C3E43A53}" type="datetimeFigureOut">
               <a:rPr lang="es-ES" smtClean="0"/>
               <a:t>30/08/2026</a:t>
             </a:fld>
@@ -2103,7 +2104,7 @@
           <p:cNvPr id="5" name="Marcador de pie de página 4">
             <a:extLst>
               <a:ext uri="{FF2B5EF4-FFF2-40B4-BE49-F238E27FC236}">
-                <a16:creationId xmlns:a16="http://schemas.microsoft.com/office/drawing/2014/main" id="{E8550410-87FF-CCD9-C5DD-6F2E0FD461F3}"/>
+                <a16:creationId xmlns:a16="http://schemas.microsoft.com/office/drawing/2014/main" id="{B340E06B-7475-4EEB-50E9-A83A7C13940A}"/>
               </a:ext>
             </a:extLst>
           </p:cNvPr>
@@ -2128,7 +2129,7 @@
           <p:cNvPr id="6" name="Marcador de número de diapositiva 5">
             <a:extLst>
               <a:ext uri="{FF2B5EF4-FFF2-40B4-BE49-F238E27FC236}">
-                <a16:creationId xmlns:a16="http://schemas.microsoft.com/office/drawing/2014/main" id="{2EA643A5-C645-3D97-D692-5150306E6EDF}"/>
+                <a16:creationId xmlns:a16="http://schemas.microsoft.com/office/drawing/2014/main" id="{F434BCE6-09AF-BCAB-0D5F-111BF115AFBA}"/>
               </a:ext>
             </a:extLst>
           </p:cNvPr>
@@ -2144,7 +2145,7 @@
           <a:bodyPr/>
           <a:lstStyle/>
           <a:p>
-            <a:fld id="{2196C22A-0490-4AE3-AAE1-554C1C44C303}" type="slidenum">
+            <a:fld id="{32D2AD85-226A-431D-94CD-1256CC25EA7B}" type="slidenum">
               <a:rPr lang="es-ES" smtClean="0"/>
               <a:t>‹Nº›</a:t>
             </a:fld>
@@ -2155,7 +2156,7 @@
     </p:spTree>
     <p:extLst>
       <p:ext uri="{BB962C8B-B14F-4D97-AF65-F5344CB8AC3E}">
-        <p14:creationId xmlns:p14="http://schemas.microsoft.com/office/powerpoint/2010/main" val="3317596263"/>
+        <p14:creationId xmlns:p14="http://schemas.microsoft.com/office/powerpoint/2010/main" val="2199551632"/>
       </p:ext>
     </p:extLst>
   </p:cSld>
@@ -2187,7 +2188,7 @@
           <p:cNvPr id="2" name="Título vertical 1">
             <a:extLst>
               <a:ext uri="{FF2B5EF4-FFF2-40B4-BE49-F238E27FC236}">
-                <a16:creationId xmlns:a16="http://schemas.microsoft.com/office/drawing/2014/main" id="{3EDC878A-42F5-8DCE-1F90-AB56EC4A9F05}"/>
+                <a16:creationId xmlns:a16="http://schemas.microsoft.com/office/drawing/2014/main" id="{10D8D713-F6E0-8173-F238-027FB105CA0F}"/>
               </a:ext>
             </a:extLst>
           </p:cNvPr>
@@ -2220,7 +2221,7 @@
           <p:cNvPr id="3" name="Marcador de texto vertical 2">
             <a:extLst>
               <a:ext uri="{FF2B5EF4-FFF2-40B4-BE49-F238E27FC236}">
-                <a16:creationId xmlns:a16="http://schemas.microsoft.com/office/drawing/2014/main" id="{41D6DF70-8128-B1F8-6D8E-EF10D58D4545}"/>
+                <a16:creationId xmlns:a16="http://schemas.microsoft.com/office/drawing/2014/main" id="{86092661-4A5C-ECCD-02DE-E366640A4533}"/>
               </a:ext>
             </a:extLst>
           </p:cNvPr>
@@ -2282,7 +2283,7 @@
           <p:cNvPr id="4" name="Marcador de fecha 3">
             <a:extLst>
               <a:ext uri="{FF2B5EF4-FFF2-40B4-BE49-F238E27FC236}">
-                <a16:creationId xmlns:a16="http://schemas.microsoft.com/office/drawing/2014/main" id="{F02254E9-D41F-E93B-7FFA-03E5F9206604}"/>
+                <a16:creationId xmlns:a16="http://schemas.microsoft.com/office/drawing/2014/main" id="{81197B39-BB2C-DB78-735E-A1F4DFD79D88}"/>
               </a:ext>
             </a:extLst>
           </p:cNvPr>
@@ -2298,7 +2299,7 @@
           <a:bodyPr/>
           <a:lstStyle/>
           <a:p>
-            <a:fld id="{2240CE9B-84DE-4934-B0C9-67879BB15753}" type="datetimeFigureOut">
+            <a:fld id="{0C062895-02B9-4539-8A29-6999C3E43A53}" type="datetimeFigureOut">
               <a:rPr lang="es-ES" smtClean="0"/>
               <a:t>30/08/2026</a:t>
             </a:fld>
@@ -2311,7 +2312,7 @@
           <p:cNvPr id="5" name="Marcador de pie de página 4">
             <a:extLst>
               <a:ext uri="{FF2B5EF4-FFF2-40B4-BE49-F238E27FC236}">
-                <a16:creationId xmlns:a16="http://schemas.microsoft.com/office/drawing/2014/main" id="{C6A8BC5C-0752-D349-2BF0-D95733158757}"/>
+                <a16:creationId xmlns:a16="http://schemas.microsoft.com/office/drawing/2014/main" id="{4FE99148-54AD-C10B-83DA-47ECFDAD7AEF}"/>
               </a:ext>
             </a:extLst>
           </p:cNvPr>
@@ -2336,7 +2337,7 @@
           <p:cNvPr id="6" name="Marcador de número de diapositiva 5">
             <a:extLst>
               <a:ext uri="{FF2B5EF4-FFF2-40B4-BE49-F238E27FC236}">
-                <a16:creationId xmlns:a16="http://schemas.microsoft.com/office/drawing/2014/main" id="{0E78135D-EE43-BA10-B434-DD9E42383609}"/>
+                <a16:creationId xmlns:a16="http://schemas.microsoft.com/office/drawing/2014/main" id="{07CFBC52-DCC1-421B-9260-20ED5F96069B}"/>
               </a:ext>
             </a:extLst>
           </p:cNvPr>
@@ -2352,7 +2353,7 @@
           <a:bodyPr/>
           <a:lstStyle/>
           <a:p>
-            <a:fld id="{2196C22A-0490-4AE3-AAE1-554C1C44C303}" type="slidenum">
+            <a:fld id="{32D2AD85-226A-431D-94CD-1256CC25EA7B}" type="slidenum">
               <a:rPr lang="es-ES" smtClean="0"/>
               <a:t>‹Nº›</a:t>
             </a:fld>
@@ -2363,7 +2364,7 @@
     </p:spTree>
     <p:extLst>
       <p:ext uri="{BB962C8B-B14F-4D97-AF65-F5344CB8AC3E}">
-        <p14:creationId xmlns:p14="http://schemas.microsoft.com/office/powerpoint/2010/main" val="2848577694"/>
+        <p14:creationId xmlns:p14="http://schemas.microsoft.com/office/powerpoint/2010/main" val="2084339868"/>
       </p:ext>
     </p:extLst>
   </p:cSld>
@@ -2395,7 +2396,7 @@
           <p:cNvPr id="2" name="Título 1">
             <a:extLst>
               <a:ext uri="{FF2B5EF4-FFF2-40B4-BE49-F238E27FC236}">
-                <a16:creationId xmlns:a16="http://schemas.microsoft.com/office/drawing/2014/main" id="{ABF06763-6F51-EABC-4DD3-E898C10DD36A}"/>
+                <a16:creationId xmlns:a16="http://schemas.microsoft.com/office/drawing/2014/main" id="{7EEB6C7E-ECA3-CED3-6732-97CDF957BE9F}"/>
               </a:ext>
             </a:extLst>
           </p:cNvPr>
@@ -2423,7 +2424,7 @@
           <p:cNvPr id="3" name="Marcador de contenido 2">
             <a:extLst>
               <a:ext uri="{FF2B5EF4-FFF2-40B4-BE49-F238E27FC236}">
-                <a16:creationId xmlns:a16="http://schemas.microsoft.com/office/drawing/2014/main" id="{2FDEA16E-A8F0-1075-4221-98185F20B50F}"/>
+                <a16:creationId xmlns:a16="http://schemas.microsoft.com/office/drawing/2014/main" id="{B2AE0D7D-2E64-E2EA-AE2E-5C0FDA7AF21B}"/>
               </a:ext>
             </a:extLst>
           </p:cNvPr>
@@ -2480,7 +2481,7 @@
           <p:cNvPr id="4" name="Marcador de fecha 3">
             <a:extLst>
               <a:ext uri="{FF2B5EF4-FFF2-40B4-BE49-F238E27FC236}">
-                <a16:creationId xmlns:a16="http://schemas.microsoft.com/office/drawing/2014/main" id="{CDBF8097-E857-B85E-DB5C-304159EDD8CD}"/>
+                <a16:creationId xmlns:a16="http://schemas.microsoft.com/office/drawing/2014/main" id="{BE51A944-7F4A-A4AE-A031-3DBD62A5D857}"/>
               </a:ext>
             </a:extLst>
           </p:cNvPr>
@@ -2496,7 +2497,7 @@
           <a:bodyPr/>
           <a:lstStyle/>
           <a:p>
-            <a:fld id="{2240CE9B-84DE-4934-B0C9-67879BB15753}" type="datetimeFigureOut">
+            <a:fld id="{0C062895-02B9-4539-8A29-6999C3E43A53}" type="datetimeFigureOut">
               <a:rPr lang="es-ES" smtClean="0"/>
               <a:t>30/08/2026</a:t>
             </a:fld>
@@ -2509,7 +2510,7 @@
           <p:cNvPr id="5" name="Marcador de pie de página 4">
             <a:extLst>
               <a:ext uri="{FF2B5EF4-FFF2-40B4-BE49-F238E27FC236}">
-                <a16:creationId xmlns:a16="http://schemas.microsoft.com/office/drawing/2014/main" id="{47FDF364-6DD9-61F1-6DDE-220325A2C581}"/>
+                <a16:creationId xmlns:a16="http://schemas.microsoft.com/office/drawing/2014/main" id="{A2DD56EA-A768-7008-03D2-AD2A0519B322}"/>
               </a:ext>
             </a:extLst>
           </p:cNvPr>
@@ -2534,7 +2535,7 @@
           <p:cNvPr id="6" name="Marcador de número de diapositiva 5">
             <a:extLst>
               <a:ext uri="{FF2B5EF4-FFF2-40B4-BE49-F238E27FC236}">
-                <a16:creationId xmlns:a16="http://schemas.microsoft.com/office/drawing/2014/main" id="{304E2258-3CDD-8A87-2D8D-2D5D79AC382D}"/>
+                <a16:creationId xmlns:a16="http://schemas.microsoft.com/office/drawing/2014/main" id="{0BF7430C-EB0B-5DB1-3859-D464CC8C3E35}"/>
               </a:ext>
             </a:extLst>
           </p:cNvPr>
@@ -2550,7 +2551,7 @@
           <a:bodyPr/>
           <a:lstStyle/>
           <a:p>
-            <a:fld id="{2196C22A-0490-4AE3-AAE1-554C1C44C303}" type="slidenum">
+            <a:fld id="{32D2AD85-226A-431D-94CD-1256CC25EA7B}" type="slidenum">
               <a:rPr lang="es-ES" smtClean="0"/>
               <a:t>‹Nº›</a:t>
             </a:fld>
@@ -2561,7 +2562,7 @@
     </p:spTree>
     <p:extLst>
       <p:ext uri="{BB962C8B-B14F-4D97-AF65-F5344CB8AC3E}">
-        <p14:creationId xmlns:p14="http://schemas.microsoft.com/office/powerpoint/2010/main" val="1605433626"/>
+        <p14:creationId xmlns:p14="http://schemas.microsoft.com/office/powerpoint/2010/main" val="2725057669"/>
       </p:ext>
     </p:extLst>
   </p:cSld>
@@ -2593,7 +2594,7 @@
           <p:cNvPr id="2" name="Título 1">
             <a:extLst>
               <a:ext uri="{FF2B5EF4-FFF2-40B4-BE49-F238E27FC236}">
-                <a16:creationId xmlns:a16="http://schemas.microsoft.com/office/drawing/2014/main" id="{D571D902-0F42-EC1D-6C1A-59BEDB38A9E1}"/>
+                <a16:creationId xmlns:a16="http://schemas.microsoft.com/office/drawing/2014/main" id="{BFA27210-6884-F031-3E2F-26ED863DA6E5}"/>
               </a:ext>
             </a:extLst>
           </p:cNvPr>
@@ -2630,7 +2631,7 @@
           <p:cNvPr id="3" name="Marcador de texto 2">
             <a:extLst>
               <a:ext uri="{FF2B5EF4-FFF2-40B4-BE49-F238E27FC236}">
-                <a16:creationId xmlns:a16="http://schemas.microsoft.com/office/drawing/2014/main" id="{23910AE6-50F3-BFB9-818D-1F0BACF5C762}"/>
+                <a16:creationId xmlns:a16="http://schemas.microsoft.com/office/drawing/2014/main" id="{7CBEDD68-54F1-355D-B083-5A31CDE499AE}"/>
               </a:ext>
             </a:extLst>
           </p:cNvPr>
@@ -2755,7 +2756,7 @@
           <p:cNvPr id="4" name="Marcador de fecha 3">
             <a:extLst>
               <a:ext uri="{FF2B5EF4-FFF2-40B4-BE49-F238E27FC236}">
-                <a16:creationId xmlns:a16="http://schemas.microsoft.com/office/drawing/2014/main" id="{D7071205-E082-3D80-92C1-BDCB669CE2A9}"/>
+                <a16:creationId xmlns:a16="http://schemas.microsoft.com/office/drawing/2014/main" id="{3DFF1A85-7E75-CA37-D782-798C951EDC7F}"/>
               </a:ext>
             </a:extLst>
           </p:cNvPr>
@@ -2771,7 +2772,7 @@
           <a:bodyPr/>
           <a:lstStyle/>
           <a:p>
-            <a:fld id="{2240CE9B-84DE-4934-B0C9-67879BB15753}" type="datetimeFigureOut">
+            <a:fld id="{0C062895-02B9-4539-8A29-6999C3E43A53}" type="datetimeFigureOut">
               <a:rPr lang="es-ES" smtClean="0"/>
               <a:t>30/08/2026</a:t>
             </a:fld>
@@ -2784,7 +2785,7 @@
           <p:cNvPr id="5" name="Marcador de pie de página 4">
             <a:extLst>
               <a:ext uri="{FF2B5EF4-FFF2-40B4-BE49-F238E27FC236}">
-                <a16:creationId xmlns:a16="http://schemas.microsoft.com/office/drawing/2014/main" id="{D0E2AE7C-8684-B446-D8A2-BD15701D1359}"/>
+                <a16:creationId xmlns:a16="http://schemas.microsoft.com/office/drawing/2014/main" id="{26323111-1B3C-64E9-5045-A4E6818B3009}"/>
               </a:ext>
             </a:extLst>
           </p:cNvPr>
@@ -2809,7 +2810,7 @@
           <p:cNvPr id="6" name="Marcador de número de diapositiva 5">
             <a:extLst>
               <a:ext uri="{FF2B5EF4-FFF2-40B4-BE49-F238E27FC236}">
-                <a16:creationId xmlns:a16="http://schemas.microsoft.com/office/drawing/2014/main" id="{6F59B10A-1035-E713-25EC-E64B2BBB2B2A}"/>
+                <a16:creationId xmlns:a16="http://schemas.microsoft.com/office/drawing/2014/main" id="{3CEC49E3-11CF-CCDA-D2AA-D491D2768597}"/>
               </a:ext>
             </a:extLst>
           </p:cNvPr>
@@ -2825,7 +2826,7 @@
           <a:bodyPr/>
           <a:lstStyle/>
           <a:p>
-            <a:fld id="{2196C22A-0490-4AE3-AAE1-554C1C44C303}" type="slidenum">
+            <a:fld id="{32D2AD85-226A-431D-94CD-1256CC25EA7B}" type="slidenum">
               <a:rPr lang="es-ES" smtClean="0"/>
               <a:t>‹Nº›</a:t>
             </a:fld>
@@ -2836,7 +2837,7 @@
     </p:spTree>
     <p:extLst>
       <p:ext uri="{BB962C8B-B14F-4D97-AF65-F5344CB8AC3E}">
-        <p14:creationId xmlns:p14="http://schemas.microsoft.com/office/powerpoint/2010/main" val="1284329207"/>
+        <p14:creationId xmlns:p14="http://schemas.microsoft.com/office/powerpoint/2010/main" val="1397467741"/>
       </p:ext>
     </p:extLst>
   </p:cSld>
@@ -2868,7 +2869,7 @@
           <p:cNvPr id="2" name="Título 1">
             <a:extLst>
               <a:ext uri="{FF2B5EF4-FFF2-40B4-BE49-F238E27FC236}">
-                <a16:creationId xmlns:a16="http://schemas.microsoft.com/office/drawing/2014/main" id="{C6A53566-4438-B0F5-6672-7685BE984C5F}"/>
+                <a16:creationId xmlns:a16="http://schemas.microsoft.com/office/drawing/2014/main" id="{FE6AC7F5-60D2-EFE4-4B60-D8A9678E7F0A}"/>
               </a:ext>
             </a:extLst>
           </p:cNvPr>
@@ -2896,7 +2897,7 @@
           <p:cNvPr id="3" name="Marcador de contenido 2">
             <a:extLst>
               <a:ext uri="{FF2B5EF4-FFF2-40B4-BE49-F238E27FC236}">
-                <a16:creationId xmlns:a16="http://schemas.microsoft.com/office/drawing/2014/main" id="{3F3C066A-FE84-D6B9-7C05-C451E45A881F}"/>
+                <a16:creationId xmlns:a16="http://schemas.microsoft.com/office/drawing/2014/main" id="{57436F4C-4C55-DAA2-3E72-E7D53E8C078D}"/>
               </a:ext>
             </a:extLst>
           </p:cNvPr>
@@ -2958,7 +2959,7 @@
           <p:cNvPr id="4" name="Marcador de contenido 3">
             <a:extLst>
               <a:ext uri="{FF2B5EF4-FFF2-40B4-BE49-F238E27FC236}">
-                <a16:creationId xmlns:a16="http://schemas.microsoft.com/office/drawing/2014/main" id="{74D1EC28-8A7F-9FD4-122A-0AC42A01EE03}"/>
+                <a16:creationId xmlns:a16="http://schemas.microsoft.com/office/drawing/2014/main" id="{4125A72A-0B63-1829-2517-1924F7757C30}"/>
               </a:ext>
             </a:extLst>
           </p:cNvPr>
@@ -3020,7 +3021,7 @@
           <p:cNvPr id="5" name="Marcador de fecha 4">
             <a:extLst>
               <a:ext uri="{FF2B5EF4-FFF2-40B4-BE49-F238E27FC236}">
-                <a16:creationId xmlns:a16="http://schemas.microsoft.com/office/drawing/2014/main" id="{42002C72-6382-C763-FFC5-722864E0CC18}"/>
+                <a16:creationId xmlns:a16="http://schemas.microsoft.com/office/drawing/2014/main" id="{EBE8AF2F-E4CF-A2B6-7BC9-959D4B0CFF69}"/>
               </a:ext>
             </a:extLst>
           </p:cNvPr>
@@ -3036,7 +3037,7 @@
           <a:bodyPr/>
           <a:lstStyle/>
           <a:p>
-            <a:fld id="{2240CE9B-84DE-4934-B0C9-67879BB15753}" type="datetimeFigureOut">
+            <a:fld id="{0C062895-02B9-4539-8A29-6999C3E43A53}" type="datetimeFigureOut">
               <a:rPr lang="es-ES" smtClean="0"/>
               <a:t>30/08/2026</a:t>
             </a:fld>
@@ -3049,7 +3050,7 @@
           <p:cNvPr id="6" name="Marcador de pie de página 5">
             <a:extLst>
               <a:ext uri="{FF2B5EF4-FFF2-40B4-BE49-F238E27FC236}">
-                <a16:creationId xmlns:a16="http://schemas.microsoft.com/office/drawing/2014/main" id="{605B87F4-C614-3F08-5F0F-4FA50AEFCC66}"/>
+                <a16:creationId xmlns:a16="http://schemas.microsoft.com/office/drawing/2014/main" id="{1CC64C9F-B59C-E205-E844-CCF04C1B5A89}"/>
               </a:ext>
             </a:extLst>
           </p:cNvPr>
@@ -3074,7 +3075,7 @@
           <p:cNvPr id="7" name="Marcador de número de diapositiva 6">
             <a:extLst>
               <a:ext uri="{FF2B5EF4-FFF2-40B4-BE49-F238E27FC236}">
-                <a16:creationId xmlns:a16="http://schemas.microsoft.com/office/drawing/2014/main" id="{C83FC888-C8E5-86E8-5602-BA815C214BE0}"/>
+                <a16:creationId xmlns:a16="http://schemas.microsoft.com/office/drawing/2014/main" id="{34822B96-68F1-60B6-42B8-50B3C64CE5FD}"/>
               </a:ext>
             </a:extLst>
           </p:cNvPr>
@@ -3090,7 +3091,7 @@
           <a:bodyPr/>
           <a:lstStyle/>
           <a:p>
-            <a:fld id="{2196C22A-0490-4AE3-AAE1-554C1C44C303}" type="slidenum">
+            <a:fld id="{32D2AD85-226A-431D-94CD-1256CC25EA7B}" type="slidenum">
               <a:rPr lang="es-ES" smtClean="0"/>
               <a:t>‹Nº›</a:t>
             </a:fld>
@@ -3101,7 +3102,7 @@
     </p:spTree>
     <p:extLst>
       <p:ext uri="{BB962C8B-B14F-4D97-AF65-F5344CB8AC3E}">
-        <p14:creationId xmlns:p14="http://schemas.microsoft.com/office/powerpoint/2010/main" val="458017009"/>
+        <p14:creationId xmlns:p14="http://schemas.microsoft.com/office/powerpoint/2010/main" val="957859002"/>
       </p:ext>
     </p:extLst>
   </p:cSld>
@@ -3133,7 +3134,7 @@
           <p:cNvPr id="2" name="Título 1">
             <a:extLst>
               <a:ext uri="{FF2B5EF4-FFF2-40B4-BE49-F238E27FC236}">
-                <a16:creationId xmlns:a16="http://schemas.microsoft.com/office/drawing/2014/main" id="{8D904E71-1A2B-EAA2-6C6F-463E472DCB16}"/>
+                <a16:creationId xmlns:a16="http://schemas.microsoft.com/office/drawing/2014/main" id="{2405199C-3CBB-1402-61A8-F6E2C64F31C2}"/>
               </a:ext>
             </a:extLst>
           </p:cNvPr>
@@ -3166,7 +3167,7 @@
           <p:cNvPr id="3" name="Marcador de texto 2">
             <a:extLst>
               <a:ext uri="{FF2B5EF4-FFF2-40B4-BE49-F238E27FC236}">
-                <a16:creationId xmlns:a16="http://schemas.microsoft.com/office/drawing/2014/main" id="{BC755DA9-9647-0AF2-DDE9-A358F4076ABD}"/>
+                <a16:creationId xmlns:a16="http://schemas.microsoft.com/office/drawing/2014/main" id="{29731004-1159-D8C4-6358-9A0304EF5C24}"/>
               </a:ext>
             </a:extLst>
           </p:cNvPr>
@@ -3237,7 +3238,7 @@
           <p:cNvPr id="4" name="Marcador de contenido 3">
             <a:extLst>
               <a:ext uri="{FF2B5EF4-FFF2-40B4-BE49-F238E27FC236}">
-                <a16:creationId xmlns:a16="http://schemas.microsoft.com/office/drawing/2014/main" id="{FF45639D-F6C3-0643-F3CB-486EC29E6CDF}"/>
+                <a16:creationId xmlns:a16="http://schemas.microsoft.com/office/drawing/2014/main" id="{5D640963-B30E-CB3F-2106-FDAA20D42327}"/>
               </a:ext>
             </a:extLst>
           </p:cNvPr>
@@ -3299,7 +3300,7 @@
           <p:cNvPr id="5" name="Marcador de texto 4">
             <a:extLst>
               <a:ext uri="{FF2B5EF4-FFF2-40B4-BE49-F238E27FC236}">
-                <a16:creationId xmlns:a16="http://schemas.microsoft.com/office/drawing/2014/main" id="{EAA9C0BA-259E-971C-354B-EA86BDF07505}"/>
+                <a16:creationId xmlns:a16="http://schemas.microsoft.com/office/drawing/2014/main" id="{763F8E84-9131-BDD5-A7C5-57D693EE2E03}"/>
               </a:ext>
             </a:extLst>
           </p:cNvPr>
@@ -3370,7 +3371,7 @@
           <p:cNvPr id="6" name="Marcador de contenido 5">
             <a:extLst>
               <a:ext uri="{FF2B5EF4-FFF2-40B4-BE49-F238E27FC236}">
-                <a16:creationId xmlns:a16="http://schemas.microsoft.com/office/drawing/2014/main" id="{DF46F584-2449-7A44-09DA-3203FB642030}"/>
+                <a16:creationId xmlns:a16="http://schemas.microsoft.com/office/drawing/2014/main" id="{B2CFC5EF-D15C-01F2-AA66-B50B703CCD16}"/>
               </a:ext>
             </a:extLst>
           </p:cNvPr>
@@ -3432,7 +3433,7 @@
           <p:cNvPr id="7" name="Marcador de fecha 6">
             <a:extLst>
               <a:ext uri="{FF2B5EF4-FFF2-40B4-BE49-F238E27FC236}">
-                <a16:creationId xmlns:a16="http://schemas.microsoft.com/office/drawing/2014/main" id="{32E4FC6B-43F5-A4A2-31BD-672163AC2CA2}"/>
+                <a16:creationId xmlns:a16="http://schemas.microsoft.com/office/drawing/2014/main" id="{E6DBD9EA-023A-41D1-0B4B-6D9FB1AC5C39}"/>
               </a:ext>
             </a:extLst>
           </p:cNvPr>
@@ -3448,7 +3449,7 @@
           <a:bodyPr/>
           <a:lstStyle/>
           <a:p>
-            <a:fld id="{2240CE9B-84DE-4934-B0C9-67879BB15753}" type="datetimeFigureOut">
+            <a:fld id="{0C062895-02B9-4539-8A29-6999C3E43A53}" type="datetimeFigureOut">
               <a:rPr lang="es-ES" smtClean="0"/>
               <a:t>30/08/2026</a:t>
             </a:fld>
@@ -3461,7 +3462,7 @@
           <p:cNvPr id="8" name="Marcador de pie de página 7">
             <a:extLst>
               <a:ext uri="{FF2B5EF4-FFF2-40B4-BE49-F238E27FC236}">
-                <a16:creationId xmlns:a16="http://schemas.microsoft.com/office/drawing/2014/main" id="{B465EA79-88BB-EA5B-2367-EF628481AA81}"/>
+                <a16:creationId xmlns:a16="http://schemas.microsoft.com/office/drawing/2014/main" id="{9AF7BF42-0375-87DD-F2F4-520021D450E9}"/>
               </a:ext>
             </a:extLst>
           </p:cNvPr>
@@ -3486,7 +3487,7 @@
           <p:cNvPr id="9" name="Marcador de número de diapositiva 8">
             <a:extLst>
               <a:ext uri="{FF2B5EF4-FFF2-40B4-BE49-F238E27FC236}">
-                <a16:creationId xmlns:a16="http://schemas.microsoft.com/office/drawing/2014/main" id="{708BC5FD-8676-5076-28B8-4BF5704FB7FD}"/>
+                <a16:creationId xmlns:a16="http://schemas.microsoft.com/office/drawing/2014/main" id="{89FA8646-1895-E141-091E-B3252DF063BF}"/>
               </a:ext>
             </a:extLst>
           </p:cNvPr>
@@ -3502,7 +3503,7 @@
           <a:bodyPr/>
           <a:lstStyle/>
           <a:p>
-            <a:fld id="{2196C22A-0490-4AE3-AAE1-554C1C44C303}" type="slidenum">
+            <a:fld id="{32D2AD85-226A-431D-94CD-1256CC25EA7B}" type="slidenum">
               <a:rPr lang="es-ES" smtClean="0"/>
               <a:t>‹Nº›</a:t>
             </a:fld>
@@ -3513,7 +3514,7 @@
     </p:spTree>
     <p:extLst>
       <p:ext uri="{BB962C8B-B14F-4D97-AF65-F5344CB8AC3E}">
-        <p14:creationId xmlns:p14="http://schemas.microsoft.com/office/powerpoint/2010/main" val="961704544"/>
+        <p14:creationId xmlns:p14="http://schemas.microsoft.com/office/powerpoint/2010/main" val="4242851619"/>
       </p:ext>
     </p:extLst>
   </p:cSld>
@@ -3545,7 +3546,7 @@
           <p:cNvPr id="2" name="Título 1">
             <a:extLst>
               <a:ext uri="{FF2B5EF4-FFF2-40B4-BE49-F238E27FC236}">
-                <a16:creationId xmlns:a16="http://schemas.microsoft.com/office/drawing/2014/main" id="{DE57490A-D359-E2A3-2B4F-90F9C3B41EFE}"/>
+                <a16:creationId xmlns:a16="http://schemas.microsoft.com/office/drawing/2014/main" id="{52D838CD-FB2A-25E6-0C14-F743E5618278}"/>
               </a:ext>
             </a:extLst>
           </p:cNvPr>
@@ -3573,7 +3574,7 @@
           <p:cNvPr id="3" name="Marcador de fecha 2">
             <a:extLst>
               <a:ext uri="{FF2B5EF4-FFF2-40B4-BE49-F238E27FC236}">
-                <a16:creationId xmlns:a16="http://schemas.microsoft.com/office/drawing/2014/main" id="{A1497A1F-6855-6FD8-F057-4DFB26B6B051}"/>
+                <a16:creationId xmlns:a16="http://schemas.microsoft.com/office/drawing/2014/main" id="{CFDD6E43-692E-C85C-9B49-3D221148A4BF}"/>
               </a:ext>
             </a:extLst>
           </p:cNvPr>
@@ -3589,7 +3590,7 @@
           <a:bodyPr/>
           <a:lstStyle/>
           <a:p>
-            <a:fld id="{2240CE9B-84DE-4934-B0C9-67879BB15753}" type="datetimeFigureOut">
+            <a:fld id="{0C062895-02B9-4539-8A29-6999C3E43A53}" type="datetimeFigureOut">
               <a:rPr lang="es-ES" smtClean="0"/>
               <a:t>30/08/2026</a:t>
             </a:fld>
@@ -3602,7 +3603,7 @@
           <p:cNvPr id="4" name="Marcador de pie de página 3">
             <a:extLst>
               <a:ext uri="{FF2B5EF4-FFF2-40B4-BE49-F238E27FC236}">
-                <a16:creationId xmlns:a16="http://schemas.microsoft.com/office/drawing/2014/main" id="{DA76D74C-B153-16DC-4891-C718B27F4B5D}"/>
+                <a16:creationId xmlns:a16="http://schemas.microsoft.com/office/drawing/2014/main" id="{C8ED8E08-27AA-0874-4EAC-8F3C5B596F34}"/>
               </a:ext>
             </a:extLst>
           </p:cNvPr>
@@ -3627,7 +3628,7 @@
           <p:cNvPr id="5" name="Marcador de número de diapositiva 4">
             <a:extLst>
               <a:ext uri="{FF2B5EF4-FFF2-40B4-BE49-F238E27FC236}">
-                <a16:creationId xmlns:a16="http://schemas.microsoft.com/office/drawing/2014/main" id="{CB49894B-F7D7-01FC-9CB4-BE59890D93E3}"/>
+                <a16:creationId xmlns:a16="http://schemas.microsoft.com/office/drawing/2014/main" id="{8CAEB461-5DBB-B53B-A1B1-268B69325286}"/>
               </a:ext>
             </a:extLst>
           </p:cNvPr>
@@ -3643,7 +3644,7 @@
           <a:bodyPr/>
           <a:lstStyle/>
           <a:p>
-            <a:fld id="{2196C22A-0490-4AE3-AAE1-554C1C44C303}" type="slidenum">
+            <a:fld id="{32D2AD85-226A-431D-94CD-1256CC25EA7B}" type="slidenum">
               <a:rPr lang="es-ES" smtClean="0"/>
               <a:t>‹Nº›</a:t>
             </a:fld>
@@ -3654,7 +3655,7 @@
     </p:spTree>
     <p:extLst>
       <p:ext uri="{BB962C8B-B14F-4D97-AF65-F5344CB8AC3E}">
-        <p14:creationId xmlns:p14="http://schemas.microsoft.com/office/powerpoint/2010/main" val="3745383077"/>
+        <p14:creationId xmlns:p14="http://schemas.microsoft.com/office/powerpoint/2010/main" val="1098838332"/>
       </p:ext>
     </p:extLst>
   </p:cSld>
@@ -3686,7 +3687,7 @@
           <p:cNvPr id="2" name="Marcador de fecha 1">
             <a:extLst>
               <a:ext uri="{FF2B5EF4-FFF2-40B4-BE49-F238E27FC236}">
-                <a16:creationId xmlns:a16="http://schemas.microsoft.com/office/drawing/2014/main" id="{CF410731-03DD-9A08-269C-022A0C2A31F1}"/>
+                <a16:creationId xmlns:a16="http://schemas.microsoft.com/office/drawing/2014/main" id="{23BDBC4E-ED4B-2977-B810-139EFF9302DA}"/>
               </a:ext>
             </a:extLst>
           </p:cNvPr>
@@ -3702,7 +3703,7 @@
           <a:bodyPr/>
           <a:lstStyle/>
           <a:p>
-            <a:fld id="{2240CE9B-84DE-4934-B0C9-67879BB15753}" type="datetimeFigureOut">
+            <a:fld id="{0C062895-02B9-4539-8A29-6999C3E43A53}" type="datetimeFigureOut">
               <a:rPr lang="es-ES" smtClean="0"/>
               <a:t>30/08/2026</a:t>
             </a:fld>
@@ -3715,7 +3716,7 @@
           <p:cNvPr id="3" name="Marcador de pie de página 2">
             <a:extLst>
               <a:ext uri="{FF2B5EF4-FFF2-40B4-BE49-F238E27FC236}">
-                <a16:creationId xmlns:a16="http://schemas.microsoft.com/office/drawing/2014/main" id="{720AF105-C795-651D-4B5D-659F0A2BC8CC}"/>
+                <a16:creationId xmlns:a16="http://schemas.microsoft.com/office/drawing/2014/main" id="{1C61B963-96DA-B129-7718-681D10F6A469}"/>
               </a:ext>
             </a:extLst>
           </p:cNvPr>
@@ -3740,7 +3741,7 @@
           <p:cNvPr id="4" name="Marcador de número de diapositiva 3">
             <a:extLst>
               <a:ext uri="{FF2B5EF4-FFF2-40B4-BE49-F238E27FC236}">
-                <a16:creationId xmlns:a16="http://schemas.microsoft.com/office/drawing/2014/main" id="{33FBE034-17C0-33CB-F1CA-0147CDC3E643}"/>
+                <a16:creationId xmlns:a16="http://schemas.microsoft.com/office/drawing/2014/main" id="{C3B8EE67-A66B-EB10-A68B-191F32B20EB1}"/>
               </a:ext>
             </a:extLst>
           </p:cNvPr>
@@ -3756,7 +3757,7 @@
           <a:bodyPr/>
           <a:lstStyle/>
           <a:p>
-            <a:fld id="{2196C22A-0490-4AE3-AAE1-554C1C44C303}" type="slidenum">
+            <a:fld id="{32D2AD85-226A-431D-94CD-1256CC25EA7B}" type="slidenum">
               <a:rPr lang="es-ES" smtClean="0"/>
               <a:t>‹Nº›</a:t>
             </a:fld>
@@ -3767,7 +3768,7 @@
     </p:spTree>
     <p:extLst>
       <p:ext uri="{BB962C8B-B14F-4D97-AF65-F5344CB8AC3E}">
-        <p14:creationId xmlns:p14="http://schemas.microsoft.com/office/powerpoint/2010/main" val="623759127"/>
+        <p14:creationId xmlns:p14="http://schemas.microsoft.com/office/powerpoint/2010/main" val="2347273436"/>
       </p:ext>
     </p:extLst>
   </p:cSld>
@@ -3799,7 +3800,7 @@
           <p:cNvPr id="2" name="Título 1">
             <a:extLst>
               <a:ext uri="{FF2B5EF4-FFF2-40B4-BE49-F238E27FC236}">
-                <a16:creationId xmlns:a16="http://schemas.microsoft.com/office/drawing/2014/main" id="{F001ED9C-2039-EEA2-C362-9655ABCC58D5}"/>
+                <a16:creationId xmlns:a16="http://schemas.microsoft.com/office/drawing/2014/main" id="{16B1C087-3642-9EBC-CF37-76BAA7F4DF57}"/>
               </a:ext>
             </a:extLst>
           </p:cNvPr>
@@ -3836,7 +3837,7 @@
           <p:cNvPr id="3" name="Marcador de contenido 2">
             <a:extLst>
               <a:ext uri="{FF2B5EF4-FFF2-40B4-BE49-F238E27FC236}">
-                <a16:creationId xmlns:a16="http://schemas.microsoft.com/office/drawing/2014/main" id="{B8C2E474-192F-FE64-BDE8-0675911B3B4A}"/>
+                <a16:creationId xmlns:a16="http://schemas.microsoft.com/office/drawing/2014/main" id="{2FBC9711-5CD3-AB53-08C4-96F9686F3B0B}"/>
               </a:ext>
             </a:extLst>
           </p:cNvPr>
@@ -3926,7 +3927,7 @@
           <p:cNvPr id="4" name="Marcador de texto 3">
             <a:extLst>
               <a:ext uri="{FF2B5EF4-FFF2-40B4-BE49-F238E27FC236}">
-                <a16:creationId xmlns:a16="http://schemas.microsoft.com/office/drawing/2014/main" id="{36277D89-08D8-3FBF-05A7-EC94679E056F}"/>
+                <a16:creationId xmlns:a16="http://schemas.microsoft.com/office/drawing/2014/main" id="{58A499CA-6E30-65F3-82B2-7CE8C0B06E02}"/>
               </a:ext>
             </a:extLst>
           </p:cNvPr>
@@ -3997,7 +3998,7 @@
           <p:cNvPr id="5" name="Marcador de fecha 4">
             <a:extLst>
               <a:ext uri="{FF2B5EF4-FFF2-40B4-BE49-F238E27FC236}">
-                <a16:creationId xmlns:a16="http://schemas.microsoft.com/office/drawing/2014/main" id="{785B180F-F396-792F-CC96-8AD542A92670}"/>
+                <a16:creationId xmlns:a16="http://schemas.microsoft.com/office/drawing/2014/main" id="{703ED32A-68FC-66A5-1F38-C856AB0CB12A}"/>
               </a:ext>
             </a:extLst>
           </p:cNvPr>
@@ -4013,7 +4014,7 @@
           <a:bodyPr/>
           <a:lstStyle/>
           <a:p>
-            <a:fld id="{2240CE9B-84DE-4934-B0C9-67879BB15753}" type="datetimeFigureOut">
+            <a:fld id="{0C062895-02B9-4539-8A29-6999C3E43A53}" type="datetimeFigureOut">
               <a:rPr lang="es-ES" smtClean="0"/>
               <a:t>30/08/2026</a:t>
             </a:fld>
@@ -4026,7 +4027,7 @@
           <p:cNvPr id="6" name="Marcador de pie de página 5">
             <a:extLst>
               <a:ext uri="{FF2B5EF4-FFF2-40B4-BE49-F238E27FC236}">
-                <a16:creationId xmlns:a16="http://schemas.microsoft.com/office/drawing/2014/main" id="{F60FF24E-84C2-0DCC-DB02-5F15E7BC5023}"/>
+                <a16:creationId xmlns:a16="http://schemas.microsoft.com/office/drawing/2014/main" id="{A9E0C3DC-67E9-8AD7-C8EA-852075519CE2}"/>
               </a:ext>
             </a:extLst>
           </p:cNvPr>
@@ -4051,7 +4052,7 @@
           <p:cNvPr id="7" name="Marcador de número de diapositiva 6">
             <a:extLst>
               <a:ext uri="{FF2B5EF4-FFF2-40B4-BE49-F238E27FC236}">
-                <a16:creationId xmlns:a16="http://schemas.microsoft.com/office/drawing/2014/main" id="{2B633731-1CC8-5E0D-FBFA-796AB876DECD}"/>
+                <a16:creationId xmlns:a16="http://schemas.microsoft.com/office/drawing/2014/main" id="{00EA00AF-A9CD-8594-E088-7D736E0D140D}"/>
               </a:ext>
             </a:extLst>
           </p:cNvPr>
@@ -4067,7 +4068,7 @@
           <a:bodyPr/>
           <a:lstStyle/>
           <a:p>
-            <a:fld id="{2196C22A-0490-4AE3-AAE1-554C1C44C303}" type="slidenum">
+            <a:fld id="{32D2AD85-226A-431D-94CD-1256CC25EA7B}" type="slidenum">
               <a:rPr lang="es-ES" smtClean="0"/>
               <a:t>‹Nº›</a:t>
             </a:fld>
@@ -4078,7 +4079,7 @@
     </p:spTree>
     <p:extLst>
       <p:ext uri="{BB962C8B-B14F-4D97-AF65-F5344CB8AC3E}">
-        <p14:creationId xmlns:p14="http://schemas.microsoft.com/office/powerpoint/2010/main" val="3403580704"/>
+        <p14:creationId xmlns:p14="http://schemas.microsoft.com/office/powerpoint/2010/main" val="4014402258"/>
       </p:ext>
     </p:extLst>
   </p:cSld>
@@ -4110,7 +4111,7 @@
           <p:cNvPr id="2" name="Título 1">
             <a:extLst>
               <a:ext uri="{FF2B5EF4-FFF2-40B4-BE49-F238E27FC236}">
-                <a16:creationId xmlns:a16="http://schemas.microsoft.com/office/drawing/2014/main" id="{9FC28DEC-5530-E210-3110-BBAA43FB1B3B}"/>
+                <a16:creationId xmlns:a16="http://schemas.microsoft.com/office/drawing/2014/main" id="{E17F0D7A-D62E-40B7-D850-3A85DC858DD5}"/>
               </a:ext>
             </a:extLst>
           </p:cNvPr>
@@ -4147,7 +4148,7 @@
           <p:cNvPr id="3" name="Marcador de posición de imagen 2">
             <a:extLst>
               <a:ext uri="{FF2B5EF4-FFF2-40B4-BE49-F238E27FC236}">
-                <a16:creationId xmlns:a16="http://schemas.microsoft.com/office/drawing/2014/main" id="{A2DAEAF0-6A0D-CC40-FB90-CDCC319DCF1A}"/>
+                <a16:creationId xmlns:a16="http://schemas.microsoft.com/office/drawing/2014/main" id="{6CEF1E1F-6D65-A7C8-0D39-6CF2AEA2999B}"/>
               </a:ext>
             </a:extLst>
           </p:cNvPr>
@@ -4214,7 +4215,7 @@
           <p:cNvPr id="4" name="Marcador de texto 3">
             <a:extLst>
               <a:ext uri="{FF2B5EF4-FFF2-40B4-BE49-F238E27FC236}">
-                <a16:creationId xmlns:a16="http://schemas.microsoft.com/office/drawing/2014/main" id="{0D26D0E9-5887-9A5F-3541-A407F8FF680C}"/>
+                <a16:creationId xmlns:a16="http://schemas.microsoft.com/office/drawing/2014/main" id="{AC5879EB-CEC0-46AD-FCF2-851989D72CEB}"/>
               </a:ext>
             </a:extLst>
           </p:cNvPr>
@@ -4285,7 +4286,7 @@
           <p:cNvPr id="5" name="Marcador de fecha 4">
             <a:extLst>
               <a:ext uri="{FF2B5EF4-FFF2-40B4-BE49-F238E27FC236}">
-                <a16:creationId xmlns:a16="http://schemas.microsoft.com/office/drawing/2014/main" id="{868180B2-BB8E-6AC6-F4A3-698B1EE25C10}"/>
+                <a16:creationId xmlns:a16="http://schemas.microsoft.com/office/drawing/2014/main" id="{6720ABF9-16C8-D6B0-E312-8FA8BCE92EA5}"/>
               </a:ext>
             </a:extLst>
           </p:cNvPr>
@@ -4301,7 +4302,7 @@
           <a:bodyPr/>
           <a:lstStyle/>
           <a:p>
-            <a:fld id="{2240CE9B-84DE-4934-B0C9-67879BB15753}" type="datetimeFigureOut">
+            <a:fld id="{0C062895-02B9-4539-8A29-6999C3E43A53}" type="datetimeFigureOut">
               <a:rPr lang="es-ES" smtClean="0"/>
               <a:t>30/08/2026</a:t>
             </a:fld>
@@ -4314,7 +4315,7 @@
           <p:cNvPr id="6" name="Marcador de pie de página 5">
             <a:extLst>
               <a:ext uri="{FF2B5EF4-FFF2-40B4-BE49-F238E27FC236}">
-                <a16:creationId xmlns:a16="http://schemas.microsoft.com/office/drawing/2014/main" id="{69B80B60-2CF8-64E7-162D-4E9A77488600}"/>
+                <a16:creationId xmlns:a16="http://schemas.microsoft.com/office/drawing/2014/main" id="{24C0EC0B-F14F-EB74-2B73-46507B3DEDD9}"/>
               </a:ext>
             </a:extLst>
           </p:cNvPr>
@@ -4339,7 +4340,7 @@
           <p:cNvPr id="7" name="Marcador de número de diapositiva 6">
             <a:extLst>
               <a:ext uri="{FF2B5EF4-FFF2-40B4-BE49-F238E27FC236}">
-                <a16:creationId xmlns:a16="http://schemas.microsoft.com/office/drawing/2014/main" id="{6F9CCC9E-4733-E7B0-B5D7-13BC02769F62}"/>
+                <a16:creationId xmlns:a16="http://schemas.microsoft.com/office/drawing/2014/main" id="{1705E5DC-2170-C950-7A29-3B7BF42397D2}"/>
               </a:ext>
             </a:extLst>
           </p:cNvPr>
@@ -4355,7 +4356,7 @@
           <a:bodyPr/>
           <a:lstStyle/>
           <a:p>
-            <a:fld id="{2196C22A-0490-4AE3-AAE1-554C1C44C303}" type="slidenum">
+            <a:fld id="{32D2AD85-226A-431D-94CD-1256CC25EA7B}" type="slidenum">
               <a:rPr lang="es-ES" smtClean="0"/>
               <a:t>‹Nº›</a:t>
             </a:fld>
@@ -4366,7 +4367,7 @@
     </p:spTree>
     <p:extLst>
       <p:ext uri="{BB962C8B-B14F-4D97-AF65-F5344CB8AC3E}">
-        <p14:creationId xmlns:p14="http://schemas.microsoft.com/office/powerpoint/2010/main" val="905473440"/>
+        <p14:creationId xmlns:p14="http://schemas.microsoft.com/office/powerpoint/2010/main" val="1665151566"/>
       </p:ext>
     </p:extLst>
   </p:cSld>
@@ -4403,7 +4404,7 @@
           <p:cNvPr id="2" name="Marcador de título 1">
             <a:extLst>
               <a:ext uri="{FF2B5EF4-FFF2-40B4-BE49-F238E27FC236}">
-                <a16:creationId xmlns:a16="http://schemas.microsoft.com/office/drawing/2014/main" id="{82BE8166-94D0-518D-1682-6049B9A8F77A}"/>
+                <a16:creationId xmlns:a16="http://schemas.microsoft.com/office/drawing/2014/main" id="{325E07CD-888D-08C7-D9B2-2003E1B12611}"/>
               </a:ext>
             </a:extLst>
           </p:cNvPr>
@@ -4441,7 +4442,7 @@
           <p:cNvPr id="3" name="Marcador de texto 2">
             <a:extLst>
               <a:ext uri="{FF2B5EF4-FFF2-40B4-BE49-F238E27FC236}">
-                <a16:creationId xmlns:a16="http://schemas.microsoft.com/office/drawing/2014/main" id="{36687951-540F-BAA7-D773-3488E0F0392E}"/>
+                <a16:creationId xmlns:a16="http://schemas.microsoft.com/office/drawing/2014/main" id="{335A8A78-5928-5DDB-2B65-856F9405DC45}"/>
               </a:ext>
             </a:extLst>
           </p:cNvPr>
@@ -4508,7 +4509,7 @@
           <p:cNvPr id="4" name="Marcador de fecha 3">
             <a:extLst>
               <a:ext uri="{FF2B5EF4-FFF2-40B4-BE49-F238E27FC236}">
-                <a16:creationId xmlns:a16="http://schemas.microsoft.com/office/drawing/2014/main" id="{BED4D1C6-B4E1-866A-DC9E-0AF5A05C6DC6}"/>
+                <a16:creationId xmlns:a16="http://schemas.microsoft.com/office/drawing/2014/main" id="{513ABB17-A8B4-70F2-A36E-C2A5B0BC6B72}"/>
               </a:ext>
             </a:extLst>
           </p:cNvPr>
@@ -4542,7 +4543,7 @@
             </a:lvl1pPr>
           </a:lstStyle>
           <a:p>
-            <a:fld id="{2240CE9B-84DE-4934-B0C9-67879BB15753}" type="datetimeFigureOut">
+            <a:fld id="{0C062895-02B9-4539-8A29-6999C3E43A53}" type="datetimeFigureOut">
               <a:rPr lang="es-ES" smtClean="0"/>
               <a:t>30/08/2026</a:t>
             </a:fld>
@@ -4555,7 +4556,7 @@
           <p:cNvPr id="5" name="Marcador de pie de página 4">
             <a:extLst>
               <a:ext uri="{FF2B5EF4-FFF2-40B4-BE49-F238E27FC236}">
-                <a16:creationId xmlns:a16="http://schemas.microsoft.com/office/drawing/2014/main" id="{EC886C8D-0ABC-C952-1221-9DDD33E77DC6}"/>
+                <a16:creationId xmlns:a16="http://schemas.microsoft.com/office/drawing/2014/main" id="{579958F8-2DB2-BAC9-43CF-69C44DE858A1}"/>
               </a:ext>
             </a:extLst>
           </p:cNvPr>
@@ -4598,7 +4599,7 @@
           <p:cNvPr id="6" name="Marcador de número de diapositiva 5">
             <a:extLst>
               <a:ext uri="{FF2B5EF4-FFF2-40B4-BE49-F238E27FC236}">
-                <a16:creationId xmlns:a16="http://schemas.microsoft.com/office/drawing/2014/main" id="{EA7E723F-A1AF-6E56-F44C-945FBA274B65}"/>
+                <a16:creationId xmlns:a16="http://schemas.microsoft.com/office/drawing/2014/main" id="{41417D5E-9870-4B22-B515-745E711105F0}"/>
               </a:ext>
             </a:extLst>
           </p:cNvPr>
@@ -4632,7 +4633,7 @@
             </a:lvl1pPr>
           </a:lstStyle>
           <a:p>
-            <a:fld id="{2196C22A-0490-4AE3-AAE1-554C1C44C303}" type="slidenum">
+            <a:fld id="{32D2AD85-226A-431D-94CD-1256CC25EA7B}" type="slidenum">
               <a:rPr lang="es-ES" smtClean="0"/>
               <a:t>‹Nº›</a:t>
             </a:fld>
@@ -4643,7 +4644,7 @@
     </p:spTree>
     <p:extLst>
       <p:ext uri="{BB962C8B-B14F-4D97-AF65-F5344CB8AC3E}">
-        <p14:creationId xmlns:p14="http://schemas.microsoft.com/office/powerpoint/2010/main" val="330008812"/>
+        <p14:creationId xmlns:p14="http://schemas.microsoft.com/office/powerpoint/2010/main" val="3450793291"/>
       </p:ext>
     </p:extLst>
   </p:cSld>
@@ -4974,7 +4975,7 @@
           <p:cNvPr id="2" name="Accent field">
             <a:extLst>
               <a:ext uri="{FF2B5EF4-FFF2-40B4-BE49-F238E27FC236}">
-                <a16:creationId xmlns:a16="http://schemas.microsoft.com/office/drawing/2014/main" id="{4D9E6F04-58CA-A0DB-149F-35DD41A208B1}"/>
+                <a16:creationId xmlns:a16="http://schemas.microsoft.com/office/drawing/2014/main" id="{579A25A2-22A0-93C2-9544-F1BAAC8C165C}"/>
               </a:ext>
             </a:extLst>
           </p:cNvPr>
@@ -5042,7 +5043,7 @@
           <p:cNvPr id="3" name="Cover accent">
             <a:extLst>
               <a:ext uri="{FF2B5EF4-FFF2-40B4-BE49-F238E27FC236}">
-                <a16:creationId xmlns:a16="http://schemas.microsoft.com/office/drawing/2014/main" id="{73EB53BD-B7D1-B863-C003-B266DB7E4354}"/>
+                <a16:creationId xmlns:a16="http://schemas.microsoft.com/office/drawing/2014/main" id="{00DC7F2F-B423-1673-129F-5C7E05D0A45C}"/>
               </a:ext>
             </a:extLst>
           </p:cNvPr>
@@ -5083,7 +5084,7 @@
           <p:cNvPr id="4" name="Cover secondary accent">
             <a:extLst>
               <a:ext uri="{FF2B5EF4-FFF2-40B4-BE49-F238E27FC236}">
-                <a16:creationId xmlns:a16="http://schemas.microsoft.com/office/drawing/2014/main" id="{7599C392-A1B0-06F5-54D5-5F40B4AF2E6B}"/>
+                <a16:creationId xmlns:a16="http://schemas.microsoft.com/office/drawing/2014/main" id="{85C21662-3021-DA26-E8CE-CC9AF12477CB}"/>
               </a:ext>
             </a:extLst>
           </p:cNvPr>
@@ -5124,7 +5125,7 @@
           <p:cNvPr id="5" name="Eyebrow">
             <a:extLst>
               <a:ext uri="{FF2B5EF4-FFF2-40B4-BE49-F238E27FC236}">
-                <a16:creationId xmlns:a16="http://schemas.microsoft.com/office/drawing/2014/main" id="{3BC023BA-D014-D11D-4ACC-4A32B2B703F1}"/>
+                <a16:creationId xmlns:a16="http://schemas.microsoft.com/office/drawing/2014/main" id="{BED0055D-19F1-CA70-9157-9D8D7DB9A972}"/>
               </a:ext>
             </a:extLst>
           </p:cNvPr>
@@ -5169,7 +5170,7 @@
           <p:cNvPr id="6" name="Deck title">
             <a:extLst>
               <a:ext uri="{FF2B5EF4-FFF2-40B4-BE49-F238E27FC236}">
-                <a16:creationId xmlns:a16="http://schemas.microsoft.com/office/drawing/2014/main" id="{D2C73854-723A-16EA-A295-4353FD9D0892}"/>
+                <a16:creationId xmlns:a16="http://schemas.microsoft.com/office/drawing/2014/main" id="{8CB24675-B676-A69E-777D-C79C5294BBD0}"/>
               </a:ext>
             </a:extLst>
           </p:cNvPr>
@@ -5215,7 +5216,7 @@
           <p:cNvPr id="7" name="Subtitle">
             <a:extLst>
               <a:ext uri="{FF2B5EF4-FFF2-40B4-BE49-F238E27FC236}">
-                <a16:creationId xmlns:a16="http://schemas.microsoft.com/office/drawing/2014/main" id="{CDC30544-540F-A8F9-8A81-E936BC8176A4}"/>
+                <a16:creationId xmlns:a16="http://schemas.microsoft.com/office/drawing/2014/main" id="{59EC86AD-B3DB-A750-53C2-17F539FBFF6A}"/>
               </a:ext>
             </a:extLst>
           </p:cNvPr>
@@ -5260,7 +5261,7 @@
           <p:cNvPr id="8" name="Author">
             <a:extLst>
               <a:ext uri="{FF2B5EF4-FFF2-40B4-BE49-F238E27FC236}">
-                <a16:creationId xmlns:a16="http://schemas.microsoft.com/office/drawing/2014/main" id="{C2159A97-D0E9-26BF-2F4B-8ED4D4F1D9D5}"/>
+                <a16:creationId xmlns:a16="http://schemas.microsoft.com/office/drawing/2014/main" id="{93415A81-B9E9-69DE-2AB4-F52F6EFFBADE}"/>
               </a:ext>
             </a:extLst>
           </p:cNvPr>
@@ -5305,7 +5306,7 @@
           <p:cNvPr id="9" name="Tutor">
             <a:extLst>
               <a:ext uri="{FF2B5EF4-FFF2-40B4-BE49-F238E27FC236}">
-                <a16:creationId xmlns:a16="http://schemas.microsoft.com/office/drawing/2014/main" id="{C2AE4C61-0507-276C-2804-E2C3798EC658}"/>
+                <a16:creationId xmlns:a16="http://schemas.microsoft.com/office/drawing/2014/main" id="{EDC8FE3B-B12D-4EED-7788-C8ACAEB19D31}"/>
               </a:ext>
             </a:extLst>
           </p:cNvPr>
@@ -5350,7 +5351,7 @@
           <p:cNvPr id="10" name="Cover mark">
             <a:extLst>
               <a:ext uri="{FF2B5EF4-FFF2-40B4-BE49-F238E27FC236}">
-                <a16:creationId xmlns:a16="http://schemas.microsoft.com/office/drawing/2014/main" id="{A2D2735E-819B-A1D3-6C8D-FA4C4225E95C}"/>
+                <a16:creationId xmlns:a16="http://schemas.microsoft.com/office/drawing/2014/main" id="{B3ACB225-2561-3DFC-7BC3-370DADCF5B9F}"/>
               </a:ext>
             </a:extLst>
           </p:cNvPr>
@@ -5393,7 +5394,7 @@
     </p:spTree>
     <p:extLst>
       <p:ext uri="{BB962C8B-B14F-4D97-AF65-F5344CB8AC3E}">
-        <p14:creationId xmlns:p14="http://schemas.microsoft.com/office/powerpoint/2010/main" val="1661823864"/>
+        <p14:creationId xmlns:p14="http://schemas.microsoft.com/office/powerpoint/2010/main" val="1191948664"/>
       </p:ext>
     </p:extLst>
   </p:cSld>
@@ -5433,7 +5434,7 @@
           <p:cNvPr id="2" name="Section">
             <a:extLst>
               <a:ext uri="{FF2B5EF4-FFF2-40B4-BE49-F238E27FC236}">
-                <a16:creationId xmlns:a16="http://schemas.microsoft.com/office/drawing/2014/main" id="{EE376F5E-353A-064F-D7A0-4C1A6393FEB5}"/>
+                <a16:creationId xmlns:a16="http://schemas.microsoft.com/office/drawing/2014/main" id="{7B066443-65BA-C977-E041-0356704DF9A6}"/>
               </a:ext>
             </a:extLst>
           </p:cNvPr>
@@ -5478,7 +5479,7 @@
           <p:cNvPr id="3" name="Slide title">
             <a:extLst>
               <a:ext uri="{FF2B5EF4-FFF2-40B4-BE49-F238E27FC236}">
-                <a16:creationId xmlns:a16="http://schemas.microsoft.com/office/drawing/2014/main" id="{A9C53296-2459-BEF1-4845-A05E1D17DF5D}"/>
+                <a16:creationId xmlns:a16="http://schemas.microsoft.com/office/drawing/2014/main" id="{86C2C0B0-EB2D-C4A3-11A9-336E5D202A93}"/>
               </a:ext>
             </a:extLst>
           </p:cNvPr>
@@ -5523,7 +5524,7 @@
           <p:cNvPr id="4" name="Accent rule">
             <a:extLst>
               <a:ext uri="{FF2B5EF4-FFF2-40B4-BE49-F238E27FC236}">
-                <a16:creationId xmlns:a16="http://schemas.microsoft.com/office/drawing/2014/main" id="{AD66E733-6DBF-A06B-56A9-1EEBE09A914D}"/>
+                <a16:creationId xmlns:a16="http://schemas.microsoft.com/office/drawing/2014/main" id="{EE54E7E4-7CBE-1AB5-C191-F2DCFB26CA56}"/>
               </a:ext>
             </a:extLst>
           </p:cNvPr>
@@ -5564,7 +5565,7 @@
           <p:cNvPr id="5" name="Footer author">
             <a:extLst>
               <a:ext uri="{FF2B5EF4-FFF2-40B4-BE49-F238E27FC236}">
-                <a16:creationId xmlns:a16="http://schemas.microsoft.com/office/drawing/2014/main" id="{B01B4CD5-BAB1-6A8B-298A-5D7B9BFB0A1B}"/>
+                <a16:creationId xmlns:a16="http://schemas.microsoft.com/office/drawing/2014/main" id="{88F63AE6-1E31-C82F-7485-AD34990B6030}"/>
               </a:ext>
             </a:extLst>
           </p:cNvPr>
@@ -5609,7 +5610,7 @@
           <p:cNvPr id="6" name="Slide number">
             <a:extLst>
               <a:ext uri="{FF2B5EF4-FFF2-40B4-BE49-F238E27FC236}">
-                <a16:creationId xmlns:a16="http://schemas.microsoft.com/office/drawing/2014/main" id="{8364520D-46E4-533A-2379-25A0A475590A}"/>
+                <a16:creationId xmlns:a16="http://schemas.microsoft.com/office/drawing/2014/main" id="{55C5EB55-3193-E533-9C17-A28400DC7C18}"/>
               </a:ext>
             </a:extLst>
           </p:cNvPr>
@@ -5654,7 +5655,7 @@
           <p:cNvPr id="7" name="Chart subtitle">
             <a:extLst>
               <a:ext uri="{FF2B5EF4-FFF2-40B4-BE49-F238E27FC236}">
-                <a16:creationId xmlns:a16="http://schemas.microsoft.com/office/drawing/2014/main" id="{FDDFEFC7-B175-7AAC-1D72-183D4C981C19}"/>
+                <a16:creationId xmlns:a16="http://schemas.microsoft.com/office/drawing/2014/main" id="{7DBCB663-B45E-FE0A-2793-40366BFEEB59}"/>
               </a:ext>
             </a:extLst>
           </p:cNvPr>
@@ -5699,7 +5700,7 @@
           <p:cNvPr id="8" name="Chart axis">
             <a:extLst>
               <a:ext uri="{FF2B5EF4-FFF2-40B4-BE49-F238E27FC236}">
-                <a16:creationId xmlns:a16="http://schemas.microsoft.com/office/drawing/2014/main" id="{C06499AE-7C0D-8A71-B56F-FF1B35B92A24}"/>
+                <a16:creationId xmlns:a16="http://schemas.microsoft.com/office/drawing/2014/main" id="{049EA37F-50F4-2A4C-9745-07402E96A0FD}"/>
               </a:ext>
             </a:extLst>
           </p:cNvPr>
@@ -5740,7 +5741,7 @@
           <p:cNvPr id="9" name="Grid 0">
             <a:extLst>
               <a:ext uri="{FF2B5EF4-FFF2-40B4-BE49-F238E27FC236}">
-                <a16:creationId xmlns:a16="http://schemas.microsoft.com/office/drawing/2014/main" id="{EF681139-95A2-21A6-7E84-654A7362160B}"/>
+                <a16:creationId xmlns:a16="http://schemas.microsoft.com/office/drawing/2014/main" id="{3F5431E2-F52C-9556-27A8-C893BEA0F305}"/>
               </a:ext>
             </a:extLst>
           </p:cNvPr>
@@ -5781,7 +5782,7 @@
           <p:cNvPr id="10" name="Tick 0">
             <a:extLst>
               <a:ext uri="{FF2B5EF4-FFF2-40B4-BE49-F238E27FC236}">
-                <a16:creationId xmlns:a16="http://schemas.microsoft.com/office/drawing/2014/main" id="{E2C0B6F8-C052-BEA8-6DCD-79A43A1DC2F3}"/>
+                <a16:creationId xmlns:a16="http://schemas.microsoft.com/office/drawing/2014/main" id="{398E9EAF-93F2-E666-5FE9-6DE715B9A2D6}"/>
               </a:ext>
             </a:extLst>
           </p:cNvPr>
@@ -5826,7 +5827,7 @@
           <p:cNvPr id="11" name="Grid 25">
             <a:extLst>
               <a:ext uri="{FF2B5EF4-FFF2-40B4-BE49-F238E27FC236}">
-                <a16:creationId xmlns:a16="http://schemas.microsoft.com/office/drawing/2014/main" id="{ED63F521-0AB0-93B7-296D-0963F96F61A9}"/>
+                <a16:creationId xmlns:a16="http://schemas.microsoft.com/office/drawing/2014/main" id="{9994E793-A0A6-D06C-D926-A2BB550D351F}"/>
               </a:ext>
             </a:extLst>
           </p:cNvPr>
@@ -5867,7 +5868,7 @@
           <p:cNvPr id="12" name="Tick 25">
             <a:extLst>
               <a:ext uri="{FF2B5EF4-FFF2-40B4-BE49-F238E27FC236}">
-                <a16:creationId xmlns:a16="http://schemas.microsoft.com/office/drawing/2014/main" id="{8D3FBB4F-022B-2EB9-9F76-1F017E61A674}"/>
+                <a16:creationId xmlns:a16="http://schemas.microsoft.com/office/drawing/2014/main" id="{EA74CCC4-9565-2AEF-C1DC-4585F5C57F8E}"/>
               </a:ext>
             </a:extLst>
           </p:cNvPr>
@@ -5912,7 +5913,7 @@
           <p:cNvPr id="13" name="Grid 50">
             <a:extLst>
               <a:ext uri="{FF2B5EF4-FFF2-40B4-BE49-F238E27FC236}">
-                <a16:creationId xmlns:a16="http://schemas.microsoft.com/office/drawing/2014/main" id="{738EA267-5E30-174B-2501-F11DB9B1B31E}"/>
+                <a16:creationId xmlns:a16="http://schemas.microsoft.com/office/drawing/2014/main" id="{8D395468-E910-47EB-454A-01E4720F5817}"/>
               </a:ext>
             </a:extLst>
           </p:cNvPr>
@@ -5953,7 +5954,7 @@
           <p:cNvPr id="14" name="Tick 50">
             <a:extLst>
               <a:ext uri="{FF2B5EF4-FFF2-40B4-BE49-F238E27FC236}">
-                <a16:creationId xmlns:a16="http://schemas.microsoft.com/office/drawing/2014/main" id="{2A8958F4-E996-50FB-6329-255D7279DC28}"/>
+                <a16:creationId xmlns:a16="http://schemas.microsoft.com/office/drawing/2014/main" id="{D47B7408-B524-7AE9-75D8-FA7888A42F36}"/>
               </a:ext>
             </a:extLst>
           </p:cNvPr>
@@ -5998,7 +5999,7 @@
           <p:cNvPr id="15" name="Grid 75">
             <a:extLst>
               <a:ext uri="{FF2B5EF4-FFF2-40B4-BE49-F238E27FC236}">
-                <a16:creationId xmlns:a16="http://schemas.microsoft.com/office/drawing/2014/main" id="{C75269B7-A03D-3C27-4ED2-9C8C2A1A98F8}"/>
+                <a16:creationId xmlns:a16="http://schemas.microsoft.com/office/drawing/2014/main" id="{F7F12925-2128-D274-0A06-3C595B186A08}"/>
               </a:ext>
             </a:extLst>
           </p:cNvPr>
@@ -6039,7 +6040,7 @@
           <p:cNvPr id="16" name="Tick 75">
             <a:extLst>
               <a:ext uri="{FF2B5EF4-FFF2-40B4-BE49-F238E27FC236}">
-                <a16:creationId xmlns:a16="http://schemas.microsoft.com/office/drawing/2014/main" id="{B1CA6AFA-DBBF-60FA-2B5F-AAB409113979}"/>
+                <a16:creationId xmlns:a16="http://schemas.microsoft.com/office/drawing/2014/main" id="{71407645-4CA2-C5E2-6C95-0CF2D1422CD2}"/>
               </a:ext>
             </a:extLst>
           </p:cNvPr>
@@ -6084,7 +6085,7 @@
           <p:cNvPr id="17" name="Grid 100">
             <a:extLst>
               <a:ext uri="{FF2B5EF4-FFF2-40B4-BE49-F238E27FC236}">
-                <a16:creationId xmlns:a16="http://schemas.microsoft.com/office/drawing/2014/main" id="{BEBA3DA5-944A-2860-8042-5D9E6C9300B5}"/>
+                <a16:creationId xmlns:a16="http://schemas.microsoft.com/office/drawing/2014/main" id="{8540CE09-32F8-BCDB-4219-C4B55BC0C1B4}"/>
               </a:ext>
             </a:extLst>
           </p:cNvPr>
@@ -6125,7 +6126,7 @@
           <p:cNvPr id="18" name="Tick 100">
             <a:extLst>
               <a:ext uri="{FF2B5EF4-FFF2-40B4-BE49-F238E27FC236}">
-                <a16:creationId xmlns:a16="http://schemas.microsoft.com/office/drawing/2014/main" id="{D51C134F-C4EC-63F1-EE85-E19554FFD867}"/>
+                <a16:creationId xmlns:a16="http://schemas.microsoft.com/office/drawing/2014/main" id="{82D34BA5-A0E0-E0D1-454E-4582EBD65165}"/>
               </a:ext>
             </a:extLst>
           </p:cNvPr>
@@ -6170,7 +6171,7 @@
           <p:cNvPr id="19" name="Legend swatch">
             <a:extLst>
               <a:ext uri="{FF2B5EF4-FFF2-40B4-BE49-F238E27FC236}">
-                <a16:creationId xmlns:a16="http://schemas.microsoft.com/office/drawing/2014/main" id="{C6021D54-C305-D323-7A9E-BE3234CB33D0}"/>
+                <a16:creationId xmlns:a16="http://schemas.microsoft.com/office/drawing/2014/main" id="{F1397946-8F2B-FF51-5388-70471B190A4F}"/>
               </a:ext>
             </a:extLst>
           </p:cNvPr>
@@ -6238,7 +6239,7 @@
           <p:cNvPr id="20" name="Legend">
             <a:extLst>
               <a:ext uri="{FF2B5EF4-FFF2-40B4-BE49-F238E27FC236}">
-                <a16:creationId xmlns:a16="http://schemas.microsoft.com/office/drawing/2014/main" id="{30910D13-964E-B4AE-BDC6-EBEE1CB280F8}"/>
+                <a16:creationId xmlns:a16="http://schemas.microsoft.com/office/drawing/2014/main" id="{FC9376B8-C350-365C-D0FC-841C81A3436D}"/>
               </a:ext>
             </a:extLst>
           </p:cNvPr>
@@ -6283,7 +6284,7 @@
           <p:cNvPr id="21" name="Legend swatch">
             <a:extLst>
               <a:ext uri="{FF2B5EF4-FFF2-40B4-BE49-F238E27FC236}">
-                <a16:creationId xmlns:a16="http://schemas.microsoft.com/office/drawing/2014/main" id="{2E70AD8A-E074-80BD-D3E9-E413F4DCFC98}"/>
+                <a16:creationId xmlns:a16="http://schemas.microsoft.com/office/drawing/2014/main" id="{4E3DB846-3A8D-9518-9C8E-CC5A21A16B88}"/>
               </a:ext>
             </a:extLst>
           </p:cNvPr>
@@ -6351,7 +6352,7 @@
           <p:cNvPr id="22" name="Legend">
             <a:extLst>
               <a:ext uri="{FF2B5EF4-FFF2-40B4-BE49-F238E27FC236}">
-                <a16:creationId xmlns:a16="http://schemas.microsoft.com/office/drawing/2014/main" id="{6935E157-6C53-4004-BE33-21495377E09F}"/>
+                <a16:creationId xmlns:a16="http://schemas.microsoft.com/office/drawing/2014/main" id="{9A966DE6-2ED5-35FD-3D79-A9668707F5A0}"/>
               </a:ext>
             </a:extLst>
           </p:cNvPr>
@@ -6396,7 +6397,7 @@
           <p:cNvPr id="23" name="Legend swatch">
             <a:extLst>
               <a:ext uri="{FF2B5EF4-FFF2-40B4-BE49-F238E27FC236}">
-                <a16:creationId xmlns:a16="http://schemas.microsoft.com/office/drawing/2014/main" id="{2DFF62AE-9959-42D6-43F2-6AED0E5C43E6}"/>
+                <a16:creationId xmlns:a16="http://schemas.microsoft.com/office/drawing/2014/main" id="{60B31D6B-760E-8A9E-E52F-12B6CF98FAF0}"/>
               </a:ext>
             </a:extLst>
           </p:cNvPr>
@@ -6464,7 +6465,7 @@
           <p:cNvPr id="24" name="Legend">
             <a:extLst>
               <a:ext uri="{FF2B5EF4-FFF2-40B4-BE49-F238E27FC236}">
-                <a16:creationId xmlns:a16="http://schemas.microsoft.com/office/drawing/2014/main" id="{300AF63C-D4C6-0844-1FC4-3D63E078439D}"/>
+                <a16:creationId xmlns:a16="http://schemas.microsoft.com/office/drawing/2014/main" id="{A5814203-3DC8-E4ED-BCDC-72F806D8F52D}"/>
               </a:ext>
             </a:extLst>
           </p:cNvPr>
@@ -6509,7 +6510,7 @@
           <p:cNvPr id="25" name="Mode label">
             <a:extLst>
               <a:ext uri="{FF2B5EF4-FFF2-40B4-BE49-F238E27FC236}">
-                <a16:creationId xmlns:a16="http://schemas.microsoft.com/office/drawing/2014/main" id="{A4613102-C816-FEE9-AA54-3DE57F8617BD}"/>
+                <a16:creationId xmlns:a16="http://schemas.microsoft.com/office/drawing/2014/main" id="{B01DDFA8-4FFC-8886-B8CA-99616E936747}"/>
               </a:ext>
             </a:extLst>
           </p:cNvPr>
@@ -6554,7 +6555,7 @@
           <p:cNvPr id="26" name="Result bar">
             <a:extLst>
               <a:ext uri="{FF2B5EF4-FFF2-40B4-BE49-F238E27FC236}">
-                <a16:creationId xmlns:a16="http://schemas.microsoft.com/office/drawing/2014/main" id="{DC463817-0F18-91F5-99B0-7CBD48B402DE}"/>
+                <a16:creationId xmlns:a16="http://schemas.microsoft.com/office/drawing/2014/main" id="{A8FF5A0E-D860-DDCC-836E-40BF2AE3CAAA}"/>
               </a:ext>
             </a:extLst>
           </p:cNvPr>
@@ -6622,7 +6623,7 @@
           <p:cNvPr id="27" name="Result value">
             <a:extLst>
               <a:ext uri="{FF2B5EF4-FFF2-40B4-BE49-F238E27FC236}">
-                <a16:creationId xmlns:a16="http://schemas.microsoft.com/office/drawing/2014/main" id="{CE48E145-D997-61F0-3CD2-7BFA8DE07240}"/>
+                <a16:creationId xmlns:a16="http://schemas.microsoft.com/office/drawing/2014/main" id="{816D8A4F-B5E5-66AD-93F4-6C469D2ACB63}"/>
               </a:ext>
             </a:extLst>
           </p:cNvPr>
@@ -6667,7 +6668,7 @@
           <p:cNvPr id="28" name="Result bar">
             <a:extLst>
               <a:ext uri="{FF2B5EF4-FFF2-40B4-BE49-F238E27FC236}">
-                <a16:creationId xmlns:a16="http://schemas.microsoft.com/office/drawing/2014/main" id="{9904FC43-35AA-BC52-CBA4-EA7340B33DD5}"/>
+                <a16:creationId xmlns:a16="http://schemas.microsoft.com/office/drawing/2014/main" id="{8FE538C1-4B22-0ECB-7433-C9349D1B6B4F}"/>
               </a:ext>
             </a:extLst>
           </p:cNvPr>
@@ -6735,7 +6736,7 @@
           <p:cNvPr id="29" name="Result value">
             <a:extLst>
               <a:ext uri="{FF2B5EF4-FFF2-40B4-BE49-F238E27FC236}">
-                <a16:creationId xmlns:a16="http://schemas.microsoft.com/office/drawing/2014/main" id="{681D3C43-A493-2B4D-750B-7062A45B1F40}"/>
+                <a16:creationId xmlns:a16="http://schemas.microsoft.com/office/drawing/2014/main" id="{BE72A289-A5D1-D47B-A2FF-BBC61401A7E9}"/>
               </a:ext>
             </a:extLst>
           </p:cNvPr>
@@ -6780,7 +6781,7 @@
           <p:cNvPr id="30" name="Result bar">
             <a:extLst>
               <a:ext uri="{FF2B5EF4-FFF2-40B4-BE49-F238E27FC236}">
-                <a16:creationId xmlns:a16="http://schemas.microsoft.com/office/drawing/2014/main" id="{143C84ED-770B-EA82-7AF2-441DC60A53B9}"/>
+                <a16:creationId xmlns:a16="http://schemas.microsoft.com/office/drawing/2014/main" id="{676F0F67-DEEE-B6A2-61EE-3B6E716949AC}"/>
               </a:ext>
             </a:extLst>
           </p:cNvPr>
@@ -6848,7 +6849,7 @@
           <p:cNvPr id="31" name="Result value">
             <a:extLst>
               <a:ext uri="{FF2B5EF4-FFF2-40B4-BE49-F238E27FC236}">
-                <a16:creationId xmlns:a16="http://schemas.microsoft.com/office/drawing/2014/main" id="{7F560EBF-7051-7A95-0BC5-4CD36DD15E31}"/>
+                <a16:creationId xmlns:a16="http://schemas.microsoft.com/office/drawing/2014/main" id="{708B4C25-50FF-1C77-F78A-9DE426DAF891}"/>
               </a:ext>
             </a:extLst>
           </p:cNvPr>
@@ -6893,7 +6894,7 @@
           <p:cNvPr id="32" name="Mode label">
             <a:extLst>
               <a:ext uri="{FF2B5EF4-FFF2-40B4-BE49-F238E27FC236}">
-                <a16:creationId xmlns:a16="http://schemas.microsoft.com/office/drawing/2014/main" id="{743665F6-A94E-F646-D050-3EF295EA4A3C}"/>
+                <a16:creationId xmlns:a16="http://schemas.microsoft.com/office/drawing/2014/main" id="{8AC64CE8-4887-992C-C400-EA9F0532472E}"/>
               </a:ext>
             </a:extLst>
           </p:cNvPr>
@@ -6938,7 +6939,7 @@
           <p:cNvPr id="33" name="Result bar">
             <a:extLst>
               <a:ext uri="{FF2B5EF4-FFF2-40B4-BE49-F238E27FC236}">
-                <a16:creationId xmlns:a16="http://schemas.microsoft.com/office/drawing/2014/main" id="{AF2A51ED-8815-664A-72C2-AA8FECA5A7B1}"/>
+                <a16:creationId xmlns:a16="http://schemas.microsoft.com/office/drawing/2014/main" id="{0AC0EE4F-3227-C57B-5470-6B8FB1CEEBB5}"/>
               </a:ext>
             </a:extLst>
           </p:cNvPr>
@@ -7006,7 +7007,7 @@
           <p:cNvPr id="34" name="Result value">
             <a:extLst>
               <a:ext uri="{FF2B5EF4-FFF2-40B4-BE49-F238E27FC236}">
-                <a16:creationId xmlns:a16="http://schemas.microsoft.com/office/drawing/2014/main" id="{5C01A688-93F7-9832-B822-7C3C5CCEFD06}"/>
+                <a16:creationId xmlns:a16="http://schemas.microsoft.com/office/drawing/2014/main" id="{426C174D-B4E0-C7B0-3489-367EA9747B07}"/>
               </a:ext>
             </a:extLst>
           </p:cNvPr>
@@ -7051,7 +7052,7 @@
           <p:cNvPr id="35" name="Result bar">
             <a:extLst>
               <a:ext uri="{FF2B5EF4-FFF2-40B4-BE49-F238E27FC236}">
-                <a16:creationId xmlns:a16="http://schemas.microsoft.com/office/drawing/2014/main" id="{C875BB6E-7E0B-CB60-51B7-B6C1D4F1A889}"/>
+                <a16:creationId xmlns:a16="http://schemas.microsoft.com/office/drawing/2014/main" id="{96E9F153-AAEA-8947-D07C-FE87E9B75487}"/>
               </a:ext>
             </a:extLst>
           </p:cNvPr>
@@ -7119,7 +7120,7 @@
           <p:cNvPr id="36" name="Result value">
             <a:extLst>
               <a:ext uri="{FF2B5EF4-FFF2-40B4-BE49-F238E27FC236}">
-                <a16:creationId xmlns:a16="http://schemas.microsoft.com/office/drawing/2014/main" id="{6AA4E248-F565-E26F-DE4B-32DC72310CF8}"/>
+                <a16:creationId xmlns:a16="http://schemas.microsoft.com/office/drawing/2014/main" id="{69BDCD0F-E71A-C000-613D-0F4CFD897F3D}"/>
               </a:ext>
             </a:extLst>
           </p:cNvPr>
@@ -7164,7 +7165,7 @@
           <p:cNvPr id="37" name="Result bar">
             <a:extLst>
               <a:ext uri="{FF2B5EF4-FFF2-40B4-BE49-F238E27FC236}">
-                <a16:creationId xmlns:a16="http://schemas.microsoft.com/office/drawing/2014/main" id="{3805D66A-092E-F386-C426-D2FB4771AE19}"/>
+                <a16:creationId xmlns:a16="http://schemas.microsoft.com/office/drawing/2014/main" id="{0D9C6E96-37FB-A005-288D-0CED6302D2ED}"/>
               </a:ext>
             </a:extLst>
           </p:cNvPr>
@@ -7232,7 +7233,7 @@
           <p:cNvPr id="38" name="Result value">
             <a:extLst>
               <a:ext uri="{FF2B5EF4-FFF2-40B4-BE49-F238E27FC236}">
-                <a16:creationId xmlns:a16="http://schemas.microsoft.com/office/drawing/2014/main" id="{1E9C4963-A023-29CD-E6FE-96D9312B430F}"/>
+                <a16:creationId xmlns:a16="http://schemas.microsoft.com/office/drawing/2014/main" id="{0F42A97B-87C8-9399-BD2F-7FCE7084B7C0}"/>
               </a:ext>
             </a:extLst>
           </p:cNvPr>
@@ -7277,7 +7278,7 @@
           <p:cNvPr id="39" name="Mode label">
             <a:extLst>
               <a:ext uri="{FF2B5EF4-FFF2-40B4-BE49-F238E27FC236}">
-                <a16:creationId xmlns:a16="http://schemas.microsoft.com/office/drawing/2014/main" id="{009C5C8A-4EDA-AF7E-73AD-D73EFE9C05FC}"/>
+                <a16:creationId xmlns:a16="http://schemas.microsoft.com/office/drawing/2014/main" id="{5E9910C1-C1AB-A142-0620-6069E3399AC6}"/>
               </a:ext>
             </a:extLst>
           </p:cNvPr>
@@ -7322,7 +7323,7 @@
           <p:cNvPr id="40" name="Result bar">
             <a:extLst>
               <a:ext uri="{FF2B5EF4-FFF2-40B4-BE49-F238E27FC236}">
-                <a16:creationId xmlns:a16="http://schemas.microsoft.com/office/drawing/2014/main" id="{6BD6D8C7-9C3A-6906-5C3E-025A937A7FA9}"/>
+                <a16:creationId xmlns:a16="http://schemas.microsoft.com/office/drawing/2014/main" id="{75547680-B47C-BBCB-D6B3-335C9C507031}"/>
               </a:ext>
             </a:extLst>
           </p:cNvPr>
@@ -7390,7 +7391,7 @@
           <p:cNvPr id="41" name="Result value">
             <a:extLst>
               <a:ext uri="{FF2B5EF4-FFF2-40B4-BE49-F238E27FC236}">
-                <a16:creationId xmlns:a16="http://schemas.microsoft.com/office/drawing/2014/main" id="{53E5255C-41FA-DEB7-3888-6F5DBA58139D}"/>
+                <a16:creationId xmlns:a16="http://schemas.microsoft.com/office/drawing/2014/main" id="{6A310FFC-5A15-5A4D-17A0-E4C96493AB51}"/>
               </a:ext>
             </a:extLst>
           </p:cNvPr>
@@ -7435,7 +7436,7 @@
           <p:cNvPr id="42" name="Result bar">
             <a:extLst>
               <a:ext uri="{FF2B5EF4-FFF2-40B4-BE49-F238E27FC236}">
-                <a16:creationId xmlns:a16="http://schemas.microsoft.com/office/drawing/2014/main" id="{D07FFDEE-8460-B747-C34F-BA5229858962}"/>
+                <a16:creationId xmlns:a16="http://schemas.microsoft.com/office/drawing/2014/main" id="{D5EF07D4-8AA8-AFE4-B48C-FD34803FFDD9}"/>
               </a:ext>
             </a:extLst>
           </p:cNvPr>
@@ -7503,7 +7504,7 @@
           <p:cNvPr id="43" name="Result value">
             <a:extLst>
               <a:ext uri="{FF2B5EF4-FFF2-40B4-BE49-F238E27FC236}">
-                <a16:creationId xmlns:a16="http://schemas.microsoft.com/office/drawing/2014/main" id="{DBAEDB75-3516-E280-72D6-164C6284C46D}"/>
+                <a16:creationId xmlns:a16="http://schemas.microsoft.com/office/drawing/2014/main" id="{41B2CF9F-D9FA-7293-F2E6-EACEB3A39F80}"/>
               </a:ext>
             </a:extLst>
           </p:cNvPr>
@@ -7548,7 +7549,7 @@
           <p:cNvPr id="44" name="Result bar">
             <a:extLst>
               <a:ext uri="{FF2B5EF4-FFF2-40B4-BE49-F238E27FC236}">
-                <a16:creationId xmlns:a16="http://schemas.microsoft.com/office/drawing/2014/main" id="{8FED2FE3-6A56-BC2D-B8DA-8C7884F85E6C}"/>
+                <a16:creationId xmlns:a16="http://schemas.microsoft.com/office/drawing/2014/main" id="{29BD125B-179C-A94F-085E-0E6893EC15AD}"/>
               </a:ext>
             </a:extLst>
           </p:cNvPr>
@@ -7616,7 +7617,7 @@
           <p:cNvPr id="45" name="Result value">
             <a:extLst>
               <a:ext uri="{FF2B5EF4-FFF2-40B4-BE49-F238E27FC236}">
-                <a16:creationId xmlns:a16="http://schemas.microsoft.com/office/drawing/2014/main" id="{7C963345-A362-F1BA-F78F-D2CA5DAE9073}"/>
+                <a16:creationId xmlns:a16="http://schemas.microsoft.com/office/drawing/2014/main" id="{2CE524BA-8E4A-8CC6-4292-B3FD053E5A62}"/>
               </a:ext>
             </a:extLst>
           </p:cNvPr>
@@ -7661,7 +7662,7 @@
           <p:cNvPr id="46" name="Result callout">
             <a:extLst>
               <a:ext uri="{FF2B5EF4-FFF2-40B4-BE49-F238E27FC236}">
-                <a16:creationId xmlns:a16="http://schemas.microsoft.com/office/drawing/2014/main" id="{FCBF444D-1810-48DD-2B55-5C56A136FCC4}"/>
+                <a16:creationId xmlns:a16="http://schemas.microsoft.com/office/drawing/2014/main" id="{EEB8F734-8260-1900-53A7-277DDE85A3CC}"/>
               </a:ext>
             </a:extLst>
           </p:cNvPr>
@@ -7729,7 +7730,7 @@
           <p:cNvPr id="47" name="Recall result">
             <a:extLst>
               <a:ext uri="{FF2B5EF4-FFF2-40B4-BE49-F238E27FC236}">
-                <a16:creationId xmlns:a16="http://schemas.microsoft.com/office/drawing/2014/main" id="{2968425A-E014-7B25-65F7-4D6F8D5DD570}"/>
+                <a16:creationId xmlns:a16="http://schemas.microsoft.com/office/drawing/2014/main" id="{CFD6BFBA-BF60-5CE7-9A3F-CA239B4270DF}"/>
               </a:ext>
             </a:extLst>
           </p:cNvPr>
@@ -7774,7 +7775,7 @@
           <p:cNvPr id="48" name="Recall detail">
             <a:extLst>
               <a:ext uri="{FF2B5EF4-FFF2-40B4-BE49-F238E27FC236}">
-                <a16:creationId xmlns:a16="http://schemas.microsoft.com/office/drawing/2014/main" id="{4C2CBBCC-1942-B277-1F8E-B925DEC4A57F}"/>
+                <a16:creationId xmlns:a16="http://schemas.microsoft.com/office/drawing/2014/main" id="{13A34FE3-099F-4F13-306E-0D525E02CF6D}"/>
               </a:ext>
             </a:extLst>
           </p:cNvPr>
@@ -7820,7 +7821,7 @@
           <p:cNvPr id="49" name="External title">
             <a:extLst>
               <a:ext uri="{FF2B5EF4-FFF2-40B4-BE49-F238E27FC236}">
-                <a16:creationId xmlns:a16="http://schemas.microsoft.com/office/drawing/2014/main" id="{80D66476-B786-5D1F-1136-AC3FDD623A94}"/>
+                <a16:creationId xmlns:a16="http://schemas.microsoft.com/office/drawing/2014/main" id="{00128DE3-65A6-C5A9-240B-A902B0068040}"/>
               </a:ext>
             </a:extLst>
           </p:cNvPr>
@@ -7865,7 +7866,7 @@
           <p:cNvPr id="50" name="External metrics">
             <a:extLst>
               <a:ext uri="{FF2B5EF4-FFF2-40B4-BE49-F238E27FC236}">
-                <a16:creationId xmlns:a16="http://schemas.microsoft.com/office/drawing/2014/main" id="{4EF58254-DB38-4258-5191-B97ECB980015}"/>
+                <a16:creationId xmlns:a16="http://schemas.microsoft.com/office/drawing/2014/main" id="{629CB0B9-6618-BB16-C075-5BD6F3963AAD}"/>
               </a:ext>
             </a:extLst>
           </p:cNvPr>
@@ -7911,7 +7912,7 @@
           <p:cNvPr id="51" name="External caveat">
             <a:extLst>
               <a:ext uri="{FF2B5EF4-FFF2-40B4-BE49-F238E27FC236}">
-                <a16:creationId xmlns:a16="http://schemas.microsoft.com/office/drawing/2014/main" id="{55241724-A8CE-B566-D0F9-B2D1C3179FD3}"/>
+                <a16:creationId xmlns:a16="http://schemas.microsoft.com/office/drawing/2014/main" id="{10678426-0D39-FF4A-3304-364FE32C6AF0}"/>
               </a:ext>
             </a:extLst>
           </p:cNvPr>
@@ -7954,7 +7955,7 @@
     </p:spTree>
     <p:extLst>
       <p:ext uri="{BB962C8B-B14F-4D97-AF65-F5344CB8AC3E}">
-        <p14:creationId xmlns:p14="http://schemas.microsoft.com/office/powerpoint/2010/main" val="514244782"/>
+        <p14:creationId xmlns:p14="http://schemas.microsoft.com/office/powerpoint/2010/main" val="2010292690"/>
       </p:ext>
     </p:extLst>
   </p:cSld>
@@ -7994,7 +7995,7 @@
           <p:cNvPr id="2" name="Section">
             <a:extLst>
               <a:ext uri="{FF2B5EF4-FFF2-40B4-BE49-F238E27FC236}">
-                <a16:creationId xmlns:a16="http://schemas.microsoft.com/office/drawing/2014/main" id="{8E9CB117-B07A-7B97-46E1-2438D186B807}"/>
+                <a16:creationId xmlns:a16="http://schemas.microsoft.com/office/drawing/2014/main" id="{2306D38C-DED3-9ADD-85F1-4C25ADE095BC}"/>
               </a:ext>
             </a:extLst>
           </p:cNvPr>
@@ -8039,7 +8040,7 @@
           <p:cNvPr id="3" name="Slide title">
             <a:extLst>
               <a:ext uri="{FF2B5EF4-FFF2-40B4-BE49-F238E27FC236}">
-                <a16:creationId xmlns:a16="http://schemas.microsoft.com/office/drawing/2014/main" id="{D073D0CD-8892-4E68-F6AB-D279EEA41F3A}"/>
+                <a16:creationId xmlns:a16="http://schemas.microsoft.com/office/drawing/2014/main" id="{5DFCA45A-9281-3817-4172-08B35651E5AA}"/>
               </a:ext>
             </a:extLst>
           </p:cNvPr>
@@ -8084,7 +8085,7 @@
           <p:cNvPr id="4" name="Accent rule">
             <a:extLst>
               <a:ext uri="{FF2B5EF4-FFF2-40B4-BE49-F238E27FC236}">
-                <a16:creationId xmlns:a16="http://schemas.microsoft.com/office/drawing/2014/main" id="{481F8A53-D6F1-AE0C-3B7E-B733A91888AA}"/>
+                <a16:creationId xmlns:a16="http://schemas.microsoft.com/office/drawing/2014/main" id="{4C038949-B48E-DD49-F523-86F5E34A1B6F}"/>
               </a:ext>
             </a:extLst>
           </p:cNvPr>
@@ -8125,7 +8126,7 @@
           <p:cNvPr id="5" name="Footer author">
             <a:extLst>
               <a:ext uri="{FF2B5EF4-FFF2-40B4-BE49-F238E27FC236}">
-                <a16:creationId xmlns:a16="http://schemas.microsoft.com/office/drawing/2014/main" id="{EC8B2518-A03D-7A72-3990-EC68D8541050}"/>
+                <a16:creationId xmlns:a16="http://schemas.microsoft.com/office/drawing/2014/main" id="{1089E00C-5F33-81B5-47CF-D8FF872E95FA}"/>
               </a:ext>
             </a:extLst>
           </p:cNvPr>
@@ -8170,7 +8171,7 @@
           <p:cNvPr id="6" name="Slide number">
             <a:extLst>
               <a:ext uri="{FF2B5EF4-FFF2-40B4-BE49-F238E27FC236}">
-                <a16:creationId xmlns:a16="http://schemas.microsoft.com/office/drawing/2014/main" id="{0B55A418-8601-9065-F899-4B598B0DD746}"/>
+                <a16:creationId xmlns:a16="http://schemas.microsoft.com/office/drawing/2014/main" id="{7C205370-FA64-00DB-F97D-F13B243BB5BC}"/>
               </a:ext>
             </a:extLst>
           </p:cNvPr>
@@ -8215,7 +8216,7 @@
           <p:cNvPr id="7" name="Metric vertical">
             <a:extLst>
               <a:ext uri="{FF2B5EF4-FFF2-40B4-BE49-F238E27FC236}">
-                <a16:creationId xmlns:a16="http://schemas.microsoft.com/office/drawing/2014/main" id="{0C6250CB-E51A-9FCF-6CD1-288B127564DE}"/>
+                <a16:creationId xmlns:a16="http://schemas.microsoft.com/office/drawing/2014/main" id="{F643A131-58D2-1ECD-5CAB-D51AFDE9341F}"/>
               </a:ext>
             </a:extLst>
           </p:cNvPr>
@@ -8256,7 +8257,7 @@
           <p:cNvPr id="8" name="Metric horizontal">
             <a:extLst>
               <a:ext uri="{FF2B5EF4-FFF2-40B4-BE49-F238E27FC236}">
-                <a16:creationId xmlns:a16="http://schemas.microsoft.com/office/drawing/2014/main" id="{CEB6976B-025D-F025-ABF2-28B1413C0215}"/>
+                <a16:creationId xmlns:a16="http://schemas.microsoft.com/office/drawing/2014/main" id="{D20394A4-BBD1-DCD4-2DCB-47B65CFBC500}"/>
               </a:ext>
             </a:extLst>
           </p:cNvPr>
@@ -8297,7 +8298,7 @@
           <p:cNvPr id="9" name="Metric value">
             <a:extLst>
               <a:ext uri="{FF2B5EF4-FFF2-40B4-BE49-F238E27FC236}">
-                <a16:creationId xmlns:a16="http://schemas.microsoft.com/office/drawing/2014/main" id="{7236F043-36AF-CDAD-E590-98046F9CDC94}"/>
+                <a16:creationId xmlns:a16="http://schemas.microsoft.com/office/drawing/2014/main" id="{92CD4023-4F0B-2657-7FD8-F101271D04EC}"/>
               </a:ext>
             </a:extLst>
           </p:cNvPr>
@@ -8342,7 +8343,7 @@
           <p:cNvPr id="10" name="Metric title">
             <a:extLst>
               <a:ext uri="{FF2B5EF4-FFF2-40B4-BE49-F238E27FC236}">
-                <a16:creationId xmlns:a16="http://schemas.microsoft.com/office/drawing/2014/main" id="{14A7AE11-FA66-D4C7-B574-1194D4A068A0}"/>
+                <a16:creationId xmlns:a16="http://schemas.microsoft.com/office/drawing/2014/main" id="{C4EAC619-A6CD-217B-D650-EB3C82BEFE93}"/>
               </a:ext>
             </a:extLst>
           </p:cNvPr>
@@ -8387,7 +8388,7 @@
           <p:cNvPr id="11" name="Metric detail">
             <a:extLst>
               <a:ext uri="{FF2B5EF4-FFF2-40B4-BE49-F238E27FC236}">
-                <a16:creationId xmlns:a16="http://schemas.microsoft.com/office/drawing/2014/main" id="{A43B4BFB-3689-9F24-7EFC-CC1960150E45}"/>
+                <a16:creationId xmlns:a16="http://schemas.microsoft.com/office/drawing/2014/main" id="{C17FDEBC-570A-0B80-EA53-F42E9818FAF9}"/>
               </a:ext>
             </a:extLst>
           </p:cNvPr>
@@ -8432,7 +8433,7 @@
           <p:cNvPr id="12" name="Metric value">
             <a:extLst>
               <a:ext uri="{FF2B5EF4-FFF2-40B4-BE49-F238E27FC236}">
-                <a16:creationId xmlns:a16="http://schemas.microsoft.com/office/drawing/2014/main" id="{CC081995-90A7-EC2E-B51E-A2267EDB0064}"/>
+                <a16:creationId xmlns:a16="http://schemas.microsoft.com/office/drawing/2014/main" id="{156E980B-F2EC-AED0-C31D-2C22907001E5}"/>
               </a:ext>
             </a:extLst>
           </p:cNvPr>
@@ -8477,7 +8478,7 @@
           <p:cNvPr id="13" name="Metric title">
             <a:extLst>
               <a:ext uri="{FF2B5EF4-FFF2-40B4-BE49-F238E27FC236}">
-                <a16:creationId xmlns:a16="http://schemas.microsoft.com/office/drawing/2014/main" id="{A35FC88E-BFD4-D8A4-8C96-91723825E595}"/>
+                <a16:creationId xmlns:a16="http://schemas.microsoft.com/office/drawing/2014/main" id="{B8E83EB2-EC35-ACA7-E722-B0CEDEFD127F}"/>
               </a:ext>
             </a:extLst>
           </p:cNvPr>
@@ -8522,7 +8523,7 @@
           <p:cNvPr id="14" name="Metric detail">
             <a:extLst>
               <a:ext uri="{FF2B5EF4-FFF2-40B4-BE49-F238E27FC236}">
-                <a16:creationId xmlns:a16="http://schemas.microsoft.com/office/drawing/2014/main" id="{96E1EF54-2BF8-BF9B-AD6A-4D9DF2FDF7F7}"/>
+                <a16:creationId xmlns:a16="http://schemas.microsoft.com/office/drawing/2014/main" id="{A7171175-63C1-7627-FCC0-6F7532A18572}"/>
               </a:ext>
             </a:extLst>
           </p:cNvPr>
@@ -8567,7 +8568,7 @@
           <p:cNvPr id="15" name="Metric value">
             <a:extLst>
               <a:ext uri="{FF2B5EF4-FFF2-40B4-BE49-F238E27FC236}">
-                <a16:creationId xmlns:a16="http://schemas.microsoft.com/office/drawing/2014/main" id="{BC9E6E07-B47D-82C0-085D-E8E6BD0AA168}"/>
+                <a16:creationId xmlns:a16="http://schemas.microsoft.com/office/drawing/2014/main" id="{E41EFF04-1D19-A520-6602-BD53CA7EC647}"/>
               </a:ext>
             </a:extLst>
           </p:cNvPr>
@@ -8612,7 +8613,7 @@
           <p:cNvPr id="16" name="Metric title">
             <a:extLst>
               <a:ext uri="{FF2B5EF4-FFF2-40B4-BE49-F238E27FC236}">
-                <a16:creationId xmlns:a16="http://schemas.microsoft.com/office/drawing/2014/main" id="{7778BB70-A072-5737-92A6-630AA73F531D}"/>
+                <a16:creationId xmlns:a16="http://schemas.microsoft.com/office/drawing/2014/main" id="{A3699D75-92CC-6FED-8D4C-A8A6B53AE283}"/>
               </a:ext>
             </a:extLst>
           </p:cNvPr>
@@ -8657,7 +8658,7 @@
           <p:cNvPr id="17" name="Metric detail">
             <a:extLst>
               <a:ext uri="{FF2B5EF4-FFF2-40B4-BE49-F238E27FC236}">
-                <a16:creationId xmlns:a16="http://schemas.microsoft.com/office/drawing/2014/main" id="{A038470C-2F3A-777F-93A4-585F3364CEBE}"/>
+                <a16:creationId xmlns:a16="http://schemas.microsoft.com/office/drawing/2014/main" id="{284445D9-6675-F597-D220-EAD149F1D3B1}"/>
               </a:ext>
             </a:extLst>
           </p:cNvPr>
@@ -8702,7 +8703,7 @@
           <p:cNvPr id="18" name="Metric value">
             <a:extLst>
               <a:ext uri="{FF2B5EF4-FFF2-40B4-BE49-F238E27FC236}">
-                <a16:creationId xmlns:a16="http://schemas.microsoft.com/office/drawing/2014/main" id="{7FF8B0A3-81DD-E78B-B3F5-0697D04BA1A1}"/>
+                <a16:creationId xmlns:a16="http://schemas.microsoft.com/office/drawing/2014/main" id="{68D32CB2-513B-F68F-A01E-C4C72BC5A120}"/>
               </a:ext>
             </a:extLst>
           </p:cNvPr>
@@ -8747,7 +8748,7 @@
           <p:cNvPr id="19" name="Metric title">
             <a:extLst>
               <a:ext uri="{FF2B5EF4-FFF2-40B4-BE49-F238E27FC236}">
-                <a16:creationId xmlns:a16="http://schemas.microsoft.com/office/drawing/2014/main" id="{A59905D9-FFCF-27AA-408B-D6A19DE13A4A}"/>
+                <a16:creationId xmlns:a16="http://schemas.microsoft.com/office/drawing/2014/main" id="{70B2F4D8-D5B9-2A3A-8224-57D3B2FAEDB6}"/>
               </a:ext>
             </a:extLst>
           </p:cNvPr>
@@ -8792,7 +8793,7 @@
           <p:cNvPr id="20" name="Metric detail">
             <a:extLst>
               <a:ext uri="{FF2B5EF4-FFF2-40B4-BE49-F238E27FC236}">
-                <a16:creationId xmlns:a16="http://schemas.microsoft.com/office/drawing/2014/main" id="{88E8185E-320F-7CE1-C8AA-9A10BA5DB3DB}"/>
+                <a16:creationId xmlns:a16="http://schemas.microsoft.com/office/drawing/2014/main" id="{41A304F1-E75C-3D17-69C5-6809B2B583EA}"/>
               </a:ext>
             </a:extLst>
           </p:cNvPr>
@@ -8835,7 +8836,7 @@
     </p:spTree>
     <p:extLst>
       <p:ext uri="{BB962C8B-B14F-4D97-AF65-F5344CB8AC3E}">
-        <p14:creationId xmlns:p14="http://schemas.microsoft.com/office/powerpoint/2010/main" val="2925145762"/>
+        <p14:creationId xmlns:p14="http://schemas.microsoft.com/office/powerpoint/2010/main" val="4169834264"/>
       </p:ext>
     </p:extLst>
   </p:cSld>
@@ -8875,7 +8876,7 @@
           <p:cNvPr id="2" name="Section">
             <a:extLst>
               <a:ext uri="{FF2B5EF4-FFF2-40B4-BE49-F238E27FC236}">
-                <a16:creationId xmlns:a16="http://schemas.microsoft.com/office/drawing/2014/main" id="{4A764767-A7BF-96F6-5938-F290769DC3C6}"/>
+                <a16:creationId xmlns:a16="http://schemas.microsoft.com/office/drawing/2014/main" id="{C517317E-C98A-31D2-C1C3-C066FF65F98E}"/>
               </a:ext>
             </a:extLst>
           </p:cNvPr>
@@ -8920,7 +8921,7 @@
           <p:cNvPr id="3" name="Slide title">
             <a:extLst>
               <a:ext uri="{FF2B5EF4-FFF2-40B4-BE49-F238E27FC236}">
-                <a16:creationId xmlns:a16="http://schemas.microsoft.com/office/drawing/2014/main" id="{04D5779C-0966-DE71-6CE0-2B9B8FDD7E96}"/>
+                <a16:creationId xmlns:a16="http://schemas.microsoft.com/office/drawing/2014/main" id="{0DFDB77C-3294-EEB6-0AC9-CCC4B7906F12}"/>
               </a:ext>
             </a:extLst>
           </p:cNvPr>
@@ -8965,7 +8966,7 @@
           <p:cNvPr id="4" name="Accent rule">
             <a:extLst>
               <a:ext uri="{FF2B5EF4-FFF2-40B4-BE49-F238E27FC236}">
-                <a16:creationId xmlns:a16="http://schemas.microsoft.com/office/drawing/2014/main" id="{4AD2E31E-82A2-5D04-FA98-D8745BD0ED8C}"/>
+                <a16:creationId xmlns:a16="http://schemas.microsoft.com/office/drawing/2014/main" id="{65B8E916-52D2-9D37-B7AC-0C063957FA59}"/>
               </a:ext>
             </a:extLst>
           </p:cNvPr>
@@ -9006,7 +9007,7 @@
           <p:cNvPr id="5" name="Footer author">
             <a:extLst>
               <a:ext uri="{FF2B5EF4-FFF2-40B4-BE49-F238E27FC236}">
-                <a16:creationId xmlns:a16="http://schemas.microsoft.com/office/drawing/2014/main" id="{A6A39F68-D4D9-A0A5-52C8-0C143F2A1826}"/>
+                <a16:creationId xmlns:a16="http://schemas.microsoft.com/office/drawing/2014/main" id="{7DA07517-01B0-9CB8-5C7E-C4E99738DDE4}"/>
               </a:ext>
             </a:extLst>
           </p:cNvPr>
@@ -9051,7 +9052,7 @@
           <p:cNvPr id="6" name="Slide number">
             <a:extLst>
               <a:ext uri="{FF2B5EF4-FFF2-40B4-BE49-F238E27FC236}">
-                <a16:creationId xmlns:a16="http://schemas.microsoft.com/office/drawing/2014/main" id="{BFE34CBE-9769-9797-80D5-4606F0D59C6C}"/>
+                <a16:creationId xmlns:a16="http://schemas.microsoft.com/office/drawing/2014/main" id="{33480503-4F3F-D344-DFE7-294CFA9F90DC}"/>
               </a:ext>
             </a:extLst>
           </p:cNvPr>
@@ -9096,7 +9097,7 @@
           <p:cNvPr id="7" name="Demo arrow">
             <a:extLst>
               <a:ext uri="{FF2B5EF4-FFF2-40B4-BE49-F238E27FC236}">
-                <a16:creationId xmlns:a16="http://schemas.microsoft.com/office/drawing/2014/main" id="{64D33ACC-BC6F-AE58-2381-041961703C19}"/>
+                <a16:creationId xmlns:a16="http://schemas.microsoft.com/office/drawing/2014/main" id="{A13B6FAB-3310-E1A6-6EF0-74B1CDDB9C45}"/>
               </a:ext>
             </a:extLst>
           </p:cNvPr>
@@ -9138,7 +9139,7 @@
           <p:cNvPr id="8" name="Demo arrow">
             <a:extLst>
               <a:ext uri="{FF2B5EF4-FFF2-40B4-BE49-F238E27FC236}">
-                <a16:creationId xmlns:a16="http://schemas.microsoft.com/office/drawing/2014/main" id="{40D0167E-E9A6-80FF-D4A5-8F0A734364C0}"/>
+                <a16:creationId xmlns:a16="http://schemas.microsoft.com/office/drawing/2014/main" id="{1F848EBC-AA17-5219-494E-D95B1A5105BE}"/>
               </a:ext>
             </a:extLst>
           </p:cNvPr>
@@ -9180,7 +9181,7 @@
           <p:cNvPr id="9" name="Demo arrow">
             <a:extLst>
               <a:ext uri="{FF2B5EF4-FFF2-40B4-BE49-F238E27FC236}">
-                <a16:creationId xmlns:a16="http://schemas.microsoft.com/office/drawing/2014/main" id="{B8173F19-9141-2384-89E8-73CA4133E7A5}"/>
+                <a16:creationId xmlns:a16="http://schemas.microsoft.com/office/drawing/2014/main" id="{7ED56186-8BA0-05A8-40FC-B9DACDB5C0C0}"/>
               </a:ext>
             </a:extLst>
           </p:cNvPr>
@@ -9222,7 +9223,7 @@
           <p:cNvPr id="10" name="Demo number">
             <a:extLst>
               <a:ext uri="{FF2B5EF4-FFF2-40B4-BE49-F238E27FC236}">
-                <a16:creationId xmlns:a16="http://schemas.microsoft.com/office/drawing/2014/main" id="{846A7884-3AEB-B6AB-FC74-88D160C0A78A}"/>
+                <a16:creationId xmlns:a16="http://schemas.microsoft.com/office/drawing/2014/main" id="{CFF9DFEC-07C1-17F0-A2F2-054DB325F164}"/>
               </a:ext>
             </a:extLst>
           </p:cNvPr>
@@ -9267,7 +9268,7 @@
           <p:cNvPr id="11" name="Demo node">
             <a:extLst>
               <a:ext uri="{FF2B5EF4-FFF2-40B4-BE49-F238E27FC236}">
-                <a16:creationId xmlns:a16="http://schemas.microsoft.com/office/drawing/2014/main" id="{625A26AD-8DCA-9B28-62D4-331F4B489BA3}"/>
+                <a16:creationId xmlns:a16="http://schemas.microsoft.com/office/drawing/2014/main" id="{688AC2C1-F32C-D6DF-0264-4771055972F6}"/>
               </a:ext>
             </a:extLst>
           </p:cNvPr>
@@ -9335,7 +9336,7 @@
           <p:cNvPr id="12" name="Demo title">
             <a:extLst>
               <a:ext uri="{FF2B5EF4-FFF2-40B4-BE49-F238E27FC236}">
-                <a16:creationId xmlns:a16="http://schemas.microsoft.com/office/drawing/2014/main" id="{90C2892D-4576-FC3A-2DD0-36D630292A12}"/>
+                <a16:creationId xmlns:a16="http://schemas.microsoft.com/office/drawing/2014/main" id="{5EC43781-4655-4133-C530-A0199D532017}"/>
               </a:ext>
             </a:extLst>
           </p:cNvPr>
@@ -9380,7 +9381,7 @@
           <p:cNvPr id="13" name="Demo detail">
             <a:extLst>
               <a:ext uri="{FF2B5EF4-FFF2-40B4-BE49-F238E27FC236}">
-                <a16:creationId xmlns:a16="http://schemas.microsoft.com/office/drawing/2014/main" id="{C3CC5815-59A9-CB0A-5D90-5160A256D6D7}"/>
+                <a16:creationId xmlns:a16="http://schemas.microsoft.com/office/drawing/2014/main" id="{AC1280C9-4353-76CB-3E37-23B2744911AF}"/>
               </a:ext>
             </a:extLst>
           </p:cNvPr>
@@ -9425,7 +9426,7 @@
           <p:cNvPr id="14" name="Demo number">
             <a:extLst>
               <a:ext uri="{FF2B5EF4-FFF2-40B4-BE49-F238E27FC236}">
-                <a16:creationId xmlns:a16="http://schemas.microsoft.com/office/drawing/2014/main" id="{5AB23BDE-9827-71C5-DF89-98B12CB93981}"/>
+                <a16:creationId xmlns:a16="http://schemas.microsoft.com/office/drawing/2014/main" id="{1C63E120-B9F0-BA61-6524-A524CF0F12A7}"/>
               </a:ext>
             </a:extLst>
           </p:cNvPr>
@@ -9470,7 +9471,7 @@
           <p:cNvPr id="15" name="Demo node">
             <a:extLst>
               <a:ext uri="{FF2B5EF4-FFF2-40B4-BE49-F238E27FC236}">
-                <a16:creationId xmlns:a16="http://schemas.microsoft.com/office/drawing/2014/main" id="{32FC5733-C44E-042C-BDC4-2E6101AE25F2}"/>
+                <a16:creationId xmlns:a16="http://schemas.microsoft.com/office/drawing/2014/main" id="{3BDCE198-10AD-E68A-0CDD-EA20539968A8}"/>
               </a:ext>
             </a:extLst>
           </p:cNvPr>
@@ -9538,7 +9539,7 @@
           <p:cNvPr id="16" name="Demo title">
             <a:extLst>
               <a:ext uri="{FF2B5EF4-FFF2-40B4-BE49-F238E27FC236}">
-                <a16:creationId xmlns:a16="http://schemas.microsoft.com/office/drawing/2014/main" id="{B8F723FA-6AFB-083A-1B70-AF67937B6FC3}"/>
+                <a16:creationId xmlns:a16="http://schemas.microsoft.com/office/drawing/2014/main" id="{332762BD-8F05-9CE5-3B37-D3C8B99503EF}"/>
               </a:ext>
             </a:extLst>
           </p:cNvPr>
@@ -9583,7 +9584,7 @@
           <p:cNvPr id="17" name="Demo detail">
             <a:extLst>
               <a:ext uri="{FF2B5EF4-FFF2-40B4-BE49-F238E27FC236}">
-                <a16:creationId xmlns:a16="http://schemas.microsoft.com/office/drawing/2014/main" id="{A245B476-E98E-C591-52C0-B6ADCAFA537E}"/>
+                <a16:creationId xmlns:a16="http://schemas.microsoft.com/office/drawing/2014/main" id="{A1196E8D-E5F0-BE40-82BD-F21A4D484008}"/>
               </a:ext>
             </a:extLst>
           </p:cNvPr>
@@ -9628,7 +9629,7 @@
           <p:cNvPr id="18" name="Demo number">
             <a:extLst>
               <a:ext uri="{FF2B5EF4-FFF2-40B4-BE49-F238E27FC236}">
-                <a16:creationId xmlns:a16="http://schemas.microsoft.com/office/drawing/2014/main" id="{DEE15E34-E294-2D6A-BDA1-D1EFF921734D}"/>
+                <a16:creationId xmlns:a16="http://schemas.microsoft.com/office/drawing/2014/main" id="{E6DAE55E-FE14-5F30-5B90-1D2595BEBF51}"/>
               </a:ext>
             </a:extLst>
           </p:cNvPr>
@@ -9673,7 +9674,7 @@
           <p:cNvPr id="19" name="Demo node">
             <a:extLst>
               <a:ext uri="{FF2B5EF4-FFF2-40B4-BE49-F238E27FC236}">
-                <a16:creationId xmlns:a16="http://schemas.microsoft.com/office/drawing/2014/main" id="{E61B68A0-1107-9CCE-21D2-6E9130494E4A}"/>
+                <a16:creationId xmlns:a16="http://schemas.microsoft.com/office/drawing/2014/main" id="{324DD070-35B3-DCA8-5435-5A4EFCD942B5}"/>
               </a:ext>
             </a:extLst>
           </p:cNvPr>
@@ -9741,7 +9742,7 @@
           <p:cNvPr id="20" name="Demo title">
             <a:extLst>
               <a:ext uri="{FF2B5EF4-FFF2-40B4-BE49-F238E27FC236}">
-                <a16:creationId xmlns:a16="http://schemas.microsoft.com/office/drawing/2014/main" id="{F2BCA1A0-02DC-93B3-DF79-8C0689C04D84}"/>
+                <a16:creationId xmlns:a16="http://schemas.microsoft.com/office/drawing/2014/main" id="{C9CDB8B3-81DF-7048-2C40-DCA4427B4943}"/>
               </a:ext>
             </a:extLst>
           </p:cNvPr>
@@ -9786,7 +9787,7 @@
           <p:cNvPr id="21" name="Demo detail">
             <a:extLst>
               <a:ext uri="{FF2B5EF4-FFF2-40B4-BE49-F238E27FC236}">
-                <a16:creationId xmlns:a16="http://schemas.microsoft.com/office/drawing/2014/main" id="{0132A301-04BA-3AB5-CEB4-CB8E28E5FB0C}"/>
+                <a16:creationId xmlns:a16="http://schemas.microsoft.com/office/drawing/2014/main" id="{ADC65AA4-361F-B38F-F94A-E4C6F2C1BCE4}"/>
               </a:ext>
             </a:extLst>
           </p:cNvPr>
@@ -9831,7 +9832,7 @@
           <p:cNvPr id="22" name="Demo number">
             <a:extLst>
               <a:ext uri="{FF2B5EF4-FFF2-40B4-BE49-F238E27FC236}">
-                <a16:creationId xmlns:a16="http://schemas.microsoft.com/office/drawing/2014/main" id="{731130CD-F388-9605-074B-9AA3B44C5FB4}"/>
+                <a16:creationId xmlns:a16="http://schemas.microsoft.com/office/drawing/2014/main" id="{68F6E7FF-8866-0316-14E4-C0B5BCA7BFCF}"/>
               </a:ext>
             </a:extLst>
           </p:cNvPr>
@@ -9876,7 +9877,7 @@
           <p:cNvPr id="23" name="Demo node">
             <a:extLst>
               <a:ext uri="{FF2B5EF4-FFF2-40B4-BE49-F238E27FC236}">
-                <a16:creationId xmlns:a16="http://schemas.microsoft.com/office/drawing/2014/main" id="{A4FB7092-FD7C-CF50-B32D-C01475ED038E}"/>
+                <a16:creationId xmlns:a16="http://schemas.microsoft.com/office/drawing/2014/main" id="{2C97D443-4532-8FD9-4E5B-9B742944A035}"/>
               </a:ext>
             </a:extLst>
           </p:cNvPr>
@@ -9944,7 +9945,7 @@
           <p:cNvPr id="24" name="Demo title">
             <a:extLst>
               <a:ext uri="{FF2B5EF4-FFF2-40B4-BE49-F238E27FC236}">
-                <a16:creationId xmlns:a16="http://schemas.microsoft.com/office/drawing/2014/main" id="{0690F5AD-EE5D-3AC5-4BBE-233FC448359F}"/>
+                <a16:creationId xmlns:a16="http://schemas.microsoft.com/office/drawing/2014/main" id="{E7DF4160-C898-3E5B-F62E-8733CE1EE71B}"/>
               </a:ext>
             </a:extLst>
           </p:cNvPr>
@@ -9989,7 +9990,7 @@
           <p:cNvPr id="25" name="Demo detail">
             <a:extLst>
               <a:ext uri="{FF2B5EF4-FFF2-40B4-BE49-F238E27FC236}">
-                <a16:creationId xmlns:a16="http://schemas.microsoft.com/office/drawing/2014/main" id="{F574DD5B-9601-5189-4EA4-6F48A326D18E}"/>
+                <a16:creationId xmlns:a16="http://schemas.microsoft.com/office/drawing/2014/main" id="{76D86B5F-9EF3-C692-25D8-3D5B4E31981E}"/>
               </a:ext>
             </a:extLst>
           </p:cNvPr>
@@ -10034,7 +10035,7 @@
           <p:cNvPr id="26" name="Demo note">
             <a:extLst>
               <a:ext uri="{FF2B5EF4-FFF2-40B4-BE49-F238E27FC236}">
-                <a16:creationId xmlns:a16="http://schemas.microsoft.com/office/drawing/2014/main" id="{09D677F5-384B-6B32-951D-BEDD63789D21}"/>
+                <a16:creationId xmlns:a16="http://schemas.microsoft.com/office/drawing/2014/main" id="{62C2A639-D814-7FE9-4E84-C332EB2022D0}"/>
               </a:ext>
             </a:extLst>
           </p:cNvPr>
@@ -10088,7 +10089,7 @@
           <p:cNvPr id="27" name="LAN note">
             <a:extLst>
               <a:ext uri="{FF2B5EF4-FFF2-40B4-BE49-F238E27FC236}">
-                <a16:creationId xmlns:a16="http://schemas.microsoft.com/office/drawing/2014/main" id="{8D53D9AC-199D-60AE-95B9-8C61E7FF53B6}"/>
+                <a16:creationId xmlns:a16="http://schemas.microsoft.com/office/drawing/2014/main" id="{5C9F801C-0729-578A-E952-7D6D8B3FD936}"/>
               </a:ext>
             </a:extLst>
           </p:cNvPr>
@@ -10131,7 +10132,7 @@
     </p:spTree>
     <p:extLst>
       <p:ext uri="{BB962C8B-B14F-4D97-AF65-F5344CB8AC3E}">
-        <p14:creationId xmlns:p14="http://schemas.microsoft.com/office/powerpoint/2010/main" val="2475956578"/>
+        <p14:creationId xmlns:p14="http://schemas.microsoft.com/office/powerpoint/2010/main" val="3674238102"/>
       </p:ext>
     </p:extLst>
   </p:cSld>
@@ -10171,7 +10172,7 @@
           <p:cNvPr id="2" name="Section">
             <a:extLst>
               <a:ext uri="{FF2B5EF4-FFF2-40B4-BE49-F238E27FC236}">
-                <a16:creationId xmlns:a16="http://schemas.microsoft.com/office/drawing/2014/main" id="{8175F2B7-4EED-E3C4-6CBE-7F2393EC9E61}"/>
+                <a16:creationId xmlns:a16="http://schemas.microsoft.com/office/drawing/2014/main" id="{B0DE57C0-A5CC-3C40-01A3-1A64E190E303}"/>
               </a:ext>
             </a:extLst>
           </p:cNvPr>
@@ -10216,7 +10217,7 @@
           <p:cNvPr id="3" name="Slide title">
             <a:extLst>
               <a:ext uri="{FF2B5EF4-FFF2-40B4-BE49-F238E27FC236}">
-                <a16:creationId xmlns:a16="http://schemas.microsoft.com/office/drawing/2014/main" id="{DF95358E-D48B-B426-BBF7-26E2F87ABA9D}"/>
+                <a16:creationId xmlns:a16="http://schemas.microsoft.com/office/drawing/2014/main" id="{C8ACA7F6-C2D5-095D-9356-94EA022E7BD2}"/>
               </a:ext>
             </a:extLst>
           </p:cNvPr>
@@ -10261,7 +10262,7 @@
           <p:cNvPr id="4" name="Accent rule">
             <a:extLst>
               <a:ext uri="{FF2B5EF4-FFF2-40B4-BE49-F238E27FC236}">
-                <a16:creationId xmlns:a16="http://schemas.microsoft.com/office/drawing/2014/main" id="{4FB3B33C-B815-15C8-D2B7-495BF359530B}"/>
+                <a16:creationId xmlns:a16="http://schemas.microsoft.com/office/drawing/2014/main" id="{21AEBC83-2A07-C59E-AD63-426E76C971D2}"/>
               </a:ext>
             </a:extLst>
           </p:cNvPr>
@@ -10302,7 +10303,7 @@
           <p:cNvPr id="5" name="Footer author">
             <a:extLst>
               <a:ext uri="{FF2B5EF4-FFF2-40B4-BE49-F238E27FC236}">
-                <a16:creationId xmlns:a16="http://schemas.microsoft.com/office/drawing/2014/main" id="{5CC871EA-A5C9-682F-5D31-199CEF09D60D}"/>
+                <a16:creationId xmlns:a16="http://schemas.microsoft.com/office/drawing/2014/main" id="{C3916F09-722A-1670-7758-79A468FFF6E6}"/>
               </a:ext>
             </a:extLst>
           </p:cNvPr>
@@ -10347,7 +10348,7 @@
           <p:cNvPr id="6" name="Slide number">
             <a:extLst>
               <a:ext uri="{FF2B5EF4-FFF2-40B4-BE49-F238E27FC236}">
-                <a16:creationId xmlns:a16="http://schemas.microsoft.com/office/drawing/2014/main" id="{072C89ED-7684-A358-783C-2D0230DCB47E}"/>
+                <a16:creationId xmlns:a16="http://schemas.microsoft.com/office/drawing/2014/main" id="{CB43EC04-928D-8AD7-171A-4470A9F1A969}"/>
               </a:ext>
             </a:extLst>
           </p:cNvPr>
@@ -10392,7 +10393,7 @@
           <p:cNvPr id="7" name="Demonstrates label">
             <a:extLst>
               <a:ext uri="{FF2B5EF4-FFF2-40B4-BE49-F238E27FC236}">
-                <a16:creationId xmlns:a16="http://schemas.microsoft.com/office/drawing/2014/main" id="{3F56495A-E25D-5EA9-9171-5B3D1C00AA82}"/>
+                <a16:creationId xmlns:a16="http://schemas.microsoft.com/office/drawing/2014/main" id="{52D10A9B-6A56-991A-D228-836779D95283}"/>
               </a:ext>
             </a:extLst>
           </p:cNvPr>
@@ -10437,7 +10438,7 @@
           <p:cNvPr id="8" name="Demonstrates">
             <a:extLst>
               <a:ext uri="{FF2B5EF4-FFF2-40B4-BE49-F238E27FC236}">
-                <a16:creationId xmlns:a16="http://schemas.microsoft.com/office/drawing/2014/main" id="{6A1D492A-EBD1-4527-69B6-8900487B525C}"/>
+                <a16:creationId xmlns:a16="http://schemas.microsoft.com/office/drawing/2014/main" id="{BA3CC961-BF6D-BFED-DE65-70F2CBDBCA06}"/>
               </a:ext>
             </a:extLst>
           </p:cNvPr>
@@ -10485,7 +10486,7 @@
           <p:cNvPr id="9" name="Limit divider">
             <a:extLst>
               <a:ext uri="{FF2B5EF4-FFF2-40B4-BE49-F238E27FC236}">
-                <a16:creationId xmlns:a16="http://schemas.microsoft.com/office/drawing/2014/main" id="{4942CFA7-C229-0E5F-5D24-525E10184521}"/>
+                <a16:creationId xmlns:a16="http://schemas.microsoft.com/office/drawing/2014/main" id="{B3412703-B662-D3A2-7AEC-74EB7811256B}"/>
               </a:ext>
             </a:extLst>
           </p:cNvPr>
@@ -10526,7 +10527,7 @@
           <p:cNvPr id="10" name="Does not label">
             <a:extLst>
               <a:ext uri="{FF2B5EF4-FFF2-40B4-BE49-F238E27FC236}">
-                <a16:creationId xmlns:a16="http://schemas.microsoft.com/office/drawing/2014/main" id="{70CA3D14-BD55-C11F-9A20-B370EF454605}"/>
+                <a16:creationId xmlns:a16="http://schemas.microsoft.com/office/drawing/2014/main" id="{B42DDAB4-5735-27D8-E209-1618F463DC22}"/>
               </a:ext>
             </a:extLst>
           </p:cNvPr>
@@ -10571,7 +10572,7 @@
           <p:cNvPr id="11" name="Does not">
             <a:extLst>
               <a:ext uri="{FF2B5EF4-FFF2-40B4-BE49-F238E27FC236}">
-                <a16:creationId xmlns:a16="http://schemas.microsoft.com/office/drawing/2014/main" id="{C2E8ADB0-E7AC-762C-C23B-39AEA4F364F7}"/>
+                <a16:creationId xmlns:a16="http://schemas.microsoft.com/office/drawing/2014/main" id="{06995531-8538-849A-CE34-B8FFB891D8DD}"/>
               </a:ext>
             </a:extLst>
           </p:cNvPr>
@@ -10619,7 +10620,7 @@
           <p:cNvPr id="12" name="Future band">
             <a:extLst>
               <a:ext uri="{FF2B5EF4-FFF2-40B4-BE49-F238E27FC236}">
-                <a16:creationId xmlns:a16="http://schemas.microsoft.com/office/drawing/2014/main" id="{56900E0C-44C3-3E85-0209-D704B67ED5EE}"/>
+                <a16:creationId xmlns:a16="http://schemas.microsoft.com/office/drawing/2014/main" id="{0A5C17E3-67A1-DB0A-E72E-892FACE230EF}"/>
               </a:ext>
             </a:extLst>
           </p:cNvPr>
@@ -10687,7 +10688,7 @@
           <p:cNvPr id="13" name="Future label">
             <a:extLst>
               <a:ext uri="{FF2B5EF4-FFF2-40B4-BE49-F238E27FC236}">
-                <a16:creationId xmlns:a16="http://schemas.microsoft.com/office/drawing/2014/main" id="{6B9DD0E0-0231-DEE5-D7B7-AABD61189605}"/>
+                <a16:creationId xmlns:a16="http://schemas.microsoft.com/office/drawing/2014/main" id="{7C3CDC22-D113-FB52-8ECD-501F0197F0A7}"/>
               </a:ext>
             </a:extLst>
           </p:cNvPr>
@@ -10732,7 +10733,7 @@
           <p:cNvPr id="14" name="Future items">
             <a:extLst>
               <a:ext uri="{FF2B5EF4-FFF2-40B4-BE49-F238E27FC236}">
-                <a16:creationId xmlns:a16="http://schemas.microsoft.com/office/drawing/2014/main" id="{F5357919-6EBA-F4C9-5D62-3B3006571F88}"/>
+                <a16:creationId xmlns:a16="http://schemas.microsoft.com/office/drawing/2014/main" id="{E0A6615A-9D81-2116-F843-EB00CF036F13}"/>
               </a:ext>
             </a:extLst>
           </p:cNvPr>
@@ -10775,7 +10776,7 @@
     </p:spTree>
     <p:extLst>
       <p:ext uri="{BB962C8B-B14F-4D97-AF65-F5344CB8AC3E}">
-        <p14:creationId xmlns:p14="http://schemas.microsoft.com/office/powerpoint/2010/main" val="631885201"/>
+        <p14:creationId xmlns:p14="http://schemas.microsoft.com/office/powerpoint/2010/main" val="2346132493"/>
       </p:ext>
     </p:extLst>
   </p:cSld>
@@ -10815,7 +10816,7 @@
           <p:cNvPr id="2" name="Closing label">
             <a:extLst>
               <a:ext uri="{FF2B5EF4-FFF2-40B4-BE49-F238E27FC236}">
-                <a16:creationId xmlns:a16="http://schemas.microsoft.com/office/drawing/2014/main" id="{E8D4D2A4-3A77-FFBC-4197-04B9266D80A3}"/>
+                <a16:creationId xmlns:a16="http://schemas.microsoft.com/office/drawing/2014/main" id="{EF8E3202-6E13-9AAA-3154-30636FC97100}"/>
               </a:ext>
             </a:extLst>
           </p:cNvPr>
@@ -10860,7 +10861,7 @@
           <p:cNvPr id="3" name="Closing title">
             <a:extLst>
               <a:ext uri="{FF2B5EF4-FFF2-40B4-BE49-F238E27FC236}">
-                <a16:creationId xmlns:a16="http://schemas.microsoft.com/office/drawing/2014/main" id="{D2405325-1BD4-7661-0B2D-94A7B013063D}"/>
+                <a16:creationId xmlns:a16="http://schemas.microsoft.com/office/drawing/2014/main" id="{F92CA4AE-AEA4-A8A4-1DD4-6034A741D2DF}"/>
               </a:ext>
             </a:extLst>
           </p:cNvPr>
@@ -10906,7 +10907,7 @@
           <p:cNvPr id="4" name="Closing thesis">
             <a:extLst>
               <a:ext uri="{FF2B5EF4-FFF2-40B4-BE49-F238E27FC236}">
-                <a16:creationId xmlns:a16="http://schemas.microsoft.com/office/drawing/2014/main" id="{E892545F-232A-9A2D-E594-9112255D700C}"/>
+                <a16:creationId xmlns:a16="http://schemas.microsoft.com/office/drawing/2014/main" id="{BBB8115C-A78E-AFC6-D6DC-D5B534DB5E31}"/>
               </a:ext>
             </a:extLst>
           </p:cNvPr>
@@ -10951,7 +10952,7 @@
           <p:cNvPr id="5" name="Closing rule">
             <a:extLst>
               <a:ext uri="{FF2B5EF4-FFF2-40B4-BE49-F238E27FC236}">
-                <a16:creationId xmlns:a16="http://schemas.microsoft.com/office/drawing/2014/main" id="{6EAA712F-ADF8-B92A-AB04-C2844C438365}"/>
+                <a16:creationId xmlns:a16="http://schemas.microsoft.com/office/drawing/2014/main" id="{B46701F5-9A4B-DA12-EFC5-B6CE972AE87B}"/>
               </a:ext>
             </a:extLst>
           </p:cNvPr>
@@ -10992,7 +10993,7 @@
           <p:cNvPr id="6" name="Closing contribution">
             <a:extLst>
               <a:ext uri="{FF2B5EF4-FFF2-40B4-BE49-F238E27FC236}">
-                <a16:creationId xmlns:a16="http://schemas.microsoft.com/office/drawing/2014/main" id="{F8BB2A8A-987E-F1EB-BC1F-C7A616CB2D6C}"/>
+                <a16:creationId xmlns:a16="http://schemas.microsoft.com/office/drawing/2014/main" id="{5E4B8DF2-60CD-0227-CF3A-1B7F8638B06A}"/>
               </a:ext>
             </a:extLst>
           </p:cNvPr>
@@ -11037,7 +11038,7 @@
           <p:cNvPr id="7" name="Questions">
             <a:extLst>
               <a:ext uri="{FF2B5EF4-FFF2-40B4-BE49-F238E27FC236}">
-                <a16:creationId xmlns:a16="http://schemas.microsoft.com/office/drawing/2014/main" id="{63A0A0FC-D726-00CA-D59A-A29F9380F425}"/>
+                <a16:creationId xmlns:a16="http://schemas.microsoft.com/office/drawing/2014/main" id="{6F4BF09C-629F-1A68-D710-C728409AA74C}"/>
               </a:ext>
             </a:extLst>
           </p:cNvPr>
@@ -11080,7 +11081,7 @@
     </p:spTree>
     <p:extLst>
       <p:ext uri="{BB962C8B-B14F-4D97-AF65-F5344CB8AC3E}">
-        <p14:creationId xmlns:p14="http://schemas.microsoft.com/office/powerpoint/2010/main" val="3195707685"/>
+        <p14:creationId xmlns:p14="http://schemas.microsoft.com/office/powerpoint/2010/main" val="1121462094"/>
       </p:ext>
     </p:extLst>
   </p:cSld>
@@ -11120,7 +11121,7 @@
           <p:cNvPr id="2" name="Section">
             <a:extLst>
               <a:ext uri="{FF2B5EF4-FFF2-40B4-BE49-F238E27FC236}">
-                <a16:creationId xmlns:a16="http://schemas.microsoft.com/office/drawing/2014/main" id="{7889828B-2487-6D74-CF13-48C1F46FF23F}"/>
+                <a16:creationId xmlns:a16="http://schemas.microsoft.com/office/drawing/2014/main" id="{075C0818-D8BB-0573-073B-53B38734CFD9}"/>
               </a:ext>
             </a:extLst>
           </p:cNvPr>
@@ -11165,7 +11166,7 @@
           <p:cNvPr id="3" name="Slide title">
             <a:extLst>
               <a:ext uri="{FF2B5EF4-FFF2-40B4-BE49-F238E27FC236}">
-                <a16:creationId xmlns:a16="http://schemas.microsoft.com/office/drawing/2014/main" id="{E8E0A7D3-959F-177D-E8D6-2D9A3982A7CB}"/>
+                <a16:creationId xmlns:a16="http://schemas.microsoft.com/office/drawing/2014/main" id="{B91543EB-136D-6D33-DFFC-FD7F4E851CEF}"/>
               </a:ext>
             </a:extLst>
           </p:cNvPr>
@@ -11210,7 +11211,7 @@
           <p:cNvPr id="4" name="Accent rule">
             <a:extLst>
               <a:ext uri="{FF2B5EF4-FFF2-40B4-BE49-F238E27FC236}">
-                <a16:creationId xmlns:a16="http://schemas.microsoft.com/office/drawing/2014/main" id="{705FE20D-2B9E-8F57-834D-D067CAB9A3B5}"/>
+                <a16:creationId xmlns:a16="http://schemas.microsoft.com/office/drawing/2014/main" id="{6DFED996-1D5B-A332-990C-6D58CAB980EF}"/>
               </a:ext>
             </a:extLst>
           </p:cNvPr>
@@ -11251,7 +11252,7 @@
           <p:cNvPr id="5" name="Footer author">
             <a:extLst>
               <a:ext uri="{FF2B5EF4-FFF2-40B4-BE49-F238E27FC236}">
-                <a16:creationId xmlns:a16="http://schemas.microsoft.com/office/drawing/2014/main" id="{C7BAFBBD-C3C7-FA3C-0958-FDA2943AF103}"/>
+                <a16:creationId xmlns:a16="http://schemas.microsoft.com/office/drawing/2014/main" id="{E303F36B-D40A-6C26-9A1B-04DB833B8F06}"/>
               </a:ext>
             </a:extLst>
           </p:cNvPr>
@@ -11296,7 +11297,7 @@
           <p:cNvPr id="6" name="Slide number">
             <a:extLst>
               <a:ext uri="{FF2B5EF4-FFF2-40B4-BE49-F238E27FC236}">
-                <a16:creationId xmlns:a16="http://schemas.microsoft.com/office/drawing/2014/main" id="{ECA098D8-DC85-F271-E306-FF01F0DCB6AE}"/>
+                <a16:creationId xmlns:a16="http://schemas.microsoft.com/office/drawing/2014/main" id="{5CDB884B-40E0-95DF-7D97-50648220AD4C}"/>
               </a:ext>
             </a:extLst>
           </p:cNvPr>
@@ -11341,7 +11342,7 @@
           <p:cNvPr id="7" name="Question field">
             <a:extLst>
               <a:ext uri="{FF2B5EF4-FFF2-40B4-BE49-F238E27FC236}">
-                <a16:creationId xmlns:a16="http://schemas.microsoft.com/office/drawing/2014/main" id="{DA7DF6BF-6092-4918-4ACB-153F2614FE04}"/>
+                <a16:creationId xmlns:a16="http://schemas.microsoft.com/office/drawing/2014/main" id="{36592ECE-A28A-9B30-1BEC-E33FB995D068}"/>
               </a:ext>
             </a:extLst>
           </p:cNvPr>
@@ -11409,7 +11410,7 @@
           <p:cNvPr id="8" name="Question">
             <a:extLst>
               <a:ext uri="{FF2B5EF4-FFF2-40B4-BE49-F238E27FC236}">
-                <a16:creationId xmlns:a16="http://schemas.microsoft.com/office/drawing/2014/main" id="{763EF413-5CE4-94D2-D37C-46F0947115B0}"/>
+                <a16:creationId xmlns:a16="http://schemas.microsoft.com/office/drawing/2014/main" id="{81645575-EE0D-3D0C-7419-13689792C723}"/>
               </a:ext>
             </a:extLst>
           </p:cNvPr>
@@ -11454,7 +11455,7 @@
           <p:cNvPr id="9" name="Question support">
             <a:extLst>
               <a:ext uri="{FF2B5EF4-FFF2-40B4-BE49-F238E27FC236}">
-                <a16:creationId xmlns:a16="http://schemas.microsoft.com/office/drawing/2014/main" id="{02245197-4963-4EDC-76B2-743003BD0498}"/>
+                <a16:creationId xmlns:a16="http://schemas.microsoft.com/office/drawing/2014/main" id="{183FE2D8-B2B0-3AEE-9540-A1C9E3D5BA3D}"/>
               </a:ext>
             </a:extLst>
           </p:cNvPr>
@@ -11499,7 +11500,7 @@
           <p:cNvPr id="10" name="Index 01">
             <a:extLst>
               <a:ext uri="{FF2B5EF4-FFF2-40B4-BE49-F238E27FC236}">
-                <a16:creationId xmlns:a16="http://schemas.microsoft.com/office/drawing/2014/main" id="{14C2D996-E6BB-1516-7C8D-369F4CEB80CD}"/>
+                <a16:creationId xmlns:a16="http://schemas.microsoft.com/office/drawing/2014/main" id="{2B2153E1-8D8B-89F5-3A10-1818074A190B}"/>
               </a:ext>
             </a:extLst>
           </p:cNvPr>
@@ -11544,7 +11545,7 @@
           <p:cNvPr id="11" name="Problem 01">
             <a:extLst>
               <a:ext uri="{FF2B5EF4-FFF2-40B4-BE49-F238E27FC236}">
-                <a16:creationId xmlns:a16="http://schemas.microsoft.com/office/drawing/2014/main" id="{BB971581-20BC-FF84-FEFA-1CAC0A3CBBFB}"/>
+                <a16:creationId xmlns:a16="http://schemas.microsoft.com/office/drawing/2014/main" id="{8978378E-70F9-0025-5DD6-5AF161F04E98}"/>
               </a:ext>
             </a:extLst>
           </p:cNvPr>
@@ -11589,7 +11590,7 @@
           <p:cNvPr id="12" name="Problem detail 01">
             <a:extLst>
               <a:ext uri="{FF2B5EF4-FFF2-40B4-BE49-F238E27FC236}">
-                <a16:creationId xmlns:a16="http://schemas.microsoft.com/office/drawing/2014/main" id="{9B3DDA20-E479-03F7-85B1-B85C99074A1B}"/>
+                <a16:creationId xmlns:a16="http://schemas.microsoft.com/office/drawing/2014/main" id="{CBE1086D-1152-3ECE-848B-C84A76726C0A}"/>
               </a:ext>
             </a:extLst>
           </p:cNvPr>
@@ -11624,7 +11625,7 @@
                 </a:solidFill>
                 <a:latin typeface="Arial" panose="020B0604020202020204" pitchFamily="34" charset="0"/>
               </a:rPr>
-              <a:t>SPF, DKIM, DMARC, dominios, URLs, HTML y adjuntos.</a:t>
+              <a:t>Resultados SPF, DKIM y DMARC presentes en cabeceras, dominios, URLs, HTML y adjuntos.</a:t>
             </a:r>
           </a:p>
         </p:txBody>
@@ -11634,7 +11635,7 @@
           <p:cNvPr id="13" name="Problem divider">
             <a:extLst>
               <a:ext uri="{FF2B5EF4-FFF2-40B4-BE49-F238E27FC236}">
-                <a16:creationId xmlns:a16="http://schemas.microsoft.com/office/drawing/2014/main" id="{56B804AC-B37F-2A26-BFCE-EAE9D7F2EEBA}"/>
+                <a16:creationId xmlns:a16="http://schemas.microsoft.com/office/drawing/2014/main" id="{EF2FC6A1-08EB-BF45-77CD-D715FC849E7E}"/>
               </a:ext>
             </a:extLst>
           </p:cNvPr>
@@ -11675,7 +11676,7 @@
           <p:cNvPr id="14" name="Index 02">
             <a:extLst>
               <a:ext uri="{FF2B5EF4-FFF2-40B4-BE49-F238E27FC236}">
-                <a16:creationId xmlns:a16="http://schemas.microsoft.com/office/drawing/2014/main" id="{F5647330-A02C-3834-A35C-DCCFCDD80EFD}"/>
+                <a16:creationId xmlns:a16="http://schemas.microsoft.com/office/drawing/2014/main" id="{C98320FA-F415-1EA6-FD66-D7C1D86CA287}"/>
               </a:ext>
             </a:extLst>
           </p:cNvPr>
@@ -11720,7 +11721,7 @@
           <p:cNvPr id="15" name="Problem 02">
             <a:extLst>
               <a:ext uri="{FF2B5EF4-FFF2-40B4-BE49-F238E27FC236}">
-                <a16:creationId xmlns:a16="http://schemas.microsoft.com/office/drawing/2014/main" id="{B099714F-E501-181C-2E67-DCB02BB8D66E}"/>
+                <a16:creationId xmlns:a16="http://schemas.microsoft.com/office/drawing/2014/main" id="{4E4E6FCD-91FD-0F28-CF67-89CD79FFF049}"/>
               </a:ext>
             </a:extLst>
           </p:cNvPr>
@@ -11765,7 +11766,7 @@
           <p:cNvPr id="16" name="Problem detail 02">
             <a:extLst>
               <a:ext uri="{FF2B5EF4-FFF2-40B4-BE49-F238E27FC236}">
-                <a16:creationId xmlns:a16="http://schemas.microsoft.com/office/drawing/2014/main" id="{B16975EB-F584-D24B-AF99-47A7A6138C64}"/>
+                <a16:creationId xmlns:a16="http://schemas.microsoft.com/office/drawing/2014/main" id="{83426D22-47FB-1CA2-24AD-0A4DAAE31F9F}"/>
               </a:ext>
             </a:extLst>
           </p:cNvPr>
@@ -11810,7 +11811,7 @@
           <p:cNvPr id="17" name="Problem divider">
             <a:extLst>
               <a:ext uri="{FF2B5EF4-FFF2-40B4-BE49-F238E27FC236}">
-                <a16:creationId xmlns:a16="http://schemas.microsoft.com/office/drawing/2014/main" id="{0C438256-B45A-73C9-0E91-5D39896FCEBE}"/>
+                <a16:creationId xmlns:a16="http://schemas.microsoft.com/office/drawing/2014/main" id="{D1129BA5-1AE6-3563-8639-40AC04B9CEE4}"/>
               </a:ext>
             </a:extLst>
           </p:cNvPr>
@@ -11851,7 +11852,7 @@
           <p:cNvPr id="18" name="Index 03">
             <a:extLst>
               <a:ext uri="{FF2B5EF4-FFF2-40B4-BE49-F238E27FC236}">
-                <a16:creationId xmlns:a16="http://schemas.microsoft.com/office/drawing/2014/main" id="{2077FEA8-5005-B3B4-7E37-B45621D4FB0B}"/>
+                <a16:creationId xmlns:a16="http://schemas.microsoft.com/office/drawing/2014/main" id="{EAE45CD0-26F8-8572-F90B-5A244EF81CED}"/>
               </a:ext>
             </a:extLst>
           </p:cNvPr>
@@ -11896,7 +11897,7 @@
           <p:cNvPr id="19" name="Problem 03">
             <a:extLst>
               <a:ext uri="{FF2B5EF4-FFF2-40B4-BE49-F238E27FC236}">
-                <a16:creationId xmlns:a16="http://schemas.microsoft.com/office/drawing/2014/main" id="{25C28981-B867-3B2C-A4FA-DCFAAEB9F668}"/>
+                <a16:creationId xmlns:a16="http://schemas.microsoft.com/office/drawing/2014/main" id="{BC28FF93-0468-5DB8-1472-0206745B31E7}"/>
               </a:ext>
             </a:extLst>
           </p:cNvPr>
@@ -11941,7 +11942,7 @@
           <p:cNvPr id="20" name="Problem detail 03">
             <a:extLst>
               <a:ext uri="{FF2B5EF4-FFF2-40B4-BE49-F238E27FC236}">
-                <a16:creationId xmlns:a16="http://schemas.microsoft.com/office/drawing/2014/main" id="{1EB55799-B3C1-8BD7-E59D-42305FB84E3C}"/>
+                <a16:creationId xmlns:a16="http://schemas.microsoft.com/office/drawing/2014/main" id="{AF25C870-5EBA-24A2-D56D-3D58AFF70C64}"/>
               </a:ext>
             </a:extLst>
           </p:cNvPr>
@@ -11984,7 +11985,7 @@
     </p:spTree>
     <p:extLst>
       <p:ext uri="{BB962C8B-B14F-4D97-AF65-F5344CB8AC3E}">
-        <p14:creationId xmlns:p14="http://schemas.microsoft.com/office/powerpoint/2010/main" val="3349840314"/>
+        <p14:creationId xmlns:p14="http://schemas.microsoft.com/office/powerpoint/2010/main" val="284445596"/>
       </p:ext>
     </p:extLst>
   </p:cSld>
@@ -12024,7 +12025,7 @@
           <p:cNvPr id="2" name="Section">
             <a:extLst>
               <a:ext uri="{FF2B5EF4-FFF2-40B4-BE49-F238E27FC236}">
-                <a16:creationId xmlns:a16="http://schemas.microsoft.com/office/drawing/2014/main" id="{8A6CC509-976C-F262-F531-46CEB847FD04}"/>
+                <a16:creationId xmlns:a16="http://schemas.microsoft.com/office/drawing/2014/main" id="{2F7FFEFF-9ECC-ECD6-F870-50D8F8DDD8A0}"/>
               </a:ext>
             </a:extLst>
           </p:cNvPr>
@@ -12069,7 +12070,7 @@
           <p:cNvPr id="3" name="Slide title">
             <a:extLst>
               <a:ext uri="{FF2B5EF4-FFF2-40B4-BE49-F238E27FC236}">
-                <a16:creationId xmlns:a16="http://schemas.microsoft.com/office/drawing/2014/main" id="{7A8A68AE-D361-352B-8585-B017C45F720D}"/>
+                <a16:creationId xmlns:a16="http://schemas.microsoft.com/office/drawing/2014/main" id="{2A73C2E8-6DDB-F372-339E-267B46BEA4BD}"/>
               </a:ext>
             </a:extLst>
           </p:cNvPr>
@@ -12114,7 +12115,7 @@
           <p:cNvPr id="4" name="Accent rule">
             <a:extLst>
               <a:ext uri="{FF2B5EF4-FFF2-40B4-BE49-F238E27FC236}">
-                <a16:creationId xmlns:a16="http://schemas.microsoft.com/office/drawing/2014/main" id="{73B5AF60-E166-B3A8-ACA5-9E809DD9D847}"/>
+                <a16:creationId xmlns:a16="http://schemas.microsoft.com/office/drawing/2014/main" id="{AB4EC1FF-543B-2040-4A81-55367EE995CD}"/>
               </a:ext>
             </a:extLst>
           </p:cNvPr>
@@ -12155,7 +12156,7 @@
           <p:cNvPr id="5" name="Footer author">
             <a:extLst>
               <a:ext uri="{FF2B5EF4-FFF2-40B4-BE49-F238E27FC236}">
-                <a16:creationId xmlns:a16="http://schemas.microsoft.com/office/drawing/2014/main" id="{DE00DBCF-07E9-E280-12A3-9333D7024FC8}"/>
+                <a16:creationId xmlns:a16="http://schemas.microsoft.com/office/drawing/2014/main" id="{34F76A29-1178-0A22-04AC-6A5A5B2A4FA4}"/>
               </a:ext>
             </a:extLst>
           </p:cNvPr>
@@ -12200,7 +12201,7 @@
           <p:cNvPr id="6" name="Slide number">
             <a:extLst>
               <a:ext uri="{FF2B5EF4-FFF2-40B4-BE49-F238E27FC236}">
-                <a16:creationId xmlns:a16="http://schemas.microsoft.com/office/drawing/2014/main" id="{BA2E0668-213E-D609-1A0A-E2954777D714}"/>
+                <a16:creationId xmlns:a16="http://schemas.microsoft.com/office/drawing/2014/main" id="{A7E6418E-BB23-1A69-4191-7DB0B23D18A6}"/>
               </a:ext>
             </a:extLst>
           </p:cNvPr>
@@ -12245,7 +12246,7 @@
           <p:cNvPr id="7" name="Thesis">
             <a:extLst>
               <a:ext uri="{FF2B5EF4-FFF2-40B4-BE49-F238E27FC236}">
-                <a16:creationId xmlns:a16="http://schemas.microsoft.com/office/drawing/2014/main" id="{937E204C-95C7-9476-0B4E-290D42A55F4F}"/>
+                <a16:creationId xmlns:a16="http://schemas.microsoft.com/office/drawing/2014/main" id="{ED701BA1-59DE-6B21-BBC0-08D038530823}"/>
               </a:ext>
             </a:extLst>
           </p:cNvPr>
@@ -12290,7 +12291,7 @@
           <p:cNvPr id="8" name="Thesis detail">
             <a:extLst>
               <a:ext uri="{FF2B5EF4-FFF2-40B4-BE49-F238E27FC236}">
-                <a16:creationId xmlns:a16="http://schemas.microsoft.com/office/drawing/2014/main" id="{8C563AD7-1458-8BE7-52DF-97D9E84780D7}"/>
+                <a16:creationId xmlns:a16="http://schemas.microsoft.com/office/drawing/2014/main" id="{1A0EB1CA-E4BB-FCC4-8651-4B9409CF6C0F}"/>
               </a:ext>
             </a:extLst>
           </p:cNvPr>
@@ -12335,7 +12336,7 @@
           <p:cNvPr id="9" name="Objective index">
             <a:extLst>
               <a:ext uri="{FF2B5EF4-FFF2-40B4-BE49-F238E27FC236}">
-                <a16:creationId xmlns:a16="http://schemas.microsoft.com/office/drawing/2014/main" id="{B5AF3FC0-EDE3-6D2F-604F-19918C709A40}"/>
+                <a16:creationId xmlns:a16="http://schemas.microsoft.com/office/drawing/2014/main" id="{FAA28E44-8717-5689-B983-ADAAA298DBAA}"/>
               </a:ext>
             </a:extLst>
           </p:cNvPr>
@@ -12380,7 +12381,7 @@
           <p:cNvPr id="10" name="Objective">
             <a:extLst>
               <a:ext uri="{FF2B5EF4-FFF2-40B4-BE49-F238E27FC236}">
-                <a16:creationId xmlns:a16="http://schemas.microsoft.com/office/drawing/2014/main" id="{0C9A7DB5-9B6C-6D20-13CA-583129EB7D6D}"/>
+                <a16:creationId xmlns:a16="http://schemas.microsoft.com/office/drawing/2014/main" id="{02A84831-3673-F18C-B99C-C94135C42191}"/>
               </a:ext>
             </a:extLst>
           </p:cNvPr>
@@ -12425,7 +12426,7 @@
           <p:cNvPr id="11" name="Objective detail">
             <a:extLst>
               <a:ext uri="{FF2B5EF4-FFF2-40B4-BE49-F238E27FC236}">
-                <a16:creationId xmlns:a16="http://schemas.microsoft.com/office/drawing/2014/main" id="{949262D4-C1B1-E99B-0CDF-7E9D03A479A4}"/>
+                <a16:creationId xmlns:a16="http://schemas.microsoft.com/office/drawing/2014/main" id="{23C25EED-0629-98D1-9C83-9A3053D55793}"/>
               </a:ext>
             </a:extLst>
           </p:cNvPr>
@@ -12470,7 +12471,7 @@
           <p:cNvPr id="12" name="Objective divider">
             <a:extLst>
               <a:ext uri="{FF2B5EF4-FFF2-40B4-BE49-F238E27FC236}">
-                <a16:creationId xmlns:a16="http://schemas.microsoft.com/office/drawing/2014/main" id="{5E0CA286-22B2-264E-C8B7-2256701A4CE5}"/>
+                <a16:creationId xmlns:a16="http://schemas.microsoft.com/office/drawing/2014/main" id="{A0B3549E-4B27-F67F-97E2-C5135EC31E79}"/>
               </a:ext>
             </a:extLst>
           </p:cNvPr>
@@ -12511,7 +12512,7 @@
           <p:cNvPr id="13" name="Objective index">
             <a:extLst>
               <a:ext uri="{FF2B5EF4-FFF2-40B4-BE49-F238E27FC236}">
-                <a16:creationId xmlns:a16="http://schemas.microsoft.com/office/drawing/2014/main" id="{1F1C87B0-96CA-F222-4E41-5FEE6794D6E7}"/>
+                <a16:creationId xmlns:a16="http://schemas.microsoft.com/office/drawing/2014/main" id="{03599531-6230-C99F-E46A-37E64DE8CB8D}"/>
               </a:ext>
             </a:extLst>
           </p:cNvPr>
@@ -12556,7 +12557,7 @@
           <p:cNvPr id="14" name="Objective">
             <a:extLst>
               <a:ext uri="{FF2B5EF4-FFF2-40B4-BE49-F238E27FC236}">
-                <a16:creationId xmlns:a16="http://schemas.microsoft.com/office/drawing/2014/main" id="{76F0271B-FE91-5A52-D396-D459DC8BDEEF}"/>
+                <a16:creationId xmlns:a16="http://schemas.microsoft.com/office/drawing/2014/main" id="{F1B03966-D628-E8B6-6831-68141D6AD87F}"/>
               </a:ext>
             </a:extLst>
           </p:cNvPr>
@@ -12601,7 +12602,7 @@
           <p:cNvPr id="15" name="Objective detail">
             <a:extLst>
               <a:ext uri="{FF2B5EF4-FFF2-40B4-BE49-F238E27FC236}">
-                <a16:creationId xmlns:a16="http://schemas.microsoft.com/office/drawing/2014/main" id="{74CF7BC8-4A33-8E2A-819B-7BC81E2ACA84}"/>
+                <a16:creationId xmlns:a16="http://schemas.microsoft.com/office/drawing/2014/main" id="{5450AAFD-EDFF-C3C8-009A-1AC70F7C4BD7}"/>
               </a:ext>
             </a:extLst>
           </p:cNvPr>
@@ -12646,7 +12647,7 @@
           <p:cNvPr id="16" name="Objective divider">
             <a:extLst>
               <a:ext uri="{FF2B5EF4-FFF2-40B4-BE49-F238E27FC236}">
-                <a16:creationId xmlns:a16="http://schemas.microsoft.com/office/drawing/2014/main" id="{D0AE6C22-EF2B-D834-3D09-B2FAA737D4D0}"/>
+                <a16:creationId xmlns:a16="http://schemas.microsoft.com/office/drawing/2014/main" id="{1D354A64-78EF-4F9F-3B8F-543125EC4299}"/>
               </a:ext>
             </a:extLst>
           </p:cNvPr>
@@ -12687,7 +12688,7 @@
           <p:cNvPr id="17" name="Objective index">
             <a:extLst>
               <a:ext uri="{FF2B5EF4-FFF2-40B4-BE49-F238E27FC236}">
-                <a16:creationId xmlns:a16="http://schemas.microsoft.com/office/drawing/2014/main" id="{A0E94BA9-4EDC-BA99-6927-64649BFAAFFA}"/>
+                <a16:creationId xmlns:a16="http://schemas.microsoft.com/office/drawing/2014/main" id="{5C5DF361-CD53-0071-2195-484B99620776}"/>
               </a:ext>
             </a:extLst>
           </p:cNvPr>
@@ -12732,7 +12733,7 @@
           <p:cNvPr id="18" name="Objective">
             <a:extLst>
               <a:ext uri="{FF2B5EF4-FFF2-40B4-BE49-F238E27FC236}">
-                <a16:creationId xmlns:a16="http://schemas.microsoft.com/office/drawing/2014/main" id="{3052EF47-0A26-9AE8-30FD-26734D3E4176}"/>
+                <a16:creationId xmlns:a16="http://schemas.microsoft.com/office/drawing/2014/main" id="{9A6EBACE-D031-807D-4B83-A6B0301294E4}"/>
               </a:ext>
             </a:extLst>
           </p:cNvPr>
@@ -12777,7 +12778,7 @@
           <p:cNvPr id="19" name="Objective detail">
             <a:extLst>
               <a:ext uri="{FF2B5EF4-FFF2-40B4-BE49-F238E27FC236}">
-                <a16:creationId xmlns:a16="http://schemas.microsoft.com/office/drawing/2014/main" id="{F47A198F-B0A5-2E5B-4254-DCAD2BA3A6FA}"/>
+                <a16:creationId xmlns:a16="http://schemas.microsoft.com/office/drawing/2014/main" id="{A9F63596-A27A-FA95-84A5-C8ADD98489DA}"/>
               </a:ext>
             </a:extLst>
           </p:cNvPr>
@@ -12822,7 +12823,7 @@
           <p:cNvPr id="20" name="Objective divider">
             <a:extLst>
               <a:ext uri="{FF2B5EF4-FFF2-40B4-BE49-F238E27FC236}">
-                <a16:creationId xmlns:a16="http://schemas.microsoft.com/office/drawing/2014/main" id="{64A2F3F6-8B3B-5861-09B7-B7307C148C1F}"/>
+                <a16:creationId xmlns:a16="http://schemas.microsoft.com/office/drawing/2014/main" id="{D64ABAB4-5AC0-AC34-763A-E533529E7B26}"/>
               </a:ext>
             </a:extLst>
           </p:cNvPr>
@@ -12863,7 +12864,7 @@
           <p:cNvPr id="21" name="Objective index">
             <a:extLst>
               <a:ext uri="{FF2B5EF4-FFF2-40B4-BE49-F238E27FC236}">
-                <a16:creationId xmlns:a16="http://schemas.microsoft.com/office/drawing/2014/main" id="{72F2C980-55C7-F1F5-8CBB-6566313010B0}"/>
+                <a16:creationId xmlns:a16="http://schemas.microsoft.com/office/drawing/2014/main" id="{21FB28C7-92F5-757D-7D2F-F87413F75ADB}"/>
               </a:ext>
             </a:extLst>
           </p:cNvPr>
@@ -12908,7 +12909,7 @@
           <p:cNvPr id="22" name="Objective">
             <a:extLst>
               <a:ext uri="{FF2B5EF4-FFF2-40B4-BE49-F238E27FC236}">
-                <a16:creationId xmlns:a16="http://schemas.microsoft.com/office/drawing/2014/main" id="{87CC89C0-0383-3629-E5CC-7861975B4AEC}"/>
+                <a16:creationId xmlns:a16="http://schemas.microsoft.com/office/drawing/2014/main" id="{74FBC23F-A2DB-4A09-6EA0-AB05A56E92D6}"/>
               </a:ext>
             </a:extLst>
           </p:cNvPr>
@@ -12953,7 +12954,7 @@
           <p:cNvPr id="23" name="Objective detail">
             <a:extLst>
               <a:ext uri="{FF2B5EF4-FFF2-40B4-BE49-F238E27FC236}">
-                <a16:creationId xmlns:a16="http://schemas.microsoft.com/office/drawing/2014/main" id="{93C1EB64-DF4F-B06E-E67C-B505043C3C58}"/>
+                <a16:creationId xmlns:a16="http://schemas.microsoft.com/office/drawing/2014/main" id="{F9BCE289-D306-9CBD-6DB8-680724E931A8}"/>
               </a:ext>
             </a:extLst>
           </p:cNvPr>
@@ -12996,7 +12997,7 @@
     </p:spTree>
     <p:extLst>
       <p:ext uri="{BB962C8B-B14F-4D97-AF65-F5344CB8AC3E}">
-        <p14:creationId xmlns:p14="http://schemas.microsoft.com/office/powerpoint/2010/main" val="699393665"/>
+        <p14:creationId xmlns:p14="http://schemas.microsoft.com/office/powerpoint/2010/main" val="174996649"/>
       </p:ext>
     </p:extLst>
   </p:cSld>
@@ -13036,7 +13037,7 @@
           <p:cNvPr id="2" name="Section">
             <a:extLst>
               <a:ext uri="{FF2B5EF4-FFF2-40B4-BE49-F238E27FC236}">
-                <a16:creationId xmlns:a16="http://schemas.microsoft.com/office/drawing/2014/main" id="{2E41275C-9E4B-C10C-68DD-41E2D45D175D}"/>
+                <a16:creationId xmlns:a16="http://schemas.microsoft.com/office/drawing/2014/main" id="{01282EB4-7CFB-DD1F-728A-D092EA9301AB}"/>
               </a:ext>
             </a:extLst>
           </p:cNvPr>
@@ -13081,7 +13082,7 @@
           <p:cNvPr id="3" name="Slide title">
             <a:extLst>
               <a:ext uri="{FF2B5EF4-FFF2-40B4-BE49-F238E27FC236}">
-                <a16:creationId xmlns:a16="http://schemas.microsoft.com/office/drawing/2014/main" id="{B6AF7868-ACD9-8A8A-78FE-3A47B3F7C977}"/>
+                <a16:creationId xmlns:a16="http://schemas.microsoft.com/office/drawing/2014/main" id="{EDBDC7F9-AB71-A997-0C5C-126BCCB6FEFD}"/>
               </a:ext>
             </a:extLst>
           </p:cNvPr>
@@ -13126,7 +13127,7 @@
           <p:cNvPr id="4" name="Accent rule">
             <a:extLst>
               <a:ext uri="{FF2B5EF4-FFF2-40B4-BE49-F238E27FC236}">
-                <a16:creationId xmlns:a16="http://schemas.microsoft.com/office/drawing/2014/main" id="{02B8CCF5-E4C1-A42A-B25B-C29F495BB5BC}"/>
+                <a16:creationId xmlns:a16="http://schemas.microsoft.com/office/drawing/2014/main" id="{A151D008-5CBC-AAB5-154E-5009F874CCAB}"/>
               </a:ext>
             </a:extLst>
           </p:cNvPr>
@@ -13167,7 +13168,7 @@
           <p:cNvPr id="5" name="Footer author">
             <a:extLst>
               <a:ext uri="{FF2B5EF4-FFF2-40B4-BE49-F238E27FC236}">
-                <a16:creationId xmlns:a16="http://schemas.microsoft.com/office/drawing/2014/main" id="{B9660DF8-9651-92FD-08F5-8973B355A43B}"/>
+                <a16:creationId xmlns:a16="http://schemas.microsoft.com/office/drawing/2014/main" id="{9887C2F5-19AF-E8C7-4326-D82A30D74304}"/>
               </a:ext>
             </a:extLst>
           </p:cNvPr>
@@ -13212,7 +13213,7 @@
           <p:cNvPr id="6" name="Slide number">
             <a:extLst>
               <a:ext uri="{FF2B5EF4-FFF2-40B4-BE49-F238E27FC236}">
-                <a16:creationId xmlns:a16="http://schemas.microsoft.com/office/drawing/2014/main" id="{FEB6FF0D-7F5E-9A2B-F799-021819EDDBF7}"/>
+                <a16:creationId xmlns:a16="http://schemas.microsoft.com/office/drawing/2014/main" id="{21DD0612-58CC-0451-8154-38CB408AA0A2}"/>
               </a:ext>
             </a:extLst>
           </p:cNvPr>
@@ -13257,7 +13258,7 @@
           <p:cNvPr id="7" name="Browser to web">
             <a:extLst>
               <a:ext uri="{FF2B5EF4-FFF2-40B4-BE49-F238E27FC236}">
-                <a16:creationId xmlns:a16="http://schemas.microsoft.com/office/drawing/2014/main" id="{0504A464-E746-1E5D-66B0-8DF2983DD0A7}"/>
+                <a16:creationId xmlns:a16="http://schemas.microsoft.com/office/drawing/2014/main" id="{52E7113E-D3C3-627B-73B1-04C96574952E}"/>
               </a:ext>
             </a:extLst>
           </p:cNvPr>
@@ -13299,7 +13300,7 @@
           <p:cNvPr id="8" name="Web to backend">
             <a:extLst>
               <a:ext uri="{FF2B5EF4-FFF2-40B4-BE49-F238E27FC236}">
-                <a16:creationId xmlns:a16="http://schemas.microsoft.com/office/drawing/2014/main" id="{1DA21616-3D49-7367-EAA5-861C96287451}"/>
+                <a16:creationId xmlns:a16="http://schemas.microsoft.com/office/drawing/2014/main" id="{E1BE4715-221F-5CC2-C823-318AC91A3804}"/>
               </a:ext>
             </a:extLst>
           </p:cNvPr>
@@ -13341,7 +13342,7 @@
           <p:cNvPr id="9" name="Extension to backend">
             <a:extLst>
               <a:ext uri="{FF2B5EF4-FFF2-40B4-BE49-F238E27FC236}">
-                <a16:creationId xmlns:a16="http://schemas.microsoft.com/office/drawing/2014/main" id="{9B0D730C-1FCF-F796-2CA9-2ED27B116B22}"/>
+                <a16:creationId xmlns:a16="http://schemas.microsoft.com/office/drawing/2014/main" id="{C66CF468-2CB7-8B79-CEC7-12A43F912C32}"/>
               </a:ext>
             </a:extLst>
           </p:cNvPr>
@@ -13383,7 +13384,7 @@
           <p:cNvPr id="10" name="Monitor to backend">
             <a:extLst>
               <a:ext uri="{FF2B5EF4-FFF2-40B4-BE49-F238E27FC236}">
-                <a16:creationId xmlns:a16="http://schemas.microsoft.com/office/drawing/2014/main" id="{15728B0D-869F-1254-C3EC-E4D055F44A19}"/>
+                <a16:creationId xmlns:a16="http://schemas.microsoft.com/office/drawing/2014/main" id="{5AB36BBB-7F4C-C817-5EC3-6BE5458B586D}"/>
               </a:ext>
             </a:extLst>
           </p:cNvPr>
@@ -13425,7 +13426,7 @@
           <p:cNvPr id="11" name="Browser">
             <a:extLst>
               <a:ext uri="{FF2B5EF4-FFF2-40B4-BE49-F238E27FC236}">
-                <a16:creationId xmlns:a16="http://schemas.microsoft.com/office/drawing/2014/main" id="{A70FF2BF-DD2E-A86C-6769-F58C0B185DD1}"/>
+                <a16:creationId xmlns:a16="http://schemas.microsoft.com/office/drawing/2014/main" id="{BF66F511-B5E0-8DCA-3E1D-1474C26863FB}"/>
               </a:ext>
             </a:extLst>
           </p:cNvPr>
@@ -13479,7 +13480,7 @@
           <p:cNvPr id="12" name="Browser title">
             <a:extLst>
               <a:ext uri="{FF2B5EF4-FFF2-40B4-BE49-F238E27FC236}">
-                <a16:creationId xmlns:a16="http://schemas.microsoft.com/office/drawing/2014/main" id="{AB485445-8C65-B87F-CB5C-2628F18A512F}"/>
+                <a16:creationId xmlns:a16="http://schemas.microsoft.com/office/drawing/2014/main" id="{09E22B8C-0404-2381-5FAD-75D20142EE11}"/>
               </a:ext>
             </a:extLst>
           </p:cNvPr>
@@ -13524,7 +13525,7 @@
           <p:cNvPr id="13" name="Browser body">
             <a:extLst>
               <a:ext uri="{FF2B5EF4-FFF2-40B4-BE49-F238E27FC236}">
-                <a16:creationId xmlns:a16="http://schemas.microsoft.com/office/drawing/2014/main" id="{2EDBFCE8-A08E-6955-5C7D-0290CC3D1C72}"/>
+                <a16:creationId xmlns:a16="http://schemas.microsoft.com/office/drawing/2014/main" id="{965D824D-B024-8DFD-7AC3-786426453937}"/>
               </a:ext>
             </a:extLst>
           </p:cNvPr>
@@ -13569,7 +13570,7 @@
           <p:cNvPr id="14" name="Streamlit">
             <a:extLst>
               <a:ext uri="{FF2B5EF4-FFF2-40B4-BE49-F238E27FC236}">
-                <a16:creationId xmlns:a16="http://schemas.microsoft.com/office/drawing/2014/main" id="{4BA9F7A5-EA6E-796F-5821-81E332931D6D}"/>
+                <a16:creationId xmlns:a16="http://schemas.microsoft.com/office/drawing/2014/main" id="{DA3125ED-A024-D2FA-8659-6F2C79CFD7D3}"/>
               </a:ext>
             </a:extLst>
           </p:cNvPr>
@@ -13623,7 +13624,7 @@
           <p:cNvPr id="15" name="Streamlit title">
             <a:extLst>
               <a:ext uri="{FF2B5EF4-FFF2-40B4-BE49-F238E27FC236}">
-                <a16:creationId xmlns:a16="http://schemas.microsoft.com/office/drawing/2014/main" id="{8E768849-0822-84CA-7DCA-20805FCE3B71}"/>
+                <a16:creationId xmlns:a16="http://schemas.microsoft.com/office/drawing/2014/main" id="{FF15C288-6C39-995F-42E4-E9D7576E7D93}"/>
               </a:ext>
             </a:extLst>
           </p:cNvPr>
@@ -13668,7 +13669,7 @@
           <p:cNvPr id="16" name="Streamlit body">
             <a:extLst>
               <a:ext uri="{FF2B5EF4-FFF2-40B4-BE49-F238E27FC236}">
-                <a16:creationId xmlns:a16="http://schemas.microsoft.com/office/drawing/2014/main" id="{86F912DA-8245-9883-E3AF-E6A3E0277D89}"/>
+                <a16:creationId xmlns:a16="http://schemas.microsoft.com/office/drawing/2014/main" id="{33E48DE7-6C1B-50D1-CA67-10A75F4E488B}"/>
               </a:ext>
             </a:extLst>
           </p:cNvPr>
@@ -13713,7 +13714,7 @@
           <p:cNvPr id="17" name="Extension">
             <a:extLst>
               <a:ext uri="{FF2B5EF4-FFF2-40B4-BE49-F238E27FC236}">
-                <a16:creationId xmlns:a16="http://schemas.microsoft.com/office/drawing/2014/main" id="{5ED47F8C-7EEE-FC22-91A2-50C4CF9A78A6}"/>
+                <a16:creationId xmlns:a16="http://schemas.microsoft.com/office/drawing/2014/main" id="{D398F88F-C60D-BF6C-C704-B4234481C75C}"/>
               </a:ext>
             </a:extLst>
           </p:cNvPr>
@@ -13767,7 +13768,7 @@
           <p:cNvPr id="18" name="Extension title">
             <a:extLst>
               <a:ext uri="{FF2B5EF4-FFF2-40B4-BE49-F238E27FC236}">
-                <a16:creationId xmlns:a16="http://schemas.microsoft.com/office/drawing/2014/main" id="{4C138AF6-7AC6-024D-CF8C-2ACE62E67B1E}"/>
+                <a16:creationId xmlns:a16="http://schemas.microsoft.com/office/drawing/2014/main" id="{546FC7A0-5DBE-C84C-AE97-AD483D1B9BDF}"/>
               </a:ext>
             </a:extLst>
           </p:cNvPr>
@@ -13812,7 +13813,7 @@
           <p:cNvPr id="19" name="Extension body">
             <a:extLst>
               <a:ext uri="{FF2B5EF4-FFF2-40B4-BE49-F238E27FC236}">
-                <a16:creationId xmlns:a16="http://schemas.microsoft.com/office/drawing/2014/main" id="{4D06F6B0-BDFD-D1E2-70DC-DA9B24F09EB4}"/>
+                <a16:creationId xmlns:a16="http://schemas.microsoft.com/office/drawing/2014/main" id="{98267644-82C9-3D5E-7CAB-543A9363FB94}"/>
               </a:ext>
             </a:extLst>
           </p:cNvPr>
@@ -13857,7 +13858,7 @@
           <p:cNvPr id="20" name="Monitor">
             <a:extLst>
               <a:ext uri="{FF2B5EF4-FFF2-40B4-BE49-F238E27FC236}">
-                <a16:creationId xmlns:a16="http://schemas.microsoft.com/office/drawing/2014/main" id="{E1052369-FEDE-ECEA-ABE6-4464B4F85A71}"/>
+                <a16:creationId xmlns:a16="http://schemas.microsoft.com/office/drawing/2014/main" id="{BB1EB741-F019-F4CF-B111-5B175A6A4F1D}"/>
               </a:ext>
             </a:extLst>
           </p:cNvPr>
@@ -13911,7 +13912,7 @@
           <p:cNvPr id="21" name="Monitor title">
             <a:extLst>
               <a:ext uri="{FF2B5EF4-FFF2-40B4-BE49-F238E27FC236}">
-                <a16:creationId xmlns:a16="http://schemas.microsoft.com/office/drawing/2014/main" id="{4CFCABB5-4C66-26DE-1875-85F832832199}"/>
+                <a16:creationId xmlns:a16="http://schemas.microsoft.com/office/drawing/2014/main" id="{6DC6E016-49E7-E370-7413-A2C8D7250AD8}"/>
               </a:ext>
             </a:extLst>
           </p:cNvPr>
@@ -13956,7 +13957,7 @@
           <p:cNvPr id="22" name="Monitor body">
             <a:extLst>
               <a:ext uri="{FF2B5EF4-FFF2-40B4-BE49-F238E27FC236}">
-                <a16:creationId xmlns:a16="http://schemas.microsoft.com/office/drawing/2014/main" id="{3106C830-9D84-6168-8947-8966B481DBB9}"/>
+                <a16:creationId xmlns:a16="http://schemas.microsoft.com/office/drawing/2014/main" id="{A88DC26B-6BAD-D6B2-3DB5-9223124E229E}"/>
               </a:ext>
             </a:extLst>
           </p:cNvPr>
@@ -14001,7 +14002,7 @@
           <p:cNvPr id="23" name="Backend central">
             <a:extLst>
               <a:ext uri="{FF2B5EF4-FFF2-40B4-BE49-F238E27FC236}">
-                <a16:creationId xmlns:a16="http://schemas.microsoft.com/office/drawing/2014/main" id="{B4FAF8EE-FA5D-DCD2-6F00-1C9B3BC04149}"/>
+                <a16:creationId xmlns:a16="http://schemas.microsoft.com/office/drawing/2014/main" id="{6B9833D1-07CE-52DD-76BA-2406D8B13FA9}"/>
               </a:ext>
             </a:extLst>
           </p:cNvPr>
@@ -14069,7 +14070,7 @@
           <p:cNvPr id="24" name="Backend title">
             <a:extLst>
               <a:ext uri="{FF2B5EF4-FFF2-40B4-BE49-F238E27FC236}">
-                <a16:creationId xmlns:a16="http://schemas.microsoft.com/office/drawing/2014/main" id="{190B08A2-848E-2A6A-4B7B-EE9009AF0433}"/>
+                <a16:creationId xmlns:a16="http://schemas.microsoft.com/office/drawing/2014/main" id="{28C54ABF-EEB5-E734-79A1-5B4296BC7CE7}"/>
               </a:ext>
             </a:extLst>
           </p:cNvPr>
@@ -14114,7 +14115,7 @@
           <p:cNvPr id="25" name="Backend contents">
             <a:extLst>
               <a:ext uri="{FF2B5EF4-FFF2-40B4-BE49-F238E27FC236}">
-                <a16:creationId xmlns:a16="http://schemas.microsoft.com/office/drawing/2014/main" id="{4E4A4DF3-4914-8303-074A-3BC8AF01CB08}"/>
+                <a16:creationId xmlns:a16="http://schemas.microsoft.com/office/drawing/2014/main" id="{9A10B739-FADB-3AC2-8709-B44AED1EAC5B}"/>
               </a:ext>
             </a:extLst>
           </p:cNvPr>
@@ -14163,7 +14164,7 @@
           <p:cNvPr id="26" name="Protocol">
             <a:extLst>
               <a:ext uri="{FF2B5EF4-FFF2-40B4-BE49-F238E27FC236}">
-                <a16:creationId xmlns:a16="http://schemas.microsoft.com/office/drawing/2014/main" id="{E3809D6C-9C94-AE72-07F7-BA9DF28E81EB}"/>
+                <a16:creationId xmlns:a16="http://schemas.microsoft.com/office/drawing/2014/main" id="{2627FC65-43B2-DB01-B706-190089526B67}"/>
               </a:ext>
             </a:extLst>
           </p:cNvPr>
@@ -14208,7 +14209,7 @@
           <p:cNvPr id="27" name="Architecture note">
             <a:extLst>
               <a:ext uri="{FF2B5EF4-FFF2-40B4-BE49-F238E27FC236}">
-                <a16:creationId xmlns:a16="http://schemas.microsoft.com/office/drawing/2014/main" id="{4134A1BD-B508-86DB-6D5E-65A8CCD553FB}"/>
+                <a16:creationId xmlns:a16="http://schemas.microsoft.com/office/drawing/2014/main" id="{D02D1D62-8E62-EDCE-86AA-C1649A9AE5AD}"/>
               </a:ext>
             </a:extLst>
           </p:cNvPr>
@@ -14251,7 +14252,7 @@
     </p:spTree>
     <p:extLst>
       <p:ext uri="{BB962C8B-B14F-4D97-AF65-F5344CB8AC3E}">
-        <p14:creationId xmlns:p14="http://schemas.microsoft.com/office/powerpoint/2010/main" val="2490584209"/>
+        <p14:creationId xmlns:p14="http://schemas.microsoft.com/office/powerpoint/2010/main" val="1349258554"/>
       </p:ext>
     </p:extLst>
   </p:cSld>
@@ -14291,7 +14292,7 @@
           <p:cNvPr id="2" name="Section">
             <a:extLst>
               <a:ext uri="{FF2B5EF4-FFF2-40B4-BE49-F238E27FC236}">
-                <a16:creationId xmlns:a16="http://schemas.microsoft.com/office/drawing/2014/main" id="{466F4DAE-6965-2085-05B7-665C2CA47FB3}"/>
+                <a16:creationId xmlns:a16="http://schemas.microsoft.com/office/drawing/2014/main" id="{695371FE-FC7C-CC17-B40F-057336B0D9D2}"/>
               </a:ext>
             </a:extLst>
           </p:cNvPr>
@@ -14336,7 +14337,7 @@
           <p:cNvPr id="3" name="Slide title">
             <a:extLst>
               <a:ext uri="{FF2B5EF4-FFF2-40B4-BE49-F238E27FC236}">
-                <a16:creationId xmlns:a16="http://schemas.microsoft.com/office/drawing/2014/main" id="{F07204E6-B6F7-E3E1-DB12-9F3447EC0DE5}"/>
+                <a16:creationId xmlns:a16="http://schemas.microsoft.com/office/drawing/2014/main" id="{755F3470-C7E0-2190-7826-BABECCE6F4F2}"/>
               </a:ext>
             </a:extLst>
           </p:cNvPr>
@@ -14381,7 +14382,7 @@
           <p:cNvPr id="4" name="Accent rule">
             <a:extLst>
               <a:ext uri="{FF2B5EF4-FFF2-40B4-BE49-F238E27FC236}">
-                <a16:creationId xmlns:a16="http://schemas.microsoft.com/office/drawing/2014/main" id="{350B9602-1102-C782-29E0-10AFFCF238DB}"/>
+                <a16:creationId xmlns:a16="http://schemas.microsoft.com/office/drawing/2014/main" id="{AA31563F-7FFF-6B1B-7F3B-EF113FD69496}"/>
               </a:ext>
             </a:extLst>
           </p:cNvPr>
@@ -14422,7 +14423,7 @@
           <p:cNvPr id="5" name="Footer author">
             <a:extLst>
               <a:ext uri="{FF2B5EF4-FFF2-40B4-BE49-F238E27FC236}">
-                <a16:creationId xmlns:a16="http://schemas.microsoft.com/office/drawing/2014/main" id="{EA169DE2-838B-F169-13D8-11112B5AA438}"/>
+                <a16:creationId xmlns:a16="http://schemas.microsoft.com/office/drawing/2014/main" id="{FDAFAF4B-3CEA-D0B6-B92D-C8C3656D9FB8}"/>
               </a:ext>
             </a:extLst>
           </p:cNvPr>
@@ -14467,7 +14468,7 @@
           <p:cNvPr id="6" name="Slide number">
             <a:extLst>
               <a:ext uri="{FF2B5EF4-FFF2-40B4-BE49-F238E27FC236}">
-                <a16:creationId xmlns:a16="http://schemas.microsoft.com/office/drawing/2014/main" id="{59C60BCE-8471-3783-3B9B-14598AB32516}"/>
+                <a16:creationId xmlns:a16="http://schemas.microsoft.com/office/drawing/2014/main" id="{0F222151-2522-E5DD-901C-7A06587FA967}"/>
               </a:ext>
             </a:extLst>
           </p:cNvPr>
@@ -14512,7 +14513,7 @@
           <p:cNvPr id="7" name="Flow arrow 0">
             <a:extLst>
               <a:ext uri="{FF2B5EF4-FFF2-40B4-BE49-F238E27FC236}">
-                <a16:creationId xmlns:a16="http://schemas.microsoft.com/office/drawing/2014/main" id="{782344CA-9CE5-728C-0351-2820976B1E34}"/>
+                <a16:creationId xmlns:a16="http://schemas.microsoft.com/office/drawing/2014/main" id="{7E685763-9B7A-EBB2-4957-DCFF17B5ECD9}"/>
               </a:ext>
             </a:extLst>
           </p:cNvPr>
@@ -14554,7 +14555,7 @@
           <p:cNvPr id="8" name="Flow arrow 1">
             <a:extLst>
               <a:ext uri="{FF2B5EF4-FFF2-40B4-BE49-F238E27FC236}">
-                <a16:creationId xmlns:a16="http://schemas.microsoft.com/office/drawing/2014/main" id="{99E9BEFA-3853-F14E-2967-771115D20719}"/>
+                <a16:creationId xmlns:a16="http://schemas.microsoft.com/office/drawing/2014/main" id="{2D47D1E2-F968-3263-6D14-C265FF0D0B9D}"/>
               </a:ext>
             </a:extLst>
           </p:cNvPr>
@@ -14596,7 +14597,7 @@
           <p:cNvPr id="9" name="Flow arrow 2">
             <a:extLst>
               <a:ext uri="{FF2B5EF4-FFF2-40B4-BE49-F238E27FC236}">
-                <a16:creationId xmlns:a16="http://schemas.microsoft.com/office/drawing/2014/main" id="{4B9F8D7F-65E8-C038-7AB8-1989CC5048C6}"/>
+                <a16:creationId xmlns:a16="http://schemas.microsoft.com/office/drawing/2014/main" id="{5ADA03BA-8515-98F2-377C-39F2D4C466B5}"/>
               </a:ext>
             </a:extLst>
           </p:cNvPr>
@@ -14638,7 +14639,7 @@
           <p:cNvPr id="10" name="Flow arrow 3">
             <a:extLst>
               <a:ext uri="{FF2B5EF4-FFF2-40B4-BE49-F238E27FC236}">
-                <a16:creationId xmlns:a16="http://schemas.microsoft.com/office/drawing/2014/main" id="{E2B971FB-624B-C26A-7385-9CCE73662497}"/>
+                <a16:creationId xmlns:a16="http://schemas.microsoft.com/office/drawing/2014/main" id="{FB2FD5D5-ADA1-7DA2-F294-1F66FF4F83E6}"/>
               </a:ext>
             </a:extLst>
           </p:cNvPr>
@@ -14680,7 +14681,7 @@
           <p:cNvPr id="11" name="Flow node 0">
             <a:extLst>
               <a:ext uri="{FF2B5EF4-FFF2-40B4-BE49-F238E27FC236}">
-                <a16:creationId xmlns:a16="http://schemas.microsoft.com/office/drawing/2014/main" id="{9473CB50-7B2F-D3F2-C88F-61230C4FAF28}"/>
+                <a16:creationId xmlns:a16="http://schemas.microsoft.com/office/drawing/2014/main" id="{F3CD2709-112D-AAED-09BD-F080619D09A5}"/>
               </a:ext>
             </a:extLst>
           </p:cNvPr>
@@ -14748,7 +14749,7 @@
           <p:cNvPr id="12" name="Flow number">
             <a:extLst>
               <a:ext uri="{FF2B5EF4-FFF2-40B4-BE49-F238E27FC236}">
-                <a16:creationId xmlns:a16="http://schemas.microsoft.com/office/drawing/2014/main" id="{4EB1A3E8-38C5-3D93-03FA-4D6F9A84CC9A}"/>
+                <a16:creationId xmlns:a16="http://schemas.microsoft.com/office/drawing/2014/main" id="{F119DD92-144F-1225-CDA8-F96668EB533D}"/>
               </a:ext>
             </a:extLst>
           </p:cNvPr>
@@ -14793,7 +14794,7 @@
           <p:cNvPr id="13" name="Flow title">
             <a:extLst>
               <a:ext uri="{FF2B5EF4-FFF2-40B4-BE49-F238E27FC236}">
-                <a16:creationId xmlns:a16="http://schemas.microsoft.com/office/drawing/2014/main" id="{E02F5C4F-C9EF-98BC-6B44-2074F2B15316}"/>
+                <a16:creationId xmlns:a16="http://schemas.microsoft.com/office/drawing/2014/main" id="{45B30140-8F9C-ADED-213C-86D9DA4C57FE}"/>
               </a:ext>
             </a:extLst>
           </p:cNvPr>
@@ -14838,7 +14839,7 @@
           <p:cNvPr id="14" name="Flow detail">
             <a:extLst>
               <a:ext uri="{FF2B5EF4-FFF2-40B4-BE49-F238E27FC236}">
-                <a16:creationId xmlns:a16="http://schemas.microsoft.com/office/drawing/2014/main" id="{989E0B2A-4382-4E5D-6994-B8C7C8A472A2}"/>
+                <a16:creationId xmlns:a16="http://schemas.microsoft.com/office/drawing/2014/main" id="{BDB45368-354D-2286-1CEA-CC190D0BC5D2}"/>
               </a:ext>
             </a:extLst>
           </p:cNvPr>
@@ -14889,7 +14890,7 @@
           <p:cNvPr id="15" name="Flow node 1">
             <a:extLst>
               <a:ext uri="{FF2B5EF4-FFF2-40B4-BE49-F238E27FC236}">
-                <a16:creationId xmlns:a16="http://schemas.microsoft.com/office/drawing/2014/main" id="{D8701D28-290E-9E81-A8A9-E9D1C77D63CC}"/>
+                <a16:creationId xmlns:a16="http://schemas.microsoft.com/office/drawing/2014/main" id="{91F82242-6FCB-9B7B-3116-0420829088D7}"/>
               </a:ext>
             </a:extLst>
           </p:cNvPr>
@@ -14957,7 +14958,7 @@
           <p:cNvPr id="16" name="Flow number">
             <a:extLst>
               <a:ext uri="{FF2B5EF4-FFF2-40B4-BE49-F238E27FC236}">
-                <a16:creationId xmlns:a16="http://schemas.microsoft.com/office/drawing/2014/main" id="{1DD05CAC-A690-FC13-E138-5E3EAEDA4BA4}"/>
+                <a16:creationId xmlns:a16="http://schemas.microsoft.com/office/drawing/2014/main" id="{2E6B8507-3E90-953D-6F99-4EA5417E35B1}"/>
               </a:ext>
             </a:extLst>
           </p:cNvPr>
@@ -15002,7 +15003,7 @@
           <p:cNvPr id="17" name="Flow title">
             <a:extLst>
               <a:ext uri="{FF2B5EF4-FFF2-40B4-BE49-F238E27FC236}">
-                <a16:creationId xmlns:a16="http://schemas.microsoft.com/office/drawing/2014/main" id="{FAEBF1D3-D8A1-71BD-FF0A-97E41A4F0A8A}"/>
+                <a16:creationId xmlns:a16="http://schemas.microsoft.com/office/drawing/2014/main" id="{DB9E837E-6293-6453-B217-E034AE933DA5}"/>
               </a:ext>
             </a:extLst>
           </p:cNvPr>
@@ -15047,7 +15048,7 @@
           <p:cNvPr id="18" name="Flow detail">
             <a:extLst>
               <a:ext uri="{FF2B5EF4-FFF2-40B4-BE49-F238E27FC236}">
-                <a16:creationId xmlns:a16="http://schemas.microsoft.com/office/drawing/2014/main" id="{F3F4524E-17E4-3D18-38BE-BE2158DE6AB2}"/>
+                <a16:creationId xmlns:a16="http://schemas.microsoft.com/office/drawing/2014/main" id="{CE166610-169D-9FCB-5945-852946F11E02}"/>
               </a:ext>
             </a:extLst>
           </p:cNvPr>
@@ -15092,7 +15093,7 @@
           <p:cNvPr id="19" name="Flow node 2">
             <a:extLst>
               <a:ext uri="{FF2B5EF4-FFF2-40B4-BE49-F238E27FC236}">
-                <a16:creationId xmlns:a16="http://schemas.microsoft.com/office/drawing/2014/main" id="{D9A622B3-2F5E-327D-AC68-6BBF18F7AECF}"/>
+                <a16:creationId xmlns:a16="http://schemas.microsoft.com/office/drawing/2014/main" id="{624471FB-A4B2-0FCA-6490-2849B0AF55B4}"/>
               </a:ext>
             </a:extLst>
           </p:cNvPr>
@@ -15160,7 +15161,7 @@
           <p:cNvPr id="20" name="Flow number">
             <a:extLst>
               <a:ext uri="{FF2B5EF4-FFF2-40B4-BE49-F238E27FC236}">
-                <a16:creationId xmlns:a16="http://schemas.microsoft.com/office/drawing/2014/main" id="{690B8E73-0D20-4431-052A-EBA1958B1223}"/>
+                <a16:creationId xmlns:a16="http://schemas.microsoft.com/office/drawing/2014/main" id="{337E2CFB-C0D6-2C6A-2C7E-90485CB95483}"/>
               </a:ext>
             </a:extLst>
           </p:cNvPr>
@@ -15205,7 +15206,7 @@
           <p:cNvPr id="21" name="Flow title">
             <a:extLst>
               <a:ext uri="{FF2B5EF4-FFF2-40B4-BE49-F238E27FC236}">
-                <a16:creationId xmlns:a16="http://schemas.microsoft.com/office/drawing/2014/main" id="{7480637C-BD9F-6ABB-801D-13C76D30C11E}"/>
+                <a16:creationId xmlns:a16="http://schemas.microsoft.com/office/drawing/2014/main" id="{3D313CD6-A3CF-580B-C928-BBCD395AEAB2}"/>
               </a:ext>
             </a:extLst>
           </p:cNvPr>
@@ -15250,7 +15251,7 @@
           <p:cNvPr id="22" name="Flow detail">
             <a:extLst>
               <a:ext uri="{FF2B5EF4-FFF2-40B4-BE49-F238E27FC236}">
-                <a16:creationId xmlns:a16="http://schemas.microsoft.com/office/drawing/2014/main" id="{74AABB22-41DF-E7FA-A2F8-AF74713FB1C2}"/>
+                <a16:creationId xmlns:a16="http://schemas.microsoft.com/office/drawing/2014/main" id="{B9FE6254-E693-33A1-4BAD-8E4E3068AFF4}"/>
               </a:ext>
             </a:extLst>
           </p:cNvPr>
@@ -15295,7 +15296,7 @@
           <p:cNvPr id="23" name="Flow node 3">
             <a:extLst>
               <a:ext uri="{FF2B5EF4-FFF2-40B4-BE49-F238E27FC236}">
-                <a16:creationId xmlns:a16="http://schemas.microsoft.com/office/drawing/2014/main" id="{76D9F1B9-8023-6E44-7811-3780370B0249}"/>
+                <a16:creationId xmlns:a16="http://schemas.microsoft.com/office/drawing/2014/main" id="{2EE552D0-20E8-1B5B-5EF4-827AACFD77C5}"/>
               </a:ext>
             </a:extLst>
           </p:cNvPr>
@@ -15363,7 +15364,7 @@
           <p:cNvPr id="24" name="Flow number">
             <a:extLst>
               <a:ext uri="{FF2B5EF4-FFF2-40B4-BE49-F238E27FC236}">
-                <a16:creationId xmlns:a16="http://schemas.microsoft.com/office/drawing/2014/main" id="{E75E48B7-BACA-DEA2-9C21-DF9FC7BB1864}"/>
+                <a16:creationId xmlns:a16="http://schemas.microsoft.com/office/drawing/2014/main" id="{5F96225E-7D66-65B0-2C49-03B03A034B73}"/>
               </a:ext>
             </a:extLst>
           </p:cNvPr>
@@ -15408,7 +15409,7 @@
           <p:cNvPr id="25" name="Flow title">
             <a:extLst>
               <a:ext uri="{FF2B5EF4-FFF2-40B4-BE49-F238E27FC236}">
-                <a16:creationId xmlns:a16="http://schemas.microsoft.com/office/drawing/2014/main" id="{662A8C1B-7B65-B965-7E63-71B5CCF91D4D}"/>
+                <a16:creationId xmlns:a16="http://schemas.microsoft.com/office/drawing/2014/main" id="{9AB67BA3-A1EE-5F05-FDBC-F593FCB37EEB}"/>
               </a:ext>
             </a:extLst>
           </p:cNvPr>
@@ -15453,7 +15454,7 @@
           <p:cNvPr id="26" name="Flow detail">
             <a:extLst>
               <a:ext uri="{FF2B5EF4-FFF2-40B4-BE49-F238E27FC236}">
-                <a16:creationId xmlns:a16="http://schemas.microsoft.com/office/drawing/2014/main" id="{FA976926-6CCE-5B47-43A6-AE114E4FCB08}"/>
+                <a16:creationId xmlns:a16="http://schemas.microsoft.com/office/drawing/2014/main" id="{79FE645F-0CDB-D8D9-4906-4F77920A771E}"/>
               </a:ext>
             </a:extLst>
           </p:cNvPr>
@@ -15498,7 +15499,7 @@
           <p:cNvPr id="27" name="Flow node 4">
             <a:extLst>
               <a:ext uri="{FF2B5EF4-FFF2-40B4-BE49-F238E27FC236}">
-                <a16:creationId xmlns:a16="http://schemas.microsoft.com/office/drawing/2014/main" id="{22702FDF-8877-D442-3512-8B8DDBDDD050}"/>
+                <a16:creationId xmlns:a16="http://schemas.microsoft.com/office/drawing/2014/main" id="{0CD0B705-5B35-97D6-32DE-84FBA6579860}"/>
               </a:ext>
             </a:extLst>
           </p:cNvPr>
@@ -15566,7 +15567,7 @@
           <p:cNvPr id="28" name="Flow number">
             <a:extLst>
               <a:ext uri="{FF2B5EF4-FFF2-40B4-BE49-F238E27FC236}">
-                <a16:creationId xmlns:a16="http://schemas.microsoft.com/office/drawing/2014/main" id="{2850F1C4-7347-3496-7BF0-354C3B6FFE40}"/>
+                <a16:creationId xmlns:a16="http://schemas.microsoft.com/office/drawing/2014/main" id="{3CC311FF-4FC7-D6BB-0FB1-761EE4717C40}"/>
               </a:ext>
             </a:extLst>
           </p:cNvPr>
@@ -15611,7 +15612,7 @@
           <p:cNvPr id="29" name="Flow title">
             <a:extLst>
               <a:ext uri="{FF2B5EF4-FFF2-40B4-BE49-F238E27FC236}">
-                <a16:creationId xmlns:a16="http://schemas.microsoft.com/office/drawing/2014/main" id="{873CEC8A-FC79-685F-CC25-3B93D7231BCF}"/>
+                <a16:creationId xmlns:a16="http://schemas.microsoft.com/office/drawing/2014/main" id="{82678DE3-E380-E1F1-F0A2-E2C556032FF0}"/>
               </a:ext>
             </a:extLst>
           </p:cNvPr>
@@ -15656,7 +15657,7 @@
           <p:cNvPr id="30" name="Flow detail">
             <a:extLst>
               <a:ext uri="{FF2B5EF4-FFF2-40B4-BE49-F238E27FC236}">
-                <a16:creationId xmlns:a16="http://schemas.microsoft.com/office/drawing/2014/main" id="{AF9AE51D-7E2F-5313-FB78-858E49D655A0}"/>
+                <a16:creationId xmlns:a16="http://schemas.microsoft.com/office/drawing/2014/main" id="{235E21FF-A2CD-15F4-C759-3494561842E8}"/>
               </a:ext>
             </a:extLst>
           </p:cNvPr>
@@ -15701,7 +15702,7 @@
           <p:cNvPr id="31" name="Flow takeaway">
             <a:extLst>
               <a:ext uri="{FF2B5EF4-FFF2-40B4-BE49-F238E27FC236}">
-                <a16:creationId xmlns:a16="http://schemas.microsoft.com/office/drawing/2014/main" id="{D579FA04-5A21-2574-E654-A595BDE37A66}"/>
+                <a16:creationId xmlns:a16="http://schemas.microsoft.com/office/drawing/2014/main" id="{365369D1-A73C-90FA-87E2-3500AFFCB9AF}"/>
               </a:ext>
             </a:extLst>
           </p:cNvPr>
@@ -15744,7 +15745,7 @@
     </p:spTree>
     <p:extLst>
       <p:ext uri="{BB962C8B-B14F-4D97-AF65-F5344CB8AC3E}">
-        <p14:creationId xmlns:p14="http://schemas.microsoft.com/office/powerpoint/2010/main" val="1768435730"/>
+        <p14:creationId xmlns:p14="http://schemas.microsoft.com/office/powerpoint/2010/main" val="2784817978"/>
       </p:ext>
     </p:extLst>
   </p:cSld>
@@ -15784,7 +15785,7 @@
           <p:cNvPr id="2" name="Section">
             <a:extLst>
               <a:ext uri="{FF2B5EF4-FFF2-40B4-BE49-F238E27FC236}">
-                <a16:creationId xmlns:a16="http://schemas.microsoft.com/office/drawing/2014/main" id="{BE1B822E-EF22-F419-6248-7C1A68330BA6}"/>
+                <a16:creationId xmlns:a16="http://schemas.microsoft.com/office/drawing/2014/main" id="{1C408FDB-6EBD-2FAA-D43D-0E83BB35AE52}"/>
               </a:ext>
             </a:extLst>
           </p:cNvPr>
@@ -15829,7 +15830,7 @@
           <p:cNvPr id="3" name="Slide title">
             <a:extLst>
               <a:ext uri="{FF2B5EF4-FFF2-40B4-BE49-F238E27FC236}">
-                <a16:creationId xmlns:a16="http://schemas.microsoft.com/office/drawing/2014/main" id="{247B7FFD-B610-5219-A5F6-8FC1E051AECC}"/>
+                <a16:creationId xmlns:a16="http://schemas.microsoft.com/office/drawing/2014/main" id="{738B6BFE-F89E-8A4B-C6C9-F5A4CF7586BE}"/>
               </a:ext>
             </a:extLst>
           </p:cNvPr>
@@ -15874,7 +15875,7 @@
           <p:cNvPr id="4" name="Accent rule">
             <a:extLst>
               <a:ext uri="{FF2B5EF4-FFF2-40B4-BE49-F238E27FC236}">
-                <a16:creationId xmlns:a16="http://schemas.microsoft.com/office/drawing/2014/main" id="{58A37781-8EE9-680A-0006-4B52ECCE6F7E}"/>
+                <a16:creationId xmlns:a16="http://schemas.microsoft.com/office/drawing/2014/main" id="{C443A20D-3FB1-0E58-6BF6-3471BD0CFB69}"/>
               </a:ext>
             </a:extLst>
           </p:cNvPr>
@@ -15915,7 +15916,7 @@
           <p:cNvPr id="5" name="Footer author">
             <a:extLst>
               <a:ext uri="{FF2B5EF4-FFF2-40B4-BE49-F238E27FC236}">
-                <a16:creationId xmlns:a16="http://schemas.microsoft.com/office/drawing/2014/main" id="{575C4859-3976-C001-B5EF-FC4E407C1B77}"/>
+                <a16:creationId xmlns:a16="http://schemas.microsoft.com/office/drawing/2014/main" id="{BFA88040-84F8-293A-9515-BFE6773DB8F4}"/>
               </a:ext>
             </a:extLst>
           </p:cNvPr>
@@ -15960,7 +15961,7 @@
           <p:cNvPr id="6" name="Slide number">
             <a:extLst>
               <a:ext uri="{FF2B5EF4-FFF2-40B4-BE49-F238E27FC236}">
-                <a16:creationId xmlns:a16="http://schemas.microsoft.com/office/drawing/2014/main" id="{EA46486F-CAD1-24F8-8B33-7391CF64A349}"/>
+                <a16:creationId xmlns:a16="http://schemas.microsoft.com/office/drawing/2014/main" id="{A0EC5276-8A83-53E1-7FB7-DB256156F444}"/>
               </a:ext>
             </a:extLst>
           </p:cNvPr>
@@ -16005,7 +16006,7 @@
           <p:cNvPr id="7" name="Heuristic label">
             <a:extLst>
               <a:ext uri="{FF2B5EF4-FFF2-40B4-BE49-F238E27FC236}">
-                <a16:creationId xmlns:a16="http://schemas.microsoft.com/office/drawing/2014/main" id="{B40DB686-7793-1835-CF78-8572F14B9634}"/>
+                <a16:creationId xmlns:a16="http://schemas.microsoft.com/office/drawing/2014/main" id="{93D67275-0874-B482-5BED-7CF0DFD08E74}"/>
               </a:ext>
             </a:extLst>
           </p:cNvPr>
@@ -16050,7 +16051,7 @@
           <p:cNvPr id="8" name="Heuristic title">
             <a:extLst>
               <a:ext uri="{FF2B5EF4-FFF2-40B4-BE49-F238E27FC236}">
-                <a16:creationId xmlns:a16="http://schemas.microsoft.com/office/drawing/2014/main" id="{A5956D05-E23E-A113-55FB-3025297BEAA9}"/>
+                <a16:creationId xmlns:a16="http://schemas.microsoft.com/office/drawing/2014/main" id="{3E6B61F1-1418-04AB-0905-BECD411952B5}"/>
               </a:ext>
             </a:extLst>
           </p:cNvPr>
@@ -16095,7 +16096,7 @@
           <p:cNvPr id="9" name="Heuristic list">
             <a:extLst>
               <a:ext uri="{FF2B5EF4-FFF2-40B4-BE49-F238E27FC236}">
-                <a16:creationId xmlns:a16="http://schemas.microsoft.com/office/drawing/2014/main" id="{2A2417A5-BF17-337E-00D5-06CAA8FE0A09}"/>
+                <a16:creationId xmlns:a16="http://schemas.microsoft.com/office/drawing/2014/main" id="{AC512D70-837A-9D13-663B-0F1FC2D2DFD7}"/>
               </a:ext>
             </a:extLst>
           </p:cNvPr>
@@ -16130,7 +16131,7 @@
                 </a:solidFill>
                 <a:latin typeface="Arial" panose="020B0604020202020204" pitchFamily="34" charset="0"/>
               </a:rPr>
-              <a:t>Autenticación SPF/DKIM/DMARC
+              <a:t>Lectura pasiva de SPF/DKIM/DMARC en cabeceras
 Remitente, dominio y URLs
 HTML, adjuntos y redirecciones
 Urgencia, credenciales y BEC</a:t>
@@ -16143,7 +16144,7 @@
           <p:cNvPr id="10" name="Detector divider">
             <a:extLst>
               <a:ext uri="{FF2B5EF4-FFF2-40B4-BE49-F238E27FC236}">
-                <a16:creationId xmlns:a16="http://schemas.microsoft.com/office/drawing/2014/main" id="{8084447B-21B5-96D7-6088-7FAE63E2F91D}"/>
+                <a16:creationId xmlns:a16="http://schemas.microsoft.com/office/drawing/2014/main" id="{AE51C9BA-6066-13D1-F2AB-770E0CAC1009}"/>
               </a:ext>
             </a:extLst>
           </p:cNvPr>
@@ -16184,7 +16185,7 @@
           <p:cNvPr id="11" name="Neural label">
             <a:extLst>
               <a:ext uri="{FF2B5EF4-FFF2-40B4-BE49-F238E27FC236}">
-                <a16:creationId xmlns:a16="http://schemas.microsoft.com/office/drawing/2014/main" id="{284B2765-7ABA-421E-0F36-14192B5A7AD5}"/>
+                <a16:creationId xmlns:a16="http://schemas.microsoft.com/office/drawing/2014/main" id="{91AA6548-D264-24AF-9BA4-AB1567D80C9D}"/>
               </a:ext>
             </a:extLst>
           </p:cNvPr>
@@ -16229,7 +16230,7 @@
           <p:cNvPr id="12" name="Neural title">
             <a:extLst>
               <a:ext uri="{FF2B5EF4-FFF2-40B4-BE49-F238E27FC236}">
-                <a16:creationId xmlns:a16="http://schemas.microsoft.com/office/drawing/2014/main" id="{5EC0250D-056C-9F25-E3E1-2FC929DE0439}"/>
+                <a16:creationId xmlns:a16="http://schemas.microsoft.com/office/drawing/2014/main" id="{772F9279-FB4A-F5DF-EE76-F3EA90A57BF6}"/>
               </a:ext>
             </a:extLst>
           </p:cNvPr>
@@ -16274,7 +16275,7 @@
           <p:cNvPr id="13" name="Neural list">
             <a:extLst>
               <a:ext uri="{FF2B5EF4-FFF2-40B4-BE49-F238E27FC236}">
-                <a16:creationId xmlns:a16="http://schemas.microsoft.com/office/drawing/2014/main" id="{87B5ECCA-0026-A443-073F-5B88CD720D1F}"/>
+                <a16:creationId xmlns:a16="http://schemas.microsoft.com/office/drawing/2014/main" id="{46EE265F-9DA4-60D9-6B31-67E09ECC78C1}"/>
               </a:ext>
             </a:extLst>
           </p:cNvPr>
@@ -16322,7 +16323,7 @@
           <p:cNvPr id="14" name="Combined band">
             <a:extLst>
               <a:ext uri="{FF2B5EF4-FFF2-40B4-BE49-F238E27FC236}">
-                <a16:creationId xmlns:a16="http://schemas.microsoft.com/office/drawing/2014/main" id="{E05B43DE-A8B1-2790-3B0E-A8AF2F9EFF7C}"/>
+                <a16:creationId xmlns:a16="http://schemas.microsoft.com/office/drawing/2014/main" id="{C66CAFB2-17A9-056C-00CA-27274A77FD0B}"/>
               </a:ext>
             </a:extLst>
           </p:cNvPr>
@@ -16390,7 +16391,7 @@
           <p:cNvPr id="15" name="Combined label">
             <a:extLst>
               <a:ext uri="{FF2B5EF4-FFF2-40B4-BE49-F238E27FC236}">
-                <a16:creationId xmlns:a16="http://schemas.microsoft.com/office/drawing/2014/main" id="{8F900BB0-F143-B387-A2B9-0AC3850DF365}"/>
+                <a16:creationId xmlns:a16="http://schemas.microsoft.com/office/drawing/2014/main" id="{B4A5E45F-B5AB-C3AB-1806-5374550C13D2}"/>
               </a:ext>
             </a:extLst>
           </p:cNvPr>
@@ -16435,7 +16436,7 @@
           <p:cNvPr id="16" name="Combined formula">
             <a:extLst>
               <a:ext uri="{FF2B5EF4-FFF2-40B4-BE49-F238E27FC236}">
-                <a16:creationId xmlns:a16="http://schemas.microsoft.com/office/drawing/2014/main" id="{C9303B88-AFEF-38F5-CD9B-9F5EF0C3B70F}"/>
+                <a16:creationId xmlns:a16="http://schemas.microsoft.com/office/drawing/2014/main" id="{8A566F99-10D3-AA2C-0BC7-F297C04C91CB}"/>
               </a:ext>
             </a:extLst>
           </p:cNvPr>
@@ -16478,7 +16479,7 @@
     </p:spTree>
     <p:extLst>
       <p:ext uri="{BB962C8B-B14F-4D97-AF65-F5344CB8AC3E}">
-        <p14:creationId xmlns:p14="http://schemas.microsoft.com/office/powerpoint/2010/main" val="1182033775"/>
+        <p14:creationId xmlns:p14="http://schemas.microsoft.com/office/powerpoint/2010/main" val="4272814350"/>
       </p:ext>
     </p:extLst>
   </p:cSld>
@@ -16518,7 +16519,7 @@
           <p:cNvPr id="2" name="Section">
             <a:extLst>
               <a:ext uri="{FF2B5EF4-FFF2-40B4-BE49-F238E27FC236}">
-                <a16:creationId xmlns:a16="http://schemas.microsoft.com/office/drawing/2014/main" id="{C6E5CFC8-CE3A-C4FC-AFB2-14638DADA75F}"/>
+                <a16:creationId xmlns:a16="http://schemas.microsoft.com/office/drawing/2014/main" id="{E61ED8B1-09C0-A539-16D2-FDB664F96F8D}"/>
               </a:ext>
             </a:extLst>
           </p:cNvPr>
@@ -16563,7 +16564,7 @@
           <p:cNvPr id="3" name="Slide title">
             <a:extLst>
               <a:ext uri="{FF2B5EF4-FFF2-40B4-BE49-F238E27FC236}">
-                <a16:creationId xmlns:a16="http://schemas.microsoft.com/office/drawing/2014/main" id="{5C852E7B-E470-F918-12F7-5CF6084E1041}"/>
+                <a16:creationId xmlns:a16="http://schemas.microsoft.com/office/drawing/2014/main" id="{BC342770-BB8D-C6D0-7B6C-DFB207EDBA74}"/>
               </a:ext>
             </a:extLst>
           </p:cNvPr>
@@ -16608,7 +16609,7 @@
           <p:cNvPr id="4" name="Accent rule">
             <a:extLst>
               <a:ext uri="{FF2B5EF4-FFF2-40B4-BE49-F238E27FC236}">
-                <a16:creationId xmlns:a16="http://schemas.microsoft.com/office/drawing/2014/main" id="{0EE9AF27-903C-04B0-ED9B-E43726DAB1E6}"/>
+                <a16:creationId xmlns:a16="http://schemas.microsoft.com/office/drawing/2014/main" id="{82F699E5-F238-60D1-CDF2-807AB6FDD607}"/>
               </a:ext>
             </a:extLst>
           </p:cNvPr>
@@ -16649,7 +16650,7 @@
           <p:cNvPr id="5" name="Footer author">
             <a:extLst>
               <a:ext uri="{FF2B5EF4-FFF2-40B4-BE49-F238E27FC236}">
-                <a16:creationId xmlns:a16="http://schemas.microsoft.com/office/drawing/2014/main" id="{9AE137A5-033F-7306-88F4-FFCD25E6BCDF}"/>
+                <a16:creationId xmlns:a16="http://schemas.microsoft.com/office/drawing/2014/main" id="{9B7D346D-6A38-4B45-694A-AE7AC8642B12}"/>
               </a:ext>
             </a:extLst>
           </p:cNvPr>
@@ -16694,7 +16695,7 @@
           <p:cNvPr id="6" name="Slide number">
             <a:extLst>
               <a:ext uri="{FF2B5EF4-FFF2-40B4-BE49-F238E27FC236}">
-                <a16:creationId xmlns:a16="http://schemas.microsoft.com/office/drawing/2014/main" id="{ABFF8058-2CD9-2AC9-FBB6-20133D571972}"/>
+                <a16:creationId xmlns:a16="http://schemas.microsoft.com/office/drawing/2014/main" id="{C9EEE3DF-BFA1-CE0A-310C-B06115B916F5}"/>
               </a:ext>
             </a:extLst>
           </p:cNvPr>
@@ -16739,7 +16740,7 @@
           <p:cNvPr id="7" name="Model timeline">
             <a:extLst>
               <a:ext uri="{FF2B5EF4-FFF2-40B4-BE49-F238E27FC236}">
-                <a16:creationId xmlns:a16="http://schemas.microsoft.com/office/drawing/2014/main" id="{62EB094F-98C1-7DEA-7C68-E3E4FC97719F}"/>
+                <a16:creationId xmlns:a16="http://schemas.microsoft.com/office/drawing/2014/main" id="{19650182-1952-A51E-979B-CE3E3CFE8C76}"/>
               </a:ext>
             </a:extLst>
           </p:cNvPr>
@@ -16780,7 +16781,7 @@
           <p:cNvPr id="8" name="Timeline dot">
             <a:extLst>
               <a:ext uri="{FF2B5EF4-FFF2-40B4-BE49-F238E27FC236}">
-                <a16:creationId xmlns:a16="http://schemas.microsoft.com/office/drawing/2014/main" id="{DD685D89-454A-B0DF-E775-24A0E18E4398}"/>
+                <a16:creationId xmlns:a16="http://schemas.microsoft.com/office/drawing/2014/main" id="{80FF5BFC-BB1D-AD26-73F5-E6E438F187DE}"/>
               </a:ext>
             </a:extLst>
           </p:cNvPr>
@@ -16848,7 +16849,7 @@
           <p:cNvPr id="9" name="Timeline dot">
             <a:extLst>
               <a:ext uri="{FF2B5EF4-FFF2-40B4-BE49-F238E27FC236}">
-                <a16:creationId xmlns:a16="http://schemas.microsoft.com/office/drawing/2014/main" id="{B2CFA66B-76DC-CD55-3DCC-C394154FCFC2}"/>
+                <a16:creationId xmlns:a16="http://schemas.microsoft.com/office/drawing/2014/main" id="{00233E41-0AF5-E4F1-61FC-63009FD64549}"/>
               </a:ext>
             </a:extLst>
           </p:cNvPr>
@@ -16916,7 +16917,7 @@
           <p:cNvPr id="10" name="Timeline dot">
             <a:extLst>
               <a:ext uri="{FF2B5EF4-FFF2-40B4-BE49-F238E27FC236}">
-                <a16:creationId xmlns:a16="http://schemas.microsoft.com/office/drawing/2014/main" id="{D4336369-4931-8700-1B84-A6267026CA2F}"/>
+                <a16:creationId xmlns:a16="http://schemas.microsoft.com/office/drawing/2014/main" id="{0CB61D57-7BC9-00A6-4462-9E1EDA347614}"/>
               </a:ext>
             </a:extLst>
           </p:cNvPr>
@@ -16984,7 +16985,7 @@
           <p:cNvPr id="11" name="Timeline label">
             <a:extLst>
               <a:ext uri="{FF2B5EF4-FFF2-40B4-BE49-F238E27FC236}">
-                <a16:creationId xmlns:a16="http://schemas.microsoft.com/office/drawing/2014/main" id="{F7E7D5EA-DDD1-442A-CE68-31498D8B9B56}"/>
+                <a16:creationId xmlns:a16="http://schemas.microsoft.com/office/drawing/2014/main" id="{ED17C14F-629C-6BC1-E108-C065845EB321}"/>
               </a:ext>
             </a:extLst>
           </p:cNvPr>
@@ -17029,7 +17030,7 @@
           <p:cNvPr id="12" name="Timeline title">
             <a:extLst>
               <a:ext uri="{FF2B5EF4-FFF2-40B4-BE49-F238E27FC236}">
-                <a16:creationId xmlns:a16="http://schemas.microsoft.com/office/drawing/2014/main" id="{5F859071-B4FD-D410-FBB7-4B69742F4677}"/>
+                <a16:creationId xmlns:a16="http://schemas.microsoft.com/office/drawing/2014/main" id="{5C3E91B8-7963-1665-7922-AF7726975198}"/>
               </a:ext>
             </a:extLst>
           </p:cNvPr>
@@ -17074,7 +17075,7 @@
           <p:cNvPr id="13" name="Timeline detail">
             <a:extLst>
               <a:ext uri="{FF2B5EF4-FFF2-40B4-BE49-F238E27FC236}">
-                <a16:creationId xmlns:a16="http://schemas.microsoft.com/office/drawing/2014/main" id="{FAC8D21B-8818-658B-4588-C6EBD5EF3F20}"/>
+                <a16:creationId xmlns:a16="http://schemas.microsoft.com/office/drawing/2014/main" id="{114EDBE0-6F59-D9BF-F35C-7259AEFEC2E3}"/>
               </a:ext>
             </a:extLst>
           </p:cNvPr>
@@ -17119,7 +17120,7 @@
           <p:cNvPr id="14" name="Timeline label">
             <a:extLst>
               <a:ext uri="{FF2B5EF4-FFF2-40B4-BE49-F238E27FC236}">
-                <a16:creationId xmlns:a16="http://schemas.microsoft.com/office/drawing/2014/main" id="{21292976-2783-D2B3-5891-A9B41D3B932B}"/>
+                <a16:creationId xmlns:a16="http://schemas.microsoft.com/office/drawing/2014/main" id="{F991FDAE-C420-A6CD-021B-294F38086BB2}"/>
               </a:ext>
             </a:extLst>
           </p:cNvPr>
@@ -17164,7 +17165,7 @@
           <p:cNvPr id="15" name="Timeline title">
             <a:extLst>
               <a:ext uri="{FF2B5EF4-FFF2-40B4-BE49-F238E27FC236}">
-                <a16:creationId xmlns:a16="http://schemas.microsoft.com/office/drawing/2014/main" id="{E7960372-12A5-B4C9-D0BD-817A235BA071}"/>
+                <a16:creationId xmlns:a16="http://schemas.microsoft.com/office/drawing/2014/main" id="{BE5B8A07-69FB-2380-82D4-264EE69EF43B}"/>
               </a:ext>
             </a:extLst>
           </p:cNvPr>
@@ -17209,7 +17210,7 @@
           <p:cNvPr id="16" name="Timeline detail">
             <a:extLst>
               <a:ext uri="{FF2B5EF4-FFF2-40B4-BE49-F238E27FC236}">
-                <a16:creationId xmlns:a16="http://schemas.microsoft.com/office/drawing/2014/main" id="{6BE4A2DD-666D-1141-7538-423A75F0856D}"/>
+                <a16:creationId xmlns:a16="http://schemas.microsoft.com/office/drawing/2014/main" id="{2E12BD5F-7AF3-CF04-9678-923F354FAB2D}"/>
               </a:ext>
             </a:extLst>
           </p:cNvPr>
@@ -17254,7 +17255,7 @@
           <p:cNvPr id="17" name="Timeline label">
             <a:extLst>
               <a:ext uri="{FF2B5EF4-FFF2-40B4-BE49-F238E27FC236}">
-                <a16:creationId xmlns:a16="http://schemas.microsoft.com/office/drawing/2014/main" id="{DC72E2EF-AA54-15A8-669B-814461EFFDDE}"/>
+                <a16:creationId xmlns:a16="http://schemas.microsoft.com/office/drawing/2014/main" id="{8DA08FD5-ADA4-091C-A5A7-929ED3064B52}"/>
               </a:ext>
             </a:extLst>
           </p:cNvPr>
@@ -17299,7 +17300,7 @@
           <p:cNvPr id="18" name="Timeline title">
             <a:extLst>
               <a:ext uri="{FF2B5EF4-FFF2-40B4-BE49-F238E27FC236}">
-                <a16:creationId xmlns:a16="http://schemas.microsoft.com/office/drawing/2014/main" id="{00B040CC-BF22-8A02-7ED7-D200A5C0930F}"/>
+                <a16:creationId xmlns:a16="http://schemas.microsoft.com/office/drawing/2014/main" id="{0CFB078B-0BAE-E80C-79C5-AED45745F275}"/>
               </a:ext>
             </a:extLst>
           </p:cNvPr>
@@ -17344,7 +17345,7 @@
           <p:cNvPr id="19" name="Timeline detail">
             <a:extLst>
               <a:ext uri="{FF2B5EF4-FFF2-40B4-BE49-F238E27FC236}">
-                <a16:creationId xmlns:a16="http://schemas.microsoft.com/office/drawing/2014/main" id="{C698968A-EB96-E134-10BE-46EF0A85BEC8}"/>
+                <a16:creationId xmlns:a16="http://schemas.microsoft.com/office/drawing/2014/main" id="{D881C9D5-C398-2E27-FD6B-3E7043C95151}"/>
               </a:ext>
             </a:extLst>
           </p:cNvPr>
@@ -17389,7 +17390,7 @@
           <p:cNvPr id="20" name="Central takeaway">
             <a:extLst>
               <a:ext uri="{FF2B5EF4-FFF2-40B4-BE49-F238E27FC236}">
-                <a16:creationId xmlns:a16="http://schemas.microsoft.com/office/drawing/2014/main" id="{12790EA6-A1D8-9FD4-21F7-72D7344B57CA}"/>
+                <a16:creationId xmlns:a16="http://schemas.microsoft.com/office/drawing/2014/main" id="{E7D98F60-A972-DF19-4829-66D9225A1B3D}"/>
               </a:ext>
             </a:extLst>
           </p:cNvPr>
@@ -17432,7 +17433,7 @@
     </p:spTree>
     <p:extLst>
       <p:ext uri="{BB962C8B-B14F-4D97-AF65-F5344CB8AC3E}">
-        <p14:creationId xmlns:p14="http://schemas.microsoft.com/office/powerpoint/2010/main" val="1556840001"/>
+        <p14:creationId xmlns:p14="http://schemas.microsoft.com/office/powerpoint/2010/main" val="2889043930"/>
       </p:ext>
     </p:extLst>
   </p:cSld>
@@ -17472,7 +17473,7 @@
           <p:cNvPr id="2" name="Section">
             <a:extLst>
               <a:ext uri="{FF2B5EF4-FFF2-40B4-BE49-F238E27FC236}">
-                <a16:creationId xmlns:a16="http://schemas.microsoft.com/office/drawing/2014/main" id="{76B3E46A-9C80-B88E-8F95-59FDE6E00AF4}"/>
+                <a16:creationId xmlns:a16="http://schemas.microsoft.com/office/drawing/2014/main" id="{2AC87802-1966-68F6-C470-739E6FD0753B}"/>
               </a:ext>
             </a:extLst>
           </p:cNvPr>
@@ -17517,7 +17518,7 @@
           <p:cNvPr id="3" name="Slide title">
             <a:extLst>
               <a:ext uri="{FF2B5EF4-FFF2-40B4-BE49-F238E27FC236}">
-                <a16:creationId xmlns:a16="http://schemas.microsoft.com/office/drawing/2014/main" id="{DF09C5A4-11DF-6437-2491-4C5FB06811B1}"/>
+                <a16:creationId xmlns:a16="http://schemas.microsoft.com/office/drawing/2014/main" id="{49578E8E-5E4D-D24C-0CCD-34F88552CAFF}"/>
               </a:ext>
             </a:extLst>
           </p:cNvPr>
@@ -17562,7 +17563,7 @@
           <p:cNvPr id="4" name="Accent rule">
             <a:extLst>
               <a:ext uri="{FF2B5EF4-FFF2-40B4-BE49-F238E27FC236}">
-                <a16:creationId xmlns:a16="http://schemas.microsoft.com/office/drawing/2014/main" id="{00DD077F-E84E-30E1-A4AD-CD4247282C50}"/>
+                <a16:creationId xmlns:a16="http://schemas.microsoft.com/office/drawing/2014/main" id="{E924B0C4-D06D-4272-1B45-8427E2B4B031}"/>
               </a:ext>
             </a:extLst>
           </p:cNvPr>
@@ -17603,7 +17604,7 @@
           <p:cNvPr id="5" name="Footer author">
             <a:extLst>
               <a:ext uri="{FF2B5EF4-FFF2-40B4-BE49-F238E27FC236}">
-                <a16:creationId xmlns:a16="http://schemas.microsoft.com/office/drawing/2014/main" id="{0D418B9B-0220-FDC8-0C56-73BAEF508D02}"/>
+                <a16:creationId xmlns:a16="http://schemas.microsoft.com/office/drawing/2014/main" id="{91ED1ED9-035A-BAB1-8983-AC581C893752}"/>
               </a:ext>
             </a:extLst>
           </p:cNvPr>
@@ -17648,7 +17649,7 @@
           <p:cNvPr id="6" name="Slide number">
             <a:extLst>
               <a:ext uri="{FF2B5EF4-FFF2-40B4-BE49-F238E27FC236}">
-                <a16:creationId xmlns:a16="http://schemas.microsoft.com/office/drawing/2014/main" id="{C0937625-6240-0B74-E5C3-BEB26C85AFEB}"/>
+                <a16:creationId xmlns:a16="http://schemas.microsoft.com/office/drawing/2014/main" id="{6FAB1FCC-6A0C-3E5C-EA68-22FABA6FF26A}"/>
               </a:ext>
             </a:extLst>
           </p:cNvPr>
@@ -17693,7 +17694,7 @@
           <p:cNvPr id="7" name="Tech label">
             <a:extLst>
               <a:ext uri="{FF2B5EF4-FFF2-40B4-BE49-F238E27FC236}">
-                <a16:creationId xmlns:a16="http://schemas.microsoft.com/office/drawing/2014/main" id="{72351E62-D56A-BAB2-F2C4-84F8F7780735}"/>
+                <a16:creationId xmlns:a16="http://schemas.microsoft.com/office/drawing/2014/main" id="{47072F21-4372-4C10-6972-3898A1CC8468}"/>
               </a:ext>
             </a:extLst>
           </p:cNvPr>
@@ -17738,7 +17739,7 @@
           <p:cNvPr id="8" name="Python">
             <a:extLst>
               <a:ext uri="{FF2B5EF4-FFF2-40B4-BE49-F238E27FC236}">
-                <a16:creationId xmlns:a16="http://schemas.microsoft.com/office/drawing/2014/main" id="{90EE45C0-0FD9-C8F9-3E34-356CC2F536E4}"/>
+                <a16:creationId xmlns:a16="http://schemas.microsoft.com/office/drawing/2014/main" id="{AD0D40F2-FC4D-C8C6-C690-CA148E41CB97}"/>
               </a:ext>
             </a:extLst>
           </p:cNvPr>
@@ -17783,7 +17784,7 @@
           <p:cNvPr id="9" name="Python reason">
             <a:extLst>
               <a:ext uri="{FF2B5EF4-FFF2-40B4-BE49-F238E27FC236}">
-                <a16:creationId xmlns:a16="http://schemas.microsoft.com/office/drawing/2014/main" id="{2A4CC80B-F9CE-79B5-1938-5B67E3ABF055}"/>
+                <a16:creationId xmlns:a16="http://schemas.microsoft.com/office/drawing/2014/main" id="{A7F7A43B-258E-9CEF-2B08-604DC3DA6EE9}"/>
               </a:ext>
             </a:extLst>
           </p:cNvPr>
@@ -17828,7 +17829,7 @@
           <p:cNvPr id="10" name="Tech line">
             <a:extLst>
               <a:ext uri="{FF2B5EF4-FFF2-40B4-BE49-F238E27FC236}">
-                <a16:creationId xmlns:a16="http://schemas.microsoft.com/office/drawing/2014/main" id="{C775CA6D-1032-4452-930D-7D8070E4163A}"/>
+                <a16:creationId xmlns:a16="http://schemas.microsoft.com/office/drawing/2014/main" id="{628007C5-B4A9-E65F-2B90-57696E9C1214}"/>
               </a:ext>
             </a:extLst>
           </p:cNvPr>
@@ -17869,7 +17870,7 @@
           <p:cNvPr id="11" name="Streamlit tech">
             <a:extLst>
               <a:ext uri="{FF2B5EF4-FFF2-40B4-BE49-F238E27FC236}">
-                <a16:creationId xmlns:a16="http://schemas.microsoft.com/office/drawing/2014/main" id="{781EE359-B5AF-4201-FCA4-AA45C42690B6}"/>
+                <a16:creationId xmlns:a16="http://schemas.microsoft.com/office/drawing/2014/main" id="{A3E28D18-AF7C-822F-7638-5AA3454F0F50}"/>
               </a:ext>
             </a:extLst>
           </p:cNvPr>
@@ -17914,7 +17915,7 @@
           <p:cNvPr id="12" name="Streamlit reason">
             <a:extLst>
               <a:ext uri="{FF2B5EF4-FFF2-40B4-BE49-F238E27FC236}">
-                <a16:creationId xmlns:a16="http://schemas.microsoft.com/office/drawing/2014/main" id="{75A078DE-C1EE-6E49-64AF-A9E58A51EB7F}"/>
+                <a16:creationId xmlns:a16="http://schemas.microsoft.com/office/drawing/2014/main" id="{F57A94F1-546E-979E-D139-5412F4726119}"/>
               </a:ext>
             </a:extLst>
           </p:cNvPr>
@@ -17959,7 +17960,7 @@
           <p:cNvPr id="13" name="Tech line">
             <a:extLst>
               <a:ext uri="{FF2B5EF4-FFF2-40B4-BE49-F238E27FC236}">
-                <a16:creationId xmlns:a16="http://schemas.microsoft.com/office/drawing/2014/main" id="{F6BB1CE4-AF05-2645-065E-29E5589FF0A6}"/>
+                <a16:creationId xmlns:a16="http://schemas.microsoft.com/office/drawing/2014/main" id="{AB55293A-0EBE-78D1-E870-65C367CE3C66}"/>
               </a:ext>
             </a:extLst>
           </p:cNvPr>
@@ -18000,7 +18001,7 @@
           <p:cNvPr id="14" name="Sklearn">
             <a:extLst>
               <a:ext uri="{FF2B5EF4-FFF2-40B4-BE49-F238E27FC236}">
-                <a16:creationId xmlns:a16="http://schemas.microsoft.com/office/drawing/2014/main" id="{E1306866-9F0B-59D8-9149-D7E9A1C602FF}"/>
+                <a16:creationId xmlns:a16="http://schemas.microsoft.com/office/drawing/2014/main" id="{31D4B4E4-1E46-DA35-B99E-0348789FB1B1}"/>
               </a:ext>
             </a:extLst>
           </p:cNvPr>
@@ -18045,7 +18046,7 @@
           <p:cNvPr id="15" name="Sklearn reason">
             <a:extLst>
               <a:ext uri="{FF2B5EF4-FFF2-40B4-BE49-F238E27FC236}">
-                <a16:creationId xmlns:a16="http://schemas.microsoft.com/office/drawing/2014/main" id="{B0E7689B-7AF8-A3EF-5D77-6089574BF508}"/>
+                <a16:creationId xmlns:a16="http://schemas.microsoft.com/office/drawing/2014/main" id="{073B89BD-AF63-B572-8228-F9993C71778B}"/>
               </a:ext>
             </a:extLst>
           </p:cNvPr>
@@ -18090,7 +18091,7 @@
           <p:cNvPr id="16" name="Tech line">
             <a:extLst>
               <a:ext uri="{FF2B5EF4-FFF2-40B4-BE49-F238E27FC236}">
-                <a16:creationId xmlns:a16="http://schemas.microsoft.com/office/drawing/2014/main" id="{27D042C2-9B70-3856-91E1-0E6DDE817837}"/>
+                <a16:creationId xmlns:a16="http://schemas.microsoft.com/office/drawing/2014/main" id="{514A4AD2-8EBA-CD34-3996-3D746B9774F9}"/>
               </a:ext>
             </a:extLst>
           </p:cNvPr>
@@ -18131,7 +18132,7 @@
           <p:cNvPr id="17" name="Integrations">
             <a:extLst>
               <a:ext uri="{FF2B5EF4-FFF2-40B4-BE49-F238E27FC236}">
-                <a16:creationId xmlns:a16="http://schemas.microsoft.com/office/drawing/2014/main" id="{614D83A7-2AEA-431B-1283-A4F7EE7F32D3}"/>
+                <a16:creationId xmlns:a16="http://schemas.microsoft.com/office/drawing/2014/main" id="{48578878-D226-10D8-FD9F-9459C6BEB793}"/>
               </a:ext>
             </a:extLst>
           </p:cNvPr>
@@ -18176,7 +18177,7 @@
           <p:cNvPr id="18" name="Integrations reason">
             <a:extLst>
               <a:ext uri="{FF2B5EF4-FFF2-40B4-BE49-F238E27FC236}">
-                <a16:creationId xmlns:a16="http://schemas.microsoft.com/office/drawing/2014/main" id="{7AFAFD13-4220-19F8-1C3F-584E00571E06}"/>
+                <a16:creationId xmlns:a16="http://schemas.microsoft.com/office/drawing/2014/main" id="{458700F3-D95C-E0DF-7E58-108F78DFC3A3}"/>
               </a:ext>
             </a:extLst>
           </p:cNvPr>
@@ -18221,7 +18222,7 @@
           <p:cNvPr id="19" name="Security field">
             <a:extLst>
               <a:ext uri="{FF2B5EF4-FFF2-40B4-BE49-F238E27FC236}">
-                <a16:creationId xmlns:a16="http://schemas.microsoft.com/office/drawing/2014/main" id="{C4EA9D26-A0D8-2475-E1BC-D10CEACB6CC8}"/>
+                <a16:creationId xmlns:a16="http://schemas.microsoft.com/office/drawing/2014/main" id="{C88114F4-97C1-16B4-82E9-EC4C75654A6F}"/>
               </a:ext>
             </a:extLst>
           </p:cNvPr>
@@ -18289,7 +18290,7 @@
           <p:cNvPr id="20" name="Security label">
             <a:extLst>
               <a:ext uri="{FF2B5EF4-FFF2-40B4-BE49-F238E27FC236}">
-                <a16:creationId xmlns:a16="http://schemas.microsoft.com/office/drawing/2014/main" id="{64A646F1-22F2-9594-27AF-6AF0C80130B4}"/>
+                <a16:creationId xmlns:a16="http://schemas.microsoft.com/office/drawing/2014/main" id="{D991A222-0955-1A82-B2C0-AB1A1120180B}"/>
               </a:ext>
             </a:extLst>
           </p:cNvPr>
@@ -18334,7 +18335,7 @@
           <p:cNvPr id="21" name="Security list">
             <a:extLst>
               <a:ext uri="{FF2B5EF4-FFF2-40B4-BE49-F238E27FC236}">
-                <a16:creationId xmlns:a16="http://schemas.microsoft.com/office/drawing/2014/main" id="{C042D631-D912-45DF-406F-AA2965BCB4C5}"/>
+                <a16:creationId xmlns:a16="http://schemas.microsoft.com/office/drawing/2014/main" id="{32727AAD-4978-F4E1-4234-37C0ACAB9D41}"/>
               </a:ext>
             </a:extLst>
           </p:cNvPr>
@@ -18384,7 +18385,7 @@
           <p:cNvPr id="22" name="Security caveat">
             <a:extLst>
               <a:ext uri="{FF2B5EF4-FFF2-40B4-BE49-F238E27FC236}">
-                <a16:creationId xmlns:a16="http://schemas.microsoft.com/office/drawing/2014/main" id="{26C09F02-F5DC-B07B-081A-5A461597EB2B}"/>
+                <a16:creationId xmlns:a16="http://schemas.microsoft.com/office/drawing/2014/main" id="{443E0702-DC05-5915-1FF6-2767AB619344}"/>
               </a:ext>
             </a:extLst>
           </p:cNvPr>
@@ -18427,7 +18428,7 @@
     </p:spTree>
     <p:extLst>
       <p:ext uri="{BB962C8B-B14F-4D97-AF65-F5344CB8AC3E}">
-        <p14:creationId xmlns:p14="http://schemas.microsoft.com/office/powerpoint/2010/main" val="1563814941"/>
+        <p14:creationId xmlns:p14="http://schemas.microsoft.com/office/powerpoint/2010/main" val="3592566310"/>
       </p:ext>
     </p:extLst>
   </p:cSld>
@@ -18467,7 +18468,7 @@
           <p:cNvPr id="2" name="Section">
             <a:extLst>
               <a:ext uri="{FF2B5EF4-FFF2-40B4-BE49-F238E27FC236}">
-                <a16:creationId xmlns:a16="http://schemas.microsoft.com/office/drawing/2014/main" id="{91399930-AD0D-E1FC-60F8-08C103DB84C8}"/>
+                <a16:creationId xmlns:a16="http://schemas.microsoft.com/office/drawing/2014/main" id="{C8E6B875-14F4-CE1D-DDF3-4E7CCDE4FEE9}"/>
               </a:ext>
             </a:extLst>
           </p:cNvPr>
@@ -18512,7 +18513,7 @@
           <p:cNvPr id="3" name="Slide title">
             <a:extLst>
               <a:ext uri="{FF2B5EF4-FFF2-40B4-BE49-F238E27FC236}">
-                <a16:creationId xmlns:a16="http://schemas.microsoft.com/office/drawing/2014/main" id="{0F93D73D-E26A-A3F3-DAC4-881928A8FA55}"/>
+                <a16:creationId xmlns:a16="http://schemas.microsoft.com/office/drawing/2014/main" id="{489A4AF9-5463-2C7B-EF8C-49D79558A148}"/>
               </a:ext>
             </a:extLst>
           </p:cNvPr>
@@ -18557,7 +18558,7 @@
           <p:cNvPr id="4" name="Accent rule">
             <a:extLst>
               <a:ext uri="{FF2B5EF4-FFF2-40B4-BE49-F238E27FC236}">
-                <a16:creationId xmlns:a16="http://schemas.microsoft.com/office/drawing/2014/main" id="{E865EBB0-0F70-CDB8-459C-9E32C6E202F1}"/>
+                <a16:creationId xmlns:a16="http://schemas.microsoft.com/office/drawing/2014/main" id="{240B07B8-06F0-F6CF-C0B4-B7E605C22F67}"/>
               </a:ext>
             </a:extLst>
           </p:cNvPr>
@@ -18598,7 +18599,7 @@
           <p:cNvPr id="5" name="Footer author">
             <a:extLst>
               <a:ext uri="{FF2B5EF4-FFF2-40B4-BE49-F238E27FC236}">
-                <a16:creationId xmlns:a16="http://schemas.microsoft.com/office/drawing/2014/main" id="{11F124FC-AE99-0B8B-B924-91E3DC9B2359}"/>
+                <a16:creationId xmlns:a16="http://schemas.microsoft.com/office/drawing/2014/main" id="{42050EFB-BC16-B29E-F08C-302443A9E40B}"/>
               </a:ext>
             </a:extLst>
           </p:cNvPr>
@@ -18643,7 +18644,7 @@
           <p:cNvPr id="6" name="Slide number">
             <a:extLst>
               <a:ext uri="{FF2B5EF4-FFF2-40B4-BE49-F238E27FC236}">
-                <a16:creationId xmlns:a16="http://schemas.microsoft.com/office/drawing/2014/main" id="{9DD56BA3-65A6-0B8F-E41B-EF20492D2F28}"/>
+                <a16:creationId xmlns:a16="http://schemas.microsoft.com/office/drawing/2014/main" id="{3C87988F-7C81-B46D-3B06-B8900C8DABE4}"/>
               </a:ext>
             </a:extLst>
           </p:cNvPr>
@@ -18688,7 +18689,7 @@
           <p:cNvPr id="7" name="Evaluation timeline">
             <a:extLst>
               <a:ext uri="{FF2B5EF4-FFF2-40B4-BE49-F238E27FC236}">
-                <a16:creationId xmlns:a16="http://schemas.microsoft.com/office/drawing/2014/main" id="{6D3F5F95-3356-DCFF-C4F3-C36C12E04BB4}"/>
+                <a16:creationId xmlns:a16="http://schemas.microsoft.com/office/drawing/2014/main" id="{5EF75F59-2A2A-64BC-1E72-FD1C86CA647B}"/>
               </a:ext>
             </a:extLst>
           </p:cNvPr>
@@ -18729,7 +18730,7 @@
           <p:cNvPr id="8" name="Evaluation dot">
             <a:extLst>
               <a:ext uri="{FF2B5EF4-FFF2-40B4-BE49-F238E27FC236}">
-                <a16:creationId xmlns:a16="http://schemas.microsoft.com/office/drawing/2014/main" id="{45140A56-19D3-576B-6007-99064C094A41}"/>
+                <a16:creationId xmlns:a16="http://schemas.microsoft.com/office/drawing/2014/main" id="{C592F643-E45B-2654-E15C-D7A4D05A146F}"/>
               </a:ext>
             </a:extLst>
           </p:cNvPr>
@@ -18797,7 +18798,7 @@
           <p:cNvPr id="9" name="Evaluation dot">
             <a:extLst>
               <a:ext uri="{FF2B5EF4-FFF2-40B4-BE49-F238E27FC236}">
-                <a16:creationId xmlns:a16="http://schemas.microsoft.com/office/drawing/2014/main" id="{05BEAA10-F6C2-695C-7F5B-1DED88BDAE59}"/>
+                <a16:creationId xmlns:a16="http://schemas.microsoft.com/office/drawing/2014/main" id="{9F76FCF7-B6F6-2EAF-BCB5-645347F923D7}"/>
               </a:ext>
             </a:extLst>
           </p:cNvPr>
@@ -18865,7 +18866,7 @@
           <p:cNvPr id="10" name="Evaluation dot">
             <a:extLst>
               <a:ext uri="{FF2B5EF4-FFF2-40B4-BE49-F238E27FC236}">
-                <a16:creationId xmlns:a16="http://schemas.microsoft.com/office/drawing/2014/main" id="{91929EE2-F7DD-942D-94B1-0E66BF1C1435}"/>
+                <a16:creationId xmlns:a16="http://schemas.microsoft.com/office/drawing/2014/main" id="{F0DDADA4-3328-94CC-A55D-123F2D5CEEEC}"/>
               </a:ext>
             </a:extLst>
           </p:cNvPr>
@@ -18933,7 +18934,7 @@
           <p:cNvPr id="11" name="Evaluation metric">
             <a:extLst>
               <a:ext uri="{FF2B5EF4-FFF2-40B4-BE49-F238E27FC236}">
-                <a16:creationId xmlns:a16="http://schemas.microsoft.com/office/drawing/2014/main" id="{FB345D0F-22AA-E0B4-9813-1369B1E5C721}"/>
+                <a16:creationId xmlns:a16="http://schemas.microsoft.com/office/drawing/2014/main" id="{8B2A8239-9FBE-ABED-B7F1-6C4EC5FD0CC8}"/>
               </a:ext>
             </a:extLst>
           </p:cNvPr>
@@ -18978,7 +18979,7 @@
           <p:cNvPr id="12" name="Evaluation title">
             <a:extLst>
               <a:ext uri="{FF2B5EF4-FFF2-40B4-BE49-F238E27FC236}">
-                <a16:creationId xmlns:a16="http://schemas.microsoft.com/office/drawing/2014/main" id="{21E2CAAA-73C7-3DCA-3444-8F399AFB2D1A}"/>
+                <a16:creationId xmlns:a16="http://schemas.microsoft.com/office/drawing/2014/main" id="{4CEBA28D-D44E-1BA5-8DE6-1143F2BDD649}"/>
               </a:ext>
             </a:extLst>
           </p:cNvPr>
@@ -19023,7 +19024,7 @@
           <p:cNvPr id="13" name="Evaluation detail">
             <a:extLst>
               <a:ext uri="{FF2B5EF4-FFF2-40B4-BE49-F238E27FC236}">
-                <a16:creationId xmlns:a16="http://schemas.microsoft.com/office/drawing/2014/main" id="{3CB19D0E-2DAD-BE06-3009-55EE02A2FB60}"/>
+                <a16:creationId xmlns:a16="http://schemas.microsoft.com/office/drawing/2014/main" id="{75DE5515-7791-A782-DEC5-45B161F17820}"/>
               </a:ext>
             </a:extLst>
           </p:cNvPr>
@@ -19068,7 +19069,7 @@
           <p:cNvPr id="14" name="Evaluation metric">
             <a:extLst>
               <a:ext uri="{FF2B5EF4-FFF2-40B4-BE49-F238E27FC236}">
-                <a16:creationId xmlns:a16="http://schemas.microsoft.com/office/drawing/2014/main" id="{5CB67AD8-467B-D072-1C31-9633A8AC0271}"/>
+                <a16:creationId xmlns:a16="http://schemas.microsoft.com/office/drawing/2014/main" id="{D728BB12-B330-0F78-FD3D-8257268EBB86}"/>
               </a:ext>
             </a:extLst>
           </p:cNvPr>
@@ -19113,7 +19114,7 @@
           <p:cNvPr id="15" name="Evaluation title">
             <a:extLst>
               <a:ext uri="{FF2B5EF4-FFF2-40B4-BE49-F238E27FC236}">
-                <a16:creationId xmlns:a16="http://schemas.microsoft.com/office/drawing/2014/main" id="{8E5C0BD0-B707-3863-73E0-77B97895121B}"/>
+                <a16:creationId xmlns:a16="http://schemas.microsoft.com/office/drawing/2014/main" id="{5C22CD0B-E052-DCE1-69E0-FFCFA42B78BB}"/>
               </a:ext>
             </a:extLst>
           </p:cNvPr>
@@ -19158,7 +19159,7 @@
           <p:cNvPr id="16" name="Evaluation detail">
             <a:extLst>
               <a:ext uri="{FF2B5EF4-FFF2-40B4-BE49-F238E27FC236}">
-                <a16:creationId xmlns:a16="http://schemas.microsoft.com/office/drawing/2014/main" id="{3366F3E4-FA7A-861A-113B-536E0B5B211E}"/>
+                <a16:creationId xmlns:a16="http://schemas.microsoft.com/office/drawing/2014/main" id="{8B8F5994-7254-0BB2-25FC-4E4A5C59AAB8}"/>
               </a:ext>
             </a:extLst>
           </p:cNvPr>
@@ -19203,7 +19204,7 @@
           <p:cNvPr id="17" name="Evaluation metric">
             <a:extLst>
               <a:ext uri="{FF2B5EF4-FFF2-40B4-BE49-F238E27FC236}">
-                <a16:creationId xmlns:a16="http://schemas.microsoft.com/office/drawing/2014/main" id="{0CA77721-BCB5-3A43-A087-855BE3D56E37}"/>
+                <a16:creationId xmlns:a16="http://schemas.microsoft.com/office/drawing/2014/main" id="{C1259433-9FD3-8130-5F0F-0F85B5AF3ADA}"/>
               </a:ext>
             </a:extLst>
           </p:cNvPr>
@@ -19248,7 +19249,7 @@
           <p:cNvPr id="18" name="Evaluation title">
             <a:extLst>
               <a:ext uri="{FF2B5EF4-FFF2-40B4-BE49-F238E27FC236}">
-                <a16:creationId xmlns:a16="http://schemas.microsoft.com/office/drawing/2014/main" id="{3D46091F-9E47-5A6C-CDDA-34C05C0ACF6A}"/>
+                <a16:creationId xmlns:a16="http://schemas.microsoft.com/office/drawing/2014/main" id="{D39480F3-FB59-57CB-F32A-37B3D08E83F3}"/>
               </a:ext>
             </a:extLst>
           </p:cNvPr>
@@ -19293,7 +19294,7 @@
           <p:cNvPr id="19" name="Evaluation detail">
             <a:extLst>
               <a:ext uri="{FF2B5EF4-FFF2-40B4-BE49-F238E27FC236}">
-                <a16:creationId xmlns:a16="http://schemas.microsoft.com/office/drawing/2014/main" id="{C62E03A2-9184-D11D-A3FE-E9E8E71F6413}"/>
+                <a16:creationId xmlns:a16="http://schemas.microsoft.com/office/drawing/2014/main" id="{33D48F9A-6EEF-1E8A-D785-ABB6EE255839}"/>
               </a:ext>
             </a:extLst>
           </p:cNvPr>
@@ -19338,7 +19339,7 @@
           <p:cNvPr id="20" name="Evaluation caveat">
             <a:extLst>
               <a:ext uri="{FF2B5EF4-FFF2-40B4-BE49-F238E27FC236}">
-                <a16:creationId xmlns:a16="http://schemas.microsoft.com/office/drawing/2014/main" id="{F9AC3B9C-A45E-0F8B-CC4E-824534E7A2A7}"/>
+                <a16:creationId xmlns:a16="http://schemas.microsoft.com/office/drawing/2014/main" id="{8CEFFA73-3781-550F-F469-29C0AC8DAE60}"/>
               </a:ext>
             </a:extLst>
           </p:cNvPr>
@@ -19381,7 +19382,7 @@
     </p:spTree>
     <p:extLst>
       <p:ext uri="{BB962C8B-B14F-4D97-AF65-F5344CB8AC3E}">
-        <p14:creationId xmlns:p14="http://schemas.microsoft.com/office/powerpoint/2010/main" val="2923572486"/>
+        <p14:creationId xmlns:p14="http://schemas.microsoft.com/office/powerpoint/2010/main" val="35028064"/>
       </p:ext>
     </p:extLst>
   </p:cSld>

</xml_diff>

<commit_message>
Completar evaluacion reproducible y defensa
</commit_message>
<xml_diff>
--- a/Presentacion_defensa_TFG.pptx
+++ b/Presentacion_defensa_TFG.pptx
@@ -203,9 +203,9 @@
             </a:lvl1pPr>
           </a:lstStyle>
           <a:p>
-            <a:fld id="{7CC186FB-0339-42DD-8219-60C2673475E3}" type="datetimeFigureOut">
+            <a:fld id="{9FD7C5BE-9978-4CEF-950D-CB3DCFAD8EB4}" type="datetimeFigureOut">
               <a:rPr lang="es-ES" smtClean="0"/>
-              <a:t>30/08/2026</a:t>
+              <a:t>31/08/2026</a:t>
             </a:fld>
             <a:endParaRPr lang="es-ES"/>
           </a:p>
@@ -361,7 +361,7 @@
             </a:lvl1pPr>
           </a:lstStyle>
           <a:p>
-            <a:fld id="{3CB51BCC-4392-4008-A116-89654DD6F7E1}" type="slidenum">
+            <a:fld id="{E3954FAD-17C0-4F9B-AC55-52F69F49E05A}" type="slidenum">
               <a:rPr lang="es-ES" smtClean="0"/>
               <a:t>‹Nº›</a:t>
             </a:fld>
@@ -372,7 +372,7 @@
     </p:spTree>
     <p:extLst>
       <p:ext uri="{BB962C8B-B14F-4D97-AF65-F5344CB8AC3E}">
-        <p14:creationId xmlns:p14="http://schemas.microsoft.com/office/powerpoint/2010/main" val="2646070627"/>
+        <p14:creationId xmlns:p14="http://schemas.microsoft.com/office/powerpoint/2010/main" val="1197380503"/>
       </p:ext>
     </p:extLst>
   </p:cSld>
@@ -541,7 +541,7 @@
           <a:bodyPr/>
           <a:lstStyle/>
           <a:p>
-            <a:fld id="{3CB51BCC-4392-4008-A116-89654DD6F7E1}" type="slidenum">
+            <a:fld id="{E3954FAD-17C0-4F9B-AC55-52F69F49E05A}" type="slidenum">
               <a:rPr lang="es-ES" smtClean="0"/>
               <a:t>1</a:t>
             </a:fld>
@@ -552,7 +552,7 @@
     </p:spTree>
     <p:extLst>
       <p:ext uri="{BB962C8B-B14F-4D97-AF65-F5344CB8AC3E}">
-        <p14:creationId xmlns:p14="http://schemas.microsoft.com/office/powerpoint/2010/main" val="2231447491"/>
+        <p14:creationId xmlns:p14="http://schemas.microsoft.com/office/powerpoint/2010/main" val="3122466140"/>
       </p:ext>
     </p:extLst>
   </p:cSld>
@@ -632,7 +632,7 @@
           <a:bodyPr/>
           <a:lstStyle/>
           <a:p>
-            <a:fld id="{3CB51BCC-4392-4008-A116-89654DD6F7E1}" type="slidenum">
+            <a:fld id="{E3954FAD-17C0-4F9B-AC55-52F69F49E05A}" type="slidenum">
               <a:rPr lang="es-ES" smtClean="0"/>
               <a:t>10</a:t>
             </a:fld>
@@ -643,7 +643,7 @@
     </p:spTree>
     <p:extLst>
       <p:ext uri="{BB962C8B-B14F-4D97-AF65-F5344CB8AC3E}">
-        <p14:creationId xmlns:p14="http://schemas.microsoft.com/office/powerpoint/2010/main" val="472512179"/>
+        <p14:creationId xmlns:p14="http://schemas.microsoft.com/office/powerpoint/2010/main" val="3398935707"/>
       </p:ext>
     </p:extLst>
   </p:cSld>
@@ -724,7 +724,7 @@
           <a:bodyPr/>
           <a:lstStyle/>
           <a:p>
-            <a:fld id="{3CB51BCC-4392-4008-A116-89654DD6F7E1}" type="slidenum">
+            <a:fld id="{E3954FAD-17C0-4F9B-AC55-52F69F49E05A}" type="slidenum">
               <a:rPr lang="es-ES" smtClean="0"/>
               <a:t>11</a:t>
             </a:fld>
@@ -735,7 +735,7 @@
     </p:spTree>
     <p:extLst>
       <p:ext uri="{BB962C8B-B14F-4D97-AF65-F5344CB8AC3E}">
-        <p14:creationId xmlns:p14="http://schemas.microsoft.com/office/powerpoint/2010/main" val="210158520"/>
+        <p14:creationId xmlns:p14="http://schemas.microsoft.com/office/powerpoint/2010/main" val="995494014"/>
       </p:ext>
     </p:extLst>
   </p:cSld>
@@ -816,7 +816,7 @@
           <a:bodyPr/>
           <a:lstStyle/>
           <a:p>
-            <a:fld id="{3CB51BCC-4392-4008-A116-89654DD6F7E1}" type="slidenum">
+            <a:fld id="{E3954FAD-17C0-4F9B-AC55-52F69F49E05A}" type="slidenum">
               <a:rPr lang="es-ES" smtClean="0"/>
               <a:t>12</a:t>
             </a:fld>
@@ -827,7 +827,7 @@
     </p:spTree>
     <p:extLst>
       <p:ext uri="{BB962C8B-B14F-4D97-AF65-F5344CB8AC3E}">
-        <p14:creationId xmlns:p14="http://schemas.microsoft.com/office/powerpoint/2010/main" val="226154271"/>
+        <p14:creationId xmlns:p14="http://schemas.microsoft.com/office/powerpoint/2010/main" val="1206899225"/>
       </p:ext>
     </p:extLst>
   </p:cSld>
@@ -907,7 +907,7 @@
           <a:bodyPr/>
           <a:lstStyle/>
           <a:p>
-            <a:fld id="{3CB51BCC-4392-4008-A116-89654DD6F7E1}" type="slidenum">
+            <a:fld id="{E3954FAD-17C0-4F9B-AC55-52F69F49E05A}" type="slidenum">
               <a:rPr lang="es-ES" smtClean="0"/>
               <a:t>13</a:t>
             </a:fld>
@@ -918,7 +918,7 @@
     </p:spTree>
     <p:extLst>
       <p:ext uri="{BB962C8B-B14F-4D97-AF65-F5344CB8AC3E}">
-        <p14:creationId xmlns:p14="http://schemas.microsoft.com/office/powerpoint/2010/main" val="391412948"/>
+        <p14:creationId xmlns:p14="http://schemas.microsoft.com/office/powerpoint/2010/main" val="1813273725"/>
       </p:ext>
     </p:extLst>
   </p:cSld>
@@ -998,7 +998,7 @@
           <a:bodyPr/>
           <a:lstStyle/>
           <a:p>
-            <a:fld id="{3CB51BCC-4392-4008-A116-89654DD6F7E1}" type="slidenum">
+            <a:fld id="{E3954FAD-17C0-4F9B-AC55-52F69F49E05A}" type="slidenum">
               <a:rPr lang="es-ES" smtClean="0"/>
               <a:t>14</a:t>
             </a:fld>
@@ -1009,7 +1009,7 @@
     </p:spTree>
     <p:extLst>
       <p:ext uri="{BB962C8B-B14F-4D97-AF65-F5344CB8AC3E}">
-        <p14:creationId xmlns:p14="http://schemas.microsoft.com/office/powerpoint/2010/main" val="3423900029"/>
+        <p14:creationId xmlns:p14="http://schemas.microsoft.com/office/powerpoint/2010/main" val="1354548166"/>
       </p:ext>
     </p:extLst>
   </p:cSld>
@@ -1088,7 +1088,7 @@
           <a:bodyPr/>
           <a:lstStyle/>
           <a:p>
-            <a:fld id="{3CB51BCC-4392-4008-A116-89654DD6F7E1}" type="slidenum">
+            <a:fld id="{E3954FAD-17C0-4F9B-AC55-52F69F49E05A}" type="slidenum">
               <a:rPr lang="es-ES" smtClean="0"/>
               <a:t>2</a:t>
             </a:fld>
@@ -1099,7 +1099,7 @@
     </p:spTree>
     <p:extLst>
       <p:ext uri="{BB962C8B-B14F-4D97-AF65-F5344CB8AC3E}">
-        <p14:creationId xmlns:p14="http://schemas.microsoft.com/office/powerpoint/2010/main" val="4033252132"/>
+        <p14:creationId xmlns:p14="http://schemas.microsoft.com/office/powerpoint/2010/main" val="4207921916"/>
       </p:ext>
     </p:extLst>
   </p:cSld>
@@ -1179,7 +1179,7 @@
           <a:bodyPr/>
           <a:lstStyle/>
           <a:p>
-            <a:fld id="{3CB51BCC-4392-4008-A116-89654DD6F7E1}" type="slidenum">
+            <a:fld id="{E3954FAD-17C0-4F9B-AC55-52F69F49E05A}" type="slidenum">
               <a:rPr lang="es-ES" smtClean="0"/>
               <a:t>3</a:t>
             </a:fld>
@@ -1190,7 +1190,7 @@
     </p:spTree>
     <p:extLst>
       <p:ext uri="{BB962C8B-B14F-4D97-AF65-F5344CB8AC3E}">
-        <p14:creationId xmlns:p14="http://schemas.microsoft.com/office/powerpoint/2010/main" val="2701454281"/>
+        <p14:creationId xmlns:p14="http://schemas.microsoft.com/office/powerpoint/2010/main" val="359607997"/>
       </p:ext>
     </p:extLst>
   </p:cSld>
@@ -1270,7 +1270,7 @@
           <a:bodyPr/>
           <a:lstStyle/>
           <a:p>
-            <a:fld id="{3CB51BCC-4392-4008-A116-89654DD6F7E1}" type="slidenum">
+            <a:fld id="{E3954FAD-17C0-4F9B-AC55-52F69F49E05A}" type="slidenum">
               <a:rPr lang="es-ES" smtClean="0"/>
               <a:t>4</a:t>
             </a:fld>
@@ -1281,7 +1281,7 @@
     </p:spTree>
     <p:extLst>
       <p:ext uri="{BB962C8B-B14F-4D97-AF65-F5344CB8AC3E}">
-        <p14:creationId xmlns:p14="http://schemas.microsoft.com/office/powerpoint/2010/main" val="3859119265"/>
+        <p14:creationId xmlns:p14="http://schemas.microsoft.com/office/powerpoint/2010/main" val="2888380582"/>
       </p:ext>
     </p:extLst>
   </p:cSld>
@@ -1361,7 +1361,7 @@
           <a:bodyPr/>
           <a:lstStyle/>
           <a:p>
-            <a:fld id="{3CB51BCC-4392-4008-A116-89654DD6F7E1}" type="slidenum">
+            <a:fld id="{E3954FAD-17C0-4F9B-AC55-52F69F49E05A}" type="slidenum">
               <a:rPr lang="es-ES" smtClean="0"/>
               <a:t>5</a:t>
             </a:fld>
@@ -1372,7 +1372,7 @@
     </p:spTree>
     <p:extLst>
       <p:ext uri="{BB962C8B-B14F-4D97-AF65-F5344CB8AC3E}">
-        <p14:creationId xmlns:p14="http://schemas.microsoft.com/office/powerpoint/2010/main" val="415083141"/>
+        <p14:creationId xmlns:p14="http://schemas.microsoft.com/office/powerpoint/2010/main" val="1256773284"/>
       </p:ext>
     </p:extLst>
   </p:cSld>
@@ -1452,7 +1452,7 @@
           <a:bodyPr/>
           <a:lstStyle/>
           <a:p>
-            <a:fld id="{3CB51BCC-4392-4008-A116-89654DD6F7E1}" type="slidenum">
+            <a:fld id="{E3954FAD-17C0-4F9B-AC55-52F69F49E05A}" type="slidenum">
               <a:rPr lang="es-ES" smtClean="0"/>
               <a:t>6</a:t>
             </a:fld>
@@ -1463,7 +1463,7 @@
     </p:spTree>
     <p:extLst>
       <p:ext uri="{BB962C8B-B14F-4D97-AF65-F5344CB8AC3E}">
-        <p14:creationId xmlns:p14="http://schemas.microsoft.com/office/powerpoint/2010/main" val="3410577185"/>
+        <p14:creationId xmlns:p14="http://schemas.microsoft.com/office/powerpoint/2010/main" val="3339263868"/>
       </p:ext>
     </p:extLst>
   </p:cSld>
@@ -1543,7 +1543,7 @@
           <a:bodyPr/>
           <a:lstStyle/>
           <a:p>
-            <a:fld id="{3CB51BCC-4392-4008-A116-89654DD6F7E1}" type="slidenum">
+            <a:fld id="{E3954FAD-17C0-4F9B-AC55-52F69F49E05A}" type="slidenum">
               <a:rPr lang="es-ES" smtClean="0"/>
               <a:t>7</a:t>
             </a:fld>
@@ -1554,7 +1554,7 @@
     </p:spTree>
     <p:extLst>
       <p:ext uri="{BB962C8B-B14F-4D97-AF65-F5344CB8AC3E}">
-        <p14:creationId xmlns:p14="http://schemas.microsoft.com/office/powerpoint/2010/main" val="777135102"/>
+        <p14:creationId xmlns:p14="http://schemas.microsoft.com/office/powerpoint/2010/main" val="2018649772"/>
       </p:ext>
     </p:extLst>
   </p:cSld>
@@ -1634,7 +1634,7 @@
           <a:bodyPr/>
           <a:lstStyle/>
           <a:p>
-            <a:fld id="{3CB51BCC-4392-4008-A116-89654DD6F7E1}" type="slidenum">
+            <a:fld id="{E3954FAD-17C0-4F9B-AC55-52F69F49E05A}" type="slidenum">
               <a:rPr lang="es-ES" smtClean="0"/>
               <a:t>8</a:t>
             </a:fld>
@@ -1645,7 +1645,7 @@
     </p:spTree>
     <p:extLst>
       <p:ext uri="{BB962C8B-B14F-4D97-AF65-F5344CB8AC3E}">
-        <p14:creationId xmlns:p14="http://schemas.microsoft.com/office/powerpoint/2010/main" val="3068410174"/>
+        <p14:creationId xmlns:p14="http://schemas.microsoft.com/office/powerpoint/2010/main" val="794814451"/>
       </p:ext>
     </p:extLst>
   </p:cSld>
@@ -1701,12 +1701,12 @@
           <a:p>
             <a:r>
               <a:rPr lang="es-ES"/>
-              <a:t>Los artefactos declaran 1.298 muestras ES y 164.971 EN. Subrayar que no se usó una división 70/30 inventada: entrenamiento, calibración de 40 casos y evaluación de 16 EML cumplen funciones separadas. DIFrauD es un diagnóstico útil, pero no una validación independiente concluyente por posible solapamiento y falta de MIME completo.
+              <a:t>El protocolo verifica SHA-256, elimina duplicados y contradicciones y separa la prueba antes del ajuste. Español conserva 209 casos oficiales; inglés usa una división 80/20 con semilla 42. Los seis corpus componentes no se suman al CSV agregado. Los 40 casos de calibración y 16 EML cumplen funciones distintas. DIFrauD y Zenodo son diagnósticos externos con límites explícitos.
 [Sources]
-- TFG.txt: diseño experimental y datasets.
+- TRAINING_EVALUATION_REPORT.md.
+- evaluation/training_sources.json.
 - EVALUATION_REPORT.md.
 - EXTERNAL_EVALUATION_REPORT.md.
-- evaluation/README.md.
 [/Sources]</a:t>
             </a:r>
           </a:p>
@@ -1727,7 +1727,7 @@
           <a:bodyPr/>
           <a:lstStyle/>
           <a:p>
-            <a:fld id="{3CB51BCC-4392-4008-A116-89654DD6F7E1}" type="slidenum">
+            <a:fld id="{E3954FAD-17C0-4F9B-AC55-52F69F49E05A}" type="slidenum">
               <a:rPr lang="es-ES" smtClean="0"/>
               <a:t>9</a:t>
             </a:fld>
@@ -1738,7 +1738,7 @@
     </p:spTree>
     <p:extLst>
       <p:ext uri="{BB962C8B-B14F-4D97-AF65-F5344CB8AC3E}">
-        <p14:creationId xmlns:p14="http://schemas.microsoft.com/office/powerpoint/2010/main" val="1684516329"/>
+        <p14:creationId xmlns:p14="http://schemas.microsoft.com/office/powerpoint/2010/main" val="4206360576"/>
       </p:ext>
     </p:extLst>
   </p:cSld>
@@ -1770,7 +1770,7 @@
           <p:cNvPr id="2" name="Título 1">
             <a:extLst>
               <a:ext uri="{FF2B5EF4-FFF2-40B4-BE49-F238E27FC236}">
-                <a16:creationId xmlns:a16="http://schemas.microsoft.com/office/drawing/2014/main" id="{684083F0-58B1-AF58-FFBA-6315538A5474}"/>
+                <a16:creationId xmlns:a16="http://schemas.microsoft.com/office/drawing/2014/main" id="{FB753028-B554-0106-8E3F-AEB890DA6932}"/>
               </a:ext>
             </a:extLst>
           </p:cNvPr>
@@ -1807,7 +1807,7 @@
           <p:cNvPr id="3" name="Subtítulo 2">
             <a:extLst>
               <a:ext uri="{FF2B5EF4-FFF2-40B4-BE49-F238E27FC236}">
-                <a16:creationId xmlns:a16="http://schemas.microsoft.com/office/drawing/2014/main" id="{0C3E214F-C515-104D-689E-733ACCF318EA}"/>
+                <a16:creationId xmlns:a16="http://schemas.microsoft.com/office/drawing/2014/main" id="{B4B345A6-F460-C5BA-7B2B-AC06DD37D980}"/>
               </a:ext>
             </a:extLst>
           </p:cNvPr>
@@ -1877,7 +1877,7 @@
           <p:cNvPr id="4" name="Marcador de fecha 3">
             <a:extLst>
               <a:ext uri="{FF2B5EF4-FFF2-40B4-BE49-F238E27FC236}">
-                <a16:creationId xmlns:a16="http://schemas.microsoft.com/office/drawing/2014/main" id="{F8A350AA-DB93-C75E-FA09-A88E7B6EC48A}"/>
+                <a16:creationId xmlns:a16="http://schemas.microsoft.com/office/drawing/2014/main" id="{9C507B69-718F-C093-FF1E-D809F9F24974}"/>
               </a:ext>
             </a:extLst>
           </p:cNvPr>
@@ -1893,9 +1893,9 @@
           <a:bodyPr/>
           <a:lstStyle/>
           <a:p>
-            <a:fld id="{0C062895-02B9-4539-8A29-6999C3E43A53}" type="datetimeFigureOut">
+            <a:fld id="{71A321C6-34C9-468A-BA2C-A274B4C2D06F}" type="datetimeFigureOut">
               <a:rPr lang="es-ES" smtClean="0"/>
-              <a:t>30/08/2026</a:t>
+              <a:t>31/08/2026</a:t>
             </a:fld>
             <a:endParaRPr lang="es-ES"/>
           </a:p>
@@ -1906,7 +1906,7 @@
           <p:cNvPr id="5" name="Marcador de pie de página 4">
             <a:extLst>
               <a:ext uri="{FF2B5EF4-FFF2-40B4-BE49-F238E27FC236}">
-                <a16:creationId xmlns:a16="http://schemas.microsoft.com/office/drawing/2014/main" id="{A0946EE0-1C36-643A-EB8A-C4C2BAD1D397}"/>
+                <a16:creationId xmlns:a16="http://schemas.microsoft.com/office/drawing/2014/main" id="{1422C606-B9DB-D750-345A-776FB1082760}"/>
               </a:ext>
             </a:extLst>
           </p:cNvPr>
@@ -1931,7 +1931,7 @@
           <p:cNvPr id="6" name="Marcador de número de diapositiva 5">
             <a:extLst>
               <a:ext uri="{FF2B5EF4-FFF2-40B4-BE49-F238E27FC236}">
-                <a16:creationId xmlns:a16="http://schemas.microsoft.com/office/drawing/2014/main" id="{499A4340-8280-9DCB-296D-3C4226CA8908}"/>
+                <a16:creationId xmlns:a16="http://schemas.microsoft.com/office/drawing/2014/main" id="{6C503321-2A25-BCDF-B167-ED293B5FBA11}"/>
               </a:ext>
             </a:extLst>
           </p:cNvPr>
@@ -1947,7 +1947,7 @@
           <a:bodyPr/>
           <a:lstStyle/>
           <a:p>
-            <a:fld id="{32D2AD85-226A-431D-94CD-1256CC25EA7B}" type="slidenum">
+            <a:fld id="{B8291F37-E9CF-4DA3-B181-C3E117B35066}" type="slidenum">
               <a:rPr lang="es-ES" smtClean="0"/>
               <a:t>‹Nº›</a:t>
             </a:fld>
@@ -1958,7 +1958,7 @@
     </p:spTree>
     <p:extLst>
       <p:ext uri="{BB962C8B-B14F-4D97-AF65-F5344CB8AC3E}">
-        <p14:creationId xmlns:p14="http://schemas.microsoft.com/office/powerpoint/2010/main" val="264273332"/>
+        <p14:creationId xmlns:p14="http://schemas.microsoft.com/office/powerpoint/2010/main" val="4232788682"/>
       </p:ext>
     </p:extLst>
   </p:cSld>
@@ -1990,7 +1990,7 @@
           <p:cNvPr id="2" name="Título 1">
             <a:extLst>
               <a:ext uri="{FF2B5EF4-FFF2-40B4-BE49-F238E27FC236}">
-                <a16:creationId xmlns:a16="http://schemas.microsoft.com/office/drawing/2014/main" id="{A00621D1-190C-7076-FC55-B77F92436087}"/>
+                <a16:creationId xmlns:a16="http://schemas.microsoft.com/office/drawing/2014/main" id="{9E3736F8-8A3C-9079-D686-CCBA7EC5C905}"/>
               </a:ext>
             </a:extLst>
           </p:cNvPr>
@@ -2018,7 +2018,7 @@
           <p:cNvPr id="3" name="Marcador de texto vertical 2">
             <a:extLst>
               <a:ext uri="{FF2B5EF4-FFF2-40B4-BE49-F238E27FC236}">
-                <a16:creationId xmlns:a16="http://schemas.microsoft.com/office/drawing/2014/main" id="{099DDC5B-9311-AAFC-6CAC-E04AE542017A}"/>
+                <a16:creationId xmlns:a16="http://schemas.microsoft.com/office/drawing/2014/main" id="{DD849A7C-7730-0AA0-9334-5FB08BCCA0E3}"/>
               </a:ext>
             </a:extLst>
           </p:cNvPr>
@@ -2075,7 +2075,7 @@
           <p:cNvPr id="4" name="Marcador de fecha 3">
             <a:extLst>
               <a:ext uri="{FF2B5EF4-FFF2-40B4-BE49-F238E27FC236}">
-                <a16:creationId xmlns:a16="http://schemas.microsoft.com/office/drawing/2014/main" id="{89ABAE14-E204-D319-1106-0253858B900C}"/>
+                <a16:creationId xmlns:a16="http://schemas.microsoft.com/office/drawing/2014/main" id="{05CEEAD9-F458-2D17-3394-AFB254118278}"/>
               </a:ext>
             </a:extLst>
           </p:cNvPr>
@@ -2091,9 +2091,9 @@
           <a:bodyPr/>
           <a:lstStyle/>
           <a:p>
-            <a:fld id="{0C062895-02B9-4539-8A29-6999C3E43A53}" type="datetimeFigureOut">
+            <a:fld id="{71A321C6-34C9-468A-BA2C-A274B4C2D06F}" type="datetimeFigureOut">
               <a:rPr lang="es-ES" smtClean="0"/>
-              <a:t>30/08/2026</a:t>
+              <a:t>31/08/2026</a:t>
             </a:fld>
             <a:endParaRPr lang="es-ES"/>
           </a:p>
@@ -2104,7 +2104,7 @@
           <p:cNvPr id="5" name="Marcador de pie de página 4">
             <a:extLst>
               <a:ext uri="{FF2B5EF4-FFF2-40B4-BE49-F238E27FC236}">
-                <a16:creationId xmlns:a16="http://schemas.microsoft.com/office/drawing/2014/main" id="{B340E06B-7475-4EEB-50E9-A83A7C13940A}"/>
+                <a16:creationId xmlns:a16="http://schemas.microsoft.com/office/drawing/2014/main" id="{67694067-EF67-91BD-F2A0-05F8D7F3FDE5}"/>
               </a:ext>
             </a:extLst>
           </p:cNvPr>
@@ -2129,7 +2129,7 @@
           <p:cNvPr id="6" name="Marcador de número de diapositiva 5">
             <a:extLst>
               <a:ext uri="{FF2B5EF4-FFF2-40B4-BE49-F238E27FC236}">
-                <a16:creationId xmlns:a16="http://schemas.microsoft.com/office/drawing/2014/main" id="{F434BCE6-09AF-BCAB-0D5F-111BF115AFBA}"/>
+                <a16:creationId xmlns:a16="http://schemas.microsoft.com/office/drawing/2014/main" id="{6CB351FF-6149-9062-CEBC-80D95B8A7CC3}"/>
               </a:ext>
             </a:extLst>
           </p:cNvPr>
@@ -2145,7 +2145,7 @@
           <a:bodyPr/>
           <a:lstStyle/>
           <a:p>
-            <a:fld id="{32D2AD85-226A-431D-94CD-1256CC25EA7B}" type="slidenum">
+            <a:fld id="{B8291F37-E9CF-4DA3-B181-C3E117B35066}" type="slidenum">
               <a:rPr lang="es-ES" smtClean="0"/>
               <a:t>‹Nº›</a:t>
             </a:fld>
@@ -2156,7 +2156,7 @@
     </p:spTree>
     <p:extLst>
       <p:ext uri="{BB962C8B-B14F-4D97-AF65-F5344CB8AC3E}">
-        <p14:creationId xmlns:p14="http://schemas.microsoft.com/office/powerpoint/2010/main" val="2199551632"/>
+        <p14:creationId xmlns:p14="http://schemas.microsoft.com/office/powerpoint/2010/main" val="3194040688"/>
       </p:ext>
     </p:extLst>
   </p:cSld>
@@ -2188,7 +2188,7 @@
           <p:cNvPr id="2" name="Título vertical 1">
             <a:extLst>
               <a:ext uri="{FF2B5EF4-FFF2-40B4-BE49-F238E27FC236}">
-                <a16:creationId xmlns:a16="http://schemas.microsoft.com/office/drawing/2014/main" id="{10D8D713-F6E0-8173-F238-027FB105CA0F}"/>
+                <a16:creationId xmlns:a16="http://schemas.microsoft.com/office/drawing/2014/main" id="{19EBDEB4-231B-C6C4-EA7E-D4965BF0E5F2}"/>
               </a:ext>
             </a:extLst>
           </p:cNvPr>
@@ -2221,7 +2221,7 @@
           <p:cNvPr id="3" name="Marcador de texto vertical 2">
             <a:extLst>
               <a:ext uri="{FF2B5EF4-FFF2-40B4-BE49-F238E27FC236}">
-                <a16:creationId xmlns:a16="http://schemas.microsoft.com/office/drawing/2014/main" id="{86092661-4A5C-ECCD-02DE-E366640A4533}"/>
+                <a16:creationId xmlns:a16="http://schemas.microsoft.com/office/drawing/2014/main" id="{2920B69E-5955-2CB0-C1FF-91851997AE1A}"/>
               </a:ext>
             </a:extLst>
           </p:cNvPr>
@@ -2283,7 +2283,7 @@
           <p:cNvPr id="4" name="Marcador de fecha 3">
             <a:extLst>
               <a:ext uri="{FF2B5EF4-FFF2-40B4-BE49-F238E27FC236}">
-                <a16:creationId xmlns:a16="http://schemas.microsoft.com/office/drawing/2014/main" id="{81197B39-BB2C-DB78-735E-A1F4DFD79D88}"/>
+                <a16:creationId xmlns:a16="http://schemas.microsoft.com/office/drawing/2014/main" id="{15B9E0F6-5C2F-865F-EC24-478E8B6FEE2F}"/>
               </a:ext>
             </a:extLst>
           </p:cNvPr>
@@ -2299,9 +2299,9 @@
           <a:bodyPr/>
           <a:lstStyle/>
           <a:p>
-            <a:fld id="{0C062895-02B9-4539-8A29-6999C3E43A53}" type="datetimeFigureOut">
+            <a:fld id="{71A321C6-34C9-468A-BA2C-A274B4C2D06F}" type="datetimeFigureOut">
               <a:rPr lang="es-ES" smtClean="0"/>
-              <a:t>30/08/2026</a:t>
+              <a:t>31/08/2026</a:t>
             </a:fld>
             <a:endParaRPr lang="es-ES"/>
           </a:p>
@@ -2312,7 +2312,7 @@
           <p:cNvPr id="5" name="Marcador de pie de página 4">
             <a:extLst>
               <a:ext uri="{FF2B5EF4-FFF2-40B4-BE49-F238E27FC236}">
-                <a16:creationId xmlns:a16="http://schemas.microsoft.com/office/drawing/2014/main" id="{4FE99148-54AD-C10B-83DA-47ECFDAD7AEF}"/>
+                <a16:creationId xmlns:a16="http://schemas.microsoft.com/office/drawing/2014/main" id="{7BE13B91-E3A1-265A-C433-1D57BD6AB184}"/>
               </a:ext>
             </a:extLst>
           </p:cNvPr>
@@ -2337,7 +2337,7 @@
           <p:cNvPr id="6" name="Marcador de número de diapositiva 5">
             <a:extLst>
               <a:ext uri="{FF2B5EF4-FFF2-40B4-BE49-F238E27FC236}">
-                <a16:creationId xmlns:a16="http://schemas.microsoft.com/office/drawing/2014/main" id="{07CFBC52-DCC1-421B-9260-20ED5F96069B}"/>
+                <a16:creationId xmlns:a16="http://schemas.microsoft.com/office/drawing/2014/main" id="{CC65FAB9-45A8-A746-DDD1-5DCF03182F58}"/>
               </a:ext>
             </a:extLst>
           </p:cNvPr>
@@ -2353,7 +2353,7 @@
           <a:bodyPr/>
           <a:lstStyle/>
           <a:p>
-            <a:fld id="{32D2AD85-226A-431D-94CD-1256CC25EA7B}" type="slidenum">
+            <a:fld id="{B8291F37-E9CF-4DA3-B181-C3E117B35066}" type="slidenum">
               <a:rPr lang="es-ES" smtClean="0"/>
               <a:t>‹Nº›</a:t>
             </a:fld>
@@ -2364,7 +2364,7 @@
     </p:spTree>
     <p:extLst>
       <p:ext uri="{BB962C8B-B14F-4D97-AF65-F5344CB8AC3E}">
-        <p14:creationId xmlns:p14="http://schemas.microsoft.com/office/powerpoint/2010/main" val="2084339868"/>
+        <p14:creationId xmlns:p14="http://schemas.microsoft.com/office/powerpoint/2010/main" val="3324211768"/>
       </p:ext>
     </p:extLst>
   </p:cSld>
@@ -2396,7 +2396,7 @@
           <p:cNvPr id="2" name="Título 1">
             <a:extLst>
               <a:ext uri="{FF2B5EF4-FFF2-40B4-BE49-F238E27FC236}">
-                <a16:creationId xmlns:a16="http://schemas.microsoft.com/office/drawing/2014/main" id="{7EEB6C7E-ECA3-CED3-6732-97CDF957BE9F}"/>
+                <a16:creationId xmlns:a16="http://schemas.microsoft.com/office/drawing/2014/main" id="{BB12E415-62CC-ED0A-9126-C62F27389CF2}"/>
               </a:ext>
             </a:extLst>
           </p:cNvPr>
@@ -2424,7 +2424,7 @@
           <p:cNvPr id="3" name="Marcador de contenido 2">
             <a:extLst>
               <a:ext uri="{FF2B5EF4-FFF2-40B4-BE49-F238E27FC236}">
-                <a16:creationId xmlns:a16="http://schemas.microsoft.com/office/drawing/2014/main" id="{B2AE0D7D-2E64-E2EA-AE2E-5C0FDA7AF21B}"/>
+                <a16:creationId xmlns:a16="http://schemas.microsoft.com/office/drawing/2014/main" id="{92EA9DF0-AFC8-12A1-CBDD-7260E8231224}"/>
               </a:ext>
             </a:extLst>
           </p:cNvPr>
@@ -2481,7 +2481,7 @@
           <p:cNvPr id="4" name="Marcador de fecha 3">
             <a:extLst>
               <a:ext uri="{FF2B5EF4-FFF2-40B4-BE49-F238E27FC236}">
-                <a16:creationId xmlns:a16="http://schemas.microsoft.com/office/drawing/2014/main" id="{BE51A944-7F4A-A4AE-A031-3DBD62A5D857}"/>
+                <a16:creationId xmlns:a16="http://schemas.microsoft.com/office/drawing/2014/main" id="{099BD82C-6E93-14C6-BEF7-B443B7A1B5EE}"/>
               </a:ext>
             </a:extLst>
           </p:cNvPr>
@@ -2497,9 +2497,9 @@
           <a:bodyPr/>
           <a:lstStyle/>
           <a:p>
-            <a:fld id="{0C062895-02B9-4539-8A29-6999C3E43A53}" type="datetimeFigureOut">
+            <a:fld id="{71A321C6-34C9-468A-BA2C-A274B4C2D06F}" type="datetimeFigureOut">
               <a:rPr lang="es-ES" smtClean="0"/>
-              <a:t>30/08/2026</a:t>
+              <a:t>31/08/2026</a:t>
             </a:fld>
             <a:endParaRPr lang="es-ES"/>
           </a:p>
@@ -2510,7 +2510,7 @@
           <p:cNvPr id="5" name="Marcador de pie de página 4">
             <a:extLst>
               <a:ext uri="{FF2B5EF4-FFF2-40B4-BE49-F238E27FC236}">
-                <a16:creationId xmlns:a16="http://schemas.microsoft.com/office/drawing/2014/main" id="{A2DD56EA-A768-7008-03D2-AD2A0519B322}"/>
+                <a16:creationId xmlns:a16="http://schemas.microsoft.com/office/drawing/2014/main" id="{1276430F-7B86-E00A-BD92-EAD754D07F92}"/>
               </a:ext>
             </a:extLst>
           </p:cNvPr>
@@ -2535,7 +2535,7 @@
           <p:cNvPr id="6" name="Marcador de número de diapositiva 5">
             <a:extLst>
               <a:ext uri="{FF2B5EF4-FFF2-40B4-BE49-F238E27FC236}">
-                <a16:creationId xmlns:a16="http://schemas.microsoft.com/office/drawing/2014/main" id="{0BF7430C-EB0B-5DB1-3859-D464CC8C3E35}"/>
+                <a16:creationId xmlns:a16="http://schemas.microsoft.com/office/drawing/2014/main" id="{89E9C685-8AF3-B5E1-BBA2-048D63636827}"/>
               </a:ext>
             </a:extLst>
           </p:cNvPr>
@@ -2551,7 +2551,7 @@
           <a:bodyPr/>
           <a:lstStyle/>
           <a:p>
-            <a:fld id="{32D2AD85-226A-431D-94CD-1256CC25EA7B}" type="slidenum">
+            <a:fld id="{B8291F37-E9CF-4DA3-B181-C3E117B35066}" type="slidenum">
               <a:rPr lang="es-ES" smtClean="0"/>
               <a:t>‹Nº›</a:t>
             </a:fld>
@@ -2562,7 +2562,7 @@
     </p:spTree>
     <p:extLst>
       <p:ext uri="{BB962C8B-B14F-4D97-AF65-F5344CB8AC3E}">
-        <p14:creationId xmlns:p14="http://schemas.microsoft.com/office/powerpoint/2010/main" val="2725057669"/>
+        <p14:creationId xmlns:p14="http://schemas.microsoft.com/office/powerpoint/2010/main" val="2163362317"/>
       </p:ext>
     </p:extLst>
   </p:cSld>
@@ -2594,7 +2594,7 @@
           <p:cNvPr id="2" name="Título 1">
             <a:extLst>
               <a:ext uri="{FF2B5EF4-FFF2-40B4-BE49-F238E27FC236}">
-                <a16:creationId xmlns:a16="http://schemas.microsoft.com/office/drawing/2014/main" id="{BFA27210-6884-F031-3E2F-26ED863DA6E5}"/>
+                <a16:creationId xmlns:a16="http://schemas.microsoft.com/office/drawing/2014/main" id="{C27AB769-B4AD-90E6-07A1-FCD271E8784D}"/>
               </a:ext>
             </a:extLst>
           </p:cNvPr>
@@ -2631,7 +2631,7 @@
           <p:cNvPr id="3" name="Marcador de texto 2">
             <a:extLst>
               <a:ext uri="{FF2B5EF4-FFF2-40B4-BE49-F238E27FC236}">
-                <a16:creationId xmlns:a16="http://schemas.microsoft.com/office/drawing/2014/main" id="{7CBEDD68-54F1-355D-B083-5A31CDE499AE}"/>
+                <a16:creationId xmlns:a16="http://schemas.microsoft.com/office/drawing/2014/main" id="{2F2E7D72-8C72-B501-A89C-B68A9187B9DC}"/>
               </a:ext>
             </a:extLst>
           </p:cNvPr>
@@ -2756,7 +2756,7 @@
           <p:cNvPr id="4" name="Marcador de fecha 3">
             <a:extLst>
               <a:ext uri="{FF2B5EF4-FFF2-40B4-BE49-F238E27FC236}">
-                <a16:creationId xmlns:a16="http://schemas.microsoft.com/office/drawing/2014/main" id="{3DFF1A85-7E75-CA37-D782-798C951EDC7F}"/>
+                <a16:creationId xmlns:a16="http://schemas.microsoft.com/office/drawing/2014/main" id="{AD72BFA6-13FF-17A5-40F6-2678A44A688F}"/>
               </a:ext>
             </a:extLst>
           </p:cNvPr>
@@ -2772,9 +2772,9 @@
           <a:bodyPr/>
           <a:lstStyle/>
           <a:p>
-            <a:fld id="{0C062895-02B9-4539-8A29-6999C3E43A53}" type="datetimeFigureOut">
+            <a:fld id="{71A321C6-34C9-468A-BA2C-A274B4C2D06F}" type="datetimeFigureOut">
               <a:rPr lang="es-ES" smtClean="0"/>
-              <a:t>30/08/2026</a:t>
+              <a:t>31/08/2026</a:t>
             </a:fld>
             <a:endParaRPr lang="es-ES"/>
           </a:p>
@@ -2785,7 +2785,7 @@
           <p:cNvPr id="5" name="Marcador de pie de página 4">
             <a:extLst>
               <a:ext uri="{FF2B5EF4-FFF2-40B4-BE49-F238E27FC236}">
-                <a16:creationId xmlns:a16="http://schemas.microsoft.com/office/drawing/2014/main" id="{26323111-1B3C-64E9-5045-A4E6818B3009}"/>
+                <a16:creationId xmlns:a16="http://schemas.microsoft.com/office/drawing/2014/main" id="{09B61FEF-F3BC-E11F-05CF-FD1F8091DE14}"/>
               </a:ext>
             </a:extLst>
           </p:cNvPr>
@@ -2810,7 +2810,7 @@
           <p:cNvPr id="6" name="Marcador de número de diapositiva 5">
             <a:extLst>
               <a:ext uri="{FF2B5EF4-FFF2-40B4-BE49-F238E27FC236}">
-                <a16:creationId xmlns:a16="http://schemas.microsoft.com/office/drawing/2014/main" id="{3CEC49E3-11CF-CCDA-D2AA-D491D2768597}"/>
+                <a16:creationId xmlns:a16="http://schemas.microsoft.com/office/drawing/2014/main" id="{9EC70598-14C9-B180-8985-17C117694815}"/>
               </a:ext>
             </a:extLst>
           </p:cNvPr>
@@ -2826,7 +2826,7 @@
           <a:bodyPr/>
           <a:lstStyle/>
           <a:p>
-            <a:fld id="{32D2AD85-226A-431D-94CD-1256CC25EA7B}" type="slidenum">
+            <a:fld id="{B8291F37-E9CF-4DA3-B181-C3E117B35066}" type="slidenum">
               <a:rPr lang="es-ES" smtClean="0"/>
               <a:t>‹Nº›</a:t>
             </a:fld>
@@ -2837,7 +2837,7 @@
     </p:spTree>
     <p:extLst>
       <p:ext uri="{BB962C8B-B14F-4D97-AF65-F5344CB8AC3E}">
-        <p14:creationId xmlns:p14="http://schemas.microsoft.com/office/powerpoint/2010/main" val="1397467741"/>
+        <p14:creationId xmlns:p14="http://schemas.microsoft.com/office/powerpoint/2010/main" val="2317253234"/>
       </p:ext>
     </p:extLst>
   </p:cSld>
@@ -2869,7 +2869,7 @@
           <p:cNvPr id="2" name="Título 1">
             <a:extLst>
               <a:ext uri="{FF2B5EF4-FFF2-40B4-BE49-F238E27FC236}">
-                <a16:creationId xmlns:a16="http://schemas.microsoft.com/office/drawing/2014/main" id="{FE6AC7F5-60D2-EFE4-4B60-D8A9678E7F0A}"/>
+                <a16:creationId xmlns:a16="http://schemas.microsoft.com/office/drawing/2014/main" id="{E8A75AA1-4E81-A74C-98DD-78FE992DC3EB}"/>
               </a:ext>
             </a:extLst>
           </p:cNvPr>
@@ -2897,7 +2897,7 @@
           <p:cNvPr id="3" name="Marcador de contenido 2">
             <a:extLst>
               <a:ext uri="{FF2B5EF4-FFF2-40B4-BE49-F238E27FC236}">
-                <a16:creationId xmlns:a16="http://schemas.microsoft.com/office/drawing/2014/main" id="{57436F4C-4C55-DAA2-3E72-E7D53E8C078D}"/>
+                <a16:creationId xmlns:a16="http://schemas.microsoft.com/office/drawing/2014/main" id="{DBA01DBB-AA39-B344-1188-263FC2A4788C}"/>
               </a:ext>
             </a:extLst>
           </p:cNvPr>
@@ -2959,7 +2959,7 @@
           <p:cNvPr id="4" name="Marcador de contenido 3">
             <a:extLst>
               <a:ext uri="{FF2B5EF4-FFF2-40B4-BE49-F238E27FC236}">
-                <a16:creationId xmlns:a16="http://schemas.microsoft.com/office/drawing/2014/main" id="{4125A72A-0B63-1829-2517-1924F7757C30}"/>
+                <a16:creationId xmlns:a16="http://schemas.microsoft.com/office/drawing/2014/main" id="{3F2CC939-FB49-957F-0184-55939641183C}"/>
               </a:ext>
             </a:extLst>
           </p:cNvPr>
@@ -3021,7 +3021,7 @@
           <p:cNvPr id="5" name="Marcador de fecha 4">
             <a:extLst>
               <a:ext uri="{FF2B5EF4-FFF2-40B4-BE49-F238E27FC236}">
-                <a16:creationId xmlns:a16="http://schemas.microsoft.com/office/drawing/2014/main" id="{EBE8AF2F-E4CF-A2B6-7BC9-959D4B0CFF69}"/>
+                <a16:creationId xmlns:a16="http://schemas.microsoft.com/office/drawing/2014/main" id="{439B09BA-133F-C5BF-EAE6-A420034D6B8C}"/>
               </a:ext>
             </a:extLst>
           </p:cNvPr>
@@ -3037,9 +3037,9 @@
           <a:bodyPr/>
           <a:lstStyle/>
           <a:p>
-            <a:fld id="{0C062895-02B9-4539-8A29-6999C3E43A53}" type="datetimeFigureOut">
+            <a:fld id="{71A321C6-34C9-468A-BA2C-A274B4C2D06F}" type="datetimeFigureOut">
               <a:rPr lang="es-ES" smtClean="0"/>
-              <a:t>30/08/2026</a:t>
+              <a:t>31/08/2026</a:t>
             </a:fld>
             <a:endParaRPr lang="es-ES"/>
           </a:p>
@@ -3050,7 +3050,7 @@
           <p:cNvPr id="6" name="Marcador de pie de página 5">
             <a:extLst>
               <a:ext uri="{FF2B5EF4-FFF2-40B4-BE49-F238E27FC236}">
-                <a16:creationId xmlns:a16="http://schemas.microsoft.com/office/drawing/2014/main" id="{1CC64C9F-B59C-E205-E844-CCF04C1B5A89}"/>
+                <a16:creationId xmlns:a16="http://schemas.microsoft.com/office/drawing/2014/main" id="{0AA6F895-A5C7-72DC-7111-AD46BB3B618A}"/>
               </a:ext>
             </a:extLst>
           </p:cNvPr>
@@ -3075,7 +3075,7 @@
           <p:cNvPr id="7" name="Marcador de número de diapositiva 6">
             <a:extLst>
               <a:ext uri="{FF2B5EF4-FFF2-40B4-BE49-F238E27FC236}">
-                <a16:creationId xmlns:a16="http://schemas.microsoft.com/office/drawing/2014/main" id="{34822B96-68F1-60B6-42B8-50B3C64CE5FD}"/>
+                <a16:creationId xmlns:a16="http://schemas.microsoft.com/office/drawing/2014/main" id="{89F4DD94-6321-7844-28B5-02DBE730B7AB}"/>
               </a:ext>
             </a:extLst>
           </p:cNvPr>
@@ -3091,7 +3091,7 @@
           <a:bodyPr/>
           <a:lstStyle/>
           <a:p>
-            <a:fld id="{32D2AD85-226A-431D-94CD-1256CC25EA7B}" type="slidenum">
+            <a:fld id="{B8291F37-E9CF-4DA3-B181-C3E117B35066}" type="slidenum">
               <a:rPr lang="es-ES" smtClean="0"/>
               <a:t>‹Nº›</a:t>
             </a:fld>
@@ -3102,7 +3102,7 @@
     </p:spTree>
     <p:extLst>
       <p:ext uri="{BB962C8B-B14F-4D97-AF65-F5344CB8AC3E}">
-        <p14:creationId xmlns:p14="http://schemas.microsoft.com/office/powerpoint/2010/main" val="957859002"/>
+        <p14:creationId xmlns:p14="http://schemas.microsoft.com/office/powerpoint/2010/main" val="3746987680"/>
       </p:ext>
     </p:extLst>
   </p:cSld>
@@ -3134,7 +3134,7 @@
           <p:cNvPr id="2" name="Título 1">
             <a:extLst>
               <a:ext uri="{FF2B5EF4-FFF2-40B4-BE49-F238E27FC236}">
-                <a16:creationId xmlns:a16="http://schemas.microsoft.com/office/drawing/2014/main" id="{2405199C-3CBB-1402-61A8-F6E2C64F31C2}"/>
+                <a16:creationId xmlns:a16="http://schemas.microsoft.com/office/drawing/2014/main" id="{AB419CD9-3F46-CFC2-9ED8-1FE3510406F8}"/>
               </a:ext>
             </a:extLst>
           </p:cNvPr>
@@ -3167,7 +3167,7 @@
           <p:cNvPr id="3" name="Marcador de texto 2">
             <a:extLst>
               <a:ext uri="{FF2B5EF4-FFF2-40B4-BE49-F238E27FC236}">
-                <a16:creationId xmlns:a16="http://schemas.microsoft.com/office/drawing/2014/main" id="{29731004-1159-D8C4-6358-9A0304EF5C24}"/>
+                <a16:creationId xmlns:a16="http://schemas.microsoft.com/office/drawing/2014/main" id="{30B4CB8A-E2AB-C24A-AA1B-FF2CEDF0293C}"/>
               </a:ext>
             </a:extLst>
           </p:cNvPr>
@@ -3238,7 +3238,7 @@
           <p:cNvPr id="4" name="Marcador de contenido 3">
             <a:extLst>
               <a:ext uri="{FF2B5EF4-FFF2-40B4-BE49-F238E27FC236}">
-                <a16:creationId xmlns:a16="http://schemas.microsoft.com/office/drawing/2014/main" id="{5D640963-B30E-CB3F-2106-FDAA20D42327}"/>
+                <a16:creationId xmlns:a16="http://schemas.microsoft.com/office/drawing/2014/main" id="{B413A9B0-51EF-B264-3899-E4FB03120C5E}"/>
               </a:ext>
             </a:extLst>
           </p:cNvPr>
@@ -3300,7 +3300,7 @@
           <p:cNvPr id="5" name="Marcador de texto 4">
             <a:extLst>
               <a:ext uri="{FF2B5EF4-FFF2-40B4-BE49-F238E27FC236}">
-                <a16:creationId xmlns:a16="http://schemas.microsoft.com/office/drawing/2014/main" id="{763F8E84-9131-BDD5-A7C5-57D693EE2E03}"/>
+                <a16:creationId xmlns:a16="http://schemas.microsoft.com/office/drawing/2014/main" id="{74B5030B-A109-13AC-82B6-75BF864725E9}"/>
               </a:ext>
             </a:extLst>
           </p:cNvPr>
@@ -3371,7 +3371,7 @@
           <p:cNvPr id="6" name="Marcador de contenido 5">
             <a:extLst>
               <a:ext uri="{FF2B5EF4-FFF2-40B4-BE49-F238E27FC236}">
-                <a16:creationId xmlns:a16="http://schemas.microsoft.com/office/drawing/2014/main" id="{B2CFC5EF-D15C-01F2-AA66-B50B703CCD16}"/>
+                <a16:creationId xmlns:a16="http://schemas.microsoft.com/office/drawing/2014/main" id="{450EE58C-1E4A-78DE-B61E-8B48886563FC}"/>
               </a:ext>
             </a:extLst>
           </p:cNvPr>
@@ -3433,7 +3433,7 @@
           <p:cNvPr id="7" name="Marcador de fecha 6">
             <a:extLst>
               <a:ext uri="{FF2B5EF4-FFF2-40B4-BE49-F238E27FC236}">
-                <a16:creationId xmlns:a16="http://schemas.microsoft.com/office/drawing/2014/main" id="{E6DBD9EA-023A-41D1-0B4B-6D9FB1AC5C39}"/>
+                <a16:creationId xmlns:a16="http://schemas.microsoft.com/office/drawing/2014/main" id="{A21E4917-6CD0-BD26-9A52-43EEB1AF5D6F}"/>
               </a:ext>
             </a:extLst>
           </p:cNvPr>
@@ -3449,9 +3449,9 @@
           <a:bodyPr/>
           <a:lstStyle/>
           <a:p>
-            <a:fld id="{0C062895-02B9-4539-8A29-6999C3E43A53}" type="datetimeFigureOut">
+            <a:fld id="{71A321C6-34C9-468A-BA2C-A274B4C2D06F}" type="datetimeFigureOut">
               <a:rPr lang="es-ES" smtClean="0"/>
-              <a:t>30/08/2026</a:t>
+              <a:t>31/08/2026</a:t>
             </a:fld>
             <a:endParaRPr lang="es-ES"/>
           </a:p>
@@ -3462,7 +3462,7 @@
           <p:cNvPr id="8" name="Marcador de pie de página 7">
             <a:extLst>
               <a:ext uri="{FF2B5EF4-FFF2-40B4-BE49-F238E27FC236}">
-                <a16:creationId xmlns:a16="http://schemas.microsoft.com/office/drawing/2014/main" id="{9AF7BF42-0375-87DD-F2F4-520021D450E9}"/>
+                <a16:creationId xmlns:a16="http://schemas.microsoft.com/office/drawing/2014/main" id="{B5F413FA-9FC2-F1A7-A662-CE63757A252F}"/>
               </a:ext>
             </a:extLst>
           </p:cNvPr>
@@ -3487,7 +3487,7 @@
           <p:cNvPr id="9" name="Marcador de número de diapositiva 8">
             <a:extLst>
               <a:ext uri="{FF2B5EF4-FFF2-40B4-BE49-F238E27FC236}">
-                <a16:creationId xmlns:a16="http://schemas.microsoft.com/office/drawing/2014/main" id="{89FA8646-1895-E141-091E-B3252DF063BF}"/>
+                <a16:creationId xmlns:a16="http://schemas.microsoft.com/office/drawing/2014/main" id="{D1FDDF3C-2268-AD7D-4DAD-7CF69340B13F}"/>
               </a:ext>
             </a:extLst>
           </p:cNvPr>
@@ -3503,7 +3503,7 @@
           <a:bodyPr/>
           <a:lstStyle/>
           <a:p>
-            <a:fld id="{32D2AD85-226A-431D-94CD-1256CC25EA7B}" type="slidenum">
+            <a:fld id="{B8291F37-E9CF-4DA3-B181-C3E117B35066}" type="slidenum">
               <a:rPr lang="es-ES" smtClean="0"/>
               <a:t>‹Nº›</a:t>
             </a:fld>
@@ -3514,7 +3514,7 @@
     </p:spTree>
     <p:extLst>
       <p:ext uri="{BB962C8B-B14F-4D97-AF65-F5344CB8AC3E}">
-        <p14:creationId xmlns:p14="http://schemas.microsoft.com/office/powerpoint/2010/main" val="4242851619"/>
+        <p14:creationId xmlns:p14="http://schemas.microsoft.com/office/powerpoint/2010/main" val="229051056"/>
       </p:ext>
     </p:extLst>
   </p:cSld>
@@ -3546,7 +3546,7 @@
           <p:cNvPr id="2" name="Título 1">
             <a:extLst>
               <a:ext uri="{FF2B5EF4-FFF2-40B4-BE49-F238E27FC236}">
-                <a16:creationId xmlns:a16="http://schemas.microsoft.com/office/drawing/2014/main" id="{52D838CD-FB2A-25E6-0C14-F743E5618278}"/>
+                <a16:creationId xmlns:a16="http://schemas.microsoft.com/office/drawing/2014/main" id="{6FC9684E-DC86-C8B5-765D-A4EE56D2D78C}"/>
               </a:ext>
             </a:extLst>
           </p:cNvPr>
@@ -3574,7 +3574,7 @@
           <p:cNvPr id="3" name="Marcador de fecha 2">
             <a:extLst>
               <a:ext uri="{FF2B5EF4-FFF2-40B4-BE49-F238E27FC236}">
-                <a16:creationId xmlns:a16="http://schemas.microsoft.com/office/drawing/2014/main" id="{CFDD6E43-692E-C85C-9B49-3D221148A4BF}"/>
+                <a16:creationId xmlns:a16="http://schemas.microsoft.com/office/drawing/2014/main" id="{99EF652F-E672-4C22-4B46-AB48003DEE50}"/>
               </a:ext>
             </a:extLst>
           </p:cNvPr>
@@ -3590,9 +3590,9 @@
           <a:bodyPr/>
           <a:lstStyle/>
           <a:p>
-            <a:fld id="{0C062895-02B9-4539-8A29-6999C3E43A53}" type="datetimeFigureOut">
+            <a:fld id="{71A321C6-34C9-468A-BA2C-A274B4C2D06F}" type="datetimeFigureOut">
               <a:rPr lang="es-ES" smtClean="0"/>
-              <a:t>30/08/2026</a:t>
+              <a:t>31/08/2026</a:t>
             </a:fld>
             <a:endParaRPr lang="es-ES"/>
           </a:p>
@@ -3603,7 +3603,7 @@
           <p:cNvPr id="4" name="Marcador de pie de página 3">
             <a:extLst>
               <a:ext uri="{FF2B5EF4-FFF2-40B4-BE49-F238E27FC236}">
-                <a16:creationId xmlns:a16="http://schemas.microsoft.com/office/drawing/2014/main" id="{C8ED8E08-27AA-0874-4EAC-8F3C5B596F34}"/>
+                <a16:creationId xmlns:a16="http://schemas.microsoft.com/office/drawing/2014/main" id="{7A22FF9A-BD42-FFAF-DFB9-4CF9D038103E}"/>
               </a:ext>
             </a:extLst>
           </p:cNvPr>
@@ -3628,7 +3628,7 @@
           <p:cNvPr id="5" name="Marcador de número de diapositiva 4">
             <a:extLst>
               <a:ext uri="{FF2B5EF4-FFF2-40B4-BE49-F238E27FC236}">
-                <a16:creationId xmlns:a16="http://schemas.microsoft.com/office/drawing/2014/main" id="{8CAEB461-5DBB-B53B-A1B1-268B69325286}"/>
+                <a16:creationId xmlns:a16="http://schemas.microsoft.com/office/drawing/2014/main" id="{12D26FAD-4684-27A1-5644-59219F0478C4}"/>
               </a:ext>
             </a:extLst>
           </p:cNvPr>
@@ -3644,7 +3644,7 @@
           <a:bodyPr/>
           <a:lstStyle/>
           <a:p>
-            <a:fld id="{32D2AD85-226A-431D-94CD-1256CC25EA7B}" type="slidenum">
+            <a:fld id="{B8291F37-E9CF-4DA3-B181-C3E117B35066}" type="slidenum">
               <a:rPr lang="es-ES" smtClean="0"/>
               <a:t>‹Nº›</a:t>
             </a:fld>
@@ -3655,7 +3655,7 @@
     </p:spTree>
     <p:extLst>
       <p:ext uri="{BB962C8B-B14F-4D97-AF65-F5344CB8AC3E}">
-        <p14:creationId xmlns:p14="http://schemas.microsoft.com/office/powerpoint/2010/main" val="1098838332"/>
+        <p14:creationId xmlns:p14="http://schemas.microsoft.com/office/powerpoint/2010/main" val="4265451685"/>
       </p:ext>
     </p:extLst>
   </p:cSld>
@@ -3687,7 +3687,7 @@
           <p:cNvPr id="2" name="Marcador de fecha 1">
             <a:extLst>
               <a:ext uri="{FF2B5EF4-FFF2-40B4-BE49-F238E27FC236}">
-                <a16:creationId xmlns:a16="http://schemas.microsoft.com/office/drawing/2014/main" id="{23BDBC4E-ED4B-2977-B810-139EFF9302DA}"/>
+                <a16:creationId xmlns:a16="http://schemas.microsoft.com/office/drawing/2014/main" id="{F9A55191-44BE-EAAF-04DD-DC33CD4BDB91}"/>
               </a:ext>
             </a:extLst>
           </p:cNvPr>
@@ -3703,9 +3703,9 @@
           <a:bodyPr/>
           <a:lstStyle/>
           <a:p>
-            <a:fld id="{0C062895-02B9-4539-8A29-6999C3E43A53}" type="datetimeFigureOut">
+            <a:fld id="{71A321C6-34C9-468A-BA2C-A274B4C2D06F}" type="datetimeFigureOut">
               <a:rPr lang="es-ES" smtClean="0"/>
-              <a:t>30/08/2026</a:t>
+              <a:t>31/08/2026</a:t>
             </a:fld>
             <a:endParaRPr lang="es-ES"/>
           </a:p>
@@ -3716,7 +3716,7 @@
           <p:cNvPr id="3" name="Marcador de pie de página 2">
             <a:extLst>
               <a:ext uri="{FF2B5EF4-FFF2-40B4-BE49-F238E27FC236}">
-                <a16:creationId xmlns:a16="http://schemas.microsoft.com/office/drawing/2014/main" id="{1C61B963-96DA-B129-7718-681D10F6A469}"/>
+                <a16:creationId xmlns:a16="http://schemas.microsoft.com/office/drawing/2014/main" id="{4E4D33EE-B68D-0AE7-C8EE-B39A0EA21457}"/>
               </a:ext>
             </a:extLst>
           </p:cNvPr>
@@ -3741,7 +3741,7 @@
           <p:cNvPr id="4" name="Marcador de número de diapositiva 3">
             <a:extLst>
               <a:ext uri="{FF2B5EF4-FFF2-40B4-BE49-F238E27FC236}">
-                <a16:creationId xmlns:a16="http://schemas.microsoft.com/office/drawing/2014/main" id="{C3B8EE67-A66B-EB10-A68B-191F32B20EB1}"/>
+                <a16:creationId xmlns:a16="http://schemas.microsoft.com/office/drawing/2014/main" id="{41626DCB-B2BA-F081-4A2D-5A37875D93B4}"/>
               </a:ext>
             </a:extLst>
           </p:cNvPr>
@@ -3757,7 +3757,7 @@
           <a:bodyPr/>
           <a:lstStyle/>
           <a:p>
-            <a:fld id="{32D2AD85-226A-431D-94CD-1256CC25EA7B}" type="slidenum">
+            <a:fld id="{B8291F37-E9CF-4DA3-B181-C3E117B35066}" type="slidenum">
               <a:rPr lang="es-ES" smtClean="0"/>
               <a:t>‹Nº›</a:t>
             </a:fld>
@@ -3768,7 +3768,7 @@
     </p:spTree>
     <p:extLst>
       <p:ext uri="{BB962C8B-B14F-4D97-AF65-F5344CB8AC3E}">
-        <p14:creationId xmlns:p14="http://schemas.microsoft.com/office/powerpoint/2010/main" val="2347273436"/>
+        <p14:creationId xmlns:p14="http://schemas.microsoft.com/office/powerpoint/2010/main" val="3778748282"/>
       </p:ext>
     </p:extLst>
   </p:cSld>
@@ -3800,7 +3800,7 @@
           <p:cNvPr id="2" name="Título 1">
             <a:extLst>
               <a:ext uri="{FF2B5EF4-FFF2-40B4-BE49-F238E27FC236}">
-                <a16:creationId xmlns:a16="http://schemas.microsoft.com/office/drawing/2014/main" id="{16B1C087-3642-9EBC-CF37-76BAA7F4DF57}"/>
+                <a16:creationId xmlns:a16="http://schemas.microsoft.com/office/drawing/2014/main" id="{D05D323A-C2AA-097C-647C-5B4C998B18ED}"/>
               </a:ext>
             </a:extLst>
           </p:cNvPr>
@@ -3837,7 +3837,7 @@
           <p:cNvPr id="3" name="Marcador de contenido 2">
             <a:extLst>
               <a:ext uri="{FF2B5EF4-FFF2-40B4-BE49-F238E27FC236}">
-                <a16:creationId xmlns:a16="http://schemas.microsoft.com/office/drawing/2014/main" id="{2FBC9711-5CD3-AB53-08C4-96F9686F3B0B}"/>
+                <a16:creationId xmlns:a16="http://schemas.microsoft.com/office/drawing/2014/main" id="{C44E824B-1E39-3D6A-289A-C581BF264947}"/>
               </a:ext>
             </a:extLst>
           </p:cNvPr>
@@ -3927,7 +3927,7 @@
           <p:cNvPr id="4" name="Marcador de texto 3">
             <a:extLst>
               <a:ext uri="{FF2B5EF4-FFF2-40B4-BE49-F238E27FC236}">
-                <a16:creationId xmlns:a16="http://schemas.microsoft.com/office/drawing/2014/main" id="{58A499CA-6E30-65F3-82B2-7CE8C0B06E02}"/>
+                <a16:creationId xmlns:a16="http://schemas.microsoft.com/office/drawing/2014/main" id="{67749F16-00D8-48CE-7A83-5B6908AD23D1}"/>
               </a:ext>
             </a:extLst>
           </p:cNvPr>
@@ -3998,7 +3998,7 @@
           <p:cNvPr id="5" name="Marcador de fecha 4">
             <a:extLst>
               <a:ext uri="{FF2B5EF4-FFF2-40B4-BE49-F238E27FC236}">
-                <a16:creationId xmlns:a16="http://schemas.microsoft.com/office/drawing/2014/main" id="{703ED32A-68FC-66A5-1F38-C856AB0CB12A}"/>
+                <a16:creationId xmlns:a16="http://schemas.microsoft.com/office/drawing/2014/main" id="{444F5CAE-151E-B9D0-EDC0-827160248520}"/>
               </a:ext>
             </a:extLst>
           </p:cNvPr>
@@ -4014,9 +4014,9 @@
           <a:bodyPr/>
           <a:lstStyle/>
           <a:p>
-            <a:fld id="{0C062895-02B9-4539-8A29-6999C3E43A53}" type="datetimeFigureOut">
+            <a:fld id="{71A321C6-34C9-468A-BA2C-A274B4C2D06F}" type="datetimeFigureOut">
               <a:rPr lang="es-ES" smtClean="0"/>
-              <a:t>30/08/2026</a:t>
+              <a:t>31/08/2026</a:t>
             </a:fld>
             <a:endParaRPr lang="es-ES"/>
           </a:p>
@@ -4027,7 +4027,7 @@
           <p:cNvPr id="6" name="Marcador de pie de página 5">
             <a:extLst>
               <a:ext uri="{FF2B5EF4-FFF2-40B4-BE49-F238E27FC236}">
-                <a16:creationId xmlns:a16="http://schemas.microsoft.com/office/drawing/2014/main" id="{A9E0C3DC-67E9-8AD7-C8EA-852075519CE2}"/>
+                <a16:creationId xmlns:a16="http://schemas.microsoft.com/office/drawing/2014/main" id="{72B008CE-9BC6-45D8-692F-D429C5CF7216}"/>
               </a:ext>
             </a:extLst>
           </p:cNvPr>
@@ -4052,7 +4052,7 @@
           <p:cNvPr id="7" name="Marcador de número de diapositiva 6">
             <a:extLst>
               <a:ext uri="{FF2B5EF4-FFF2-40B4-BE49-F238E27FC236}">
-                <a16:creationId xmlns:a16="http://schemas.microsoft.com/office/drawing/2014/main" id="{00EA00AF-A9CD-8594-E088-7D736E0D140D}"/>
+                <a16:creationId xmlns:a16="http://schemas.microsoft.com/office/drawing/2014/main" id="{BAAE1F5C-FE90-14E6-D6E4-4C0FB9618614}"/>
               </a:ext>
             </a:extLst>
           </p:cNvPr>
@@ -4068,7 +4068,7 @@
           <a:bodyPr/>
           <a:lstStyle/>
           <a:p>
-            <a:fld id="{32D2AD85-226A-431D-94CD-1256CC25EA7B}" type="slidenum">
+            <a:fld id="{B8291F37-E9CF-4DA3-B181-C3E117B35066}" type="slidenum">
               <a:rPr lang="es-ES" smtClean="0"/>
               <a:t>‹Nº›</a:t>
             </a:fld>
@@ -4079,7 +4079,7 @@
     </p:spTree>
     <p:extLst>
       <p:ext uri="{BB962C8B-B14F-4D97-AF65-F5344CB8AC3E}">
-        <p14:creationId xmlns:p14="http://schemas.microsoft.com/office/powerpoint/2010/main" val="4014402258"/>
+        <p14:creationId xmlns:p14="http://schemas.microsoft.com/office/powerpoint/2010/main" val="3616995103"/>
       </p:ext>
     </p:extLst>
   </p:cSld>
@@ -4111,7 +4111,7 @@
           <p:cNvPr id="2" name="Título 1">
             <a:extLst>
               <a:ext uri="{FF2B5EF4-FFF2-40B4-BE49-F238E27FC236}">
-                <a16:creationId xmlns:a16="http://schemas.microsoft.com/office/drawing/2014/main" id="{E17F0D7A-D62E-40B7-D850-3A85DC858DD5}"/>
+                <a16:creationId xmlns:a16="http://schemas.microsoft.com/office/drawing/2014/main" id="{C46EFE78-31CD-B963-7A52-9E2B3E11E07C}"/>
               </a:ext>
             </a:extLst>
           </p:cNvPr>
@@ -4148,7 +4148,7 @@
           <p:cNvPr id="3" name="Marcador de posición de imagen 2">
             <a:extLst>
               <a:ext uri="{FF2B5EF4-FFF2-40B4-BE49-F238E27FC236}">
-                <a16:creationId xmlns:a16="http://schemas.microsoft.com/office/drawing/2014/main" id="{6CEF1E1F-6D65-A7C8-0D39-6CF2AEA2999B}"/>
+                <a16:creationId xmlns:a16="http://schemas.microsoft.com/office/drawing/2014/main" id="{50B2529B-276A-C1C4-6F31-2FF87421C7AB}"/>
               </a:ext>
             </a:extLst>
           </p:cNvPr>
@@ -4215,7 +4215,7 @@
           <p:cNvPr id="4" name="Marcador de texto 3">
             <a:extLst>
               <a:ext uri="{FF2B5EF4-FFF2-40B4-BE49-F238E27FC236}">
-                <a16:creationId xmlns:a16="http://schemas.microsoft.com/office/drawing/2014/main" id="{AC5879EB-CEC0-46AD-FCF2-851989D72CEB}"/>
+                <a16:creationId xmlns:a16="http://schemas.microsoft.com/office/drawing/2014/main" id="{1496FBEB-8758-D76E-993D-40DDBEB9380A}"/>
               </a:ext>
             </a:extLst>
           </p:cNvPr>
@@ -4286,7 +4286,7 @@
           <p:cNvPr id="5" name="Marcador de fecha 4">
             <a:extLst>
               <a:ext uri="{FF2B5EF4-FFF2-40B4-BE49-F238E27FC236}">
-                <a16:creationId xmlns:a16="http://schemas.microsoft.com/office/drawing/2014/main" id="{6720ABF9-16C8-D6B0-E312-8FA8BCE92EA5}"/>
+                <a16:creationId xmlns:a16="http://schemas.microsoft.com/office/drawing/2014/main" id="{D9B8323A-8882-3E8E-379F-064BA753FB31}"/>
               </a:ext>
             </a:extLst>
           </p:cNvPr>
@@ -4302,9 +4302,9 @@
           <a:bodyPr/>
           <a:lstStyle/>
           <a:p>
-            <a:fld id="{0C062895-02B9-4539-8A29-6999C3E43A53}" type="datetimeFigureOut">
+            <a:fld id="{71A321C6-34C9-468A-BA2C-A274B4C2D06F}" type="datetimeFigureOut">
               <a:rPr lang="es-ES" smtClean="0"/>
-              <a:t>30/08/2026</a:t>
+              <a:t>31/08/2026</a:t>
             </a:fld>
             <a:endParaRPr lang="es-ES"/>
           </a:p>
@@ -4315,7 +4315,7 @@
           <p:cNvPr id="6" name="Marcador de pie de página 5">
             <a:extLst>
               <a:ext uri="{FF2B5EF4-FFF2-40B4-BE49-F238E27FC236}">
-                <a16:creationId xmlns:a16="http://schemas.microsoft.com/office/drawing/2014/main" id="{24C0EC0B-F14F-EB74-2B73-46507B3DEDD9}"/>
+                <a16:creationId xmlns:a16="http://schemas.microsoft.com/office/drawing/2014/main" id="{22344C40-513A-EB01-44A4-AB71F5F8B85F}"/>
               </a:ext>
             </a:extLst>
           </p:cNvPr>
@@ -4340,7 +4340,7 @@
           <p:cNvPr id="7" name="Marcador de número de diapositiva 6">
             <a:extLst>
               <a:ext uri="{FF2B5EF4-FFF2-40B4-BE49-F238E27FC236}">
-                <a16:creationId xmlns:a16="http://schemas.microsoft.com/office/drawing/2014/main" id="{1705E5DC-2170-C950-7A29-3B7BF42397D2}"/>
+                <a16:creationId xmlns:a16="http://schemas.microsoft.com/office/drawing/2014/main" id="{0141A224-EF1D-1D36-905B-653E0B29EE5F}"/>
               </a:ext>
             </a:extLst>
           </p:cNvPr>
@@ -4356,7 +4356,7 @@
           <a:bodyPr/>
           <a:lstStyle/>
           <a:p>
-            <a:fld id="{32D2AD85-226A-431D-94CD-1256CC25EA7B}" type="slidenum">
+            <a:fld id="{B8291F37-E9CF-4DA3-B181-C3E117B35066}" type="slidenum">
               <a:rPr lang="es-ES" smtClean="0"/>
               <a:t>‹Nº›</a:t>
             </a:fld>
@@ -4367,7 +4367,7 @@
     </p:spTree>
     <p:extLst>
       <p:ext uri="{BB962C8B-B14F-4D97-AF65-F5344CB8AC3E}">
-        <p14:creationId xmlns:p14="http://schemas.microsoft.com/office/powerpoint/2010/main" val="1665151566"/>
+        <p14:creationId xmlns:p14="http://schemas.microsoft.com/office/powerpoint/2010/main" val="612623675"/>
       </p:ext>
     </p:extLst>
   </p:cSld>
@@ -4404,7 +4404,7 @@
           <p:cNvPr id="2" name="Marcador de título 1">
             <a:extLst>
               <a:ext uri="{FF2B5EF4-FFF2-40B4-BE49-F238E27FC236}">
-                <a16:creationId xmlns:a16="http://schemas.microsoft.com/office/drawing/2014/main" id="{325E07CD-888D-08C7-D9B2-2003E1B12611}"/>
+                <a16:creationId xmlns:a16="http://schemas.microsoft.com/office/drawing/2014/main" id="{ECAD88B6-24DE-A2EE-C7E5-25B076AAA839}"/>
               </a:ext>
             </a:extLst>
           </p:cNvPr>
@@ -4442,7 +4442,7 @@
           <p:cNvPr id="3" name="Marcador de texto 2">
             <a:extLst>
               <a:ext uri="{FF2B5EF4-FFF2-40B4-BE49-F238E27FC236}">
-                <a16:creationId xmlns:a16="http://schemas.microsoft.com/office/drawing/2014/main" id="{335A8A78-5928-5DDB-2B65-856F9405DC45}"/>
+                <a16:creationId xmlns:a16="http://schemas.microsoft.com/office/drawing/2014/main" id="{72DF2E3C-472E-F633-76A9-0FF1728C3EA6}"/>
               </a:ext>
             </a:extLst>
           </p:cNvPr>
@@ -4509,7 +4509,7 @@
           <p:cNvPr id="4" name="Marcador de fecha 3">
             <a:extLst>
               <a:ext uri="{FF2B5EF4-FFF2-40B4-BE49-F238E27FC236}">
-                <a16:creationId xmlns:a16="http://schemas.microsoft.com/office/drawing/2014/main" id="{513ABB17-A8B4-70F2-A36E-C2A5B0BC6B72}"/>
+                <a16:creationId xmlns:a16="http://schemas.microsoft.com/office/drawing/2014/main" id="{A3145302-DC40-93F7-C38D-0D6F246D8A1D}"/>
               </a:ext>
             </a:extLst>
           </p:cNvPr>
@@ -4543,9 +4543,9 @@
             </a:lvl1pPr>
           </a:lstStyle>
           <a:p>
-            <a:fld id="{0C062895-02B9-4539-8A29-6999C3E43A53}" type="datetimeFigureOut">
+            <a:fld id="{71A321C6-34C9-468A-BA2C-A274B4C2D06F}" type="datetimeFigureOut">
               <a:rPr lang="es-ES" smtClean="0"/>
-              <a:t>30/08/2026</a:t>
+              <a:t>31/08/2026</a:t>
             </a:fld>
             <a:endParaRPr lang="es-ES"/>
           </a:p>
@@ -4556,7 +4556,7 @@
           <p:cNvPr id="5" name="Marcador de pie de página 4">
             <a:extLst>
               <a:ext uri="{FF2B5EF4-FFF2-40B4-BE49-F238E27FC236}">
-                <a16:creationId xmlns:a16="http://schemas.microsoft.com/office/drawing/2014/main" id="{579958F8-2DB2-BAC9-43CF-69C44DE858A1}"/>
+                <a16:creationId xmlns:a16="http://schemas.microsoft.com/office/drawing/2014/main" id="{5AC8463C-CAE7-2036-9B01-918EE941DB8E}"/>
               </a:ext>
             </a:extLst>
           </p:cNvPr>
@@ -4599,7 +4599,7 @@
           <p:cNvPr id="6" name="Marcador de número de diapositiva 5">
             <a:extLst>
               <a:ext uri="{FF2B5EF4-FFF2-40B4-BE49-F238E27FC236}">
-                <a16:creationId xmlns:a16="http://schemas.microsoft.com/office/drawing/2014/main" id="{41417D5E-9870-4B22-B515-745E711105F0}"/>
+                <a16:creationId xmlns:a16="http://schemas.microsoft.com/office/drawing/2014/main" id="{A56A3FD2-B2E9-262A-32AA-89A7BECEE003}"/>
               </a:ext>
             </a:extLst>
           </p:cNvPr>
@@ -4633,7 +4633,7 @@
             </a:lvl1pPr>
           </a:lstStyle>
           <a:p>
-            <a:fld id="{32D2AD85-226A-431D-94CD-1256CC25EA7B}" type="slidenum">
+            <a:fld id="{B8291F37-E9CF-4DA3-B181-C3E117B35066}" type="slidenum">
               <a:rPr lang="es-ES" smtClean="0"/>
               <a:t>‹Nº›</a:t>
             </a:fld>
@@ -4644,7 +4644,7 @@
     </p:spTree>
     <p:extLst>
       <p:ext uri="{BB962C8B-B14F-4D97-AF65-F5344CB8AC3E}">
-        <p14:creationId xmlns:p14="http://schemas.microsoft.com/office/powerpoint/2010/main" val="3450793291"/>
+        <p14:creationId xmlns:p14="http://schemas.microsoft.com/office/powerpoint/2010/main" val="3097989790"/>
       </p:ext>
     </p:extLst>
   </p:cSld>
@@ -4975,7 +4975,7 @@
           <p:cNvPr id="2" name="Accent field">
             <a:extLst>
               <a:ext uri="{FF2B5EF4-FFF2-40B4-BE49-F238E27FC236}">
-                <a16:creationId xmlns:a16="http://schemas.microsoft.com/office/drawing/2014/main" id="{579A25A2-22A0-93C2-9544-F1BAAC8C165C}"/>
+                <a16:creationId xmlns:a16="http://schemas.microsoft.com/office/drawing/2014/main" id="{5BF2640F-172B-2D00-1C5A-ABDC5629E8F8}"/>
               </a:ext>
             </a:extLst>
           </p:cNvPr>
@@ -5043,7 +5043,7 @@
           <p:cNvPr id="3" name="Cover accent">
             <a:extLst>
               <a:ext uri="{FF2B5EF4-FFF2-40B4-BE49-F238E27FC236}">
-                <a16:creationId xmlns:a16="http://schemas.microsoft.com/office/drawing/2014/main" id="{00DC7F2F-B423-1673-129F-5C7E05D0A45C}"/>
+                <a16:creationId xmlns:a16="http://schemas.microsoft.com/office/drawing/2014/main" id="{B49F7BC1-3069-B672-CDE3-55BF9E7864F9}"/>
               </a:ext>
             </a:extLst>
           </p:cNvPr>
@@ -5084,7 +5084,7 @@
           <p:cNvPr id="4" name="Cover secondary accent">
             <a:extLst>
               <a:ext uri="{FF2B5EF4-FFF2-40B4-BE49-F238E27FC236}">
-                <a16:creationId xmlns:a16="http://schemas.microsoft.com/office/drawing/2014/main" id="{85C21662-3021-DA26-E8CE-CC9AF12477CB}"/>
+                <a16:creationId xmlns:a16="http://schemas.microsoft.com/office/drawing/2014/main" id="{0FBB6233-898A-BA1A-6DD1-28C95C00482B}"/>
               </a:ext>
             </a:extLst>
           </p:cNvPr>
@@ -5125,7 +5125,7 @@
           <p:cNvPr id="5" name="Eyebrow">
             <a:extLst>
               <a:ext uri="{FF2B5EF4-FFF2-40B4-BE49-F238E27FC236}">
-                <a16:creationId xmlns:a16="http://schemas.microsoft.com/office/drawing/2014/main" id="{BED0055D-19F1-CA70-9157-9D8D7DB9A972}"/>
+                <a16:creationId xmlns:a16="http://schemas.microsoft.com/office/drawing/2014/main" id="{52B92CB4-31D0-BABB-222F-B0D22431AEF8}"/>
               </a:ext>
             </a:extLst>
           </p:cNvPr>
@@ -5170,7 +5170,7 @@
           <p:cNvPr id="6" name="Deck title">
             <a:extLst>
               <a:ext uri="{FF2B5EF4-FFF2-40B4-BE49-F238E27FC236}">
-                <a16:creationId xmlns:a16="http://schemas.microsoft.com/office/drawing/2014/main" id="{8CB24675-B676-A69E-777D-C79C5294BBD0}"/>
+                <a16:creationId xmlns:a16="http://schemas.microsoft.com/office/drawing/2014/main" id="{4212A658-33EC-F01A-9601-2C84B9859DEE}"/>
               </a:ext>
             </a:extLst>
           </p:cNvPr>
@@ -5216,7 +5216,7 @@
           <p:cNvPr id="7" name="Subtitle">
             <a:extLst>
               <a:ext uri="{FF2B5EF4-FFF2-40B4-BE49-F238E27FC236}">
-                <a16:creationId xmlns:a16="http://schemas.microsoft.com/office/drawing/2014/main" id="{59EC86AD-B3DB-A750-53C2-17F539FBFF6A}"/>
+                <a16:creationId xmlns:a16="http://schemas.microsoft.com/office/drawing/2014/main" id="{3C5F2114-CA07-CCDE-A240-86FDFEF948DA}"/>
               </a:ext>
             </a:extLst>
           </p:cNvPr>
@@ -5261,7 +5261,7 @@
           <p:cNvPr id="8" name="Author">
             <a:extLst>
               <a:ext uri="{FF2B5EF4-FFF2-40B4-BE49-F238E27FC236}">
-                <a16:creationId xmlns:a16="http://schemas.microsoft.com/office/drawing/2014/main" id="{93415A81-B9E9-69DE-2AB4-F52F6EFFBADE}"/>
+                <a16:creationId xmlns:a16="http://schemas.microsoft.com/office/drawing/2014/main" id="{40FE3776-5485-33E9-95ED-50A9671FEEFC}"/>
               </a:ext>
             </a:extLst>
           </p:cNvPr>
@@ -5306,7 +5306,7 @@
           <p:cNvPr id="9" name="Tutor">
             <a:extLst>
               <a:ext uri="{FF2B5EF4-FFF2-40B4-BE49-F238E27FC236}">
-                <a16:creationId xmlns:a16="http://schemas.microsoft.com/office/drawing/2014/main" id="{EDC8FE3B-B12D-4EED-7788-C8ACAEB19D31}"/>
+                <a16:creationId xmlns:a16="http://schemas.microsoft.com/office/drawing/2014/main" id="{3A78F284-8678-F1A9-8073-F128DC56E88F}"/>
               </a:ext>
             </a:extLst>
           </p:cNvPr>
@@ -5351,7 +5351,7 @@
           <p:cNvPr id="10" name="Cover mark">
             <a:extLst>
               <a:ext uri="{FF2B5EF4-FFF2-40B4-BE49-F238E27FC236}">
-                <a16:creationId xmlns:a16="http://schemas.microsoft.com/office/drawing/2014/main" id="{B3ACB225-2561-3DFC-7BC3-370DADCF5B9F}"/>
+                <a16:creationId xmlns:a16="http://schemas.microsoft.com/office/drawing/2014/main" id="{191648A7-3C1E-D06C-204F-5065ACDEB318}"/>
               </a:ext>
             </a:extLst>
           </p:cNvPr>
@@ -5394,7 +5394,7 @@
     </p:spTree>
     <p:extLst>
       <p:ext uri="{BB962C8B-B14F-4D97-AF65-F5344CB8AC3E}">
-        <p14:creationId xmlns:p14="http://schemas.microsoft.com/office/powerpoint/2010/main" val="1191948664"/>
+        <p14:creationId xmlns:p14="http://schemas.microsoft.com/office/powerpoint/2010/main" val="1503223368"/>
       </p:ext>
     </p:extLst>
   </p:cSld>
@@ -5434,7 +5434,7 @@
           <p:cNvPr id="2" name="Section">
             <a:extLst>
               <a:ext uri="{FF2B5EF4-FFF2-40B4-BE49-F238E27FC236}">
-                <a16:creationId xmlns:a16="http://schemas.microsoft.com/office/drawing/2014/main" id="{7B066443-65BA-C977-E041-0356704DF9A6}"/>
+                <a16:creationId xmlns:a16="http://schemas.microsoft.com/office/drawing/2014/main" id="{BF86F60E-D99A-81C9-2AA6-825D3906012F}"/>
               </a:ext>
             </a:extLst>
           </p:cNvPr>
@@ -5479,7 +5479,7 @@
           <p:cNvPr id="3" name="Slide title">
             <a:extLst>
               <a:ext uri="{FF2B5EF4-FFF2-40B4-BE49-F238E27FC236}">
-                <a16:creationId xmlns:a16="http://schemas.microsoft.com/office/drawing/2014/main" id="{86C2C0B0-EB2D-C4A3-11A9-336E5D202A93}"/>
+                <a16:creationId xmlns:a16="http://schemas.microsoft.com/office/drawing/2014/main" id="{3B65D5C4-D22B-51A7-59D9-1DB2786A4B34}"/>
               </a:ext>
             </a:extLst>
           </p:cNvPr>
@@ -5524,7 +5524,7 @@
           <p:cNvPr id="4" name="Accent rule">
             <a:extLst>
               <a:ext uri="{FF2B5EF4-FFF2-40B4-BE49-F238E27FC236}">
-                <a16:creationId xmlns:a16="http://schemas.microsoft.com/office/drawing/2014/main" id="{EE54E7E4-7CBE-1AB5-C191-F2DCFB26CA56}"/>
+                <a16:creationId xmlns:a16="http://schemas.microsoft.com/office/drawing/2014/main" id="{BEE996D4-187C-1998-FBC6-DDC08D1FC8CC}"/>
               </a:ext>
             </a:extLst>
           </p:cNvPr>
@@ -5565,7 +5565,7 @@
           <p:cNvPr id="5" name="Footer author">
             <a:extLst>
               <a:ext uri="{FF2B5EF4-FFF2-40B4-BE49-F238E27FC236}">
-                <a16:creationId xmlns:a16="http://schemas.microsoft.com/office/drawing/2014/main" id="{88F63AE6-1E31-C82F-7485-AD34990B6030}"/>
+                <a16:creationId xmlns:a16="http://schemas.microsoft.com/office/drawing/2014/main" id="{0685FB68-2E7A-E53E-4953-4E278CEB9503}"/>
               </a:ext>
             </a:extLst>
           </p:cNvPr>
@@ -5610,7 +5610,7 @@
           <p:cNvPr id="6" name="Slide number">
             <a:extLst>
               <a:ext uri="{FF2B5EF4-FFF2-40B4-BE49-F238E27FC236}">
-                <a16:creationId xmlns:a16="http://schemas.microsoft.com/office/drawing/2014/main" id="{55C5EB55-3193-E533-9C17-A28400DC7C18}"/>
+                <a16:creationId xmlns:a16="http://schemas.microsoft.com/office/drawing/2014/main" id="{7957D524-B617-2858-CFCF-ADCC274E72FE}"/>
               </a:ext>
             </a:extLst>
           </p:cNvPr>
@@ -5655,16 +5655,16 @@
           <p:cNvPr id="7" name="Chart subtitle">
             <a:extLst>
               <a:ext uri="{FF2B5EF4-FFF2-40B4-BE49-F238E27FC236}">
-                <a16:creationId xmlns:a16="http://schemas.microsoft.com/office/drawing/2014/main" id="{7DBCB663-B45E-FE0A-2793-40366BFEEB59}"/>
-              </a:ext>
-            </a:extLst>
-          </p:cNvPr>
-          <p:cNvSpPr txBox="1"/>
-          <p:nvPr/>
-        </p:nvSpPr>
-        <p:spPr>
-          <a:xfrm>
-            <a:off x="863600" y="1536700"/>
+                <a16:creationId xmlns:a16="http://schemas.microsoft.com/office/drawing/2014/main" id="{09A4AFD2-BB71-D63A-2349-6337D95C5439}"/>
+              </a:ext>
+            </a:extLst>
+          </p:cNvPr>
+          <p:cNvSpPr txBox="1"/>
+          <p:nvPr/>
+        </p:nvSpPr>
+        <p:spPr>
+          <a:xfrm>
+            <a:off x="863600" y="1435100"/>
             <a:ext cx="5207000" cy="276999"/>
           </a:xfrm>
           <a:prstGeom prst="rect">
@@ -5700,7 +5700,7 @@
           <p:cNvPr id="8" name="Chart axis">
             <a:extLst>
               <a:ext uri="{FF2B5EF4-FFF2-40B4-BE49-F238E27FC236}">
-                <a16:creationId xmlns:a16="http://schemas.microsoft.com/office/drawing/2014/main" id="{049EA37F-50F4-2A4C-9745-07402E96A0FD}"/>
+                <a16:creationId xmlns:a16="http://schemas.microsoft.com/office/drawing/2014/main" id="{6C206354-37C7-1330-FE27-A29A36E942F8}"/>
               </a:ext>
             </a:extLst>
           </p:cNvPr>
@@ -5709,7 +5709,7 @@
         </p:nvCxnSpPr>
         <p:spPr>
           <a:xfrm>
-            <a:off x="2565400" y="5613400"/>
+            <a:off x="2565400" y="5816600"/>
             <a:ext cx="4826000" cy="0"/>
           </a:xfrm>
           <a:prstGeom prst="line">
@@ -5741,7 +5741,7 @@
           <p:cNvPr id="9" name="Grid 0">
             <a:extLst>
               <a:ext uri="{FF2B5EF4-FFF2-40B4-BE49-F238E27FC236}">
-                <a16:creationId xmlns:a16="http://schemas.microsoft.com/office/drawing/2014/main" id="{3F5431E2-F52C-9556-27A8-C893BEA0F305}"/>
+                <a16:creationId xmlns:a16="http://schemas.microsoft.com/office/drawing/2014/main" id="{44D97308-6955-D283-55E1-84554294C388}"/>
               </a:ext>
             </a:extLst>
           </p:cNvPr>
@@ -5750,8 +5750,8 @@
         </p:nvCxnSpPr>
         <p:spPr>
           <a:xfrm>
-            <a:off x="2565400" y="2006600"/>
-            <a:ext cx="0" cy="3606800"/>
+            <a:off x="2565400" y="2235200"/>
+            <a:ext cx="0" cy="3581400"/>
           </a:xfrm>
           <a:prstGeom prst="line">
             <a:avLst/>
@@ -5782,16 +5782,16 @@
           <p:cNvPr id="10" name="Tick 0">
             <a:extLst>
               <a:ext uri="{FF2B5EF4-FFF2-40B4-BE49-F238E27FC236}">
-                <a16:creationId xmlns:a16="http://schemas.microsoft.com/office/drawing/2014/main" id="{398E9EAF-93F2-E666-5FE9-6DE715B9A2D6}"/>
-              </a:ext>
-            </a:extLst>
-          </p:cNvPr>
-          <p:cNvSpPr txBox="1"/>
-          <p:nvPr/>
-        </p:nvSpPr>
-        <p:spPr>
-          <a:xfrm>
-            <a:off x="2387600" y="5727700"/>
+                <a16:creationId xmlns:a16="http://schemas.microsoft.com/office/drawing/2014/main" id="{8ECE95AB-0836-F23F-2896-A123B0242865}"/>
+              </a:ext>
+            </a:extLst>
+          </p:cNvPr>
+          <p:cNvSpPr txBox="1"/>
+          <p:nvPr/>
+        </p:nvSpPr>
+        <p:spPr>
+          <a:xfrm>
+            <a:off x="2387600" y="5930900"/>
             <a:ext cx="355600" cy="276999"/>
           </a:xfrm>
           <a:prstGeom prst="rect">
@@ -5827,7 +5827,7 @@
           <p:cNvPr id="11" name="Grid 25">
             <a:extLst>
               <a:ext uri="{FF2B5EF4-FFF2-40B4-BE49-F238E27FC236}">
-                <a16:creationId xmlns:a16="http://schemas.microsoft.com/office/drawing/2014/main" id="{9994E793-A0A6-D06C-D926-A2BB550D351F}"/>
+                <a16:creationId xmlns:a16="http://schemas.microsoft.com/office/drawing/2014/main" id="{32735625-DE36-4622-AD9B-44BA2E88B7F5}"/>
               </a:ext>
             </a:extLst>
           </p:cNvPr>
@@ -5836,8 +5836,8 @@
         </p:nvCxnSpPr>
         <p:spPr>
           <a:xfrm>
-            <a:off x="3771900" y="2006600"/>
-            <a:ext cx="0" cy="3606800"/>
+            <a:off x="3771900" y="2235200"/>
+            <a:ext cx="0" cy="3581400"/>
           </a:xfrm>
           <a:prstGeom prst="line">
             <a:avLst/>
@@ -5868,16 +5868,16 @@
           <p:cNvPr id="12" name="Tick 25">
             <a:extLst>
               <a:ext uri="{FF2B5EF4-FFF2-40B4-BE49-F238E27FC236}">
-                <a16:creationId xmlns:a16="http://schemas.microsoft.com/office/drawing/2014/main" id="{EA74CCC4-9565-2AEF-C1DC-4585F5C57F8E}"/>
-              </a:ext>
-            </a:extLst>
-          </p:cNvPr>
-          <p:cNvSpPr txBox="1"/>
-          <p:nvPr/>
-        </p:nvSpPr>
-        <p:spPr>
-          <a:xfrm>
-            <a:off x="3594100" y="5727700"/>
+                <a16:creationId xmlns:a16="http://schemas.microsoft.com/office/drawing/2014/main" id="{FAF0B68E-1754-7BCA-4DB1-22F40EAFA254}"/>
+              </a:ext>
+            </a:extLst>
+          </p:cNvPr>
+          <p:cNvSpPr txBox="1"/>
+          <p:nvPr/>
+        </p:nvSpPr>
+        <p:spPr>
+          <a:xfrm>
+            <a:off x="3594100" y="5930900"/>
             <a:ext cx="355600" cy="276999"/>
           </a:xfrm>
           <a:prstGeom prst="rect">
@@ -5913,7 +5913,7 @@
           <p:cNvPr id="13" name="Grid 50">
             <a:extLst>
               <a:ext uri="{FF2B5EF4-FFF2-40B4-BE49-F238E27FC236}">
-                <a16:creationId xmlns:a16="http://schemas.microsoft.com/office/drawing/2014/main" id="{8D395468-E910-47EB-454A-01E4720F5817}"/>
+                <a16:creationId xmlns:a16="http://schemas.microsoft.com/office/drawing/2014/main" id="{9A7C08D4-7017-87E6-F17B-A673D5FBC5B0}"/>
               </a:ext>
             </a:extLst>
           </p:cNvPr>
@@ -5922,8 +5922,8 @@
         </p:nvCxnSpPr>
         <p:spPr>
           <a:xfrm>
-            <a:off x="4978400" y="2006600"/>
-            <a:ext cx="0" cy="3606800"/>
+            <a:off x="4978400" y="2235200"/>
+            <a:ext cx="0" cy="3581400"/>
           </a:xfrm>
           <a:prstGeom prst="line">
             <a:avLst/>
@@ -5954,16 +5954,16 @@
           <p:cNvPr id="14" name="Tick 50">
             <a:extLst>
               <a:ext uri="{FF2B5EF4-FFF2-40B4-BE49-F238E27FC236}">
-                <a16:creationId xmlns:a16="http://schemas.microsoft.com/office/drawing/2014/main" id="{D47B7408-B524-7AE9-75D8-FA7888A42F36}"/>
-              </a:ext>
-            </a:extLst>
-          </p:cNvPr>
-          <p:cNvSpPr txBox="1"/>
-          <p:nvPr/>
-        </p:nvSpPr>
-        <p:spPr>
-          <a:xfrm>
-            <a:off x="4800600" y="5727700"/>
+                <a16:creationId xmlns:a16="http://schemas.microsoft.com/office/drawing/2014/main" id="{95EF9C77-D69C-F424-C63A-41CF740FBA77}"/>
+              </a:ext>
+            </a:extLst>
+          </p:cNvPr>
+          <p:cNvSpPr txBox="1"/>
+          <p:nvPr/>
+        </p:nvSpPr>
+        <p:spPr>
+          <a:xfrm>
+            <a:off x="4800600" y="5930900"/>
             <a:ext cx="355600" cy="276999"/>
           </a:xfrm>
           <a:prstGeom prst="rect">
@@ -5999,7 +5999,7 @@
           <p:cNvPr id="15" name="Grid 75">
             <a:extLst>
               <a:ext uri="{FF2B5EF4-FFF2-40B4-BE49-F238E27FC236}">
-                <a16:creationId xmlns:a16="http://schemas.microsoft.com/office/drawing/2014/main" id="{F7F12925-2128-D274-0A06-3C595B186A08}"/>
+                <a16:creationId xmlns:a16="http://schemas.microsoft.com/office/drawing/2014/main" id="{BF4CEC79-A9A6-840D-2026-BC7BED969772}"/>
               </a:ext>
             </a:extLst>
           </p:cNvPr>
@@ -6008,8 +6008,8 @@
         </p:nvCxnSpPr>
         <p:spPr>
           <a:xfrm>
-            <a:off x="6184900" y="2006600"/>
-            <a:ext cx="0" cy="3606800"/>
+            <a:off x="6184900" y="2235200"/>
+            <a:ext cx="0" cy="3581400"/>
           </a:xfrm>
           <a:prstGeom prst="line">
             <a:avLst/>
@@ -6040,16 +6040,16 @@
           <p:cNvPr id="16" name="Tick 75">
             <a:extLst>
               <a:ext uri="{FF2B5EF4-FFF2-40B4-BE49-F238E27FC236}">
-                <a16:creationId xmlns:a16="http://schemas.microsoft.com/office/drawing/2014/main" id="{71407645-4CA2-C5E2-6C95-0CF2D1422CD2}"/>
-              </a:ext>
-            </a:extLst>
-          </p:cNvPr>
-          <p:cNvSpPr txBox="1"/>
-          <p:nvPr/>
-        </p:nvSpPr>
-        <p:spPr>
-          <a:xfrm>
-            <a:off x="6007100" y="5727700"/>
+                <a16:creationId xmlns:a16="http://schemas.microsoft.com/office/drawing/2014/main" id="{A7037740-3B07-5BEE-2A3D-6E6126C4B5E5}"/>
+              </a:ext>
+            </a:extLst>
+          </p:cNvPr>
+          <p:cNvSpPr txBox="1"/>
+          <p:nvPr/>
+        </p:nvSpPr>
+        <p:spPr>
+          <a:xfrm>
+            <a:off x="6007100" y="5930900"/>
             <a:ext cx="355600" cy="276999"/>
           </a:xfrm>
           <a:prstGeom prst="rect">
@@ -6085,7 +6085,7 @@
           <p:cNvPr id="17" name="Grid 100">
             <a:extLst>
               <a:ext uri="{FF2B5EF4-FFF2-40B4-BE49-F238E27FC236}">
-                <a16:creationId xmlns:a16="http://schemas.microsoft.com/office/drawing/2014/main" id="{8540CE09-32F8-BCDB-4219-C4B55BC0C1B4}"/>
+                <a16:creationId xmlns:a16="http://schemas.microsoft.com/office/drawing/2014/main" id="{085C963E-8C34-4390-3D23-0A524FB192DD}"/>
               </a:ext>
             </a:extLst>
           </p:cNvPr>
@@ -6094,8 +6094,8 @@
         </p:nvCxnSpPr>
         <p:spPr>
           <a:xfrm>
-            <a:off x="7391400" y="2006600"/>
-            <a:ext cx="0" cy="3606800"/>
+            <a:off x="7391400" y="2235200"/>
+            <a:ext cx="0" cy="3581400"/>
           </a:xfrm>
           <a:prstGeom prst="line">
             <a:avLst/>
@@ -6126,16 +6126,16 @@
           <p:cNvPr id="18" name="Tick 100">
             <a:extLst>
               <a:ext uri="{FF2B5EF4-FFF2-40B4-BE49-F238E27FC236}">
-                <a16:creationId xmlns:a16="http://schemas.microsoft.com/office/drawing/2014/main" id="{82D34BA5-A0E0-E0D1-454E-4582EBD65165}"/>
-              </a:ext>
-            </a:extLst>
-          </p:cNvPr>
-          <p:cNvSpPr txBox="1"/>
-          <p:nvPr/>
-        </p:nvSpPr>
-        <p:spPr>
-          <a:xfrm>
-            <a:off x="7213600" y="5727700"/>
+                <a16:creationId xmlns:a16="http://schemas.microsoft.com/office/drawing/2014/main" id="{4E300757-10C4-965F-74A3-D3B809770347}"/>
+              </a:ext>
+            </a:extLst>
+          </p:cNvPr>
+          <p:cNvSpPr txBox="1"/>
+          <p:nvPr/>
+        </p:nvSpPr>
+        <p:spPr>
+          <a:xfrm>
+            <a:off x="7213600" y="5930900"/>
             <a:ext cx="355600" cy="276999"/>
           </a:xfrm>
           <a:prstGeom prst="rect">
@@ -6171,7 +6171,7 @@
           <p:cNvPr id="19" name="Legend swatch">
             <a:extLst>
               <a:ext uri="{FF2B5EF4-FFF2-40B4-BE49-F238E27FC236}">
-                <a16:creationId xmlns:a16="http://schemas.microsoft.com/office/drawing/2014/main" id="{F1397946-8F2B-FF51-5388-70471B190A4F}"/>
+                <a16:creationId xmlns:a16="http://schemas.microsoft.com/office/drawing/2014/main" id="{AFE2A7E5-9D51-8B0C-78F3-8DB0BCB48F4B}"/>
               </a:ext>
             </a:extLst>
           </p:cNvPr>
@@ -6180,7 +6180,7 @@
         </p:nvSpPr>
         <p:spPr>
           <a:xfrm>
-            <a:off x="2667000" y="1676400"/>
+            <a:off x="2667000" y="1905000"/>
             <a:ext cx="139700" cy="139700"/>
           </a:xfrm>
           <a:prstGeom prst="rect">
@@ -6239,16 +6239,16 @@
           <p:cNvPr id="20" name="Legend">
             <a:extLst>
               <a:ext uri="{FF2B5EF4-FFF2-40B4-BE49-F238E27FC236}">
-                <a16:creationId xmlns:a16="http://schemas.microsoft.com/office/drawing/2014/main" id="{FC9376B8-C350-365C-D0FC-841C81A3436D}"/>
-              </a:ext>
-            </a:extLst>
-          </p:cNvPr>
-          <p:cNvSpPr txBox="1"/>
-          <p:nvPr/>
-        </p:nvSpPr>
-        <p:spPr>
-          <a:xfrm>
-            <a:off x="2882900" y="1625600"/>
+                <a16:creationId xmlns:a16="http://schemas.microsoft.com/office/drawing/2014/main" id="{D08BF4B8-83E9-FCB6-C33E-95D94EE8F246}"/>
+              </a:ext>
+            </a:extLst>
+          </p:cNvPr>
+          <p:cNvSpPr txBox="1"/>
+          <p:nvPr/>
+        </p:nvSpPr>
+        <p:spPr>
+          <a:xfrm>
+            <a:off x="2882900" y="1854200"/>
             <a:ext cx="914400" cy="276999"/>
           </a:xfrm>
           <a:prstGeom prst="rect">
@@ -6284,7 +6284,7 @@
           <p:cNvPr id="21" name="Legend swatch">
             <a:extLst>
               <a:ext uri="{FF2B5EF4-FFF2-40B4-BE49-F238E27FC236}">
-                <a16:creationId xmlns:a16="http://schemas.microsoft.com/office/drawing/2014/main" id="{4E3DB846-3A8D-9518-9C8E-CC5A21A16B88}"/>
+                <a16:creationId xmlns:a16="http://schemas.microsoft.com/office/drawing/2014/main" id="{9D8315AB-AF06-3FFC-D9C8-7D15D82A606B}"/>
               </a:ext>
             </a:extLst>
           </p:cNvPr>
@@ -6293,7 +6293,7 @@
         </p:nvSpPr>
         <p:spPr>
           <a:xfrm>
-            <a:off x="3937000" y="1676400"/>
+            <a:off x="3937000" y="1905000"/>
             <a:ext cx="139700" cy="139700"/>
           </a:xfrm>
           <a:prstGeom prst="rect">
@@ -6352,16 +6352,16 @@
           <p:cNvPr id="22" name="Legend">
             <a:extLst>
               <a:ext uri="{FF2B5EF4-FFF2-40B4-BE49-F238E27FC236}">
-                <a16:creationId xmlns:a16="http://schemas.microsoft.com/office/drawing/2014/main" id="{9A966DE6-2ED5-35FD-3D79-A9668707F5A0}"/>
-              </a:ext>
-            </a:extLst>
-          </p:cNvPr>
-          <p:cNvSpPr txBox="1"/>
-          <p:nvPr/>
-        </p:nvSpPr>
-        <p:spPr>
-          <a:xfrm>
-            <a:off x="4152900" y="1625600"/>
+                <a16:creationId xmlns:a16="http://schemas.microsoft.com/office/drawing/2014/main" id="{9FFFBCDF-34A8-0C86-973B-C9F5DECA33B7}"/>
+              </a:ext>
+            </a:extLst>
+          </p:cNvPr>
+          <p:cNvSpPr txBox="1"/>
+          <p:nvPr/>
+        </p:nvSpPr>
+        <p:spPr>
+          <a:xfrm>
+            <a:off x="4152900" y="1854200"/>
             <a:ext cx="914400" cy="276999"/>
           </a:xfrm>
           <a:prstGeom prst="rect">
@@ -6397,7 +6397,7 @@
           <p:cNvPr id="23" name="Legend swatch">
             <a:extLst>
               <a:ext uri="{FF2B5EF4-FFF2-40B4-BE49-F238E27FC236}">
-                <a16:creationId xmlns:a16="http://schemas.microsoft.com/office/drawing/2014/main" id="{60B31D6B-760E-8A9E-E52F-12B6CF98FAF0}"/>
+                <a16:creationId xmlns:a16="http://schemas.microsoft.com/office/drawing/2014/main" id="{4C67968C-A41E-9D84-4CD7-D9F5EDBE6AD0}"/>
               </a:ext>
             </a:extLst>
           </p:cNvPr>
@@ -6406,7 +6406,7 @@
         </p:nvSpPr>
         <p:spPr>
           <a:xfrm>
-            <a:off x="5207000" y="1676400"/>
+            <a:off x="5207000" y="1905000"/>
             <a:ext cx="139700" cy="139700"/>
           </a:xfrm>
           <a:prstGeom prst="rect">
@@ -6465,16 +6465,16 @@
           <p:cNvPr id="24" name="Legend">
             <a:extLst>
               <a:ext uri="{FF2B5EF4-FFF2-40B4-BE49-F238E27FC236}">
-                <a16:creationId xmlns:a16="http://schemas.microsoft.com/office/drawing/2014/main" id="{A5814203-3DC8-E4ED-BCDC-72F806D8F52D}"/>
-              </a:ext>
-            </a:extLst>
-          </p:cNvPr>
-          <p:cNvSpPr txBox="1"/>
-          <p:nvPr/>
-        </p:nvSpPr>
-        <p:spPr>
-          <a:xfrm>
-            <a:off x="5422900" y="1625600"/>
+                <a16:creationId xmlns:a16="http://schemas.microsoft.com/office/drawing/2014/main" id="{6A7BE21E-50F2-5C0D-4D49-3533C03FE570}"/>
+              </a:ext>
+            </a:extLst>
+          </p:cNvPr>
+          <p:cNvSpPr txBox="1"/>
+          <p:nvPr/>
+        </p:nvSpPr>
+        <p:spPr>
+          <a:xfrm>
+            <a:off x="5422900" y="1854200"/>
             <a:ext cx="914400" cy="276999"/>
           </a:xfrm>
           <a:prstGeom prst="rect">
@@ -6510,16 +6510,16 @@
           <p:cNvPr id="25" name="Mode label">
             <a:extLst>
               <a:ext uri="{FF2B5EF4-FFF2-40B4-BE49-F238E27FC236}">
-                <a16:creationId xmlns:a16="http://schemas.microsoft.com/office/drawing/2014/main" id="{B01DDFA8-4FFC-8886-B8CA-99616E936747}"/>
-              </a:ext>
-            </a:extLst>
-          </p:cNvPr>
-          <p:cNvSpPr txBox="1"/>
-          <p:nvPr/>
-        </p:nvSpPr>
-        <p:spPr>
-          <a:xfrm>
-            <a:off x="863600" y="2578100"/>
+                <a16:creationId xmlns:a16="http://schemas.microsoft.com/office/drawing/2014/main" id="{911A69E7-4A36-43E7-9880-0F8B1D8A5AF2}"/>
+              </a:ext>
+            </a:extLst>
+          </p:cNvPr>
+          <p:cNvSpPr txBox="1"/>
+          <p:nvPr/>
+        </p:nvSpPr>
+        <p:spPr>
+          <a:xfrm>
+            <a:off x="863600" y="2679700"/>
             <a:ext cx="1473200" cy="276999"/>
           </a:xfrm>
           <a:prstGeom prst="rect">
@@ -6555,7 +6555,7 @@
           <p:cNvPr id="26" name="Result bar">
             <a:extLst>
               <a:ext uri="{FF2B5EF4-FFF2-40B4-BE49-F238E27FC236}">
-                <a16:creationId xmlns:a16="http://schemas.microsoft.com/office/drawing/2014/main" id="{A8FF5A0E-D860-DDCC-836E-40BF2AE3CAAA}"/>
+                <a16:creationId xmlns:a16="http://schemas.microsoft.com/office/drawing/2014/main" id="{09ECC826-4802-ED66-78A6-FDD506A6D87D}"/>
               </a:ext>
             </a:extLst>
           </p:cNvPr>
@@ -6564,7 +6564,7 @@
         </p:nvSpPr>
         <p:spPr>
           <a:xfrm>
-            <a:off x="2565400" y="2413000"/>
+            <a:off x="2565400" y="2514600"/>
             <a:ext cx="4826000" cy="165100"/>
           </a:xfrm>
           <a:prstGeom prst="rect">
@@ -6623,16 +6623,16 @@
           <p:cNvPr id="27" name="Result value">
             <a:extLst>
               <a:ext uri="{FF2B5EF4-FFF2-40B4-BE49-F238E27FC236}">
-                <a16:creationId xmlns:a16="http://schemas.microsoft.com/office/drawing/2014/main" id="{816D8A4F-B5E5-66AD-93F4-6C469D2ACB63}"/>
-              </a:ext>
-            </a:extLst>
-          </p:cNvPr>
-          <p:cNvSpPr txBox="1"/>
-          <p:nvPr/>
-        </p:nvSpPr>
-        <p:spPr>
-          <a:xfrm>
-            <a:off x="7467600" y="2400300"/>
+                <a16:creationId xmlns:a16="http://schemas.microsoft.com/office/drawing/2014/main" id="{7BB9BCAD-231B-C6AB-814B-288535B1A27D}"/>
+              </a:ext>
+            </a:extLst>
+          </p:cNvPr>
+          <p:cNvSpPr txBox="1"/>
+          <p:nvPr/>
+        </p:nvSpPr>
+        <p:spPr>
+          <a:xfrm>
+            <a:off x="7467600" y="2501900"/>
             <a:ext cx="685800" cy="276999"/>
           </a:xfrm>
           <a:prstGeom prst="rect">
@@ -6668,7 +6668,7 @@
           <p:cNvPr id="28" name="Result bar">
             <a:extLst>
               <a:ext uri="{FF2B5EF4-FFF2-40B4-BE49-F238E27FC236}">
-                <a16:creationId xmlns:a16="http://schemas.microsoft.com/office/drawing/2014/main" id="{8FE538C1-4B22-0ECB-7433-C9349D1B6B4F}"/>
+                <a16:creationId xmlns:a16="http://schemas.microsoft.com/office/drawing/2014/main" id="{06C53BF8-6C55-3394-1EF5-ACAE47613164}"/>
               </a:ext>
             </a:extLst>
           </p:cNvPr>
@@ -6677,7 +6677,7 @@
         </p:nvSpPr>
         <p:spPr>
           <a:xfrm>
-            <a:off x="2565400" y="2679700"/>
+            <a:off x="2565400" y="2781300"/>
             <a:ext cx="4826000" cy="165100"/>
           </a:xfrm>
           <a:prstGeom prst="rect">
@@ -6736,16 +6736,16 @@
           <p:cNvPr id="29" name="Result value">
             <a:extLst>
               <a:ext uri="{FF2B5EF4-FFF2-40B4-BE49-F238E27FC236}">
-                <a16:creationId xmlns:a16="http://schemas.microsoft.com/office/drawing/2014/main" id="{BE72A289-A5D1-D47B-A2FF-BBC61401A7E9}"/>
-              </a:ext>
-            </a:extLst>
-          </p:cNvPr>
-          <p:cNvSpPr txBox="1"/>
-          <p:nvPr/>
-        </p:nvSpPr>
-        <p:spPr>
-          <a:xfrm>
-            <a:off x="7467600" y="2667000"/>
+                <a16:creationId xmlns:a16="http://schemas.microsoft.com/office/drawing/2014/main" id="{E030619D-4BD0-93BB-AB13-99D14F14CFF3}"/>
+              </a:ext>
+            </a:extLst>
+          </p:cNvPr>
+          <p:cNvSpPr txBox="1"/>
+          <p:nvPr/>
+        </p:nvSpPr>
+        <p:spPr>
+          <a:xfrm>
+            <a:off x="7467600" y="2768600"/>
             <a:ext cx="685800" cy="276999"/>
           </a:xfrm>
           <a:prstGeom prst="rect">
@@ -6781,7 +6781,7 @@
           <p:cNvPr id="30" name="Result bar">
             <a:extLst>
               <a:ext uri="{FF2B5EF4-FFF2-40B4-BE49-F238E27FC236}">
-                <a16:creationId xmlns:a16="http://schemas.microsoft.com/office/drawing/2014/main" id="{676F0F67-DEEE-B6A2-61EE-3B6E716949AC}"/>
+                <a16:creationId xmlns:a16="http://schemas.microsoft.com/office/drawing/2014/main" id="{155756F1-4DC5-AC81-1A0F-475A35E7A958}"/>
               </a:ext>
             </a:extLst>
           </p:cNvPr>
@@ -6790,7 +6790,7 @@
         </p:nvSpPr>
         <p:spPr>
           <a:xfrm>
-            <a:off x="2565400" y="2946400"/>
+            <a:off x="2565400" y="3048000"/>
             <a:ext cx="4826000" cy="165100"/>
           </a:xfrm>
           <a:prstGeom prst="rect">
@@ -6849,16 +6849,16 @@
           <p:cNvPr id="31" name="Result value">
             <a:extLst>
               <a:ext uri="{FF2B5EF4-FFF2-40B4-BE49-F238E27FC236}">
-                <a16:creationId xmlns:a16="http://schemas.microsoft.com/office/drawing/2014/main" id="{708B4C25-50FF-1C77-F78A-9DE426DAF891}"/>
-              </a:ext>
-            </a:extLst>
-          </p:cNvPr>
-          <p:cNvSpPr txBox="1"/>
-          <p:nvPr/>
-        </p:nvSpPr>
-        <p:spPr>
-          <a:xfrm>
-            <a:off x="7467600" y="2933700"/>
+                <a16:creationId xmlns:a16="http://schemas.microsoft.com/office/drawing/2014/main" id="{FE527660-5C73-BCFA-6AFA-CD9E9085EF1C}"/>
+              </a:ext>
+            </a:extLst>
+          </p:cNvPr>
+          <p:cNvSpPr txBox="1"/>
+          <p:nvPr/>
+        </p:nvSpPr>
+        <p:spPr>
+          <a:xfrm>
+            <a:off x="7467600" y="3035300"/>
             <a:ext cx="685800" cy="276999"/>
           </a:xfrm>
           <a:prstGeom prst="rect">
@@ -6894,16 +6894,16 @@
           <p:cNvPr id="32" name="Mode label">
             <a:extLst>
               <a:ext uri="{FF2B5EF4-FFF2-40B4-BE49-F238E27FC236}">
-                <a16:creationId xmlns:a16="http://schemas.microsoft.com/office/drawing/2014/main" id="{8AC64CE8-4887-992C-C400-EA9F0532472E}"/>
-              </a:ext>
-            </a:extLst>
-          </p:cNvPr>
-          <p:cNvSpPr txBox="1"/>
-          <p:nvPr/>
-        </p:nvSpPr>
-        <p:spPr>
-          <a:xfrm>
-            <a:off x="863600" y="3771900"/>
+                <a16:creationId xmlns:a16="http://schemas.microsoft.com/office/drawing/2014/main" id="{6850A37A-5D92-407B-0BA3-9B2773241444}"/>
+              </a:ext>
+            </a:extLst>
+          </p:cNvPr>
+          <p:cNvSpPr txBox="1"/>
+          <p:nvPr/>
+        </p:nvSpPr>
+        <p:spPr>
+          <a:xfrm>
+            <a:off x="863600" y="3873500"/>
             <a:ext cx="1473200" cy="276999"/>
           </a:xfrm>
           <a:prstGeom prst="rect">
@@ -6939,7 +6939,7 @@
           <p:cNvPr id="33" name="Result bar">
             <a:extLst>
               <a:ext uri="{FF2B5EF4-FFF2-40B4-BE49-F238E27FC236}">
-                <a16:creationId xmlns:a16="http://schemas.microsoft.com/office/drawing/2014/main" id="{0AC0EE4F-3227-C57B-5470-6B8FB1CEEBB5}"/>
+                <a16:creationId xmlns:a16="http://schemas.microsoft.com/office/drawing/2014/main" id="{7B506F11-B677-0E37-0C6A-920A10DB68A2}"/>
               </a:ext>
             </a:extLst>
           </p:cNvPr>
@@ -6948,8 +6948,8 @@
         </p:nvSpPr>
         <p:spPr>
           <a:xfrm>
-            <a:off x="2565400" y="3606800"/>
-            <a:ext cx="3619500" cy="165100"/>
+            <a:off x="2565400" y="3708400"/>
+            <a:ext cx="3918712" cy="165100"/>
           </a:xfrm>
           <a:prstGeom prst="rect">
             <a:avLst/>
@@ -7007,16 +7007,16 @@
           <p:cNvPr id="34" name="Result value">
             <a:extLst>
               <a:ext uri="{FF2B5EF4-FFF2-40B4-BE49-F238E27FC236}">
-                <a16:creationId xmlns:a16="http://schemas.microsoft.com/office/drawing/2014/main" id="{426C174D-B4E0-C7B0-3489-367EA9747B07}"/>
-              </a:ext>
-            </a:extLst>
-          </p:cNvPr>
-          <p:cNvSpPr txBox="1"/>
-          <p:nvPr/>
-        </p:nvSpPr>
-        <p:spPr>
-          <a:xfrm>
-            <a:off x="6261100" y="3594100"/>
+                <a16:creationId xmlns:a16="http://schemas.microsoft.com/office/drawing/2014/main" id="{E8D3B060-6CDC-C36E-7294-6B49F49FCA2F}"/>
+              </a:ext>
+            </a:extLst>
+          </p:cNvPr>
+          <p:cNvSpPr txBox="1"/>
+          <p:nvPr/>
+        </p:nvSpPr>
+        <p:spPr>
+          <a:xfrm>
+            <a:off x="6560312" y="3695700"/>
             <a:ext cx="685800" cy="276999"/>
           </a:xfrm>
           <a:prstGeom prst="rect">
@@ -7042,7 +7042,7 @@
                 </a:solidFill>
                 <a:latin typeface="Arial" panose="020B0604020202020204" pitchFamily="34" charset="0"/>
               </a:rPr>
-              <a:t>75,0 %</a:t>
+              <a:t>81,2 %</a:t>
             </a:r>
           </a:p>
         </p:txBody>
@@ -7052,7 +7052,7 @@
           <p:cNvPr id="35" name="Result bar">
             <a:extLst>
               <a:ext uri="{FF2B5EF4-FFF2-40B4-BE49-F238E27FC236}">
-                <a16:creationId xmlns:a16="http://schemas.microsoft.com/office/drawing/2014/main" id="{96E9F153-AAEA-8947-D07C-FE87E9B75487}"/>
+                <a16:creationId xmlns:a16="http://schemas.microsoft.com/office/drawing/2014/main" id="{03AA179D-0482-7B61-2451-9D28CCE10030}"/>
               </a:ext>
             </a:extLst>
           </p:cNvPr>
@@ -7061,8 +7061,8 @@
         </p:nvSpPr>
         <p:spPr>
           <a:xfrm>
-            <a:off x="2565400" y="3873500"/>
-            <a:ext cx="3619500" cy="165100"/>
+            <a:off x="2565400" y="3975100"/>
+            <a:ext cx="4222750" cy="165100"/>
           </a:xfrm>
           <a:prstGeom prst="rect">
             <a:avLst/>
@@ -7120,16 +7120,16 @@
           <p:cNvPr id="36" name="Result value">
             <a:extLst>
               <a:ext uri="{FF2B5EF4-FFF2-40B4-BE49-F238E27FC236}">
-                <a16:creationId xmlns:a16="http://schemas.microsoft.com/office/drawing/2014/main" id="{69BDCD0F-E71A-C000-613D-0F4CFD897F3D}"/>
-              </a:ext>
-            </a:extLst>
-          </p:cNvPr>
-          <p:cNvSpPr txBox="1"/>
-          <p:nvPr/>
-        </p:nvSpPr>
-        <p:spPr>
-          <a:xfrm>
-            <a:off x="6261100" y="3860800"/>
+                <a16:creationId xmlns:a16="http://schemas.microsoft.com/office/drawing/2014/main" id="{77ACF68C-4FEB-84C5-2648-0A87B5FD78E3}"/>
+              </a:ext>
+            </a:extLst>
+          </p:cNvPr>
+          <p:cNvSpPr txBox="1"/>
+          <p:nvPr/>
+        </p:nvSpPr>
+        <p:spPr>
+          <a:xfrm>
+            <a:off x="6864350" y="3962400"/>
             <a:ext cx="685800" cy="276999"/>
           </a:xfrm>
           <a:prstGeom prst="rect">
@@ -7155,7 +7155,7 @@
                 </a:solidFill>
                 <a:latin typeface="Arial" panose="020B0604020202020204" pitchFamily="34" charset="0"/>
               </a:rPr>
-              <a:t>75,0 %</a:t>
+              <a:t>87,5 %</a:t>
             </a:r>
           </a:p>
         </p:txBody>
@@ -7165,7 +7165,7 @@
           <p:cNvPr id="37" name="Result bar">
             <a:extLst>
               <a:ext uri="{FF2B5EF4-FFF2-40B4-BE49-F238E27FC236}">
-                <a16:creationId xmlns:a16="http://schemas.microsoft.com/office/drawing/2014/main" id="{0D9C6E96-37FB-A005-288D-0CED6302D2ED}"/>
+                <a16:creationId xmlns:a16="http://schemas.microsoft.com/office/drawing/2014/main" id="{37B670BE-468E-D7B7-F99A-79BD246078D4}"/>
               </a:ext>
             </a:extLst>
           </p:cNvPr>
@@ -7174,8 +7174,8 @@
         </p:nvSpPr>
         <p:spPr>
           <a:xfrm>
-            <a:off x="2565400" y="4140200"/>
-            <a:ext cx="3619500" cy="165100"/>
+            <a:off x="2565400" y="4241800"/>
+            <a:ext cx="3971798" cy="165100"/>
           </a:xfrm>
           <a:prstGeom prst="rect">
             <a:avLst/>
@@ -7233,16 +7233,16 @@
           <p:cNvPr id="38" name="Result value">
             <a:extLst>
               <a:ext uri="{FF2B5EF4-FFF2-40B4-BE49-F238E27FC236}">
-                <a16:creationId xmlns:a16="http://schemas.microsoft.com/office/drawing/2014/main" id="{0F42A97B-87C8-9399-BD2F-7FCE7084B7C0}"/>
-              </a:ext>
-            </a:extLst>
-          </p:cNvPr>
-          <p:cNvSpPr txBox="1"/>
-          <p:nvPr/>
-        </p:nvSpPr>
-        <p:spPr>
-          <a:xfrm>
-            <a:off x="6261100" y="4127500"/>
+                <a16:creationId xmlns:a16="http://schemas.microsoft.com/office/drawing/2014/main" id="{DE02C2BB-306C-A6D4-8642-BBD2C6D9AA4B}"/>
+              </a:ext>
+            </a:extLst>
+          </p:cNvPr>
+          <p:cNvSpPr txBox="1"/>
+          <p:nvPr/>
+        </p:nvSpPr>
+        <p:spPr>
+          <a:xfrm>
+            <a:off x="6613398" y="4229100"/>
             <a:ext cx="685800" cy="276999"/>
           </a:xfrm>
           <a:prstGeom prst="rect">
@@ -7268,7 +7268,7 @@
                 </a:solidFill>
                 <a:latin typeface="Arial" panose="020B0604020202020204" pitchFamily="34" charset="0"/>
               </a:rPr>
-              <a:t>75,0 %</a:t>
+              <a:t>82,3 %</a:t>
             </a:r>
           </a:p>
         </p:txBody>
@@ -7278,16 +7278,16 @@
           <p:cNvPr id="39" name="Mode label">
             <a:extLst>
               <a:ext uri="{FF2B5EF4-FFF2-40B4-BE49-F238E27FC236}">
-                <a16:creationId xmlns:a16="http://schemas.microsoft.com/office/drawing/2014/main" id="{5E9910C1-C1AB-A142-0620-6069E3399AC6}"/>
-              </a:ext>
-            </a:extLst>
-          </p:cNvPr>
-          <p:cNvSpPr txBox="1"/>
-          <p:nvPr/>
-        </p:nvSpPr>
-        <p:spPr>
-          <a:xfrm>
-            <a:off x="863600" y="4965700"/>
+                <a16:creationId xmlns:a16="http://schemas.microsoft.com/office/drawing/2014/main" id="{B164208C-96C8-1934-ABBF-085B75A15397}"/>
+              </a:ext>
+            </a:extLst>
+          </p:cNvPr>
+          <p:cNvSpPr txBox="1"/>
+          <p:nvPr/>
+        </p:nvSpPr>
+        <p:spPr>
+          <a:xfrm>
+            <a:off x="863600" y="5067300"/>
             <a:ext cx="1473200" cy="276999"/>
           </a:xfrm>
           <a:prstGeom prst="rect">
@@ -7323,7 +7323,7 @@
           <p:cNvPr id="40" name="Result bar">
             <a:extLst>
               <a:ext uri="{FF2B5EF4-FFF2-40B4-BE49-F238E27FC236}">
-                <a16:creationId xmlns:a16="http://schemas.microsoft.com/office/drawing/2014/main" id="{75547680-B47C-BBCB-D6B3-335C9C507031}"/>
+                <a16:creationId xmlns:a16="http://schemas.microsoft.com/office/drawing/2014/main" id="{868FE782-5404-0F97-1ECE-0A480BFE2417}"/>
               </a:ext>
             </a:extLst>
           </p:cNvPr>
@@ -7332,8 +7332,8 @@
         </p:nvSpPr>
         <p:spPr>
           <a:xfrm>
-            <a:off x="2565400" y="4800600"/>
-            <a:ext cx="4526788" cy="165100"/>
+            <a:off x="2565400" y="4902200"/>
+            <a:ext cx="4222750" cy="165100"/>
           </a:xfrm>
           <a:prstGeom prst="rect">
             <a:avLst/>
@@ -7391,16 +7391,16 @@
           <p:cNvPr id="41" name="Result value">
             <a:extLst>
               <a:ext uri="{FF2B5EF4-FFF2-40B4-BE49-F238E27FC236}">
-                <a16:creationId xmlns:a16="http://schemas.microsoft.com/office/drawing/2014/main" id="{6A310FFC-5A15-5A4D-17A0-E4C96493AB51}"/>
-              </a:ext>
-            </a:extLst>
-          </p:cNvPr>
-          <p:cNvSpPr txBox="1"/>
-          <p:nvPr/>
-        </p:nvSpPr>
-        <p:spPr>
-          <a:xfrm>
-            <a:off x="7168388" y="4787900"/>
+                <a16:creationId xmlns:a16="http://schemas.microsoft.com/office/drawing/2014/main" id="{D93F89AC-6EC3-0944-6B01-700F6EE2951A}"/>
+              </a:ext>
+            </a:extLst>
+          </p:cNvPr>
+          <p:cNvSpPr txBox="1"/>
+          <p:nvPr/>
+        </p:nvSpPr>
+        <p:spPr>
+          <a:xfrm>
+            <a:off x="6864350" y="4889500"/>
             <a:ext cx="685800" cy="276999"/>
           </a:xfrm>
           <a:prstGeom prst="rect">
@@ -7426,7 +7426,7 @@
                 </a:solidFill>
                 <a:latin typeface="Arial" panose="020B0604020202020204" pitchFamily="34" charset="0"/>
               </a:rPr>
-              <a:t>93,8 %</a:t>
+              <a:t>87,5 %</a:t>
             </a:r>
           </a:p>
         </p:txBody>
@@ -7436,7 +7436,7 @@
           <p:cNvPr id="42" name="Result bar">
             <a:extLst>
               <a:ext uri="{FF2B5EF4-FFF2-40B4-BE49-F238E27FC236}">
-                <a16:creationId xmlns:a16="http://schemas.microsoft.com/office/drawing/2014/main" id="{D5EF07D4-8AA8-AFE4-B48C-FD34803FFDD9}"/>
+                <a16:creationId xmlns:a16="http://schemas.microsoft.com/office/drawing/2014/main" id="{B4FDD4D0-21A7-A12E-4C6B-0706FFF9D3F0}"/>
               </a:ext>
             </a:extLst>
           </p:cNvPr>
@@ -7445,7 +7445,7 @@
         </p:nvSpPr>
         <p:spPr>
           <a:xfrm>
-            <a:off x="2565400" y="5067300"/>
+            <a:off x="2565400" y="5168900"/>
             <a:ext cx="4826000" cy="165100"/>
           </a:xfrm>
           <a:prstGeom prst="rect">
@@ -7504,16 +7504,16 @@
           <p:cNvPr id="43" name="Result value">
             <a:extLst>
               <a:ext uri="{FF2B5EF4-FFF2-40B4-BE49-F238E27FC236}">
-                <a16:creationId xmlns:a16="http://schemas.microsoft.com/office/drawing/2014/main" id="{41B2CF9F-D9FA-7293-F2E6-EACEB3A39F80}"/>
-              </a:ext>
-            </a:extLst>
-          </p:cNvPr>
-          <p:cNvSpPr txBox="1"/>
-          <p:nvPr/>
-        </p:nvSpPr>
-        <p:spPr>
-          <a:xfrm>
-            <a:off x="7467600" y="5054600"/>
+                <a16:creationId xmlns:a16="http://schemas.microsoft.com/office/drawing/2014/main" id="{0167BFE6-C071-6BB3-C968-AE693E6ECC5A}"/>
+              </a:ext>
+            </a:extLst>
+          </p:cNvPr>
+          <p:cNvSpPr txBox="1"/>
+          <p:nvPr/>
+        </p:nvSpPr>
+        <p:spPr>
+          <a:xfrm>
+            <a:off x="7467600" y="5156200"/>
             <a:ext cx="685800" cy="276999"/>
           </a:xfrm>
           <a:prstGeom prst="rect">
@@ -7549,7 +7549,7 @@
           <p:cNvPr id="44" name="Result bar">
             <a:extLst>
               <a:ext uri="{FF2B5EF4-FFF2-40B4-BE49-F238E27FC236}">
-                <a16:creationId xmlns:a16="http://schemas.microsoft.com/office/drawing/2014/main" id="{29BD125B-179C-A94F-085E-0E6893EC15AD}"/>
+                <a16:creationId xmlns:a16="http://schemas.microsoft.com/office/drawing/2014/main" id="{971546D0-C307-A18A-56AF-ED8671725403}"/>
               </a:ext>
             </a:extLst>
           </p:cNvPr>
@@ -7558,8 +7558,8 @@
         </p:nvSpPr>
         <p:spPr>
           <a:xfrm>
-            <a:off x="2565400" y="5334000"/>
-            <a:ext cx="4541265" cy="165100"/>
+            <a:off x="2565400" y="5435600"/>
+            <a:ext cx="4290314" cy="165100"/>
           </a:xfrm>
           <a:prstGeom prst="rect">
             <a:avLst/>
@@ -7617,16 +7617,16 @@
           <p:cNvPr id="45" name="Result value">
             <a:extLst>
               <a:ext uri="{FF2B5EF4-FFF2-40B4-BE49-F238E27FC236}">
-                <a16:creationId xmlns:a16="http://schemas.microsoft.com/office/drawing/2014/main" id="{2CE524BA-8E4A-8CC6-4292-B3FD053E5A62}"/>
-              </a:ext>
-            </a:extLst>
-          </p:cNvPr>
-          <p:cNvSpPr txBox="1"/>
-          <p:nvPr/>
-        </p:nvSpPr>
-        <p:spPr>
-          <a:xfrm>
-            <a:off x="7182866" y="5321300"/>
+                <a16:creationId xmlns:a16="http://schemas.microsoft.com/office/drawing/2014/main" id="{206755A5-F015-387B-7362-073256ADCEC3}"/>
+              </a:ext>
+            </a:extLst>
+          </p:cNvPr>
+          <p:cNvSpPr txBox="1"/>
+          <p:nvPr/>
+        </p:nvSpPr>
+        <p:spPr>
+          <a:xfrm>
+            <a:off x="6931914" y="5422900"/>
             <a:ext cx="685800" cy="276999"/>
           </a:xfrm>
           <a:prstGeom prst="rect">
@@ -7652,7 +7652,7 @@
                 </a:solidFill>
                 <a:latin typeface="Arial" panose="020B0604020202020204" pitchFamily="34" charset="0"/>
               </a:rPr>
-              <a:t>94,1 %</a:t>
+              <a:t>88,9 %</a:t>
             </a:r>
           </a:p>
         </p:txBody>
@@ -7662,7 +7662,7 @@
           <p:cNvPr id="46" name="Result callout">
             <a:extLst>
               <a:ext uri="{FF2B5EF4-FFF2-40B4-BE49-F238E27FC236}">
-                <a16:creationId xmlns:a16="http://schemas.microsoft.com/office/drawing/2014/main" id="{EEB8F734-8260-1900-53A7-277DDE85A3CC}"/>
+                <a16:creationId xmlns:a16="http://schemas.microsoft.com/office/drawing/2014/main" id="{6250CB7C-05C8-2BCE-2379-D9D7C448EB3B}"/>
               </a:ext>
             </a:extLst>
           </p:cNvPr>
@@ -7730,7 +7730,7 @@
           <p:cNvPr id="47" name="Recall result">
             <a:extLst>
               <a:ext uri="{FF2B5EF4-FFF2-40B4-BE49-F238E27FC236}">
-                <a16:creationId xmlns:a16="http://schemas.microsoft.com/office/drawing/2014/main" id="{CFD6BFBA-BF60-5CE7-9A3F-CA239B4270DF}"/>
+                <a16:creationId xmlns:a16="http://schemas.microsoft.com/office/drawing/2014/main" id="{DE5D03EF-4D99-903C-F564-D8C42067854D}"/>
               </a:ext>
             </a:extLst>
           </p:cNvPr>
@@ -7775,7 +7775,7 @@
           <p:cNvPr id="48" name="Recall detail">
             <a:extLst>
               <a:ext uri="{FF2B5EF4-FFF2-40B4-BE49-F238E27FC236}">
-                <a16:creationId xmlns:a16="http://schemas.microsoft.com/office/drawing/2014/main" id="{13A34FE3-099F-4F13-306E-0D525E02CF6D}"/>
+                <a16:creationId xmlns:a16="http://schemas.microsoft.com/office/drawing/2014/main" id="{3C2137DE-E75B-DCBE-D0EB-C73DD26540D4}"/>
               </a:ext>
             </a:extLst>
           </p:cNvPr>
@@ -7811,7 +7811,7 @@
                 <a:latin typeface="Arial" panose="020B0604020202020204" pitchFamily="34" charset="0"/>
               </a:rPr>
               <a:t>8/8 phishing detectados
-0 falsos negativos · 1 falso positivo</a:t>
+0 falsos negativos · 2 falsos positivos</a:t>
             </a:r>
           </a:p>
         </p:txBody>
@@ -7821,7 +7821,7 @@
           <p:cNvPr id="49" name="External title">
             <a:extLst>
               <a:ext uri="{FF2B5EF4-FFF2-40B4-BE49-F238E27FC236}">
-                <a16:creationId xmlns:a16="http://schemas.microsoft.com/office/drawing/2014/main" id="{00128DE3-65A6-C5A9-240B-A902B0068040}"/>
+                <a16:creationId xmlns:a16="http://schemas.microsoft.com/office/drawing/2014/main" id="{D341971E-E04B-DA49-51BB-7D13FE2706A1}"/>
               </a:ext>
             </a:extLst>
           </p:cNvPr>
@@ -7866,7 +7866,7 @@
           <p:cNvPr id="50" name="External metrics">
             <a:extLst>
               <a:ext uri="{FF2B5EF4-FFF2-40B4-BE49-F238E27FC236}">
-                <a16:creationId xmlns:a16="http://schemas.microsoft.com/office/drawing/2014/main" id="{629CB0B9-6618-BB16-C075-5BD6F3963AAD}"/>
+                <a16:creationId xmlns:a16="http://schemas.microsoft.com/office/drawing/2014/main" id="{BF4F9DB0-24F5-FCA8-9236-5D09D13D0197}"/>
               </a:ext>
             </a:extLst>
           </p:cNvPr>
@@ -7901,8 +7901,8 @@
                 </a:solidFill>
                 <a:latin typeface="Arial" panose="020B0604020202020204" pitchFamily="34" charset="0"/>
               </a:rPr>
-              <a:t>90,8 % accuracy
-96,4 % recall</a:t>
+              <a:t>89,0 % accuracy
+93,4 % recall</a:t>
             </a:r>
           </a:p>
         </p:txBody>
@@ -7912,7 +7912,7 @@
           <p:cNvPr id="51" name="External caveat">
             <a:extLst>
               <a:ext uri="{FF2B5EF4-FFF2-40B4-BE49-F238E27FC236}">
-                <a16:creationId xmlns:a16="http://schemas.microsoft.com/office/drawing/2014/main" id="{10678426-0D39-FF4A-3304-364FE32C6AF0}"/>
+                <a16:creationId xmlns:a16="http://schemas.microsoft.com/office/drawing/2014/main" id="{82874F98-ED28-524C-3D25-B170BC8A6C05}"/>
               </a:ext>
             </a:extLst>
           </p:cNvPr>
@@ -7955,7 +7955,7 @@
     </p:spTree>
     <p:extLst>
       <p:ext uri="{BB962C8B-B14F-4D97-AF65-F5344CB8AC3E}">
-        <p14:creationId xmlns:p14="http://schemas.microsoft.com/office/powerpoint/2010/main" val="2010292690"/>
+        <p14:creationId xmlns:p14="http://schemas.microsoft.com/office/powerpoint/2010/main" val="3349345149"/>
       </p:ext>
     </p:extLst>
   </p:cSld>
@@ -7995,7 +7995,7 @@
           <p:cNvPr id="2" name="Section">
             <a:extLst>
               <a:ext uri="{FF2B5EF4-FFF2-40B4-BE49-F238E27FC236}">
-                <a16:creationId xmlns:a16="http://schemas.microsoft.com/office/drawing/2014/main" id="{2306D38C-DED3-9ADD-85F1-4C25ADE095BC}"/>
+                <a16:creationId xmlns:a16="http://schemas.microsoft.com/office/drawing/2014/main" id="{C85A2EA7-5C37-F11F-AB94-330B8ECC73BF}"/>
               </a:ext>
             </a:extLst>
           </p:cNvPr>
@@ -8040,7 +8040,7 @@
           <p:cNvPr id="3" name="Slide title">
             <a:extLst>
               <a:ext uri="{FF2B5EF4-FFF2-40B4-BE49-F238E27FC236}">
-                <a16:creationId xmlns:a16="http://schemas.microsoft.com/office/drawing/2014/main" id="{5DFCA45A-9281-3817-4172-08B35651E5AA}"/>
+                <a16:creationId xmlns:a16="http://schemas.microsoft.com/office/drawing/2014/main" id="{53653746-71E8-F290-EDA0-1BB23E433702}"/>
               </a:ext>
             </a:extLst>
           </p:cNvPr>
@@ -8085,7 +8085,7 @@
           <p:cNvPr id="4" name="Accent rule">
             <a:extLst>
               <a:ext uri="{FF2B5EF4-FFF2-40B4-BE49-F238E27FC236}">
-                <a16:creationId xmlns:a16="http://schemas.microsoft.com/office/drawing/2014/main" id="{4C038949-B48E-DD49-F523-86F5E34A1B6F}"/>
+                <a16:creationId xmlns:a16="http://schemas.microsoft.com/office/drawing/2014/main" id="{222FA827-B1D5-839A-B32A-87FE4E8FF27E}"/>
               </a:ext>
             </a:extLst>
           </p:cNvPr>
@@ -8126,7 +8126,7 @@
           <p:cNvPr id="5" name="Footer author">
             <a:extLst>
               <a:ext uri="{FF2B5EF4-FFF2-40B4-BE49-F238E27FC236}">
-                <a16:creationId xmlns:a16="http://schemas.microsoft.com/office/drawing/2014/main" id="{1089E00C-5F33-81B5-47CF-D8FF872E95FA}"/>
+                <a16:creationId xmlns:a16="http://schemas.microsoft.com/office/drawing/2014/main" id="{9E230524-C2FE-5C5D-092E-322189614B79}"/>
               </a:ext>
             </a:extLst>
           </p:cNvPr>
@@ -8171,7 +8171,7 @@
           <p:cNvPr id="6" name="Slide number">
             <a:extLst>
               <a:ext uri="{FF2B5EF4-FFF2-40B4-BE49-F238E27FC236}">
-                <a16:creationId xmlns:a16="http://schemas.microsoft.com/office/drawing/2014/main" id="{7C205370-FA64-00DB-F97D-F13B243BB5BC}"/>
+                <a16:creationId xmlns:a16="http://schemas.microsoft.com/office/drawing/2014/main" id="{353A79C2-EAE4-830C-3782-5EDFDD1F2540}"/>
               </a:ext>
             </a:extLst>
           </p:cNvPr>
@@ -8216,7 +8216,7 @@
           <p:cNvPr id="7" name="Metric vertical">
             <a:extLst>
               <a:ext uri="{FF2B5EF4-FFF2-40B4-BE49-F238E27FC236}">
-                <a16:creationId xmlns:a16="http://schemas.microsoft.com/office/drawing/2014/main" id="{F643A131-58D2-1ECD-5CAB-D51AFDE9341F}"/>
+                <a16:creationId xmlns:a16="http://schemas.microsoft.com/office/drawing/2014/main" id="{FF319EAA-635B-C879-00CE-B8355EADA3DF}"/>
               </a:ext>
             </a:extLst>
           </p:cNvPr>
@@ -8257,7 +8257,7 @@
           <p:cNvPr id="8" name="Metric horizontal">
             <a:extLst>
               <a:ext uri="{FF2B5EF4-FFF2-40B4-BE49-F238E27FC236}">
-                <a16:creationId xmlns:a16="http://schemas.microsoft.com/office/drawing/2014/main" id="{D20394A4-BBD1-DCD4-2DCB-47B65CFBC500}"/>
+                <a16:creationId xmlns:a16="http://schemas.microsoft.com/office/drawing/2014/main" id="{4CF65D13-5D90-CE1B-21A3-017269944676}"/>
               </a:ext>
             </a:extLst>
           </p:cNvPr>
@@ -8298,7 +8298,7 @@
           <p:cNvPr id="9" name="Metric value">
             <a:extLst>
               <a:ext uri="{FF2B5EF4-FFF2-40B4-BE49-F238E27FC236}">
-                <a16:creationId xmlns:a16="http://schemas.microsoft.com/office/drawing/2014/main" id="{92CD4023-4F0B-2657-7FD8-F101271D04EC}"/>
+                <a16:creationId xmlns:a16="http://schemas.microsoft.com/office/drawing/2014/main" id="{60C8F773-6C3F-E294-79E2-B6A8224DEEC8}"/>
               </a:ext>
             </a:extLst>
           </p:cNvPr>
@@ -8333,7 +8333,7 @@
                 </a:solidFill>
                 <a:latin typeface="Arial" panose="020B0604020202020204" pitchFamily="34" charset="0"/>
               </a:rPr>
-              <a:t>87</a:t>
+              <a:t>89</a:t>
             </a:r>
           </a:p>
         </p:txBody>
@@ -8343,7 +8343,7 @@
           <p:cNvPr id="10" name="Metric title">
             <a:extLst>
               <a:ext uri="{FF2B5EF4-FFF2-40B4-BE49-F238E27FC236}">
-                <a16:creationId xmlns:a16="http://schemas.microsoft.com/office/drawing/2014/main" id="{C4EAC619-A6CD-217B-D650-EB3C82BEFE93}"/>
+                <a16:creationId xmlns:a16="http://schemas.microsoft.com/office/drawing/2014/main" id="{1E296D03-3FE9-BB98-91E0-F5DDFCD7C58B}"/>
               </a:ext>
             </a:extLst>
           </p:cNvPr>
@@ -8388,7 +8388,7 @@
           <p:cNvPr id="11" name="Metric detail">
             <a:extLst>
               <a:ext uri="{FF2B5EF4-FFF2-40B4-BE49-F238E27FC236}">
-                <a16:creationId xmlns:a16="http://schemas.microsoft.com/office/drawing/2014/main" id="{C17FDEBC-570A-0B80-EA53-F42E9818FAF9}"/>
+                <a16:creationId xmlns:a16="http://schemas.microsoft.com/office/drawing/2014/main" id="{AF532DC7-0370-7B11-B677-3AD8C9B16846}"/>
               </a:ext>
             </a:extLst>
           </p:cNvPr>
@@ -8433,7 +8433,7 @@
           <p:cNvPr id="12" name="Metric value">
             <a:extLst>
               <a:ext uri="{FF2B5EF4-FFF2-40B4-BE49-F238E27FC236}">
-                <a16:creationId xmlns:a16="http://schemas.microsoft.com/office/drawing/2014/main" id="{156E980B-F2EC-AED0-C31D-2C22907001E5}"/>
+                <a16:creationId xmlns:a16="http://schemas.microsoft.com/office/drawing/2014/main" id="{A3030102-8E20-EF46-9CDA-8BF2889D8609}"/>
               </a:ext>
             </a:extLst>
           </p:cNvPr>
@@ -8478,7 +8478,7 @@
           <p:cNvPr id="13" name="Metric title">
             <a:extLst>
               <a:ext uri="{FF2B5EF4-FFF2-40B4-BE49-F238E27FC236}">
-                <a16:creationId xmlns:a16="http://schemas.microsoft.com/office/drawing/2014/main" id="{B8E83EB2-EC35-ACA7-E722-B0CEDEFD127F}"/>
+                <a16:creationId xmlns:a16="http://schemas.microsoft.com/office/drawing/2014/main" id="{0C611822-BE5D-23B9-A19C-51FEAA720EF2}"/>
               </a:ext>
             </a:extLst>
           </p:cNvPr>
@@ -8523,7 +8523,7 @@
           <p:cNvPr id="14" name="Metric detail">
             <a:extLst>
               <a:ext uri="{FF2B5EF4-FFF2-40B4-BE49-F238E27FC236}">
-                <a16:creationId xmlns:a16="http://schemas.microsoft.com/office/drawing/2014/main" id="{A7171175-63C1-7627-FCC0-6F7532A18572}"/>
+                <a16:creationId xmlns:a16="http://schemas.microsoft.com/office/drawing/2014/main" id="{EF1D1612-7F85-CC0E-71BA-85D2C8C54122}"/>
               </a:ext>
             </a:extLst>
           </p:cNvPr>
@@ -8568,7 +8568,7 @@
           <p:cNvPr id="15" name="Metric value">
             <a:extLst>
               <a:ext uri="{FF2B5EF4-FFF2-40B4-BE49-F238E27FC236}">
-                <a16:creationId xmlns:a16="http://schemas.microsoft.com/office/drawing/2014/main" id="{E41EFF04-1D19-A520-6602-BD53CA7EC647}"/>
+                <a16:creationId xmlns:a16="http://schemas.microsoft.com/office/drawing/2014/main" id="{229A213B-191E-D8B2-6F25-CFD0E231967C}"/>
               </a:ext>
             </a:extLst>
           </p:cNvPr>
@@ -8613,7 +8613,7 @@
           <p:cNvPr id="16" name="Metric title">
             <a:extLst>
               <a:ext uri="{FF2B5EF4-FFF2-40B4-BE49-F238E27FC236}">
-                <a16:creationId xmlns:a16="http://schemas.microsoft.com/office/drawing/2014/main" id="{A3699D75-92CC-6FED-8D4C-A8A6B53AE283}"/>
+                <a16:creationId xmlns:a16="http://schemas.microsoft.com/office/drawing/2014/main" id="{64A029C0-D33E-BB1B-DD5B-BAA1E611EFE9}"/>
               </a:ext>
             </a:extLst>
           </p:cNvPr>
@@ -8658,7 +8658,7 @@
           <p:cNvPr id="17" name="Metric detail">
             <a:extLst>
               <a:ext uri="{FF2B5EF4-FFF2-40B4-BE49-F238E27FC236}">
-                <a16:creationId xmlns:a16="http://schemas.microsoft.com/office/drawing/2014/main" id="{284445D9-6675-F597-D220-EAD149F1D3B1}"/>
+                <a16:creationId xmlns:a16="http://schemas.microsoft.com/office/drawing/2014/main" id="{F4D4D95E-9968-8C40-8B87-81F41132413E}"/>
               </a:ext>
             </a:extLst>
           </p:cNvPr>
@@ -8703,7 +8703,7 @@
           <p:cNvPr id="18" name="Metric value">
             <a:extLst>
               <a:ext uri="{FF2B5EF4-FFF2-40B4-BE49-F238E27FC236}">
-                <a16:creationId xmlns:a16="http://schemas.microsoft.com/office/drawing/2014/main" id="{68D32CB2-513B-F68F-A01E-C4C72BC5A120}"/>
+                <a16:creationId xmlns:a16="http://schemas.microsoft.com/office/drawing/2014/main" id="{16D3ACEE-DB12-DD62-8A1B-3019114B8508}"/>
               </a:ext>
             </a:extLst>
           </p:cNvPr>
@@ -8748,7 +8748,7 @@
           <p:cNvPr id="19" name="Metric title">
             <a:extLst>
               <a:ext uri="{FF2B5EF4-FFF2-40B4-BE49-F238E27FC236}">
-                <a16:creationId xmlns:a16="http://schemas.microsoft.com/office/drawing/2014/main" id="{70B2F4D8-D5B9-2A3A-8224-57D3B2FAEDB6}"/>
+                <a16:creationId xmlns:a16="http://schemas.microsoft.com/office/drawing/2014/main" id="{8A945C44-2941-BA63-DB3D-7B84C0F4A955}"/>
               </a:ext>
             </a:extLst>
           </p:cNvPr>
@@ -8793,7 +8793,7 @@
           <p:cNvPr id="20" name="Metric detail">
             <a:extLst>
               <a:ext uri="{FF2B5EF4-FFF2-40B4-BE49-F238E27FC236}">
-                <a16:creationId xmlns:a16="http://schemas.microsoft.com/office/drawing/2014/main" id="{41A304F1-E75C-3D17-69C5-6809B2B583EA}"/>
+                <a16:creationId xmlns:a16="http://schemas.microsoft.com/office/drawing/2014/main" id="{7B366D9C-604D-1B2E-9FE6-AB9AB8306997}"/>
               </a:ext>
             </a:extLst>
           </p:cNvPr>
@@ -8836,7 +8836,7 @@
     </p:spTree>
     <p:extLst>
       <p:ext uri="{BB962C8B-B14F-4D97-AF65-F5344CB8AC3E}">
-        <p14:creationId xmlns:p14="http://schemas.microsoft.com/office/powerpoint/2010/main" val="4169834264"/>
+        <p14:creationId xmlns:p14="http://schemas.microsoft.com/office/powerpoint/2010/main" val="837227487"/>
       </p:ext>
     </p:extLst>
   </p:cSld>
@@ -8876,7 +8876,7 @@
           <p:cNvPr id="2" name="Section">
             <a:extLst>
               <a:ext uri="{FF2B5EF4-FFF2-40B4-BE49-F238E27FC236}">
-                <a16:creationId xmlns:a16="http://schemas.microsoft.com/office/drawing/2014/main" id="{C517317E-C98A-31D2-C1C3-C066FF65F98E}"/>
+                <a16:creationId xmlns:a16="http://schemas.microsoft.com/office/drawing/2014/main" id="{6D7414EF-425B-E612-AC99-B801D7751EC0}"/>
               </a:ext>
             </a:extLst>
           </p:cNvPr>
@@ -8921,7 +8921,7 @@
           <p:cNvPr id="3" name="Slide title">
             <a:extLst>
               <a:ext uri="{FF2B5EF4-FFF2-40B4-BE49-F238E27FC236}">
-                <a16:creationId xmlns:a16="http://schemas.microsoft.com/office/drawing/2014/main" id="{0DFDB77C-3294-EEB6-0AC9-CCC4B7906F12}"/>
+                <a16:creationId xmlns:a16="http://schemas.microsoft.com/office/drawing/2014/main" id="{1CC9CD37-23FE-1FD6-713B-5D6890E6ED6C}"/>
               </a:ext>
             </a:extLst>
           </p:cNvPr>
@@ -8966,7 +8966,7 @@
           <p:cNvPr id="4" name="Accent rule">
             <a:extLst>
               <a:ext uri="{FF2B5EF4-FFF2-40B4-BE49-F238E27FC236}">
-                <a16:creationId xmlns:a16="http://schemas.microsoft.com/office/drawing/2014/main" id="{65B8E916-52D2-9D37-B7AC-0C063957FA59}"/>
+                <a16:creationId xmlns:a16="http://schemas.microsoft.com/office/drawing/2014/main" id="{DA6B8E74-9731-6565-6E53-432781DC0901}"/>
               </a:ext>
             </a:extLst>
           </p:cNvPr>
@@ -9007,7 +9007,7 @@
           <p:cNvPr id="5" name="Footer author">
             <a:extLst>
               <a:ext uri="{FF2B5EF4-FFF2-40B4-BE49-F238E27FC236}">
-                <a16:creationId xmlns:a16="http://schemas.microsoft.com/office/drawing/2014/main" id="{7DA07517-01B0-9CB8-5C7E-C4E99738DDE4}"/>
+                <a16:creationId xmlns:a16="http://schemas.microsoft.com/office/drawing/2014/main" id="{67375D4A-7DEE-4E06-A47C-57A316588B7F}"/>
               </a:ext>
             </a:extLst>
           </p:cNvPr>
@@ -9052,7 +9052,7 @@
           <p:cNvPr id="6" name="Slide number">
             <a:extLst>
               <a:ext uri="{FF2B5EF4-FFF2-40B4-BE49-F238E27FC236}">
-                <a16:creationId xmlns:a16="http://schemas.microsoft.com/office/drawing/2014/main" id="{33480503-4F3F-D344-DFE7-294CFA9F90DC}"/>
+                <a16:creationId xmlns:a16="http://schemas.microsoft.com/office/drawing/2014/main" id="{5D2B20F1-785C-594E-E2B9-6F3E714BA9EF}"/>
               </a:ext>
             </a:extLst>
           </p:cNvPr>
@@ -9097,7 +9097,7 @@
           <p:cNvPr id="7" name="Demo arrow">
             <a:extLst>
               <a:ext uri="{FF2B5EF4-FFF2-40B4-BE49-F238E27FC236}">
-                <a16:creationId xmlns:a16="http://schemas.microsoft.com/office/drawing/2014/main" id="{A13B6FAB-3310-E1A6-6EF0-74B1CDDB9C45}"/>
+                <a16:creationId xmlns:a16="http://schemas.microsoft.com/office/drawing/2014/main" id="{921EC79B-E85A-5CDA-9AE7-4E1437301D39}"/>
               </a:ext>
             </a:extLst>
           </p:cNvPr>
@@ -9139,7 +9139,7 @@
           <p:cNvPr id="8" name="Demo arrow">
             <a:extLst>
               <a:ext uri="{FF2B5EF4-FFF2-40B4-BE49-F238E27FC236}">
-                <a16:creationId xmlns:a16="http://schemas.microsoft.com/office/drawing/2014/main" id="{1F848EBC-AA17-5219-494E-D95B1A5105BE}"/>
+                <a16:creationId xmlns:a16="http://schemas.microsoft.com/office/drawing/2014/main" id="{F29598AC-5256-4CBC-5E71-ADA53C9ABB20}"/>
               </a:ext>
             </a:extLst>
           </p:cNvPr>
@@ -9181,7 +9181,7 @@
           <p:cNvPr id="9" name="Demo arrow">
             <a:extLst>
               <a:ext uri="{FF2B5EF4-FFF2-40B4-BE49-F238E27FC236}">
-                <a16:creationId xmlns:a16="http://schemas.microsoft.com/office/drawing/2014/main" id="{7ED56186-8BA0-05A8-40FC-B9DACDB5C0C0}"/>
+                <a16:creationId xmlns:a16="http://schemas.microsoft.com/office/drawing/2014/main" id="{0E16FF7C-5B0B-A72F-82C7-DEAB4098DFE5}"/>
               </a:ext>
             </a:extLst>
           </p:cNvPr>
@@ -9223,7 +9223,7 @@
           <p:cNvPr id="10" name="Demo number">
             <a:extLst>
               <a:ext uri="{FF2B5EF4-FFF2-40B4-BE49-F238E27FC236}">
-                <a16:creationId xmlns:a16="http://schemas.microsoft.com/office/drawing/2014/main" id="{CFF9DFEC-07C1-17F0-A2F2-054DB325F164}"/>
+                <a16:creationId xmlns:a16="http://schemas.microsoft.com/office/drawing/2014/main" id="{D14187B2-6FA4-F546-CF3F-08C30F2D42F9}"/>
               </a:ext>
             </a:extLst>
           </p:cNvPr>
@@ -9268,7 +9268,7 @@
           <p:cNvPr id="11" name="Demo node">
             <a:extLst>
               <a:ext uri="{FF2B5EF4-FFF2-40B4-BE49-F238E27FC236}">
-                <a16:creationId xmlns:a16="http://schemas.microsoft.com/office/drawing/2014/main" id="{688AC2C1-F32C-D6DF-0264-4771055972F6}"/>
+                <a16:creationId xmlns:a16="http://schemas.microsoft.com/office/drawing/2014/main" id="{355D45A4-9CF5-470E-84A0-7AB1BF7CE5B7}"/>
               </a:ext>
             </a:extLst>
           </p:cNvPr>
@@ -9336,7 +9336,7 @@
           <p:cNvPr id="12" name="Demo title">
             <a:extLst>
               <a:ext uri="{FF2B5EF4-FFF2-40B4-BE49-F238E27FC236}">
-                <a16:creationId xmlns:a16="http://schemas.microsoft.com/office/drawing/2014/main" id="{5EC43781-4655-4133-C530-A0199D532017}"/>
+                <a16:creationId xmlns:a16="http://schemas.microsoft.com/office/drawing/2014/main" id="{149C1A3E-7435-2E24-D172-AAA03C7037A6}"/>
               </a:ext>
             </a:extLst>
           </p:cNvPr>
@@ -9381,7 +9381,7 @@
           <p:cNvPr id="13" name="Demo detail">
             <a:extLst>
               <a:ext uri="{FF2B5EF4-FFF2-40B4-BE49-F238E27FC236}">
-                <a16:creationId xmlns:a16="http://schemas.microsoft.com/office/drawing/2014/main" id="{AC1280C9-4353-76CB-3E37-23B2744911AF}"/>
+                <a16:creationId xmlns:a16="http://schemas.microsoft.com/office/drawing/2014/main" id="{8B6056C2-0C34-A384-FA76-0FD5726F40C2}"/>
               </a:ext>
             </a:extLst>
           </p:cNvPr>
@@ -9426,7 +9426,7 @@
           <p:cNvPr id="14" name="Demo number">
             <a:extLst>
               <a:ext uri="{FF2B5EF4-FFF2-40B4-BE49-F238E27FC236}">
-                <a16:creationId xmlns:a16="http://schemas.microsoft.com/office/drawing/2014/main" id="{1C63E120-B9F0-BA61-6524-A524CF0F12A7}"/>
+                <a16:creationId xmlns:a16="http://schemas.microsoft.com/office/drawing/2014/main" id="{8AC7A7CF-C0F6-6D53-A095-AE70F4968F75}"/>
               </a:ext>
             </a:extLst>
           </p:cNvPr>
@@ -9471,7 +9471,7 @@
           <p:cNvPr id="15" name="Demo node">
             <a:extLst>
               <a:ext uri="{FF2B5EF4-FFF2-40B4-BE49-F238E27FC236}">
-                <a16:creationId xmlns:a16="http://schemas.microsoft.com/office/drawing/2014/main" id="{3BDCE198-10AD-E68A-0CDD-EA20539968A8}"/>
+                <a16:creationId xmlns:a16="http://schemas.microsoft.com/office/drawing/2014/main" id="{9DC36BF4-4F25-D350-DF5F-5989F62CFA97}"/>
               </a:ext>
             </a:extLst>
           </p:cNvPr>
@@ -9539,7 +9539,7 @@
           <p:cNvPr id="16" name="Demo title">
             <a:extLst>
               <a:ext uri="{FF2B5EF4-FFF2-40B4-BE49-F238E27FC236}">
-                <a16:creationId xmlns:a16="http://schemas.microsoft.com/office/drawing/2014/main" id="{332762BD-8F05-9CE5-3B37-D3C8B99503EF}"/>
+                <a16:creationId xmlns:a16="http://schemas.microsoft.com/office/drawing/2014/main" id="{E80E9DE9-0FC7-3A48-C2A0-E8454977270A}"/>
               </a:ext>
             </a:extLst>
           </p:cNvPr>
@@ -9584,7 +9584,7 @@
           <p:cNvPr id="17" name="Demo detail">
             <a:extLst>
               <a:ext uri="{FF2B5EF4-FFF2-40B4-BE49-F238E27FC236}">
-                <a16:creationId xmlns:a16="http://schemas.microsoft.com/office/drawing/2014/main" id="{A1196E8D-E5F0-BE40-82BD-F21A4D484008}"/>
+                <a16:creationId xmlns:a16="http://schemas.microsoft.com/office/drawing/2014/main" id="{5D6CA46C-EFF4-F695-9D9E-7E87CD0B244A}"/>
               </a:ext>
             </a:extLst>
           </p:cNvPr>
@@ -9629,7 +9629,7 @@
           <p:cNvPr id="18" name="Demo number">
             <a:extLst>
               <a:ext uri="{FF2B5EF4-FFF2-40B4-BE49-F238E27FC236}">
-                <a16:creationId xmlns:a16="http://schemas.microsoft.com/office/drawing/2014/main" id="{E6DAE55E-FE14-5F30-5B90-1D2595BEBF51}"/>
+                <a16:creationId xmlns:a16="http://schemas.microsoft.com/office/drawing/2014/main" id="{97CF7463-D240-C446-E0C9-4B7117D8E7D6}"/>
               </a:ext>
             </a:extLst>
           </p:cNvPr>
@@ -9674,7 +9674,7 @@
           <p:cNvPr id="19" name="Demo node">
             <a:extLst>
               <a:ext uri="{FF2B5EF4-FFF2-40B4-BE49-F238E27FC236}">
-                <a16:creationId xmlns:a16="http://schemas.microsoft.com/office/drawing/2014/main" id="{324DD070-35B3-DCA8-5435-5A4EFCD942B5}"/>
+                <a16:creationId xmlns:a16="http://schemas.microsoft.com/office/drawing/2014/main" id="{5EF8F2F4-DE0B-7638-2CF3-5EBDE89757BF}"/>
               </a:ext>
             </a:extLst>
           </p:cNvPr>
@@ -9742,7 +9742,7 @@
           <p:cNvPr id="20" name="Demo title">
             <a:extLst>
               <a:ext uri="{FF2B5EF4-FFF2-40B4-BE49-F238E27FC236}">
-                <a16:creationId xmlns:a16="http://schemas.microsoft.com/office/drawing/2014/main" id="{C9CDB8B3-81DF-7048-2C40-DCA4427B4943}"/>
+                <a16:creationId xmlns:a16="http://schemas.microsoft.com/office/drawing/2014/main" id="{FC354531-3980-DB64-BD9F-9632353CB16E}"/>
               </a:ext>
             </a:extLst>
           </p:cNvPr>
@@ -9787,7 +9787,7 @@
           <p:cNvPr id="21" name="Demo detail">
             <a:extLst>
               <a:ext uri="{FF2B5EF4-FFF2-40B4-BE49-F238E27FC236}">
-                <a16:creationId xmlns:a16="http://schemas.microsoft.com/office/drawing/2014/main" id="{ADC65AA4-361F-B38F-F94A-E4C6F2C1BCE4}"/>
+                <a16:creationId xmlns:a16="http://schemas.microsoft.com/office/drawing/2014/main" id="{0F9D597C-4632-C75F-D2DC-06BF799C0E99}"/>
               </a:ext>
             </a:extLst>
           </p:cNvPr>
@@ -9832,7 +9832,7 @@
           <p:cNvPr id="22" name="Demo number">
             <a:extLst>
               <a:ext uri="{FF2B5EF4-FFF2-40B4-BE49-F238E27FC236}">
-                <a16:creationId xmlns:a16="http://schemas.microsoft.com/office/drawing/2014/main" id="{68F6E7FF-8866-0316-14E4-C0B5BCA7BFCF}"/>
+                <a16:creationId xmlns:a16="http://schemas.microsoft.com/office/drawing/2014/main" id="{8339020B-6F36-39D3-1506-BAB86D03F19B}"/>
               </a:ext>
             </a:extLst>
           </p:cNvPr>
@@ -9877,7 +9877,7 @@
           <p:cNvPr id="23" name="Demo node">
             <a:extLst>
               <a:ext uri="{FF2B5EF4-FFF2-40B4-BE49-F238E27FC236}">
-                <a16:creationId xmlns:a16="http://schemas.microsoft.com/office/drawing/2014/main" id="{2C97D443-4532-8FD9-4E5B-9B742944A035}"/>
+                <a16:creationId xmlns:a16="http://schemas.microsoft.com/office/drawing/2014/main" id="{136949D5-23D2-5A0A-8BDD-E2C832790E29}"/>
               </a:ext>
             </a:extLst>
           </p:cNvPr>
@@ -9945,7 +9945,7 @@
           <p:cNvPr id="24" name="Demo title">
             <a:extLst>
               <a:ext uri="{FF2B5EF4-FFF2-40B4-BE49-F238E27FC236}">
-                <a16:creationId xmlns:a16="http://schemas.microsoft.com/office/drawing/2014/main" id="{E7DF4160-C898-3E5B-F62E-8733CE1EE71B}"/>
+                <a16:creationId xmlns:a16="http://schemas.microsoft.com/office/drawing/2014/main" id="{1022EDCC-D734-9B17-FA90-B354703C4B88}"/>
               </a:ext>
             </a:extLst>
           </p:cNvPr>
@@ -9990,7 +9990,7 @@
           <p:cNvPr id="25" name="Demo detail">
             <a:extLst>
               <a:ext uri="{FF2B5EF4-FFF2-40B4-BE49-F238E27FC236}">
-                <a16:creationId xmlns:a16="http://schemas.microsoft.com/office/drawing/2014/main" id="{76D86B5F-9EF3-C692-25D8-3D5B4E31981E}"/>
+                <a16:creationId xmlns:a16="http://schemas.microsoft.com/office/drawing/2014/main" id="{11C4521C-7DE5-6C48-1598-A6C17E88ED46}"/>
               </a:ext>
             </a:extLst>
           </p:cNvPr>
@@ -10035,7 +10035,7 @@
           <p:cNvPr id="26" name="Demo note">
             <a:extLst>
               <a:ext uri="{FF2B5EF4-FFF2-40B4-BE49-F238E27FC236}">
-                <a16:creationId xmlns:a16="http://schemas.microsoft.com/office/drawing/2014/main" id="{62C2A639-D814-7FE9-4E84-C332EB2022D0}"/>
+                <a16:creationId xmlns:a16="http://schemas.microsoft.com/office/drawing/2014/main" id="{61A911BD-00C3-5515-0856-3AAA25FC9987}"/>
               </a:ext>
             </a:extLst>
           </p:cNvPr>
@@ -10089,7 +10089,7 @@
           <p:cNvPr id="27" name="LAN note">
             <a:extLst>
               <a:ext uri="{FF2B5EF4-FFF2-40B4-BE49-F238E27FC236}">
-                <a16:creationId xmlns:a16="http://schemas.microsoft.com/office/drawing/2014/main" id="{5C9F801C-0729-578A-E952-7D6D8B3FD936}"/>
+                <a16:creationId xmlns:a16="http://schemas.microsoft.com/office/drawing/2014/main" id="{E9F40078-A074-1581-B3EA-BFA0B2AB148E}"/>
               </a:ext>
             </a:extLst>
           </p:cNvPr>
@@ -10132,7 +10132,7 @@
     </p:spTree>
     <p:extLst>
       <p:ext uri="{BB962C8B-B14F-4D97-AF65-F5344CB8AC3E}">
-        <p14:creationId xmlns:p14="http://schemas.microsoft.com/office/powerpoint/2010/main" val="3674238102"/>
+        <p14:creationId xmlns:p14="http://schemas.microsoft.com/office/powerpoint/2010/main" val="1640630761"/>
       </p:ext>
     </p:extLst>
   </p:cSld>
@@ -10172,7 +10172,7 @@
           <p:cNvPr id="2" name="Section">
             <a:extLst>
               <a:ext uri="{FF2B5EF4-FFF2-40B4-BE49-F238E27FC236}">
-                <a16:creationId xmlns:a16="http://schemas.microsoft.com/office/drawing/2014/main" id="{B0DE57C0-A5CC-3C40-01A3-1A64E190E303}"/>
+                <a16:creationId xmlns:a16="http://schemas.microsoft.com/office/drawing/2014/main" id="{797D9ABF-684B-970C-8BF9-7F1FA1016CC9}"/>
               </a:ext>
             </a:extLst>
           </p:cNvPr>
@@ -10217,7 +10217,7 @@
           <p:cNvPr id="3" name="Slide title">
             <a:extLst>
               <a:ext uri="{FF2B5EF4-FFF2-40B4-BE49-F238E27FC236}">
-                <a16:creationId xmlns:a16="http://schemas.microsoft.com/office/drawing/2014/main" id="{C8ACA7F6-C2D5-095D-9356-94EA022E7BD2}"/>
+                <a16:creationId xmlns:a16="http://schemas.microsoft.com/office/drawing/2014/main" id="{DBA87566-2483-0495-FAAC-8807165CEF2A}"/>
               </a:ext>
             </a:extLst>
           </p:cNvPr>
@@ -10262,7 +10262,7 @@
           <p:cNvPr id="4" name="Accent rule">
             <a:extLst>
               <a:ext uri="{FF2B5EF4-FFF2-40B4-BE49-F238E27FC236}">
-                <a16:creationId xmlns:a16="http://schemas.microsoft.com/office/drawing/2014/main" id="{21AEBC83-2A07-C59E-AD63-426E76C971D2}"/>
+                <a16:creationId xmlns:a16="http://schemas.microsoft.com/office/drawing/2014/main" id="{6EB17625-F2B1-1500-4AA8-8E9C323F3630}"/>
               </a:ext>
             </a:extLst>
           </p:cNvPr>
@@ -10303,7 +10303,7 @@
           <p:cNvPr id="5" name="Footer author">
             <a:extLst>
               <a:ext uri="{FF2B5EF4-FFF2-40B4-BE49-F238E27FC236}">
-                <a16:creationId xmlns:a16="http://schemas.microsoft.com/office/drawing/2014/main" id="{C3916F09-722A-1670-7758-79A468FFF6E6}"/>
+                <a16:creationId xmlns:a16="http://schemas.microsoft.com/office/drawing/2014/main" id="{BD07C382-EA3D-658F-04ED-480730B6999B}"/>
               </a:ext>
             </a:extLst>
           </p:cNvPr>
@@ -10348,7 +10348,7 @@
           <p:cNvPr id="6" name="Slide number">
             <a:extLst>
               <a:ext uri="{FF2B5EF4-FFF2-40B4-BE49-F238E27FC236}">
-                <a16:creationId xmlns:a16="http://schemas.microsoft.com/office/drawing/2014/main" id="{CB43EC04-928D-8AD7-171A-4470A9F1A969}"/>
+                <a16:creationId xmlns:a16="http://schemas.microsoft.com/office/drawing/2014/main" id="{40C9B59F-9D67-0C3B-D743-626AC62EA70D}"/>
               </a:ext>
             </a:extLst>
           </p:cNvPr>
@@ -10393,7 +10393,7 @@
           <p:cNvPr id="7" name="Demonstrates label">
             <a:extLst>
               <a:ext uri="{FF2B5EF4-FFF2-40B4-BE49-F238E27FC236}">
-                <a16:creationId xmlns:a16="http://schemas.microsoft.com/office/drawing/2014/main" id="{52D10A9B-6A56-991A-D228-836779D95283}"/>
+                <a16:creationId xmlns:a16="http://schemas.microsoft.com/office/drawing/2014/main" id="{FF7630B0-33B3-E0B8-33AB-BFCF5D29D80A}"/>
               </a:ext>
             </a:extLst>
           </p:cNvPr>
@@ -10438,7 +10438,7 @@
           <p:cNvPr id="8" name="Demonstrates">
             <a:extLst>
               <a:ext uri="{FF2B5EF4-FFF2-40B4-BE49-F238E27FC236}">
-                <a16:creationId xmlns:a16="http://schemas.microsoft.com/office/drawing/2014/main" id="{BA3CC961-BF6D-BFED-DE65-70F2CBDBCA06}"/>
+                <a16:creationId xmlns:a16="http://schemas.microsoft.com/office/drawing/2014/main" id="{6F892264-12B7-4C1C-7D49-93CC1C70078E}"/>
               </a:ext>
             </a:extLst>
           </p:cNvPr>
@@ -10486,7 +10486,7 @@
           <p:cNvPr id="9" name="Limit divider">
             <a:extLst>
               <a:ext uri="{FF2B5EF4-FFF2-40B4-BE49-F238E27FC236}">
-                <a16:creationId xmlns:a16="http://schemas.microsoft.com/office/drawing/2014/main" id="{B3412703-B662-D3A2-7AEC-74EB7811256B}"/>
+                <a16:creationId xmlns:a16="http://schemas.microsoft.com/office/drawing/2014/main" id="{AA1EAA73-69D9-BD0D-EDD2-D7B38EAFCB93}"/>
               </a:ext>
             </a:extLst>
           </p:cNvPr>
@@ -10527,7 +10527,7 @@
           <p:cNvPr id="10" name="Does not label">
             <a:extLst>
               <a:ext uri="{FF2B5EF4-FFF2-40B4-BE49-F238E27FC236}">
-                <a16:creationId xmlns:a16="http://schemas.microsoft.com/office/drawing/2014/main" id="{B42DDAB4-5735-27D8-E209-1618F463DC22}"/>
+                <a16:creationId xmlns:a16="http://schemas.microsoft.com/office/drawing/2014/main" id="{179E3B8F-9050-3EB9-B84C-EF7BFCA15CB5}"/>
               </a:ext>
             </a:extLst>
           </p:cNvPr>
@@ -10572,7 +10572,7 @@
           <p:cNvPr id="11" name="Does not">
             <a:extLst>
               <a:ext uri="{FF2B5EF4-FFF2-40B4-BE49-F238E27FC236}">
-                <a16:creationId xmlns:a16="http://schemas.microsoft.com/office/drawing/2014/main" id="{06995531-8538-849A-CE34-B8FFB891D8DD}"/>
+                <a16:creationId xmlns:a16="http://schemas.microsoft.com/office/drawing/2014/main" id="{99ABC533-22B2-8152-1FC2-A9FEE88BD959}"/>
               </a:ext>
             </a:extLst>
           </p:cNvPr>
@@ -10620,7 +10620,7 @@
           <p:cNvPr id="12" name="Future band">
             <a:extLst>
               <a:ext uri="{FF2B5EF4-FFF2-40B4-BE49-F238E27FC236}">
-                <a16:creationId xmlns:a16="http://schemas.microsoft.com/office/drawing/2014/main" id="{0A5C17E3-67A1-DB0A-E72E-892FACE230EF}"/>
+                <a16:creationId xmlns:a16="http://schemas.microsoft.com/office/drawing/2014/main" id="{D85BB2DB-EB69-9DFE-9CEC-289ACD9120D3}"/>
               </a:ext>
             </a:extLst>
           </p:cNvPr>
@@ -10688,7 +10688,7 @@
           <p:cNvPr id="13" name="Future label">
             <a:extLst>
               <a:ext uri="{FF2B5EF4-FFF2-40B4-BE49-F238E27FC236}">
-                <a16:creationId xmlns:a16="http://schemas.microsoft.com/office/drawing/2014/main" id="{7C3CDC22-D113-FB52-8ECD-501F0197F0A7}"/>
+                <a16:creationId xmlns:a16="http://schemas.microsoft.com/office/drawing/2014/main" id="{E0ACF1A0-2D5D-1852-583F-2ABFF68B7A9A}"/>
               </a:ext>
             </a:extLst>
           </p:cNvPr>
@@ -10733,7 +10733,7 @@
           <p:cNvPr id="14" name="Future items">
             <a:extLst>
               <a:ext uri="{FF2B5EF4-FFF2-40B4-BE49-F238E27FC236}">
-                <a16:creationId xmlns:a16="http://schemas.microsoft.com/office/drawing/2014/main" id="{E0A6615A-9D81-2116-F843-EB00CF036F13}"/>
+                <a16:creationId xmlns:a16="http://schemas.microsoft.com/office/drawing/2014/main" id="{9144D84F-B80C-016C-0404-0178E6CAFE84}"/>
               </a:ext>
             </a:extLst>
           </p:cNvPr>
@@ -10776,7 +10776,7 @@
     </p:spTree>
     <p:extLst>
       <p:ext uri="{BB962C8B-B14F-4D97-AF65-F5344CB8AC3E}">
-        <p14:creationId xmlns:p14="http://schemas.microsoft.com/office/powerpoint/2010/main" val="2346132493"/>
+        <p14:creationId xmlns:p14="http://schemas.microsoft.com/office/powerpoint/2010/main" val="226512851"/>
       </p:ext>
     </p:extLst>
   </p:cSld>
@@ -10816,7 +10816,7 @@
           <p:cNvPr id="2" name="Closing label">
             <a:extLst>
               <a:ext uri="{FF2B5EF4-FFF2-40B4-BE49-F238E27FC236}">
-                <a16:creationId xmlns:a16="http://schemas.microsoft.com/office/drawing/2014/main" id="{EF8E3202-6E13-9AAA-3154-30636FC97100}"/>
+                <a16:creationId xmlns:a16="http://schemas.microsoft.com/office/drawing/2014/main" id="{32D77C1D-EF3D-56D6-3199-32FD85F6789A}"/>
               </a:ext>
             </a:extLst>
           </p:cNvPr>
@@ -10861,7 +10861,7 @@
           <p:cNvPr id="3" name="Closing title">
             <a:extLst>
               <a:ext uri="{FF2B5EF4-FFF2-40B4-BE49-F238E27FC236}">
-                <a16:creationId xmlns:a16="http://schemas.microsoft.com/office/drawing/2014/main" id="{F92CA4AE-AEA4-A8A4-1DD4-6034A741D2DF}"/>
+                <a16:creationId xmlns:a16="http://schemas.microsoft.com/office/drawing/2014/main" id="{B2AD5089-727E-1751-866E-846D201F57DA}"/>
               </a:ext>
             </a:extLst>
           </p:cNvPr>
@@ -10907,7 +10907,7 @@
           <p:cNvPr id="4" name="Closing thesis">
             <a:extLst>
               <a:ext uri="{FF2B5EF4-FFF2-40B4-BE49-F238E27FC236}">
-                <a16:creationId xmlns:a16="http://schemas.microsoft.com/office/drawing/2014/main" id="{BBB8115C-A78E-AFC6-D6DC-D5B534DB5E31}"/>
+                <a16:creationId xmlns:a16="http://schemas.microsoft.com/office/drawing/2014/main" id="{1078CCD8-408B-28C4-1F2D-DDDB01D1E8ED}"/>
               </a:ext>
             </a:extLst>
           </p:cNvPr>
@@ -10952,7 +10952,7 @@
           <p:cNvPr id="5" name="Closing rule">
             <a:extLst>
               <a:ext uri="{FF2B5EF4-FFF2-40B4-BE49-F238E27FC236}">
-                <a16:creationId xmlns:a16="http://schemas.microsoft.com/office/drawing/2014/main" id="{B46701F5-9A4B-DA12-EFC5-B6CE972AE87B}"/>
+                <a16:creationId xmlns:a16="http://schemas.microsoft.com/office/drawing/2014/main" id="{84696F4E-5B37-406D-13F1-8A8F2F91679C}"/>
               </a:ext>
             </a:extLst>
           </p:cNvPr>
@@ -10993,7 +10993,7 @@
           <p:cNvPr id="6" name="Closing contribution">
             <a:extLst>
               <a:ext uri="{FF2B5EF4-FFF2-40B4-BE49-F238E27FC236}">
-                <a16:creationId xmlns:a16="http://schemas.microsoft.com/office/drawing/2014/main" id="{5E4B8DF2-60CD-0227-CF3A-1B7F8638B06A}"/>
+                <a16:creationId xmlns:a16="http://schemas.microsoft.com/office/drawing/2014/main" id="{76041376-5611-DADC-8955-23B97512C603}"/>
               </a:ext>
             </a:extLst>
           </p:cNvPr>
@@ -11038,7 +11038,7 @@
           <p:cNvPr id="7" name="Questions">
             <a:extLst>
               <a:ext uri="{FF2B5EF4-FFF2-40B4-BE49-F238E27FC236}">
-                <a16:creationId xmlns:a16="http://schemas.microsoft.com/office/drawing/2014/main" id="{6F4BF09C-629F-1A68-D710-C728409AA74C}"/>
+                <a16:creationId xmlns:a16="http://schemas.microsoft.com/office/drawing/2014/main" id="{E847B6BA-82A7-198E-5491-C18D01078E90}"/>
               </a:ext>
             </a:extLst>
           </p:cNvPr>
@@ -11081,7 +11081,7 @@
     </p:spTree>
     <p:extLst>
       <p:ext uri="{BB962C8B-B14F-4D97-AF65-F5344CB8AC3E}">
-        <p14:creationId xmlns:p14="http://schemas.microsoft.com/office/powerpoint/2010/main" val="1121462094"/>
+        <p14:creationId xmlns:p14="http://schemas.microsoft.com/office/powerpoint/2010/main" val="750712838"/>
       </p:ext>
     </p:extLst>
   </p:cSld>
@@ -11121,7 +11121,7 @@
           <p:cNvPr id="2" name="Section">
             <a:extLst>
               <a:ext uri="{FF2B5EF4-FFF2-40B4-BE49-F238E27FC236}">
-                <a16:creationId xmlns:a16="http://schemas.microsoft.com/office/drawing/2014/main" id="{075C0818-D8BB-0573-073B-53B38734CFD9}"/>
+                <a16:creationId xmlns:a16="http://schemas.microsoft.com/office/drawing/2014/main" id="{E5A50822-C913-7E42-1E1A-DE9C81C2B61B}"/>
               </a:ext>
             </a:extLst>
           </p:cNvPr>
@@ -11166,7 +11166,7 @@
           <p:cNvPr id="3" name="Slide title">
             <a:extLst>
               <a:ext uri="{FF2B5EF4-FFF2-40B4-BE49-F238E27FC236}">
-                <a16:creationId xmlns:a16="http://schemas.microsoft.com/office/drawing/2014/main" id="{B91543EB-136D-6D33-DFFC-FD7F4E851CEF}"/>
+                <a16:creationId xmlns:a16="http://schemas.microsoft.com/office/drawing/2014/main" id="{16164423-AE1A-3751-926D-E69836C4301A}"/>
               </a:ext>
             </a:extLst>
           </p:cNvPr>
@@ -11211,7 +11211,7 @@
           <p:cNvPr id="4" name="Accent rule">
             <a:extLst>
               <a:ext uri="{FF2B5EF4-FFF2-40B4-BE49-F238E27FC236}">
-                <a16:creationId xmlns:a16="http://schemas.microsoft.com/office/drawing/2014/main" id="{6DFED996-1D5B-A332-990C-6D58CAB980EF}"/>
+                <a16:creationId xmlns:a16="http://schemas.microsoft.com/office/drawing/2014/main" id="{166845B6-C41E-3650-46FF-01056C51AEEE}"/>
               </a:ext>
             </a:extLst>
           </p:cNvPr>
@@ -11252,7 +11252,7 @@
           <p:cNvPr id="5" name="Footer author">
             <a:extLst>
               <a:ext uri="{FF2B5EF4-FFF2-40B4-BE49-F238E27FC236}">
-                <a16:creationId xmlns:a16="http://schemas.microsoft.com/office/drawing/2014/main" id="{E303F36B-D40A-6C26-9A1B-04DB833B8F06}"/>
+                <a16:creationId xmlns:a16="http://schemas.microsoft.com/office/drawing/2014/main" id="{05335EEB-FCE2-A792-ACA2-DC8974E4C461}"/>
               </a:ext>
             </a:extLst>
           </p:cNvPr>
@@ -11297,7 +11297,7 @@
           <p:cNvPr id="6" name="Slide number">
             <a:extLst>
               <a:ext uri="{FF2B5EF4-FFF2-40B4-BE49-F238E27FC236}">
-                <a16:creationId xmlns:a16="http://schemas.microsoft.com/office/drawing/2014/main" id="{5CDB884B-40E0-95DF-7D97-50648220AD4C}"/>
+                <a16:creationId xmlns:a16="http://schemas.microsoft.com/office/drawing/2014/main" id="{868C48B2-440F-8875-AF4F-94B5E923779F}"/>
               </a:ext>
             </a:extLst>
           </p:cNvPr>
@@ -11342,7 +11342,7 @@
           <p:cNvPr id="7" name="Question field">
             <a:extLst>
               <a:ext uri="{FF2B5EF4-FFF2-40B4-BE49-F238E27FC236}">
-                <a16:creationId xmlns:a16="http://schemas.microsoft.com/office/drawing/2014/main" id="{36592ECE-A28A-9B30-1BEC-E33FB995D068}"/>
+                <a16:creationId xmlns:a16="http://schemas.microsoft.com/office/drawing/2014/main" id="{76F3B65F-6243-FAA6-AA62-8269E0356EA2}"/>
               </a:ext>
             </a:extLst>
           </p:cNvPr>
@@ -11410,7 +11410,7 @@
           <p:cNvPr id="8" name="Question">
             <a:extLst>
               <a:ext uri="{FF2B5EF4-FFF2-40B4-BE49-F238E27FC236}">
-                <a16:creationId xmlns:a16="http://schemas.microsoft.com/office/drawing/2014/main" id="{81645575-EE0D-3D0C-7419-13689792C723}"/>
+                <a16:creationId xmlns:a16="http://schemas.microsoft.com/office/drawing/2014/main" id="{8BE1E035-47D0-6902-B56C-1BFBCD4F0621}"/>
               </a:ext>
             </a:extLst>
           </p:cNvPr>
@@ -11455,7 +11455,7 @@
           <p:cNvPr id="9" name="Question support">
             <a:extLst>
               <a:ext uri="{FF2B5EF4-FFF2-40B4-BE49-F238E27FC236}">
-                <a16:creationId xmlns:a16="http://schemas.microsoft.com/office/drawing/2014/main" id="{183FE2D8-B2B0-3AEE-9540-A1C9E3D5BA3D}"/>
+                <a16:creationId xmlns:a16="http://schemas.microsoft.com/office/drawing/2014/main" id="{E3034625-D9B2-1025-C486-8CE22923B26B}"/>
               </a:ext>
             </a:extLst>
           </p:cNvPr>
@@ -11500,7 +11500,7 @@
           <p:cNvPr id="10" name="Index 01">
             <a:extLst>
               <a:ext uri="{FF2B5EF4-FFF2-40B4-BE49-F238E27FC236}">
-                <a16:creationId xmlns:a16="http://schemas.microsoft.com/office/drawing/2014/main" id="{2B2153E1-8D8B-89F5-3A10-1818074A190B}"/>
+                <a16:creationId xmlns:a16="http://schemas.microsoft.com/office/drawing/2014/main" id="{23C32ABA-CD84-1DCA-E8B5-3D384D1AE7C1}"/>
               </a:ext>
             </a:extLst>
           </p:cNvPr>
@@ -11545,7 +11545,7 @@
           <p:cNvPr id="11" name="Problem 01">
             <a:extLst>
               <a:ext uri="{FF2B5EF4-FFF2-40B4-BE49-F238E27FC236}">
-                <a16:creationId xmlns:a16="http://schemas.microsoft.com/office/drawing/2014/main" id="{8978378E-70F9-0025-5DD6-5AF161F04E98}"/>
+                <a16:creationId xmlns:a16="http://schemas.microsoft.com/office/drawing/2014/main" id="{A486CF7F-8CEF-F232-53EC-401E9292490B}"/>
               </a:ext>
             </a:extLst>
           </p:cNvPr>
@@ -11590,7 +11590,7 @@
           <p:cNvPr id="12" name="Problem detail 01">
             <a:extLst>
               <a:ext uri="{FF2B5EF4-FFF2-40B4-BE49-F238E27FC236}">
-                <a16:creationId xmlns:a16="http://schemas.microsoft.com/office/drawing/2014/main" id="{CBE1086D-1152-3ECE-848B-C84A76726C0A}"/>
+                <a16:creationId xmlns:a16="http://schemas.microsoft.com/office/drawing/2014/main" id="{CF5AB035-5565-0353-559D-C9086353C008}"/>
               </a:ext>
             </a:extLst>
           </p:cNvPr>
@@ -11635,7 +11635,7 @@
           <p:cNvPr id="13" name="Problem divider">
             <a:extLst>
               <a:ext uri="{FF2B5EF4-FFF2-40B4-BE49-F238E27FC236}">
-                <a16:creationId xmlns:a16="http://schemas.microsoft.com/office/drawing/2014/main" id="{EF2FC6A1-08EB-BF45-77CD-D715FC849E7E}"/>
+                <a16:creationId xmlns:a16="http://schemas.microsoft.com/office/drawing/2014/main" id="{5054E791-32BA-F15F-BBDB-84DCFC20DD24}"/>
               </a:ext>
             </a:extLst>
           </p:cNvPr>
@@ -11676,7 +11676,7 @@
           <p:cNvPr id="14" name="Index 02">
             <a:extLst>
               <a:ext uri="{FF2B5EF4-FFF2-40B4-BE49-F238E27FC236}">
-                <a16:creationId xmlns:a16="http://schemas.microsoft.com/office/drawing/2014/main" id="{C98320FA-F415-1EA6-FD66-D7C1D86CA287}"/>
+                <a16:creationId xmlns:a16="http://schemas.microsoft.com/office/drawing/2014/main" id="{14B70B25-50C4-504D-74BF-E503ECA7E99E}"/>
               </a:ext>
             </a:extLst>
           </p:cNvPr>
@@ -11721,7 +11721,7 @@
           <p:cNvPr id="15" name="Problem 02">
             <a:extLst>
               <a:ext uri="{FF2B5EF4-FFF2-40B4-BE49-F238E27FC236}">
-                <a16:creationId xmlns:a16="http://schemas.microsoft.com/office/drawing/2014/main" id="{4E4E6FCD-91FD-0F28-CF67-89CD79FFF049}"/>
+                <a16:creationId xmlns:a16="http://schemas.microsoft.com/office/drawing/2014/main" id="{F80345DD-750C-0897-049F-064E09A00671}"/>
               </a:ext>
             </a:extLst>
           </p:cNvPr>
@@ -11766,7 +11766,7 @@
           <p:cNvPr id="16" name="Problem detail 02">
             <a:extLst>
               <a:ext uri="{FF2B5EF4-FFF2-40B4-BE49-F238E27FC236}">
-                <a16:creationId xmlns:a16="http://schemas.microsoft.com/office/drawing/2014/main" id="{83426D22-47FB-1CA2-24AD-0A4DAAE31F9F}"/>
+                <a16:creationId xmlns:a16="http://schemas.microsoft.com/office/drawing/2014/main" id="{E1D6364A-3ED0-C37A-FFE6-1FB392FB3712}"/>
               </a:ext>
             </a:extLst>
           </p:cNvPr>
@@ -11811,7 +11811,7 @@
           <p:cNvPr id="17" name="Problem divider">
             <a:extLst>
               <a:ext uri="{FF2B5EF4-FFF2-40B4-BE49-F238E27FC236}">
-                <a16:creationId xmlns:a16="http://schemas.microsoft.com/office/drawing/2014/main" id="{D1129BA5-1AE6-3563-8639-40AC04B9CEE4}"/>
+                <a16:creationId xmlns:a16="http://schemas.microsoft.com/office/drawing/2014/main" id="{5B8AB0C6-114C-DEB3-3FA2-4840B0A5ADBC}"/>
               </a:ext>
             </a:extLst>
           </p:cNvPr>
@@ -11852,7 +11852,7 @@
           <p:cNvPr id="18" name="Index 03">
             <a:extLst>
               <a:ext uri="{FF2B5EF4-FFF2-40B4-BE49-F238E27FC236}">
-                <a16:creationId xmlns:a16="http://schemas.microsoft.com/office/drawing/2014/main" id="{EAE45CD0-26F8-8572-F90B-5A244EF81CED}"/>
+                <a16:creationId xmlns:a16="http://schemas.microsoft.com/office/drawing/2014/main" id="{3160A884-A5FD-21A8-4222-38A607F169DF}"/>
               </a:ext>
             </a:extLst>
           </p:cNvPr>
@@ -11897,7 +11897,7 @@
           <p:cNvPr id="19" name="Problem 03">
             <a:extLst>
               <a:ext uri="{FF2B5EF4-FFF2-40B4-BE49-F238E27FC236}">
-                <a16:creationId xmlns:a16="http://schemas.microsoft.com/office/drawing/2014/main" id="{BC28FF93-0468-5DB8-1472-0206745B31E7}"/>
+                <a16:creationId xmlns:a16="http://schemas.microsoft.com/office/drawing/2014/main" id="{E50C2E6A-A2B5-8E11-9B8D-E14125C9CC06}"/>
               </a:ext>
             </a:extLst>
           </p:cNvPr>
@@ -11942,7 +11942,7 @@
           <p:cNvPr id="20" name="Problem detail 03">
             <a:extLst>
               <a:ext uri="{FF2B5EF4-FFF2-40B4-BE49-F238E27FC236}">
-                <a16:creationId xmlns:a16="http://schemas.microsoft.com/office/drawing/2014/main" id="{AF25C870-5EBA-24A2-D56D-3D58AFF70C64}"/>
+                <a16:creationId xmlns:a16="http://schemas.microsoft.com/office/drawing/2014/main" id="{4EFD7A93-989B-DBAA-937F-FCE477CCC4E8}"/>
               </a:ext>
             </a:extLst>
           </p:cNvPr>
@@ -11985,7 +11985,7 @@
     </p:spTree>
     <p:extLst>
       <p:ext uri="{BB962C8B-B14F-4D97-AF65-F5344CB8AC3E}">
-        <p14:creationId xmlns:p14="http://schemas.microsoft.com/office/powerpoint/2010/main" val="284445596"/>
+        <p14:creationId xmlns:p14="http://schemas.microsoft.com/office/powerpoint/2010/main" val="3135857498"/>
       </p:ext>
     </p:extLst>
   </p:cSld>
@@ -12025,7 +12025,7 @@
           <p:cNvPr id="2" name="Section">
             <a:extLst>
               <a:ext uri="{FF2B5EF4-FFF2-40B4-BE49-F238E27FC236}">
-                <a16:creationId xmlns:a16="http://schemas.microsoft.com/office/drawing/2014/main" id="{2F7FFEFF-9ECC-ECD6-F870-50D8F8DDD8A0}"/>
+                <a16:creationId xmlns:a16="http://schemas.microsoft.com/office/drawing/2014/main" id="{994778DE-4628-9BFA-BF95-9AE8DBE33C60}"/>
               </a:ext>
             </a:extLst>
           </p:cNvPr>
@@ -12070,7 +12070,7 @@
           <p:cNvPr id="3" name="Slide title">
             <a:extLst>
               <a:ext uri="{FF2B5EF4-FFF2-40B4-BE49-F238E27FC236}">
-                <a16:creationId xmlns:a16="http://schemas.microsoft.com/office/drawing/2014/main" id="{2A73C2E8-6DDB-F372-339E-267B46BEA4BD}"/>
+                <a16:creationId xmlns:a16="http://schemas.microsoft.com/office/drawing/2014/main" id="{D2265BE0-3C2A-0C8A-93EA-8A130AC8DA5F}"/>
               </a:ext>
             </a:extLst>
           </p:cNvPr>
@@ -12115,7 +12115,7 @@
           <p:cNvPr id="4" name="Accent rule">
             <a:extLst>
               <a:ext uri="{FF2B5EF4-FFF2-40B4-BE49-F238E27FC236}">
-                <a16:creationId xmlns:a16="http://schemas.microsoft.com/office/drawing/2014/main" id="{AB4EC1FF-543B-2040-4A81-55367EE995CD}"/>
+                <a16:creationId xmlns:a16="http://schemas.microsoft.com/office/drawing/2014/main" id="{9D09B167-0AC1-5640-9801-D67C61AC921B}"/>
               </a:ext>
             </a:extLst>
           </p:cNvPr>
@@ -12156,7 +12156,7 @@
           <p:cNvPr id="5" name="Footer author">
             <a:extLst>
               <a:ext uri="{FF2B5EF4-FFF2-40B4-BE49-F238E27FC236}">
-                <a16:creationId xmlns:a16="http://schemas.microsoft.com/office/drawing/2014/main" id="{34F76A29-1178-0A22-04AC-6A5A5B2A4FA4}"/>
+                <a16:creationId xmlns:a16="http://schemas.microsoft.com/office/drawing/2014/main" id="{8F68A7EC-AFA0-3A96-A9B5-C99FE5DC6447}"/>
               </a:ext>
             </a:extLst>
           </p:cNvPr>
@@ -12201,7 +12201,7 @@
           <p:cNvPr id="6" name="Slide number">
             <a:extLst>
               <a:ext uri="{FF2B5EF4-FFF2-40B4-BE49-F238E27FC236}">
-                <a16:creationId xmlns:a16="http://schemas.microsoft.com/office/drawing/2014/main" id="{A7E6418E-BB23-1A69-4191-7DB0B23D18A6}"/>
+                <a16:creationId xmlns:a16="http://schemas.microsoft.com/office/drawing/2014/main" id="{B22B1342-E9C8-4E1D-5F5A-C4060C061AE5}"/>
               </a:ext>
             </a:extLst>
           </p:cNvPr>
@@ -12246,7 +12246,7 @@
           <p:cNvPr id="7" name="Thesis">
             <a:extLst>
               <a:ext uri="{FF2B5EF4-FFF2-40B4-BE49-F238E27FC236}">
-                <a16:creationId xmlns:a16="http://schemas.microsoft.com/office/drawing/2014/main" id="{ED701BA1-59DE-6B21-BBC0-08D038530823}"/>
+                <a16:creationId xmlns:a16="http://schemas.microsoft.com/office/drawing/2014/main" id="{97788861-510F-62BF-1E33-6AFACDE714A6}"/>
               </a:ext>
             </a:extLst>
           </p:cNvPr>
@@ -12291,7 +12291,7 @@
           <p:cNvPr id="8" name="Thesis detail">
             <a:extLst>
               <a:ext uri="{FF2B5EF4-FFF2-40B4-BE49-F238E27FC236}">
-                <a16:creationId xmlns:a16="http://schemas.microsoft.com/office/drawing/2014/main" id="{1A0EB1CA-E4BB-FCC4-8651-4B9409CF6C0F}"/>
+                <a16:creationId xmlns:a16="http://schemas.microsoft.com/office/drawing/2014/main" id="{C200A70E-C629-B06D-5780-E85B2BAE4A7F}"/>
               </a:ext>
             </a:extLst>
           </p:cNvPr>
@@ -12336,7 +12336,7 @@
           <p:cNvPr id="9" name="Objective index">
             <a:extLst>
               <a:ext uri="{FF2B5EF4-FFF2-40B4-BE49-F238E27FC236}">
-                <a16:creationId xmlns:a16="http://schemas.microsoft.com/office/drawing/2014/main" id="{FAA28E44-8717-5689-B983-ADAAA298DBAA}"/>
+                <a16:creationId xmlns:a16="http://schemas.microsoft.com/office/drawing/2014/main" id="{9CA95D51-B1FB-597B-CF60-54F6A043F98B}"/>
               </a:ext>
             </a:extLst>
           </p:cNvPr>
@@ -12381,7 +12381,7 @@
           <p:cNvPr id="10" name="Objective">
             <a:extLst>
               <a:ext uri="{FF2B5EF4-FFF2-40B4-BE49-F238E27FC236}">
-                <a16:creationId xmlns:a16="http://schemas.microsoft.com/office/drawing/2014/main" id="{02A84831-3673-F18C-B99C-C94135C42191}"/>
+                <a16:creationId xmlns:a16="http://schemas.microsoft.com/office/drawing/2014/main" id="{8CECE450-D262-A0F3-B5B2-981DF0D517B0}"/>
               </a:ext>
             </a:extLst>
           </p:cNvPr>
@@ -12426,7 +12426,7 @@
           <p:cNvPr id="11" name="Objective detail">
             <a:extLst>
               <a:ext uri="{FF2B5EF4-FFF2-40B4-BE49-F238E27FC236}">
-                <a16:creationId xmlns:a16="http://schemas.microsoft.com/office/drawing/2014/main" id="{23C25EED-0629-98D1-9C83-9A3053D55793}"/>
+                <a16:creationId xmlns:a16="http://schemas.microsoft.com/office/drawing/2014/main" id="{BA3B1B63-3F1E-3B6E-92B0-45830A816822}"/>
               </a:ext>
             </a:extLst>
           </p:cNvPr>
@@ -12471,7 +12471,7 @@
           <p:cNvPr id="12" name="Objective divider">
             <a:extLst>
               <a:ext uri="{FF2B5EF4-FFF2-40B4-BE49-F238E27FC236}">
-                <a16:creationId xmlns:a16="http://schemas.microsoft.com/office/drawing/2014/main" id="{A0B3549E-4B27-F67F-97E2-C5135EC31E79}"/>
+                <a16:creationId xmlns:a16="http://schemas.microsoft.com/office/drawing/2014/main" id="{256E3121-DBA2-6A8A-D4E9-8E89D22C5324}"/>
               </a:ext>
             </a:extLst>
           </p:cNvPr>
@@ -12512,7 +12512,7 @@
           <p:cNvPr id="13" name="Objective index">
             <a:extLst>
               <a:ext uri="{FF2B5EF4-FFF2-40B4-BE49-F238E27FC236}">
-                <a16:creationId xmlns:a16="http://schemas.microsoft.com/office/drawing/2014/main" id="{03599531-6230-C99F-E46A-37E64DE8CB8D}"/>
+                <a16:creationId xmlns:a16="http://schemas.microsoft.com/office/drawing/2014/main" id="{FAF4BBD9-B569-E4EA-C41A-0096382E1E84}"/>
               </a:ext>
             </a:extLst>
           </p:cNvPr>
@@ -12557,7 +12557,7 @@
           <p:cNvPr id="14" name="Objective">
             <a:extLst>
               <a:ext uri="{FF2B5EF4-FFF2-40B4-BE49-F238E27FC236}">
-                <a16:creationId xmlns:a16="http://schemas.microsoft.com/office/drawing/2014/main" id="{F1B03966-D628-E8B6-6831-68141D6AD87F}"/>
+                <a16:creationId xmlns:a16="http://schemas.microsoft.com/office/drawing/2014/main" id="{1ACA25D6-E120-AE8F-10D9-95044E3F1F00}"/>
               </a:ext>
             </a:extLst>
           </p:cNvPr>
@@ -12602,7 +12602,7 @@
           <p:cNvPr id="15" name="Objective detail">
             <a:extLst>
               <a:ext uri="{FF2B5EF4-FFF2-40B4-BE49-F238E27FC236}">
-                <a16:creationId xmlns:a16="http://schemas.microsoft.com/office/drawing/2014/main" id="{5450AAFD-EDFF-C3C8-009A-1AC70F7C4BD7}"/>
+                <a16:creationId xmlns:a16="http://schemas.microsoft.com/office/drawing/2014/main" id="{95F04695-8FEC-1123-3D6E-AB2EA1E36B2C}"/>
               </a:ext>
             </a:extLst>
           </p:cNvPr>
@@ -12647,7 +12647,7 @@
           <p:cNvPr id="16" name="Objective divider">
             <a:extLst>
               <a:ext uri="{FF2B5EF4-FFF2-40B4-BE49-F238E27FC236}">
-                <a16:creationId xmlns:a16="http://schemas.microsoft.com/office/drawing/2014/main" id="{1D354A64-78EF-4F9F-3B8F-543125EC4299}"/>
+                <a16:creationId xmlns:a16="http://schemas.microsoft.com/office/drawing/2014/main" id="{1E810FB2-7DFE-9A08-5152-7450B38206D5}"/>
               </a:ext>
             </a:extLst>
           </p:cNvPr>
@@ -12688,7 +12688,7 @@
           <p:cNvPr id="17" name="Objective index">
             <a:extLst>
               <a:ext uri="{FF2B5EF4-FFF2-40B4-BE49-F238E27FC236}">
-                <a16:creationId xmlns:a16="http://schemas.microsoft.com/office/drawing/2014/main" id="{5C5DF361-CD53-0071-2195-484B99620776}"/>
+                <a16:creationId xmlns:a16="http://schemas.microsoft.com/office/drawing/2014/main" id="{C05FF35F-96F4-DC12-DCC8-40E55A877E99}"/>
               </a:ext>
             </a:extLst>
           </p:cNvPr>
@@ -12733,7 +12733,7 @@
           <p:cNvPr id="18" name="Objective">
             <a:extLst>
               <a:ext uri="{FF2B5EF4-FFF2-40B4-BE49-F238E27FC236}">
-                <a16:creationId xmlns:a16="http://schemas.microsoft.com/office/drawing/2014/main" id="{9A6EBACE-D031-807D-4B83-A6B0301294E4}"/>
+                <a16:creationId xmlns:a16="http://schemas.microsoft.com/office/drawing/2014/main" id="{A37CD911-0613-F4F9-678B-E839FB1D5CCF}"/>
               </a:ext>
             </a:extLst>
           </p:cNvPr>
@@ -12778,7 +12778,7 @@
           <p:cNvPr id="19" name="Objective detail">
             <a:extLst>
               <a:ext uri="{FF2B5EF4-FFF2-40B4-BE49-F238E27FC236}">
-                <a16:creationId xmlns:a16="http://schemas.microsoft.com/office/drawing/2014/main" id="{A9F63596-A27A-FA95-84A5-C8ADD98489DA}"/>
+                <a16:creationId xmlns:a16="http://schemas.microsoft.com/office/drawing/2014/main" id="{0B6867A9-AE65-E754-8DA0-95E573939CA5}"/>
               </a:ext>
             </a:extLst>
           </p:cNvPr>
@@ -12823,7 +12823,7 @@
           <p:cNvPr id="20" name="Objective divider">
             <a:extLst>
               <a:ext uri="{FF2B5EF4-FFF2-40B4-BE49-F238E27FC236}">
-                <a16:creationId xmlns:a16="http://schemas.microsoft.com/office/drawing/2014/main" id="{D64ABAB4-5AC0-AC34-763A-E533529E7B26}"/>
+                <a16:creationId xmlns:a16="http://schemas.microsoft.com/office/drawing/2014/main" id="{9D7833C7-7210-8C49-CDB2-E77DB16E2B8A}"/>
               </a:ext>
             </a:extLst>
           </p:cNvPr>
@@ -12864,7 +12864,7 @@
           <p:cNvPr id="21" name="Objective index">
             <a:extLst>
               <a:ext uri="{FF2B5EF4-FFF2-40B4-BE49-F238E27FC236}">
-                <a16:creationId xmlns:a16="http://schemas.microsoft.com/office/drawing/2014/main" id="{21FB28C7-92F5-757D-7D2F-F87413F75ADB}"/>
+                <a16:creationId xmlns:a16="http://schemas.microsoft.com/office/drawing/2014/main" id="{7749B6C9-B6B7-5811-3D45-80D563E30546}"/>
               </a:ext>
             </a:extLst>
           </p:cNvPr>
@@ -12909,7 +12909,7 @@
           <p:cNvPr id="22" name="Objective">
             <a:extLst>
               <a:ext uri="{FF2B5EF4-FFF2-40B4-BE49-F238E27FC236}">
-                <a16:creationId xmlns:a16="http://schemas.microsoft.com/office/drawing/2014/main" id="{74FBC23F-A2DB-4A09-6EA0-AB05A56E92D6}"/>
+                <a16:creationId xmlns:a16="http://schemas.microsoft.com/office/drawing/2014/main" id="{1C7E7831-8CBA-BA28-ED7A-376B4F5E9E7E}"/>
               </a:ext>
             </a:extLst>
           </p:cNvPr>
@@ -12954,7 +12954,7 @@
           <p:cNvPr id="23" name="Objective detail">
             <a:extLst>
               <a:ext uri="{FF2B5EF4-FFF2-40B4-BE49-F238E27FC236}">
-                <a16:creationId xmlns:a16="http://schemas.microsoft.com/office/drawing/2014/main" id="{F9BCE289-D306-9CBD-6DB8-680724E931A8}"/>
+                <a16:creationId xmlns:a16="http://schemas.microsoft.com/office/drawing/2014/main" id="{70D60633-8CEF-3B0F-13F2-85D837DE65C2}"/>
               </a:ext>
             </a:extLst>
           </p:cNvPr>
@@ -12997,7 +12997,7 @@
     </p:spTree>
     <p:extLst>
       <p:ext uri="{BB962C8B-B14F-4D97-AF65-F5344CB8AC3E}">
-        <p14:creationId xmlns:p14="http://schemas.microsoft.com/office/powerpoint/2010/main" val="174996649"/>
+        <p14:creationId xmlns:p14="http://schemas.microsoft.com/office/powerpoint/2010/main" val="2688394455"/>
       </p:ext>
     </p:extLst>
   </p:cSld>
@@ -13037,7 +13037,7 @@
           <p:cNvPr id="2" name="Section">
             <a:extLst>
               <a:ext uri="{FF2B5EF4-FFF2-40B4-BE49-F238E27FC236}">
-                <a16:creationId xmlns:a16="http://schemas.microsoft.com/office/drawing/2014/main" id="{01282EB4-7CFB-DD1F-728A-D092EA9301AB}"/>
+                <a16:creationId xmlns:a16="http://schemas.microsoft.com/office/drawing/2014/main" id="{51A8367E-9CA0-D8B4-5D17-8DF400C347BE}"/>
               </a:ext>
             </a:extLst>
           </p:cNvPr>
@@ -13082,7 +13082,7 @@
           <p:cNvPr id="3" name="Slide title">
             <a:extLst>
               <a:ext uri="{FF2B5EF4-FFF2-40B4-BE49-F238E27FC236}">
-                <a16:creationId xmlns:a16="http://schemas.microsoft.com/office/drawing/2014/main" id="{EDBDC7F9-AB71-A997-0C5C-126BCCB6FEFD}"/>
+                <a16:creationId xmlns:a16="http://schemas.microsoft.com/office/drawing/2014/main" id="{E8D53F63-733D-DF29-86B6-B6F41C159EE9}"/>
               </a:ext>
             </a:extLst>
           </p:cNvPr>
@@ -13127,7 +13127,7 @@
           <p:cNvPr id="4" name="Accent rule">
             <a:extLst>
               <a:ext uri="{FF2B5EF4-FFF2-40B4-BE49-F238E27FC236}">
-                <a16:creationId xmlns:a16="http://schemas.microsoft.com/office/drawing/2014/main" id="{A151D008-5CBC-AAB5-154E-5009F874CCAB}"/>
+                <a16:creationId xmlns:a16="http://schemas.microsoft.com/office/drawing/2014/main" id="{F70EE7D6-2697-1EA0-2974-26E52FC752F6}"/>
               </a:ext>
             </a:extLst>
           </p:cNvPr>
@@ -13168,7 +13168,7 @@
           <p:cNvPr id="5" name="Footer author">
             <a:extLst>
               <a:ext uri="{FF2B5EF4-FFF2-40B4-BE49-F238E27FC236}">
-                <a16:creationId xmlns:a16="http://schemas.microsoft.com/office/drawing/2014/main" id="{9887C2F5-19AF-E8C7-4326-D82A30D74304}"/>
+                <a16:creationId xmlns:a16="http://schemas.microsoft.com/office/drawing/2014/main" id="{CEEB1F32-0B85-2374-4986-9FA9F11F39DA}"/>
               </a:ext>
             </a:extLst>
           </p:cNvPr>
@@ -13213,7 +13213,7 @@
           <p:cNvPr id="6" name="Slide number">
             <a:extLst>
               <a:ext uri="{FF2B5EF4-FFF2-40B4-BE49-F238E27FC236}">
-                <a16:creationId xmlns:a16="http://schemas.microsoft.com/office/drawing/2014/main" id="{21DD0612-58CC-0451-8154-38CB408AA0A2}"/>
+                <a16:creationId xmlns:a16="http://schemas.microsoft.com/office/drawing/2014/main" id="{E7FF1D0F-721A-8F53-0672-4BCD126C8560}"/>
               </a:ext>
             </a:extLst>
           </p:cNvPr>
@@ -13258,7 +13258,7 @@
           <p:cNvPr id="7" name="Browser to web">
             <a:extLst>
               <a:ext uri="{FF2B5EF4-FFF2-40B4-BE49-F238E27FC236}">
-                <a16:creationId xmlns:a16="http://schemas.microsoft.com/office/drawing/2014/main" id="{52E7113E-D3C3-627B-73B1-04C96574952E}"/>
+                <a16:creationId xmlns:a16="http://schemas.microsoft.com/office/drawing/2014/main" id="{1A540282-7B2F-B37E-CD44-7029E975397F}"/>
               </a:ext>
             </a:extLst>
           </p:cNvPr>
@@ -13300,7 +13300,7 @@
           <p:cNvPr id="8" name="Web to backend">
             <a:extLst>
               <a:ext uri="{FF2B5EF4-FFF2-40B4-BE49-F238E27FC236}">
-                <a16:creationId xmlns:a16="http://schemas.microsoft.com/office/drawing/2014/main" id="{E1BE4715-221F-5CC2-C823-318AC91A3804}"/>
+                <a16:creationId xmlns:a16="http://schemas.microsoft.com/office/drawing/2014/main" id="{F383CFDA-42D4-BEB2-FC3C-9F8C9B74390E}"/>
               </a:ext>
             </a:extLst>
           </p:cNvPr>
@@ -13342,7 +13342,7 @@
           <p:cNvPr id="9" name="Extension to backend">
             <a:extLst>
               <a:ext uri="{FF2B5EF4-FFF2-40B4-BE49-F238E27FC236}">
-                <a16:creationId xmlns:a16="http://schemas.microsoft.com/office/drawing/2014/main" id="{C66CF468-2CB7-8B79-CEC7-12A43F912C32}"/>
+                <a16:creationId xmlns:a16="http://schemas.microsoft.com/office/drawing/2014/main" id="{818BF757-A2B9-34B5-C9F0-3F55FC6CF6D7}"/>
               </a:ext>
             </a:extLst>
           </p:cNvPr>
@@ -13384,7 +13384,7 @@
           <p:cNvPr id="10" name="Monitor to backend">
             <a:extLst>
               <a:ext uri="{FF2B5EF4-FFF2-40B4-BE49-F238E27FC236}">
-                <a16:creationId xmlns:a16="http://schemas.microsoft.com/office/drawing/2014/main" id="{5AB36BBB-7F4C-C817-5EC3-6BE5458B586D}"/>
+                <a16:creationId xmlns:a16="http://schemas.microsoft.com/office/drawing/2014/main" id="{0ED2C284-4C1E-F269-68E9-DB44ED95ECEA}"/>
               </a:ext>
             </a:extLst>
           </p:cNvPr>
@@ -13426,7 +13426,7 @@
           <p:cNvPr id="11" name="Browser">
             <a:extLst>
               <a:ext uri="{FF2B5EF4-FFF2-40B4-BE49-F238E27FC236}">
-                <a16:creationId xmlns:a16="http://schemas.microsoft.com/office/drawing/2014/main" id="{BF66F511-B5E0-8DCA-3E1D-1474C26863FB}"/>
+                <a16:creationId xmlns:a16="http://schemas.microsoft.com/office/drawing/2014/main" id="{1E3C6589-311D-BDA1-CB32-815C7B636CA0}"/>
               </a:ext>
             </a:extLst>
           </p:cNvPr>
@@ -13480,7 +13480,7 @@
           <p:cNvPr id="12" name="Browser title">
             <a:extLst>
               <a:ext uri="{FF2B5EF4-FFF2-40B4-BE49-F238E27FC236}">
-                <a16:creationId xmlns:a16="http://schemas.microsoft.com/office/drawing/2014/main" id="{09E22B8C-0404-2381-5FAD-75D20142EE11}"/>
+                <a16:creationId xmlns:a16="http://schemas.microsoft.com/office/drawing/2014/main" id="{3E000DDA-4F20-A8E2-F883-EDB72123C6F0}"/>
               </a:ext>
             </a:extLst>
           </p:cNvPr>
@@ -13525,7 +13525,7 @@
           <p:cNvPr id="13" name="Browser body">
             <a:extLst>
               <a:ext uri="{FF2B5EF4-FFF2-40B4-BE49-F238E27FC236}">
-                <a16:creationId xmlns:a16="http://schemas.microsoft.com/office/drawing/2014/main" id="{965D824D-B024-8DFD-7AC3-786426453937}"/>
+                <a16:creationId xmlns:a16="http://schemas.microsoft.com/office/drawing/2014/main" id="{E9C3C1B0-2FC2-4C28-6510-393C5EE27811}"/>
               </a:ext>
             </a:extLst>
           </p:cNvPr>
@@ -13570,7 +13570,7 @@
           <p:cNvPr id="14" name="Streamlit">
             <a:extLst>
               <a:ext uri="{FF2B5EF4-FFF2-40B4-BE49-F238E27FC236}">
-                <a16:creationId xmlns:a16="http://schemas.microsoft.com/office/drawing/2014/main" id="{DA3125ED-A024-D2FA-8659-6F2C79CFD7D3}"/>
+                <a16:creationId xmlns:a16="http://schemas.microsoft.com/office/drawing/2014/main" id="{01B397DE-E8D7-F838-5097-F751A3CDDA72}"/>
               </a:ext>
             </a:extLst>
           </p:cNvPr>
@@ -13624,7 +13624,7 @@
           <p:cNvPr id="15" name="Streamlit title">
             <a:extLst>
               <a:ext uri="{FF2B5EF4-FFF2-40B4-BE49-F238E27FC236}">
-                <a16:creationId xmlns:a16="http://schemas.microsoft.com/office/drawing/2014/main" id="{FF15C288-6C39-995F-42E4-E9D7576E7D93}"/>
+                <a16:creationId xmlns:a16="http://schemas.microsoft.com/office/drawing/2014/main" id="{E9002A5D-703B-0C50-4C58-283F8F2125BE}"/>
               </a:ext>
             </a:extLst>
           </p:cNvPr>
@@ -13669,7 +13669,7 @@
           <p:cNvPr id="16" name="Streamlit body">
             <a:extLst>
               <a:ext uri="{FF2B5EF4-FFF2-40B4-BE49-F238E27FC236}">
-                <a16:creationId xmlns:a16="http://schemas.microsoft.com/office/drawing/2014/main" id="{33E48DE7-6C1B-50D1-CA67-10A75F4E488B}"/>
+                <a16:creationId xmlns:a16="http://schemas.microsoft.com/office/drawing/2014/main" id="{9316563F-6F3A-370D-10E7-5330730763F5}"/>
               </a:ext>
             </a:extLst>
           </p:cNvPr>
@@ -13714,7 +13714,7 @@
           <p:cNvPr id="17" name="Extension">
             <a:extLst>
               <a:ext uri="{FF2B5EF4-FFF2-40B4-BE49-F238E27FC236}">
-                <a16:creationId xmlns:a16="http://schemas.microsoft.com/office/drawing/2014/main" id="{D398F88F-C60D-BF6C-C704-B4234481C75C}"/>
+                <a16:creationId xmlns:a16="http://schemas.microsoft.com/office/drawing/2014/main" id="{B667610A-8AE3-D82D-D408-32C6A57EF428}"/>
               </a:ext>
             </a:extLst>
           </p:cNvPr>
@@ -13768,7 +13768,7 @@
           <p:cNvPr id="18" name="Extension title">
             <a:extLst>
               <a:ext uri="{FF2B5EF4-FFF2-40B4-BE49-F238E27FC236}">
-                <a16:creationId xmlns:a16="http://schemas.microsoft.com/office/drawing/2014/main" id="{546FC7A0-5DBE-C84C-AE97-AD483D1B9BDF}"/>
+                <a16:creationId xmlns:a16="http://schemas.microsoft.com/office/drawing/2014/main" id="{10457163-AEFE-E794-D296-BD3E15D297A9}"/>
               </a:ext>
             </a:extLst>
           </p:cNvPr>
@@ -13813,7 +13813,7 @@
           <p:cNvPr id="19" name="Extension body">
             <a:extLst>
               <a:ext uri="{FF2B5EF4-FFF2-40B4-BE49-F238E27FC236}">
-                <a16:creationId xmlns:a16="http://schemas.microsoft.com/office/drawing/2014/main" id="{98267644-82C9-3D5E-7CAB-543A9363FB94}"/>
+                <a16:creationId xmlns:a16="http://schemas.microsoft.com/office/drawing/2014/main" id="{2F67C120-252E-1946-6343-62900C2BD200}"/>
               </a:ext>
             </a:extLst>
           </p:cNvPr>
@@ -13858,7 +13858,7 @@
           <p:cNvPr id="20" name="Monitor">
             <a:extLst>
               <a:ext uri="{FF2B5EF4-FFF2-40B4-BE49-F238E27FC236}">
-                <a16:creationId xmlns:a16="http://schemas.microsoft.com/office/drawing/2014/main" id="{BB1EB741-F019-F4CF-B111-5B175A6A4F1D}"/>
+                <a16:creationId xmlns:a16="http://schemas.microsoft.com/office/drawing/2014/main" id="{09A8E00F-BA70-30B5-522E-0BCE7239ED75}"/>
               </a:ext>
             </a:extLst>
           </p:cNvPr>
@@ -13912,7 +13912,7 @@
           <p:cNvPr id="21" name="Monitor title">
             <a:extLst>
               <a:ext uri="{FF2B5EF4-FFF2-40B4-BE49-F238E27FC236}">
-                <a16:creationId xmlns:a16="http://schemas.microsoft.com/office/drawing/2014/main" id="{6DC6E016-49E7-E370-7413-A2C8D7250AD8}"/>
+                <a16:creationId xmlns:a16="http://schemas.microsoft.com/office/drawing/2014/main" id="{EEA3923F-7294-284A-9355-8C4DD1514EC1}"/>
               </a:ext>
             </a:extLst>
           </p:cNvPr>
@@ -13957,7 +13957,7 @@
           <p:cNvPr id="22" name="Monitor body">
             <a:extLst>
               <a:ext uri="{FF2B5EF4-FFF2-40B4-BE49-F238E27FC236}">
-                <a16:creationId xmlns:a16="http://schemas.microsoft.com/office/drawing/2014/main" id="{A88DC26B-6BAD-D6B2-3DB5-9223124E229E}"/>
+                <a16:creationId xmlns:a16="http://schemas.microsoft.com/office/drawing/2014/main" id="{BC3CD883-4DDE-991E-99DB-E461D57F90D1}"/>
               </a:ext>
             </a:extLst>
           </p:cNvPr>
@@ -14002,7 +14002,7 @@
           <p:cNvPr id="23" name="Backend central">
             <a:extLst>
               <a:ext uri="{FF2B5EF4-FFF2-40B4-BE49-F238E27FC236}">
-                <a16:creationId xmlns:a16="http://schemas.microsoft.com/office/drawing/2014/main" id="{6B9833D1-07CE-52DD-76BA-2406D8B13FA9}"/>
+                <a16:creationId xmlns:a16="http://schemas.microsoft.com/office/drawing/2014/main" id="{12258A1A-2968-D97F-408E-D2A3C03C1923}"/>
               </a:ext>
             </a:extLst>
           </p:cNvPr>
@@ -14070,7 +14070,7 @@
           <p:cNvPr id="24" name="Backend title">
             <a:extLst>
               <a:ext uri="{FF2B5EF4-FFF2-40B4-BE49-F238E27FC236}">
-                <a16:creationId xmlns:a16="http://schemas.microsoft.com/office/drawing/2014/main" id="{28C54ABF-EEB5-E734-79A1-5B4296BC7CE7}"/>
+                <a16:creationId xmlns:a16="http://schemas.microsoft.com/office/drawing/2014/main" id="{3799389B-76A5-EB90-22AB-460D6B558664}"/>
               </a:ext>
             </a:extLst>
           </p:cNvPr>
@@ -14115,7 +14115,7 @@
           <p:cNvPr id="25" name="Backend contents">
             <a:extLst>
               <a:ext uri="{FF2B5EF4-FFF2-40B4-BE49-F238E27FC236}">
-                <a16:creationId xmlns:a16="http://schemas.microsoft.com/office/drawing/2014/main" id="{9A10B739-FADB-3AC2-8709-B44AED1EAC5B}"/>
+                <a16:creationId xmlns:a16="http://schemas.microsoft.com/office/drawing/2014/main" id="{ACFCCD39-889F-BC37-B344-D133BBC2706A}"/>
               </a:ext>
             </a:extLst>
           </p:cNvPr>
@@ -14164,7 +14164,7 @@
           <p:cNvPr id="26" name="Protocol">
             <a:extLst>
               <a:ext uri="{FF2B5EF4-FFF2-40B4-BE49-F238E27FC236}">
-                <a16:creationId xmlns:a16="http://schemas.microsoft.com/office/drawing/2014/main" id="{2627FC65-43B2-DB01-B706-190089526B67}"/>
+                <a16:creationId xmlns:a16="http://schemas.microsoft.com/office/drawing/2014/main" id="{A1670CEB-59CA-01E2-DA51-583CB85DC86B}"/>
               </a:ext>
             </a:extLst>
           </p:cNvPr>
@@ -14209,7 +14209,7 @@
           <p:cNvPr id="27" name="Architecture note">
             <a:extLst>
               <a:ext uri="{FF2B5EF4-FFF2-40B4-BE49-F238E27FC236}">
-                <a16:creationId xmlns:a16="http://schemas.microsoft.com/office/drawing/2014/main" id="{D02D1D62-8E62-EDCE-86AA-C1649A9AE5AD}"/>
+                <a16:creationId xmlns:a16="http://schemas.microsoft.com/office/drawing/2014/main" id="{40DEF03D-5B1F-1625-D0B0-BC2345390C34}"/>
               </a:ext>
             </a:extLst>
           </p:cNvPr>
@@ -14252,7 +14252,7 @@
     </p:spTree>
     <p:extLst>
       <p:ext uri="{BB962C8B-B14F-4D97-AF65-F5344CB8AC3E}">
-        <p14:creationId xmlns:p14="http://schemas.microsoft.com/office/powerpoint/2010/main" val="1349258554"/>
+        <p14:creationId xmlns:p14="http://schemas.microsoft.com/office/powerpoint/2010/main" val="1987409380"/>
       </p:ext>
     </p:extLst>
   </p:cSld>
@@ -14292,7 +14292,7 @@
           <p:cNvPr id="2" name="Section">
             <a:extLst>
               <a:ext uri="{FF2B5EF4-FFF2-40B4-BE49-F238E27FC236}">
-                <a16:creationId xmlns:a16="http://schemas.microsoft.com/office/drawing/2014/main" id="{695371FE-FC7C-CC17-B40F-057336B0D9D2}"/>
+                <a16:creationId xmlns:a16="http://schemas.microsoft.com/office/drawing/2014/main" id="{5A712C40-86E9-D114-2B98-CA90D3E2001A}"/>
               </a:ext>
             </a:extLst>
           </p:cNvPr>
@@ -14337,7 +14337,7 @@
           <p:cNvPr id="3" name="Slide title">
             <a:extLst>
               <a:ext uri="{FF2B5EF4-FFF2-40B4-BE49-F238E27FC236}">
-                <a16:creationId xmlns:a16="http://schemas.microsoft.com/office/drawing/2014/main" id="{755F3470-C7E0-2190-7826-BABECCE6F4F2}"/>
+                <a16:creationId xmlns:a16="http://schemas.microsoft.com/office/drawing/2014/main" id="{4FB56157-B932-7230-8163-9B1F890DCB5F}"/>
               </a:ext>
             </a:extLst>
           </p:cNvPr>
@@ -14382,7 +14382,7 @@
           <p:cNvPr id="4" name="Accent rule">
             <a:extLst>
               <a:ext uri="{FF2B5EF4-FFF2-40B4-BE49-F238E27FC236}">
-                <a16:creationId xmlns:a16="http://schemas.microsoft.com/office/drawing/2014/main" id="{AA31563F-7FFF-6B1B-7F3B-EF113FD69496}"/>
+                <a16:creationId xmlns:a16="http://schemas.microsoft.com/office/drawing/2014/main" id="{6AC5241E-894E-DFF9-B98F-D5148510E152}"/>
               </a:ext>
             </a:extLst>
           </p:cNvPr>
@@ -14423,7 +14423,7 @@
           <p:cNvPr id="5" name="Footer author">
             <a:extLst>
               <a:ext uri="{FF2B5EF4-FFF2-40B4-BE49-F238E27FC236}">
-                <a16:creationId xmlns:a16="http://schemas.microsoft.com/office/drawing/2014/main" id="{FDAFAF4B-3CEA-D0B6-B92D-C8C3656D9FB8}"/>
+                <a16:creationId xmlns:a16="http://schemas.microsoft.com/office/drawing/2014/main" id="{94A373FE-23AE-A61B-BE6A-C5670359A0A5}"/>
               </a:ext>
             </a:extLst>
           </p:cNvPr>
@@ -14468,7 +14468,7 @@
           <p:cNvPr id="6" name="Slide number">
             <a:extLst>
               <a:ext uri="{FF2B5EF4-FFF2-40B4-BE49-F238E27FC236}">
-                <a16:creationId xmlns:a16="http://schemas.microsoft.com/office/drawing/2014/main" id="{0F222151-2522-E5DD-901C-7A06587FA967}"/>
+                <a16:creationId xmlns:a16="http://schemas.microsoft.com/office/drawing/2014/main" id="{B733CC3A-7F85-5BED-11A9-8A28CD58A745}"/>
               </a:ext>
             </a:extLst>
           </p:cNvPr>
@@ -14513,7 +14513,7 @@
           <p:cNvPr id="7" name="Flow arrow 0">
             <a:extLst>
               <a:ext uri="{FF2B5EF4-FFF2-40B4-BE49-F238E27FC236}">
-                <a16:creationId xmlns:a16="http://schemas.microsoft.com/office/drawing/2014/main" id="{7E685763-9B7A-EBB2-4957-DCFF17B5ECD9}"/>
+                <a16:creationId xmlns:a16="http://schemas.microsoft.com/office/drawing/2014/main" id="{93679BA5-57F6-CAEF-AB7D-602C67AD10F1}"/>
               </a:ext>
             </a:extLst>
           </p:cNvPr>
@@ -14555,7 +14555,7 @@
           <p:cNvPr id="8" name="Flow arrow 1">
             <a:extLst>
               <a:ext uri="{FF2B5EF4-FFF2-40B4-BE49-F238E27FC236}">
-                <a16:creationId xmlns:a16="http://schemas.microsoft.com/office/drawing/2014/main" id="{2D47D1E2-F968-3263-6D14-C265FF0D0B9D}"/>
+                <a16:creationId xmlns:a16="http://schemas.microsoft.com/office/drawing/2014/main" id="{5F76CFB4-0D34-2FAF-5CF0-B1EB13ECCA75}"/>
               </a:ext>
             </a:extLst>
           </p:cNvPr>
@@ -14597,7 +14597,7 @@
           <p:cNvPr id="9" name="Flow arrow 2">
             <a:extLst>
               <a:ext uri="{FF2B5EF4-FFF2-40B4-BE49-F238E27FC236}">
-                <a16:creationId xmlns:a16="http://schemas.microsoft.com/office/drawing/2014/main" id="{5ADA03BA-8515-98F2-377C-39F2D4C466B5}"/>
+                <a16:creationId xmlns:a16="http://schemas.microsoft.com/office/drawing/2014/main" id="{9083F959-3B35-A1A7-35E2-614D28DD2F36}"/>
               </a:ext>
             </a:extLst>
           </p:cNvPr>
@@ -14639,7 +14639,7 @@
           <p:cNvPr id="10" name="Flow arrow 3">
             <a:extLst>
               <a:ext uri="{FF2B5EF4-FFF2-40B4-BE49-F238E27FC236}">
-                <a16:creationId xmlns:a16="http://schemas.microsoft.com/office/drawing/2014/main" id="{FB2FD5D5-ADA1-7DA2-F294-1F66FF4F83E6}"/>
+                <a16:creationId xmlns:a16="http://schemas.microsoft.com/office/drawing/2014/main" id="{0A543358-3CCE-43F9-48A7-EC230D480E83}"/>
               </a:ext>
             </a:extLst>
           </p:cNvPr>
@@ -14681,7 +14681,7 @@
           <p:cNvPr id="11" name="Flow node 0">
             <a:extLst>
               <a:ext uri="{FF2B5EF4-FFF2-40B4-BE49-F238E27FC236}">
-                <a16:creationId xmlns:a16="http://schemas.microsoft.com/office/drawing/2014/main" id="{F3CD2709-112D-AAED-09BD-F080619D09A5}"/>
+                <a16:creationId xmlns:a16="http://schemas.microsoft.com/office/drawing/2014/main" id="{D2C4E712-71CF-85BE-A982-6F1F692DF59D}"/>
               </a:ext>
             </a:extLst>
           </p:cNvPr>
@@ -14749,7 +14749,7 @@
           <p:cNvPr id="12" name="Flow number">
             <a:extLst>
               <a:ext uri="{FF2B5EF4-FFF2-40B4-BE49-F238E27FC236}">
-                <a16:creationId xmlns:a16="http://schemas.microsoft.com/office/drawing/2014/main" id="{F119DD92-144F-1225-CDA8-F96668EB533D}"/>
+                <a16:creationId xmlns:a16="http://schemas.microsoft.com/office/drawing/2014/main" id="{A000FC34-55B3-E2D2-21E7-2785A69AFD0E}"/>
               </a:ext>
             </a:extLst>
           </p:cNvPr>
@@ -14794,7 +14794,7 @@
           <p:cNvPr id="13" name="Flow title">
             <a:extLst>
               <a:ext uri="{FF2B5EF4-FFF2-40B4-BE49-F238E27FC236}">
-                <a16:creationId xmlns:a16="http://schemas.microsoft.com/office/drawing/2014/main" id="{45B30140-8F9C-ADED-213C-86D9DA4C57FE}"/>
+                <a16:creationId xmlns:a16="http://schemas.microsoft.com/office/drawing/2014/main" id="{29415BCF-0DCE-449D-1F0A-5BBCF04543FD}"/>
               </a:ext>
             </a:extLst>
           </p:cNvPr>
@@ -14839,7 +14839,7 @@
           <p:cNvPr id="14" name="Flow detail">
             <a:extLst>
               <a:ext uri="{FF2B5EF4-FFF2-40B4-BE49-F238E27FC236}">
-                <a16:creationId xmlns:a16="http://schemas.microsoft.com/office/drawing/2014/main" id="{BDB45368-354D-2286-1CEA-CC190D0BC5D2}"/>
+                <a16:creationId xmlns:a16="http://schemas.microsoft.com/office/drawing/2014/main" id="{2F191B5C-1737-1957-C541-E55378163C74}"/>
               </a:ext>
             </a:extLst>
           </p:cNvPr>
@@ -14890,7 +14890,7 @@
           <p:cNvPr id="15" name="Flow node 1">
             <a:extLst>
               <a:ext uri="{FF2B5EF4-FFF2-40B4-BE49-F238E27FC236}">
-                <a16:creationId xmlns:a16="http://schemas.microsoft.com/office/drawing/2014/main" id="{91F82242-6FCB-9B7B-3116-0420829088D7}"/>
+                <a16:creationId xmlns:a16="http://schemas.microsoft.com/office/drawing/2014/main" id="{AEE7C1BB-66C1-B329-9FAA-E3CAAF8D3AFE}"/>
               </a:ext>
             </a:extLst>
           </p:cNvPr>
@@ -14958,7 +14958,7 @@
           <p:cNvPr id="16" name="Flow number">
             <a:extLst>
               <a:ext uri="{FF2B5EF4-FFF2-40B4-BE49-F238E27FC236}">
-                <a16:creationId xmlns:a16="http://schemas.microsoft.com/office/drawing/2014/main" id="{2E6B8507-3E90-953D-6F99-4EA5417E35B1}"/>
+                <a16:creationId xmlns:a16="http://schemas.microsoft.com/office/drawing/2014/main" id="{74EF575F-AEA0-8B31-7802-C48C12A533DB}"/>
               </a:ext>
             </a:extLst>
           </p:cNvPr>
@@ -15003,7 +15003,7 @@
           <p:cNvPr id="17" name="Flow title">
             <a:extLst>
               <a:ext uri="{FF2B5EF4-FFF2-40B4-BE49-F238E27FC236}">
-                <a16:creationId xmlns:a16="http://schemas.microsoft.com/office/drawing/2014/main" id="{DB9E837E-6293-6453-B217-E034AE933DA5}"/>
+                <a16:creationId xmlns:a16="http://schemas.microsoft.com/office/drawing/2014/main" id="{285DFFD1-FC31-3122-351E-6A6AE7FB6768}"/>
               </a:ext>
             </a:extLst>
           </p:cNvPr>
@@ -15048,7 +15048,7 @@
           <p:cNvPr id="18" name="Flow detail">
             <a:extLst>
               <a:ext uri="{FF2B5EF4-FFF2-40B4-BE49-F238E27FC236}">
-                <a16:creationId xmlns:a16="http://schemas.microsoft.com/office/drawing/2014/main" id="{CE166610-169D-9FCB-5945-852946F11E02}"/>
+                <a16:creationId xmlns:a16="http://schemas.microsoft.com/office/drawing/2014/main" id="{BD7D7455-8A85-A4B1-760D-9309D5F38354}"/>
               </a:ext>
             </a:extLst>
           </p:cNvPr>
@@ -15093,7 +15093,7 @@
           <p:cNvPr id="19" name="Flow node 2">
             <a:extLst>
               <a:ext uri="{FF2B5EF4-FFF2-40B4-BE49-F238E27FC236}">
-                <a16:creationId xmlns:a16="http://schemas.microsoft.com/office/drawing/2014/main" id="{624471FB-A4B2-0FCA-6490-2849B0AF55B4}"/>
+                <a16:creationId xmlns:a16="http://schemas.microsoft.com/office/drawing/2014/main" id="{B13BB637-1404-B666-94B0-9FB27837B263}"/>
               </a:ext>
             </a:extLst>
           </p:cNvPr>
@@ -15161,7 +15161,7 @@
           <p:cNvPr id="20" name="Flow number">
             <a:extLst>
               <a:ext uri="{FF2B5EF4-FFF2-40B4-BE49-F238E27FC236}">
-                <a16:creationId xmlns:a16="http://schemas.microsoft.com/office/drawing/2014/main" id="{337E2CFB-C0D6-2C6A-2C7E-90485CB95483}"/>
+                <a16:creationId xmlns:a16="http://schemas.microsoft.com/office/drawing/2014/main" id="{9AA4108E-A142-CEDB-8ED0-7BF6851C9BF3}"/>
               </a:ext>
             </a:extLst>
           </p:cNvPr>
@@ -15206,7 +15206,7 @@
           <p:cNvPr id="21" name="Flow title">
             <a:extLst>
               <a:ext uri="{FF2B5EF4-FFF2-40B4-BE49-F238E27FC236}">
-                <a16:creationId xmlns:a16="http://schemas.microsoft.com/office/drawing/2014/main" id="{3D313CD6-A3CF-580B-C928-BBCD395AEAB2}"/>
+                <a16:creationId xmlns:a16="http://schemas.microsoft.com/office/drawing/2014/main" id="{95EA672B-357A-97A9-A780-020CA6BC96D6}"/>
               </a:ext>
             </a:extLst>
           </p:cNvPr>
@@ -15251,7 +15251,7 @@
           <p:cNvPr id="22" name="Flow detail">
             <a:extLst>
               <a:ext uri="{FF2B5EF4-FFF2-40B4-BE49-F238E27FC236}">
-                <a16:creationId xmlns:a16="http://schemas.microsoft.com/office/drawing/2014/main" id="{B9FE6254-E693-33A1-4BAD-8E4E3068AFF4}"/>
+                <a16:creationId xmlns:a16="http://schemas.microsoft.com/office/drawing/2014/main" id="{2D8369D8-1CEC-2258-9528-6846B6A1F8E0}"/>
               </a:ext>
             </a:extLst>
           </p:cNvPr>
@@ -15296,7 +15296,7 @@
           <p:cNvPr id="23" name="Flow node 3">
             <a:extLst>
               <a:ext uri="{FF2B5EF4-FFF2-40B4-BE49-F238E27FC236}">
-                <a16:creationId xmlns:a16="http://schemas.microsoft.com/office/drawing/2014/main" id="{2EE552D0-20E8-1B5B-5EF4-827AACFD77C5}"/>
+                <a16:creationId xmlns:a16="http://schemas.microsoft.com/office/drawing/2014/main" id="{80A00E61-3CB9-232A-03F8-D975EF2B3401}"/>
               </a:ext>
             </a:extLst>
           </p:cNvPr>
@@ -15364,7 +15364,7 @@
           <p:cNvPr id="24" name="Flow number">
             <a:extLst>
               <a:ext uri="{FF2B5EF4-FFF2-40B4-BE49-F238E27FC236}">
-                <a16:creationId xmlns:a16="http://schemas.microsoft.com/office/drawing/2014/main" id="{5F96225E-7D66-65B0-2C49-03B03A034B73}"/>
+                <a16:creationId xmlns:a16="http://schemas.microsoft.com/office/drawing/2014/main" id="{EA2EE377-A6BD-4810-5067-F37DCE510FC0}"/>
               </a:ext>
             </a:extLst>
           </p:cNvPr>
@@ -15409,7 +15409,7 @@
           <p:cNvPr id="25" name="Flow title">
             <a:extLst>
               <a:ext uri="{FF2B5EF4-FFF2-40B4-BE49-F238E27FC236}">
-                <a16:creationId xmlns:a16="http://schemas.microsoft.com/office/drawing/2014/main" id="{9AB67BA3-A1EE-5F05-FDBC-F593FCB37EEB}"/>
+                <a16:creationId xmlns:a16="http://schemas.microsoft.com/office/drawing/2014/main" id="{8C2906ED-F6A2-6EAE-F614-EC43103425DD}"/>
               </a:ext>
             </a:extLst>
           </p:cNvPr>
@@ -15454,7 +15454,7 @@
           <p:cNvPr id="26" name="Flow detail">
             <a:extLst>
               <a:ext uri="{FF2B5EF4-FFF2-40B4-BE49-F238E27FC236}">
-                <a16:creationId xmlns:a16="http://schemas.microsoft.com/office/drawing/2014/main" id="{79FE645F-0CDB-D8D9-4906-4F77920A771E}"/>
+                <a16:creationId xmlns:a16="http://schemas.microsoft.com/office/drawing/2014/main" id="{5A6729D5-1819-58C4-E5BD-13B40BED802B}"/>
               </a:ext>
             </a:extLst>
           </p:cNvPr>
@@ -15499,7 +15499,7 @@
           <p:cNvPr id="27" name="Flow node 4">
             <a:extLst>
               <a:ext uri="{FF2B5EF4-FFF2-40B4-BE49-F238E27FC236}">
-                <a16:creationId xmlns:a16="http://schemas.microsoft.com/office/drawing/2014/main" id="{0CD0B705-5B35-97D6-32DE-84FBA6579860}"/>
+                <a16:creationId xmlns:a16="http://schemas.microsoft.com/office/drawing/2014/main" id="{3D8E91B6-C474-0F9F-7F78-C561E397E4E1}"/>
               </a:ext>
             </a:extLst>
           </p:cNvPr>
@@ -15567,7 +15567,7 @@
           <p:cNvPr id="28" name="Flow number">
             <a:extLst>
               <a:ext uri="{FF2B5EF4-FFF2-40B4-BE49-F238E27FC236}">
-                <a16:creationId xmlns:a16="http://schemas.microsoft.com/office/drawing/2014/main" id="{3CC311FF-4FC7-D6BB-0FB1-761EE4717C40}"/>
+                <a16:creationId xmlns:a16="http://schemas.microsoft.com/office/drawing/2014/main" id="{D03A1C0D-0371-8DB5-E348-56FA0B66E7B5}"/>
               </a:ext>
             </a:extLst>
           </p:cNvPr>
@@ -15612,7 +15612,7 @@
           <p:cNvPr id="29" name="Flow title">
             <a:extLst>
               <a:ext uri="{FF2B5EF4-FFF2-40B4-BE49-F238E27FC236}">
-                <a16:creationId xmlns:a16="http://schemas.microsoft.com/office/drawing/2014/main" id="{82678DE3-E380-E1F1-F0A2-E2C556032FF0}"/>
+                <a16:creationId xmlns:a16="http://schemas.microsoft.com/office/drawing/2014/main" id="{E6175013-000C-0F06-5109-2602BC1AB539}"/>
               </a:ext>
             </a:extLst>
           </p:cNvPr>
@@ -15657,7 +15657,7 @@
           <p:cNvPr id="30" name="Flow detail">
             <a:extLst>
               <a:ext uri="{FF2B5EF4-FFF2-40B4-BE49-F238E27FC236}">
-                <a16:creationId xmlns:a16="http://schemas.microsoft.com/office/drawing/2014/main" id="{235E21FF-A2CD-15F4-C759-3494561842E8}"/>
+                <a16:creationId xmlns:a16="http://schemas.microsoft.com/office/drawing/2014/main" id="{C51D10CB-4CE5-3539-9F75-508638F4BCD2}"/>
               </a:ext>
             </a:extLst>
           </p:cNvPr>
@@ -15702,7 +15702,7 @@
           <p:cNvPr id="31" name="Flow takeaway">
             <a:extLst>
               <a:ext uri="{FF2B5EF4-FFF2-40B4-BE49-F238E27FC236}">
-                <a16:creationId xmlns:a16="http://schemas.microsoft.com/office/drawing/2014/main" id="{365369D1-A73C-90FA-87E2-3500AFFCB9AF}"/>
+                <a16:creationId xmlns:a16="http://schemas.microsoft.com/office/drawing/2014/main" id="{7D364921-0AEE-74DC-BD5C-46E540AD58A1}"/>
               </a:ext>
             </a:extLst>
           </p:cNvPr>
@@ -15745,7 +15745,7 @@
     </p:spTree>
     <p:extLst>
       <p:ext uri="{BB962C8B-B14F-4D97-AF65-F5344CB8AC3E}">
-        <p14:creationId xmlns:p14="http://schemas.microsoft.com/office/powerpoint/2010/main" val="2784817978"/>
+        <p14:creationId xmlns:p14="http://schemas.microsoft.com/office/powerpoint/2010/main" val="1604779329"/>
       </p:ext>
     </p:extLst>
   </p:cSld>
@@ -15785,7 +15785,7 @@
           <p:cNvPr id="2" name="Section">
             <a:extLst>
               <a:ext uri="{FF2B5EF4-FFF2-40B4-BE49-F238E27FC236}">
-                <a16:creationId xmlns:a16="http://schemas.microsoft.com/office/drawing/2014/main" id="{1C408FDB-6EBD-2FAA-D43D-0E83BB35AE52}"/>
+                <a16:creationId xmlns:a16="http://schemas.microsoft.com/office/drawing/2014/main" id="{9AE3A140-F621-69A4-0211-43171108A8A7}"/>
               </a:ext>
             </a:extLst>
           </p:cNvPr>
@@ -15830,7 +15830,7 @@
           <p:cNvPr id="3" name="Slide title">
             <a:extLst>
               <a:ext uri="{FF2B5EF4-FFF2-40B4-BE49-F238E27FC236}">
-                <a16:creationId xmlns:a16="http://schemas.microsoft.com/office/drawing/2014/main" id="{738B6BFE-F89E-8A4B-C6C9-F5A4CF7586BE}"/>
+                <a16:creationId xmlns:a16="http://schemas.microsoft.com/office/drawing/2014/main" id="{79CC7945-2F98-CEAC-CBD3-EB74797649F5}"/>
               </a:ext>
             </a:extLst>
           </p:cNvPr>
@@ -15875,7 +15875,7 @@
           <p:cNvPr id="4" name="Accent rule">
             <a:extLst>
               <a:ext uri="{FF2B5EF4-FFF2-40B4-BE49-F238E27FC236}">
-                <a16:creationId xmlns:a16="http://schemas.microsoft.com/office/drawing/2014/main" id="{C443A20D-3FB1-0E58-6BF6-3471BD0CFB69}"/>
+                <a16:creationId xmlns:a16="http://schemas.microsoft.com/office/drawing/2014/main" id="{4E6ADDDF-9661-F99C-9554-F92558CACFFA}"/>
               </a:ext>
             </a:extLst>
           </p:cNvPr>
@@ -15916,7 +15916,7 @@
           <p:cNvPr id="5" name="Footer author">
             <a:extLst>
               <a:ext uri="{FF2B5EF4-FFF2-40B4-BE49-F238E27FC236}">
-                <a16:creationId xmlns:a16="http://schemas.microsoft.com/office/drawing/2014/main" id="{BFA88040-84F8-293A-9515-BFE6773DB8F4}"/>
+                <a16:creationId xmlns:a16="http://schemas.microsoft.com/office/drawing/2014/main" id="{DC2435D4-22BE-F9AE-C35B-2071E441C41E}"/>
               </a:ext>
             </a:extLst>
           </p:cNvPr>
@@ -15961,7 +15961,7 @@
           <p:cNvPr id="6" name="Slide number">
             <a:extLst>
               <a:ext uri="{FF2B5EF4-FFF2-40B4-BE49-F238E27FC236}">
-                <a16:creationId xmlns:a16="http://schemas.microsoft.com/office/drawing/2014/main" id="{A0EC5276-8A83-53E1-7FB7-DB256156F444}"/>
+                <a16:creationId xmlns:a16="http://schemas.microsoft.com/office/drawing/2014/main" id="{6770E28B-A575-8104-3429-62E36697D142}"/>
               </a:ext>
             </a:extLst>
           </p:cNvPr>
@@ -16006,7 +16006,7 @@
           <p:cNvPr id="7" name="Heuristic label">
             <a:extLst>
               <a:ext uri="{FF2B5EF4-FFF2-40B4-BE49-F238E27FC236}">
-                <a16:creationId xmlns:a16="http://schemas.microsoft.com/office/drawing/2014/main" id="{93D67275-0874-B482-5BED-7CF0DFD08E74}"/>
+                <a16:creationId xmlns:a16="http://schemas.microsoft.com/office/drawing/2014/main" id="{1DF298F4-357F-8B35-7254-F13E8B7DDFE1}"/>
               </a:ext>
             </a:extLst>
           </p:cNvPr>
@@ -16051,7 +16051,7 @@
           <p:cNvPr id="8" name="Heuristic title">
             <a:extLst>
               <a:ext uri="{FF2B5EF4-FFF2-40B4-BE49-F238E27FC236}">
-                <a16:creationId xmlns:a16="http://schemas.microsoft.com/office/drawing/2014/main" id="{3E6B61F1-1418-04AB-0905-BECD411952B5}"/>
+                <a16:creationId xmlns:a16="http://schemas.microsoft.com/office/drawing/2014/main" id="{C1412AC8-461E-CE4F-A37B-1284FDDA6997}"/>
               </a:ext>
             </a:extLst>
           </p:cNvPr>
@@ -16096,7 +16096,7 @@
           <p:cNvPr id="9" name="Heuristic list">
             <a:extLst>
               <a:ext uri="{FF2B5EF4-FFF2-40B4-BE49-F238E27FC236}">
-                <a16:creationId xmlns:a16="http://schemas.microsoft.com/office/drawing/2014/main" id="{AC512D70-837A-9D13-663B-0F1FC2D2DFD7}"/>
+                <a16:creationId xmlns:a16="http://schemas.microsoft.com/office/drawing/2014/main" id="{5B59371A-7313-65FB-79FD-7F274E7CBD96}"/>
               </a:ext>
             </a:extLst>
           </p:cNvPr>
@@ -16144,7 +16144,7 @@
           <p:cNvPr id="10" name="Detector divider">
             <a:extLst>
               <a:ext uri="{FF2B5EF4-FFF2-40B4-BE49-F238E27FC236}">
-                <a16:creationId xmlns:a16="http://schemas.microsoft.com/office/drawing/2014/main" id="{AE51C9BA-6066-13D1-F2AB-770E0CAC1009}"/>
+                <a16:creationId xmlns:a16="http://schemas.microsoft.com/office/drawing/2014/main" id="{B4189029-5ED0-D301-C71A-224D3BB45A8F}"/>
               </a:ext>
             </a:extLst>
           </p:cNvPr>
@@ -16185,7 +16185,7 @@
           <p:cNvPr id="11" name="Neural label">
             <a:extLst>
               <a:ext uri="{FF2B5EF4-FFF2-40B4-BE49-F238E27FC236}">
-                <a16:creationId xmlns:a16="http://schemas.microsoft.com/office/drawing/2014/main" id="{91AA6548-D264-24AF-9BA4-AB1567D80C9D}"/>
+                <a16:creationId xmlns:a16="http://schemas.microsoft.com/office/drawing/2014/main" id="{AE42FDB3-61E4-228C-DFE7-EF49004D9CCA}"/>
               </a:ext>
             </a:extLst>
           </p:cNvPr>
@@ -16230,7 +16230,7 @@
           <p:cNvPr id="12" name="Neural title">
             <a:extLst>
               <a:ext uri="{FF2B5EF4-FFF2-40B4-BE49-F238E27FC236}">
-                <a16:creationId xmlns:a16="http://schemas.microsoft.com/office/drawing/2014/main" id="{772F9279-FB4A-F5DF-EE76-F3EA90A57BF6}"/>
+                <a16:creationId xmlns:a16="http://schemas.microsoft.com/office/drawing/2014/main" id="{3A0422B7-4DD6-0854-DE39-E3B07060E8D4}"/>
               </a:ext>
             </a:extLst>
           </p:cNvPr>
@@ -16275,7 +16275,7 @@
           <p:cNvPr id="13" name="Neural list">
             <a:extLst>
               <a:ext uri="{FF2B5EF4-FFF2-40B4-BE49-F238E27FC236}">
-                <a16:creationId xmlns:a16="http://schemas.microsoft.com/office/drawing/2014/main" id="{46EE265F-9DA4-60D9-6B31-67E09ECC78C1}"/>
+                <a16:creationId xmlns:a16="http://schemas.microsoft.com/office/drawing/2014/main" id="{8E49224F-AB60-F0CE-948A-740EEB71B9B5}"/>
               </a:ext>
             </a:extLst>
           </p:cNvPr>
@@ -16323,7 +16323,7 @@
           <p:cNvPr id="14" name="Combined band">
             <a:extLst>
               <a:ext uri="{FF2B5EF4-FFF2-40B4-BE49-F238E27FC236}">
-                <a16:creationId xmlns:a16="http://schemas.microsoft.com/office/drawing/2014/main" id="{C66CAFB2-17A9-056C-00CA-27274A77FD0B}"/>
+                <a16:creationId xmlns:a16="http://schemas.microsoft.com/office/drawing/2014/main" id="{02F8C5F7-7C70-8A37-FCA0-06FF21600E21}"/>
               </a:ext>
             </a:extLst>
           </p:cNvPr>
@@ -16391,7 +16391,7 @@
           <p:cNvPr id="15" name="Combined label">
             <a:extLst>
               <a:ext uri="{FF2B5EF4-FFF2-40B4-BE49-F238E27FC236}">
-                <a16:creationId xmlns:a16="http://schemas.microsoft.com/office/drawing/2014/main" id="{B4A5E45F-B5AB-C3AB-1806-5374550C13D2}"/>
+                <a16:creationId xmlns:a16="http://schemas.microsoft.com/office/drawing/2014/main" id="{7475925F-4E11-AAF5-BEFA-E86FFDD0AE4F}"/>
               </a:ext>
             </a:extLst>
           </p:cNvPr>
@@ -16436,7 +16436,7 @@
           <p:cNvPr id="16" name="Combined formula">
             <a:extLst>
               <a:ext uri="{FF2B5EF4-FFF2-40B4-BE49-F238E27FC236}">
-                <a16:creationId xmlns:a16="http://schemas.microsoft.com/office/drawing/2014/main" id="{8A566F99-10D3-AA2C-0BC7-F297C04C91CB}"/>
+                <a16:creationId xmlns:a16="http://schemas.microsoft.com/office/drawing/2014/main" id="{D56C00D4-61DB-E618-1647-4FC2B8800DDA}"/>
               </a:ext>
             </a:extLst>
           </p:cNvPr>
@@ -16471,7 +16471,7 @@
                 </a:solidFill>
                 <a:latin typeface="Arial" panose="020B0604020202020204" pitchFamily="34" charset="0"/>
               </a:rPr>
-              <a:t>35/65 · umbral 26 · alta confianza ≥ 70</a:t>
+              <a:t>45/55 · umbral 21 · alta confianza ≥ 70</a:t>
             </a:r>
           </a:p>
         </p:txBody>
@@ -16479,7 +16479,7 @@
     </p:spTree>
     <p:extLst>
       <p:ext uri="{BB962C8B-B14F-4D97-AF65-F5344CB8AC3E}">
-        <p14:creationId xmlns:p14="http://schemas.microsoft.com/office/powerpoint/2010/main" val="4272814350"/>
+        <p14:creationId xmlns:p14="http://schemas.microsoft.com/office/powerpoint/2010/main" val="2954790585"/>
       </p:ext>
     </p:extLst>
   </p:cSld>
@@ -16519,7 +16519,7 @@
           <p:cNvPr id="2" name="Section">
             <a:extLst>
               <a:ext uri="{FF2B5EF4-FFF2-40B4-BE49-F238E27FC236}">
-                <a16:creationId xmlns:a16="http://schemas.microsoft.com/office/drawing/2014/main" id="{E61ED8B1-09C0-A539-16D2-FDB664F96F8D}"/>
+                <a16:creationId xmlns:a16="http://schemas.microsoft.com/office/drawing/2014/main" id="{BBB3D50A-2361-877B-9061-11DBF938E9E8}"/>
               </a:ext>
             </a:extLst>
           </p:cNvPr>
@@ -16564,7 +16564,7 @@
           <p:cNvPr id="3" name="Slide title">
             <a:extLst>
               <a:ext uri="{FF2B5EF4-FFF2-40B4-BE49-F238E27FC236}">
-                <a16:creationId xmlns:a16="http://schemas.microsoft.com/office/drawing/2014/main" id="{BC342770-BB8D-C6D0-7B6C-DFB207EDBA74}"/>
+                <a16:creationId xmlns:a16="http://schemas.microsoft.com/office/drawing/2014/main" id="{A1EDF4BB-4504-E49A-ED47-B5F567DFE105}"/>
               </a:ext>
             </a:extLst>
           </p:cNvPr>
@@ -16609,7 +16609,7 @@
           <p:cNvPr id="4" name="Accent rule">
             <a:extLst>
               <a:ext uri="{FF2B5EF4-FFF2-40B4-BE49-F238E27FC236}">
-                <a16:creationId xmlns:a16="http://schemas.microsoft.com/office/drawing/2014/main" id="{82F699E5-F238-60D1-CDF2-807AB6FDD607}"/>
+                <a16:creationId xmlns:a16="http://schemas.microsoft.com/office/drawing/2014/main" id="{49FAFAC8-709D-34C7-F2FC-85182511DADD}"/>
               </a:ext>
             </a:extLst>
           </p:cNvPr>
@@ -16650,7 +16650,7 @@
           <p:cNvPr id="5" name="Footer author">
             <a:extLst>
               <a:ext uri="{FF2B5EF4-FFF2-40B4-BE49-F238E27FC236}">
-                <a16:creationId xmlns:a16="http://schemas.microsoft.com/office/drawing/2014/main" id="{9B7D346D-6A38-4B45-694A-AE7AC8642B12}"/>
+                <a16:creationId xmlns:a16="http://schemas.microsoft.com/office/drawing/2014/main" id="{C76C30EA-38F0-22EC-2393-764C1035E0E1}"/>
               </a:ext>
             </a:extLst>
           </p:cNvPr>
@@ -16695,7 +16695,7 @@
           <p:cNvPr id="6" name="Slide number">
             <a:extLst>
               <a:ext uri="{FF2B5EF4-FFF2-40B4-BE49-F238E27FC236}">
-                <a16:creationId xmlns:a16="http://schemas.microsoft.com/office/drawing/2014/main" id="{C9EEE3DF-BFA1-CE0A-310C-B06115B916F5}"/>
+                <a16:creationId xmlns:a16="http://schemas.microsoft.com/office/drawing/2014/main" id="{3663EC40-E874-A440-CFD3-44F8A67370FB}"/>
               </a:ext>
             </a:extLst>
           </p:cNvPr>
@@ -16740,7 +16740,7 @@
           <p:cNvPr id="7" name="Model timeline">
             <a:extLst>
               <a:ext uri="{FF2B5EF4-FFF2-40B4-BE49-F238E27FC236}">
-                <a16:creationId xmlns:a16="http://schemas.microsoft.com/office/drawing/2014/main" id="{19650182-1952-A51E-979B-CE3E3CFE8C76}"/>
+                <a16:creationId xmlns:a16="http://schemas.microsoft.com/office/drawing/2014/main" id="{D77AF56A-CE4D-0FA1-2849-97C204B12B67}"/>
               </a:ext>
             </a:extLst>
           </p:cNvPr>
@@ -16781,7 +16781,7 @@
           <p:cNvPr id="8" name="Timeline dot">
             <a:extLst>
               <a:ext uri="{FF2B5EF4-FFF2-40B4-BE49-F238E27FC236}">
-                <a16:creationId xmlns:a16="http://schemas.microsoft.com/office/drawing/2014/main" id="{80FF5BFC-BB1D-AD26-73F5-E6E438F187DE}"/>
+                <a16:creationId xmlns:a16="http://schemas.microsoft.com/office/drawing/2014/main" id="{87E4BAF7-1B11-AD37-14A3-41FC8FBB91F4}"/>
               </a:ext>
             </a:extLst>
           </p:cNvPr>
@@ -16849,7 +16849,7 @@
           <p:cNvPr id="9" name="Timeline dot">
             <a:extLst>
               <a:ext uri="{FF2B5EF4-FFF2-40B4-BE49-F238E27FC236}">
-                <a16:creationId xmlns:a16="http://schemas.microsoft.com/office/drawing/2014/main" id="{00233E41-0AF5-E4F1-61FC-63009FD64549}"/>
+                <a16:creationId xmlns:a16="http://schemas.microsoft.com/office/drawing/2014/main" id="{A100C1B7-EEE2-4F32-BFD7-360804F2601F}"/>
               </a:ext>
             </a:extLst>
           </p:cNvPr>
@@ -16917,7 +16917,7 @@
           <p:cNvPr id="10" name="Timeline dot">
             <a:extLst>
               <a:ext uri="{FF2B5EF4-FFF2-40B4-BE49-F238E27FC236}">
-                <a16:creationId xmlns:a16="http://schemas.microsoft.com/office/drawing/2014/main" id="{0CB61D57-7BC9-00A6-4462-9E1EDA347614}"/>
+                <a16:creationId xmlns:a16="http://schemas.microsoft.com/office/drawing/2014/main" id="{ACDB98C6-5C5D-C094-1A44-7C316DC0044E}"/>
               </a:ext>
             </a:extLst>
           </p:cNvPr>
@@ -16985,7 +16985,7 @@
           <p:cNvPr id="11" name="Timeline label">
             <a:extLst>
               <a:ext uri="{FF2B5EF4-FFF2-40B4-BE49-F238E27FC236}">
-                <a16:creationId xmlns:a16="http://schemas.microsoft.com/office/drawing/2014/main" id="{ED17C14F-629C-6BC1-E108-C065845EB321}"/>
+                <a16:creationId xmlns:a16="http://schemas.microsoft.com/office/drawing/2014/main" id="{21802F4A-8EC2-1DC1-B7D7-895CE9B2C0AC}"/>
               </a:ext>
             </a:extLst>
           </p:cNvPr>
@@ -17030,7 +17030,7 @@
           <p:cNvPr id="12" name="Timeline title">
             <a:extLst>
               <a:ext uri="{FF2B5EF4-FFF2-40B4-BE49-F238E27FC236}">
-                <a16:creationId xmlns:a16="http://schemas.microsoft.com/office/drawing/2014/main" id="{5C3E91B8-7963-1665-7922-AF7726975198}"/>
+                <a16:creationId xmlns:a16="http://schemas.microsoft.com/office/drawing/2014/main" id="{37363456-86D8-5A53-472C-B04B7806D8D3}"/>
               </a:ext>
             </a:extLst>
           </p:cNvPr>
@@ -17075,7 +17075,7 @@
           <p:cNvPr id="13" name="Timeline detail">
             <a:extLst>
               <a:ext uri="{FF2B5EF4-FFF2-40B4-BE49-F238E27FC236}">
-                <a16:creationId xmlns:a16="http://schemas.microsoft.com/office/drawing/2014/main" id="{114EDBE0-6F59-D9BF-F35C-7259AEFEC2E3}"/>
+                <a16:creationId xmlns:a16="http://schemas.microsoft.com/office/drawing/2014/main" id="{738D6DE4-D921-E6B6-70D9-33E05FCF8674}"/>
               </a:ext>
             </a:extLst>
           </p:cNvPr>
@@ -17120,7 +17120,7 @@
           <p:cNvPr id="14" name="Timeline label">
             <a:extLst>
               <a:ext uri="{FF2B5EF4-FFF2-40B4-BE49-F238E27FC236}">
-                <a16:creationId xmlns:a16="http://schemas.microsoft.com/office/drawing/2014/main" id="{F991FDAE-C420-A6CD-021B-294F38086BB2}"/>
+                <a16:creationId xmlns:a16="http://schemas.microsoft.com/office/drawing/2014/main" id="{FE511827-F349-9A9A-16D4-E2C7B4E238CF}"/>
               </a:ext>
             </a:extLst>
           </p:cNvPr>
@@ -17165,7 +17165,7 @@
           <p:cNvPr id="15" name="Timeline title">
             <a:extLst>
               <a:ext uri="{FF2B5EF4-FFF2-40B4-BE49-F238E27FC236}">
-                <a16:creationId xmlns:a16="http://schemas.microsoft.com/office/drawing/2014/main" id="{BE5B8A07-69FB-2380-82D4-264EE69EF43B}"/>
+                <a16:creationId xmlns:a16="http://schemas.microsoft.com/office/drawing/2014/main" id="{4548022D-EDC2-B28E-518F-31FBB575361D}"/>
               </a:ext>
             </a:extLst>
           </p:cNvPr>
@@ -17210,7 +17210,7 @@
           <p:cNvPr id="16" name="Timeline detail">
             <a:extLst>
               <a:ext uri="{FF2B5EF4-FFF2-40B4-BE49-F238E27FC236}">
-                <a16:creationId xmlns:a16="http://schemas.microsoft.com/office/drawing/2014/main" id="{2E12BD5F-7AF3-CF04-9678-923F354FAB2D}"/>
+                <a16:creationId xmlns:a16="http://schemas.microsoft.com/office/drawing/2014/main" id="{C8D49877-414B-0F67-85AA-307D12EEB0BA}"/>
               </a:ext>
             </a:extLst>
           </p:cNvPr>
@@ -17255,7 +17255,7 @@
           <p:cNvPr id="17" name="Timeline label">
             <a:extLst>
               <a:ext uri="{FF2B5EF4-FFF2-40B4-BE49-F238E27FC236}">
-                <a16:creationId xmlns:a16="http://schemas.microsoft.com/office/drawing/2014/main" id="{8DA08FD5-ADA4-091C-A5A7-929ED3064B52}"/>
+                <a16:creationId xmlns:a16="http://schemas.microsoft.com/office/drawing/2014/main" id="{28C5A64D-BB3F-941B-8A19-2DEF4F54386C}"/>
               </a:ext>
             </a:extLst>
           </p:cNvPr>
@@ -17300,7 +17300,7 @@
           <p:cNvPr id="18" name="Timeline title">
             <a:extLst>
               <a:ext uri="{FF2B5EF4-FFF2-40B4-BE49-F238E27FC236}">
-                <a16:creationId xmlns:a16="http://schemas.microsoft.com/office/drawing/2014/main" id="{0CFB078B-0BAE-E80C-79C5-AED45745F275}"/>
+                <a16:creationId xmlns:a16="http://schemas.microsoft.com/office/drawing/2014/main" id="{3CD8513F-27F8-DB30-8B28-038D34CDCD64}"/>
               </a:ext>
             </a:extLst>
           </p:cNvPr>
@@ -17345,7 +17345,7 @@
           <p:cNvPr id="19" name="Timeline detail">
             <a:extLst>
               <a:ext uri="{FF2B5EF4-FFF2-40B4-BE49-F238E27FC236}">
-                <a16:creationId xmlns:a16="http://schemas.microsoft.com/office/drawing/2014/main" id="{D881C9D5-C398-2E27-FD6B-3E7043C95151}"/>
+                <a16:creationId xmlns:a16="http://schemas.microsoft.com/office/drawing/2014/main" id="{B5948467-2869-E89E-46A2-A6F64F2B9795}"/>
               </a:ext>
             </a:extLst>
           </p:cNvPr>
@@ -17390,7 +17390,7 @@
           <p:cNvPr id="20" name="Central takeaway">
             <a:extLst>
               <a:ext uri="{FF2B5EF4-FFF2-40B4-BE49-F238E27FC236}">
-                <a16:creationId xmlns:a16="http://schemas.microsoft.com/office/drawing/2014/main" id="{E7D98F60-A972-DF19-4829-66D9225A1B3D}"/>
+                <a16:creationId xmlns:a16="http://schemas.microsoft.com/office/drawing/2014/main" id="{2DFCE61F-CD1A-7C07-82F3-EC3077D1FB4A}"/>
               </a:ext>
             </a:extLst>
           </p:cNvPr>
@@ -17433,7 +17433,7 @@
     </p:spTree>
     <p:extLst>
       <p:ext uri="{BB962C8B-B14F-4D97-AF65-F5344CB8AC3E}">
-        <p14:creationId xmlns:p14="http://schemas.microsoft.com/office/powerpoint/2010/main" val="2889043930"/>
+        <p14:creationId xmlns:p14="http://schemas.microsoft.com/office/powerpoint/2010/main" val="2824587135"/>
       </p:ext>
     </p:extLst>
   </p:cSld>
@@ -17473,7 +17473,7 @@
           <p:cNvPr id="2" name="Section">
             <a:extLst>
               <a:ext uri="{FF2B5EF4-FFF2-40B4-BE49-F238E27FC236}">
-                <a16:creationId xmlns:a16="http://schemas.microsoft.com/office/drawing/2014/main" id="{2AC87802-1966-68F6-C470-739E6FD0753B}"/>
+                <a16:creationId xmlns:a16="http://schemas.microsoft.com/office/drawing/2014/main" id="{BD8431CD-F86B-6447-2077-83190DA9D7AE}"/>
               </a:ext>
             </a:extLst>
           </p:cNvPr>
@@ -17518,7 +17518,7 @@
           <p:cNvPr id="3" name="Slide title">
             <a:extLst>
               <a:ext uri="{FF2B5EF4-FFF2-40B4-BE49-F238E27FC236}">
-                <a16:creationId xmlns:a16="http://schemas.microsoft.com/office/drawing/2014/main" id="{49578E8E-5E4D-D24C-0CCD-34F88552CAFF}"/>
+                <a16:creationId xmlns:a16="http://schemas.microsoft.com/office/drawing/2014/main" id="{CE66A05E-8FD2-84F0-033E-A394B5A04DF5}"/>
               </a:ext>
             </a:extLst>
           </p:cNvPr>
@@ -17563,7 +17563,7 @@
           <p:cNvPr id="4" name="Accent rule">
             <a:extLst>
               <a:ext uri="{FF2B5EF4-FFF2-40B4-BE49-F238E27FC236}">
-                <a16:creationId xmlns:a16="http://schemas.microsoft.com/office/drawing/2014/main" id="{E924B0C4-D06D-4272-1B45-8427E2B4B031}"/>
+                <a16:creationId xmlns:a16="http://schemas.microsoft.com/office/drawing/2014/main" id="{A324981E-8C21-1089-5DA2-2E3A4AFBCCE8}"/>
               </a:ext>
             </a:extLst>
           </p:cNvPr>
@@ -17604,7 +17604,7 @@
           <p:cNvPr id="5" name="Footer author">
             <a:extLst>
               <a:ext uri="{FF2B5EF4-FFF2-40B4-BE49-F238E27FC236}">
-                <a16:creationId xmlns:a16="http://schemas.microsoft.com/office/drawing/2014/main" id="{91ED1ED9-035A-BAB1-8983-AC581C893752}"/>
+                <a16:creationId xmlns:a16="http://schemas.microsoft.com/office/drawing/2014/main" id="{9E2DF812-C902-0EE7-C9A1-5828B9C9AF32}"/>
               </a:ext>
             </a:extLst>
           </p:cNvPr>
@@ -17649,7 +17649,7 @@
           <p:cNvPr id="6" name="Slide number">
             <a:extLst>
               <a:ext uri="{FF2B5EF4-FFF2-40B4-BE49-F238E27FC236}">
-                <a16:creationId xmlns:a16="http://schemas.microsoft.com/office/drawing/2014/main" id="{6FAB1FCC-6A0C-3E5C-EA68-22FABA6FF26A}"/>
+                <a16:creationId xmlns:a16="http://schemas.microsoft.com/office/drawing/2014/main" id="{344871D2-C418-30EC-8FA3-A7CFD617EF30}"/>
               </a:ext>
             </a:extLst>
           </p:cNvPr>
@@ -17694,7 +17694,7 @@
           <p:cNvPr id="7" name="Tech label">
             <a:extLst>
               <a:ext uri="{FF2B5EF4-FFF2-40B4-BE49-F238E27FC236}">
-                <a16:creationId xmlns:a16="http://schemas.microsoft.com/office/drawing/2014/main" id="{47072F21-4372-4C10-6972-3898A1CC8468}"/>
+                <a16:creationId xmlns:a16="http://schemas.microsoft.com/office/drawing/2014/main" id="{CA0333AC-10F0-BC2D-7B11-20C7DC8F3B0F}"/>
               </a:ext>
             </a:extLst>
           </p:cNvPr>
@@ -17739,7 +17739,7 @@
           <p:cNvPr id="8" name="Python">
             <a:extLst>
               <a:ext uri="{FF2B5EF4-FFF2-40B4-BE49-F238E27FC236}">
-                <a16:creationId xmlns:a16="http://schemas.microsoft.com/office/drawing/2014/main" id="{AD0D40F2-FC4D-C8C6-C690-CA148E41CB97}"/>
+                <a16:creationId xmlns:a16="http://schemas.microsoft.com/office/drawing/2014/main" id="{F5503B8C-BCCA-13AF-6D7A-3008F1F68B69}"/>
               </a:ext>
             </a:extLst>
           </p:cNvPr>
@@ -17784,7 +17784,7 @@
           <p:cNvPr id="9" name="Python reason">
             <a:extLst>
               <a:ext uri="{FF2B5EF4-FFF2-40B4-BE49-F238E27FC236}">
-                <a16:creationId xmlns:a16="http://schemas.microsoft.com/office/drawing/2014/main" id="{A7F7A43B-258E-9CEF-2B08-604DC3DA6EE9}"/>
+                <a16:creationId xmlns:a16="http://schemas.microsoft.com/office/drawing/2014/main" id="{1D4A8934-D7A7-D454-494F-92CB936BBF34}"/>
               </a:ext>
             </a:extLst>
           </p:cNvPr>
@@ -17829,7 +17829,7 @@
           <p:cNvPr id="10" name="Tech line">
             <a:extLst>
               <a:ext uri="{FF2B5EF4-FFF2-40B4-BE49-F238E27FC236}">
-                <a16:creationId xmlns:a16="http://schemas.microsoft.com/office/drawing/2014/main" id="{628007C5-B4A9-E65F-2B90-57696E9C1214}"/>
+                <a16:creationId xmlns:a16="http://schemas.microsoft.com/office/drawing/2014/main" id="{1C682C96-51A3-E09A-EEFC-DC1C58BA44AC}"/>
               </a:ext>
             </a:extLst>
           </p:cNvPr>
@@ -17870,7 +17870,7 @@
           <p:cNvPr id="11" name="Streamlit tech">
             <a:extLst>
               <a:ext uri="{FF2B5EF4-FFF2-40B4-BE49-F238E27FC236}">
-                <a16:creationId xmlns:a16="http://schemas.microsoft.com/office/drawing/2014/main" id="{A3E28D18-AF7C-822F-7638-5AA3454F0F50}"/>
+                <a16:creationId xmlns:a16="http://schemas.microsoft.com/office/drawing/2014/main" id="{6AC7EADE-8AC2-9F79-B769-BB89C3A3A933}"/>
               </a:ext>
             </a:extLst>
           </p:cNvPr>
@@ -17915,7 +17915,7 @@
           <p:cNvPr id="12" name="Streamlit reason">
             <a:extLst>
               <a:ext uri="{FF2B5EF4-FFF2-40B4-BE49-F238E27FC236}">
-                <a16:creationId xmlns:a16="http://schemas.microsoft.com/office/drawing/2014/main" id="{F57A94F1-546E-979E-D139-5412F4726119}"/>
+                <a16:creationId xmlns:a16="http://schemas.microsoft.com/office/drawing/2014/main" id="{3A11AF3B-6208-7269-378D-66A0A2680BF4}"/>
               </a:ext>
             </a:extLst>
           </p:cNvPr>
@@ -17960,7 +17960,7 @@
           <p:cNvPr id="13" name="Tech line">
             <a:extLst>
               <a:ext uri="{FF2B5EF4-FFF2-40B4-BE49-F238E27FC236}">
-                <a16:creationId xmlns:a16="http://schemas.microsoft.com/office/drawing/2014/main" id="{AB55293A-0EBE-78D1-E870-65C367CE3C66}"/>
+                <a16:creationId xmlns:a16="http://schemas.microsoft.com/office/drawing/2014/main" id="{0E281BF2-30AA-5839-1106-0811ED666102}"/>
               </a:ext>
             </a:extLst>
           </p:cNvPr>
@@ -18001,7 +18001,7 @@
           <p:cNvPr id="14" name="Sklearn">
             <a:extLst>
               <a:ext uri="{FF2B5EF4-FFF2-40B4-BE49-F238E27FC236}">
-                <a16:creationId xmlns:a16="http://schemas.microsoft.com/office/drawing/2014/main" id="{31D4B4E4-1E46-DA35-B99E-0348789FB1B1}"/>
+                <a16:creationId xmlns:a16="http://schemas.microsoft.com/office/drawing/2014/main" id="{0AF15E3A-B23B-3A6B-1AA2-63392C9683C3}"/>
               </a:ext>
             </a:extLst>
           </p:cNvPr>
@@ -18046,7 +18046,7 @@
           <p:cNvPr id="15" name="Sklearn reason">
             <a:extLst>
               <a:ext uri="{FF2B5EF4-FFF2-40B4-BE49-F238E27FC236}">
-                <a16:creationId xmlns:a16="http://schemas.microsoft.com/office/drawing/2014/main" id="{073B89BD-AF63-B572-8228-F9993C71778B}"/>
+                <a16:creationId xmlns:a16="http://schemas.microsoft.com/office/drawing/2014/main" id="{7C5753A7-9CCB-F345-033F-DB5CECFB728E}"/>
               </a:ext>
             </a:extLst>
           </p:cNvPr>
@@ -18091,7 +18091,7 @@
           <p:cNvPr id="16" name="Tech line">
             <a:extLst>
               <a:ext uri="{FF2B5EF4-FFF2-40B4-BE49-F238E27FC236}">
-                <a16:creationId xmlns:a16="http://schemas.microsoft.com/office/drawing/2014/main" id="{514A4AD2-8EBA-CD34-3996-3D746B9774F9}"/>
+                <a16:creationId xmlns:a16="http://schemas.microsoft.com/office/drawing/2014/main" id="{C42883B3-F450-4ABA-1685-8CA7C707433C}"/>
               </a:ext>
             </a:extLst>
           </p:cNvPr>
@@ -18132,7 +18132,7 @@
           <p:cNvPr id="17" name="Integrations">
             <a:extLst>
               <a:ext uri="{FF2B5EF4-FFF2-40B4-BE49-F238E27FC236}">
-                <a16:creationId xmlns:a16="http://schemas.microsoft.com/office/drawing/2014/main" id="{48578878-D226-10D8-FD9F-9459C6BEB793}"/>
+                <a16:creationId xmlns:a16="http://schemas.microsoft.com/office/drawing/2014/main" id="{1AEC99C8-54EB-5AB4-87B6-5FF0222AB094}"/>
               </a:ext>
             </a:extLst>
           </p:cNvPr>
@@ -18177,7 +18177,7 @@
           <p:cNvPr id="18" name="Integrations reason">
             <a:extLst>
               <a:ext uri="{FF2B5EF4-FFF2-40B4-BE49-F238E27FC236}">
-                <a16:creationId xmlns:a16="http://schemas.microsoft.com/office/drawing/2014/main" id="{458700F3-D95C-E0DF-7E58-108F78DFC3A3}"/>
+                <a16:creationId xmlns:a16="http://schemas.microsoft.com/office/drawing/2014/main" id="{E2B812B3-A1E9-A265-8927-4C8BB6FB0153}"/>
               </a:ext>
             </a:extLst>
           </p:cNvPr>
@@ -18222,7 +18222,7 @@
           <p:cNvPr id="19" name="Security field">
             <a:extLst>
               <a:ext uri="{FF2B5EF4-FFF2-40B4-BE49-F238E27FC236}">
-                <a16:creationId xmlns:a16="http://schemas.microsoft.com/office/drawing/2014/main" id="{C88114F4-97C1-16B4-82E9-EC4C75654A6F}"/>
+                <a16:creationId xmlns:a16="http://schemas.microsoft.com/office/drawing/2014/main" id="{3671883D-2D6C-8F47-55C7-B73525D5F3C1}"/>
               </a:ext>
             </a:extLst>
           </p:cNvPr>
@@ -18290,7 +18290,7 @@
           <p:cNvPr id="20" name="Security label">
             <a:extLst>
               <a:ext uri="{FF2B5EF4-FFF2-40B4-BE49-F238E27FC236}">
-                <a16:creationId xmlns:a16="http://schemas.microsoft.com/office/drawing/2014/main" id="{D991A222-0955-1A82-B2C0-AB1A1120180B}"/>
+                <a16:creationId xmlns:a16="http://schemas.microsoft.com/office/drawing/2014/main" id="{EE424743-E803-ABA2-839E-52301B4157A2}"/>
               </a:ext>
             </a:extLst>
           </p:cNvPr>
@@ -18335,7 +18335,7 @@
           <p:cNvPr id="21" name="Security list">
             <a:extLst>
               <a:ext uri="{FF2B5EF4-FFF2-40B4-BE49-F238E27FC236}">
-                <a16:creationId xmlns:a16="http://schemas.microsoft.com/office/drawing/2014/main" id="{32727AAD-4978-F4E1-4234-37C0ACAB9D41}"/>
+                <a16:creationId xmlns:a16="http://schemas.microsoft.com/office/drawing/2014/main" id="{29D4BCE9-DDB2-6B0F-6B6A-A77CE1BBE2C1}"/>
               </a:ext>
             </a:extLst>
           </p:cNvPr>
@@ -18385,7 +18385,7 @@
           <p:cNvPr id="22" name="Security caveat">
             <a:extLst>
               <a:ext uri="{FF2B5EF4-FFF2-40B4-BE49-F238E27FC236}">
-                <a16:creationId xmlns:a16="http://schemas.microsoft.com/office/drawing/2014/main" id="{443E0702-DC05-5915-1FF6-2767AB619344}"/>
+                <a16:creationId xmlns:a16="http://schemas.microsoft.com/office/drawing/2014/main" id="{436BD864-833B-9BEC-FDD0-C00BD3B92BFE}"/>
               </a:ext>
             </a:extLst>
           </p:cNvPr>
@@ -18428,7 +18428,7 @@
     </p:spTree>
     <p:extLst>
       <p:ext uri="{BB962C8B-B14F-4D97-AF65-F5344CB8AC3E}">
-        <p14:creationId xmlns:p14="http://schemas.microsoft.com/office/powerpoint/2010/main" val="3592566310"/>
+        <p14:creationId xmlns:p14="http://schemas.microsoft.com/office/powerpoint/2010/main" val="3475064687"/>
       </p:ext>
     </p:extLst>
   </p:cSld>
@@ -18468,7 +18468,7 @@
           <p:cNvPr id="2" name="Section">
             <a:extLst>
               <a:ext uri="{FF2B5EF4-FFF2-40B4-BE49-F238E27FC236}">
-                <a16:creationId xmlns:a16="http://schemas.microsoft.com/office/drawing/2014/main" id="{C8E6B875-14F4-CE1D-DDF3-4E7CCDE4FEE9}"/>
+                <a16:creationId xmlns:a16="http://schemas.microsoft.com/office/drawing/2014/main" id="{7B3E4D2E-1894-F228-9880-E4715829810C}"/>
               </a:ext>
             </a:extLst>
           </p:cNvPr>
@@ -18513,7 +18513,7 @@
           <p:cNvPr id="3" name="Slide title">
             <a:extLst>
               <a:ext uri="{FF2B5EF4-FFF2-40B4-BE49-F238E27FC236}">
-                <a16:creationId xmlns:a16="http://schemas.microsoft.com/office/drawing/2014/main" id="{489A4AF9-5463-2C7B-EF8C-49D79558A148}"/>
+                <a16:creationId xmlns:a16="http://schemas.microsoft.com/office/drawing/2014/main" id="{2751B266-5C00-8145-E63C-B2367509B9F1}"/>
               </a:ext>
             </a:extLst>
           </p:cNvPr>
@@ -18558,7 +18558,7 @@
           <p:cNvPr id="4" name="Accent rule">
             <a:extLst>
               <a:ext uri="{FF2B5EF4-FFF2-40B4-BE49-F238E27FC236}">
-                <a16:creationId xmlns:a16="http://schemas.microsoft.com/office/drawing/2014/main" id="{240B07B8-06F0-F6CF-C0B4-B7E605C22F67}"/>
+                <a16:creationId xmlns:a16="http://schemas.microsoft.com/office/drawing/2014/main" id="{3176E519-7FC8-7BC0-CA6A-3A57F9879662}"/>
               </a:ext>
             </a:extLst>
           </p:cNvPr>
@@ -18599,7 +18599,7 @@
           <p:cNvPr id="5" name="Footer author">
             <a:extLst>
               <a:ext uri="{FF2B5EF4-FFF2-40B4-BE49-F238E27FC236}">
-                <a16:creationId xmlns:a16="http://schemas.microsoft.com/office/drawing/2014/main" id="{42050EFB-BC16-B29E-F08C-302443A9E40B}"/>
+                <a16:creationId xmlns:a16="http://schemas.microsoft.com/office/drawing/2014/main" id="{7E321A63-508A-5D2D-D5CF-6D1261A8A9EC}"/>
               </a:ext>
             </a:extLst>
           </p:cNvPr>
@@ -18644,7 +18644,7 @@
           <p:cNvPr id="6" name="Slide number">
             <a:extLst>
               <a:ext uri="{FF2B5EF4-FFF2-40B4-BE49-F238E27FC236}">
-                <a16:creationId xmlns:a16="http://schemas.microsoft.com/office/drawing/2014/main" id="{3C87988F-7C81-B46D-3B06-B8900C8DABE4}"/>
+                <a16:creationId xmlns:a16="http://schemas.microsoft.com/office/drawing/2014/main" id="{DEC3BF54-7720-E738-C1CA-D7903F620253}"/>
               </a:ext>
             </a:extLst>
           </p:cNvPr>
@@ -18689,7 +18689,7 @@
           <p:cNvPr id="7" name="Evaluation timeline">
             <a:extLst>
               <a:ext uri="{FF2B5EF4-FFF2-40B4-BE49-F238E27FC236}">
-                <a16:creationId xmlns:a16="http://schemas.microsoft.com/office/drawing/2014/main" id="{5EF75F59-2A2A-64BC-1E72-FD1C86CA647B}"/>
+                <a16:creationId xmlns:a16="http://schemas.microsoft.com/office/drawing/2014/main" id="{06205B3C-A5D7-6F3E-DE97-0C3DAF84DEFD}"/>
               </a:ext>
             </a:extLst>
           </p:cNvPr>
@@ -18730,7 +18730,7 @@
           <p:cNvPr id="8" name="Evaluation dot">
             <a:extLst>
               <a:ext uri="{FF2B5EF4-FFF2-40B4-BE49-F238E27FC236}">
-                <a16:creationId xmlns:a16="http://schemas.microsoft.com/office/drawing/2014/main" id="{C592F643-E45B-2654-E15C-D7A4D05A146F}"/>
+                <a16:creationId xmlns:a16="http://schemas.microsoft.com/office/drawing/2014/main" id="{7BEB0CBF-6FA1-7AEA-6230-BE532A0098AE}"/>
               </a:ext>
             </a:extLst>
           </p:cNvPr>
@@ -18798,7 +18798,7 @@
           <p:cNvPr id="9" name="Evaluation dot">
             <a:extLst>
               <a:ext uri="{FF2B5EF4-FFF2-40B4-BE49-F238E27FC236}">
-                <a16:creationId xmlns:a16="http://schemas.microsoft.com/office/drawing/2014/main" id="{9F76FCF7-B6F6-2EAF-BCB5-645347F923D7}"/>
+                <a16:creationId xmlns:a16="http://schemas.microsoft.com/office/drawing/2014/main" id="{9AF19158-5B10-E7C2-2F35-1FAAC7F6D2DA}"/>
               </a:ext>
             </a:extLst>
           </p:cNvPr>
@@ -18866,7 +18866,7 @@
           <p:cNvPr id="10" name="Evaluation dot">
             <a:extLst>
               <a:ext uri="{FF2B5EF4-FFF2-40B4-BE49-F238E27FC236}">
-                <a16:creationId xmlns:a16="http://schemas.microsoft.com/office/drawing/2014/main" id="{F0DDADA4-3328-94CC-A55D-123F2D5CEEEC}"/>
+                <a16:creationId xmlns:a16="http://schemas.microsoft.com/office/drawing/2014/main" id="{A9A9E146-90E1-9E73-EEE2-A1C507E81A00}"/>
               </a:ext>
             </a:extLst>
           </p:cNvPr>
@@ -18934,7 +18934,7 @@
           <p:cNvPr id="11" name="Evaluation metric">
             <a:extLst>
               <a:ext uri="{FF2B5EF4-FFF2-40B4-BE49-F238E27FC236}">
-                <a16:creationId xmlns:a16="http://schemas.microsoft.com/office/drawing/2014/main" id="{8B2A8239-9FBE-ABED-B7F1-6C4EC5FD0CC8}"/>
+                <a16:creationId xmlns:a16="http://schemas.microsoft.com/office/drawing/2014/main" id="{6E0013BF-4D43-9DF7-C7CE-A8B5B716A11E}"/>
               </a:ext>
             </a:extLst>
           </p:cNvPr>
@@ -18969,7 +18969,7 @@
                 </a:solidFill>
                 <a:latin typeface="Arial" panose="020B0604020202020204" pitchFamily="34" charset="0"/>
               </a:rPr>
-              <a:t>40 CASOS</a:t>
+              <a:t>1.148 + 209</a:t>
             </a:r>
           </a:p>
         </p:txBody>
@@ -18979,7 +18979,7 @@
           <p:cNvPr id="12" name="Evaluation title">
             <a:extLst>
               <a:ext uri="{FF2B5EF4-FFF2-40B4-BE49-F238E27FC236}">
-                <a16:creationId xmlns:a16="http://schemas.microsoft.com/office/drawing/2014/main" id="{4CEBA28D-D44E-1BA5-8DE6-1143F2BDD649}"/>
+                <a16:creationId xmlns:a16="http://schemas.microsoft.com/office/drawing/2014/main" id="{53A58565-F70B-12CD-6A95-C7691E9DBE51}"/>
               </a:ext>
             </a:extLst>
           </p:cNvPr>
@@ -19014,7 +19014,7 @@
                 </a:solidFill>
                 <a:latin typeface="Arial" panose="020B0604020202020204" pitchFamily="34" charset="0"/>
               </a:rPr>
-              <a:t>Calibración controlada</a:t>
+              <a:t>Corpus español</a:t>
             </a:r>
           </a:p>
         </p:txBody>
@@ -19024,7 +19024,7 @@
           <p:cNvPr id="13" name="Evaluation detail">
             <a:extLst>
               <a:ext uri="{FF2B5EF4-FFF2-40B4-BE49-F238E27FC236}">
-                <a16:creationId xmlns:a16="http://schemas.microsoft.com/office/drawing/2014/main" id="{75DE5515-7791-A782-DEC5-45B161F17820}"/>
+                <a16:creationId xmlns:a16="http://schemas.microsoft.com/office/drawing/2014/main" id="{9A1923C4-4AE8-ED7A-805F-6D238F1A1F80}"/>
               </a:ext>
             </a:extLst>
           </p:cNvPr>
@@ -19059,7 +19059,7 @@
                 </a:solidFill>
                 <a:latin typeface="Arial" panose="020B0604020202020204" pitchFamily="34" charset="0"/>
               </a:rPr>
-              <a:t>Cinco particiones estratificadas seleccionan pesos y umbrales.</a:t>
+              <a:t>Entrenamiento limpio y split oficial de prueba sin solapamientos.</a:t>
             </a:r>
           </a:p>
         </p:txBody>
@@ -19069,7 +19069,7 @@
           <p:cNvPr id="14" name="Evaluation metric">
             <a:extLst>
               <a:ext uri="{FF2B5EF4-FFF2-40B4-BE49-F238E27FC236}">
-                <a16:creationId xmlns:a16="http://schemas.microsoft.com/office/drawing/2014/main" id="{D728BB12-B330-0F78-FD3D-8257268EBB86}"/>
+                <a16:creationId xmlns:a16="http://schemas.microsoft.com/office/drawing/2014/main" id="{C6C1CCFF-4EAD-8E0E-140D-BE8C6E5B8091}"/>
               </a:ext>
             </a:extLst>
           </p:cNvPr>
@@ -19104,7 +19104,7 @@
                 </a:solidFill>
                 <a:latin typeface="Arial" panose="020B0604020202020204" pitchFamily="34" charset="0"/>
               </a:rPr>
-              <a:t>16 EML</a:t>
+              <a:t>65.661 + 16.416</a:t>
             </a:r>
           </a:p>
         </p:txBody>
@@ -19114,7 +19114,7 @@
           <p:cNvPr id="15" name="Evaluation title">
             <a:extLst>
               <a:ext uri="{FF2B5EF4-FFF2-40B4-BE49-F238E27FC236}">
-                <a16:creationId xmlns:a16="http://schemas.microsoft.com/office/drawing/2014/main" id="{5C22CD0B-E052-DCE1-69E0-FFCFA42B78BB}"/>
+                <a16:creationId xmlns:a16="http://schemas.microsoft.com/office/drawing/2014/main" id="{1D25C58E-4E8B-9471-F2E7-17CF91BBBECE}"/>
               </a:ext>
             </a:extLst>
           </p:cNvPr>
@@ -19149,7 +19149,7 @@
                 </a:solidFill>
                 <a:latin typeface="Arial" panose="020B0604020202020204" pitchFamily="34" charset="0"/>
               </a:rPr>
-              <a:t>Comprobación final</a:t>
+              <a:t>Corpus inglés</a:t>
             </a:r>
           </a:p>
         </p:txBody>
@@ -19159,7 +19159,7 @@
           <p:cNvPr id="16" name="Evaluation detail">
             <a:extLst>
               <a:ext uri="{FF2B5EF4-FFF2-40B4-BE49-F238E27FC236}">
-                <a16:creationId xmlns:a16="http://schemas.microsoft.com/office/drawing/2014/main" id="{8B8F5994-7254-0BB2-25FC-4E4A5C59AAB8}"/>
+                <a16:creationId xmlns:a16="http://schemas.microsoft.com/office/drawing/2014/main" id="{0131F974-AF2C-86F1-B1AC-C2ECDB952C29}"/>
               </a:ext>
             </a:extLst>
           </p:cNvPr>
@@ -19194,7 +19194,7 @@
                 </a:solidFill>
                 <a:latin typeface="Arial" panose="020B0604020202020204" pitchFamily="34" charset="0"/>
               </a:rPr>
-              <a:t>Mensajes bilingües reservados con MIME, cabeceras y escenarios BEC.</a:t>
+              <a:t>División 80/20 estratificada tras deduplicar el CSV agregado.</a:t>
             </a:r>
           </a:p>
         </p:txBody>
@@ -19204,7 +19204,7 @@
           <p:cNvPr id="17" name="Evaluation metric">
             <a:extLst>
               <a:ext uri="{FF2B5EF4-FFF2-40B4-BE49-F238E27FC236}">
-                <a16:creationId xmlns:a16="http://schemas.microsoft.com/office/drawing/2014/main" id="{C1259433-9FD3-8130-5F0F-0F85B5AF3ADA}"/>
+                <a16:creationId xmlns:a16="http://schemas.microsoft.com/office/drawing/2014/main" id="{EA78AB91-1416-D00C-2E46-3D97DBE45F26}"/>
               </a:ext>
             </a:extLst>
           </p:cNvPr>
@@ -19239,7 +19239,7 @@
                 </a:solidFill>
                 <a:latin typeface="Arial" panose="020B0604020202020204" pitchFamily="34" charset="0"/>
               </a:rPr>
-              <a:t>1.528 TEXTOS</a:t>
+              <a:t>40 + 16 EML</a:t>
             </a:r>
           </a:p>
         </p:txBody>
@@ -19249,7 +19249,7 @@
           <p:cNvPr id="18" name="Evaluation title">
             <a:extLst>
               <a:ext uri="{FF2B5EF4-FFF2-40B4-BE49-F238E27FC236}">
-                <a16:creationId xmlns:a16="http://schemas.microsoft.com/office/drawing/2014/main" id="{D39480F3-FB59-57CB-F32A-37B3D08E83F3}"/>
+                <a16:creationId xmlns:a16="http://schemas.microsoft.com/office/drawing/2014/main" id="{24D919EC-E5FD-F251-6837-F8595F9D1325}"/>
               </a:ext>
             </a:extLst>
           </p:cNvPr>
@@ -19284,7 +19284,7 @@
                 </a:solidFill>
                 <a:latin typeface="Arial" panose="020B0604020202020204" pitchFamily="34" charset="0"/>
               </a:rPr>
-              <a:t>Diagnóstico externo</a:t>
+              <a:t>Sistema completo</a:t>
             </a:r>
           </a:p>
         </p:txBody>
@@ -19294,7 +19294,7 @@
           <p:cNvPr id="19" name="Evaluation detail">
             <a:extLst>
               <a:ext uri="{FF2B5EF4-FFF2-40B4-BE49-F238E27FC236}">
-                <a16:creationId xmlns:a16="http://schemas.microsoft.com/office/drawing/2014/main" id="{33D48F9A-6EEF-1E8A-D785-ABB6EE255839}"/>
+                <a16:creationId xmlns:a16="http://schemas.microsoft.com/office/drawing/2014/main" id="{45135867-B344-AE86-993C-F321D4E15B41}"/>
               </a:ext>
             </a:extLst>
           </p:cNvPr>
@@ -19329,7 +19329,7 @@
                 </a:solidFill>
                 <a:latin typeface="Arial" panose="020B0604020202020204" pitchFamily="34" charset="0"/>
               </a:rPr>
-              <a:t>DIFrauD aporta escala, pero es histórico y puede solaparse.</a:t>
+              <a:t>Calibración separada y comprobación bilingüe con MIME y cabeceras.</a:t>
             </a:r>
           </a:p>
         </p:txBody>
@@ -19339,7 +19339,7 @@
           <p:cNvPr id="20" name="Evaluation caveat">
             <a:extLst>
               <a:ext uri="{FF2B5EF4-FFF2-40B4-BE49-F238E27FC236}">
-                <a16:creationId xmlns:a16="http://schemas.microsoft.com/office/drawing/2014/main" id="{8CEFFA73-3781-550F-F469-29C0AC8DAE60}"/>
+                <a16:creationId xmlns:a16="http://schemas.microsoft.com/office/drawing/2014/main" id="{FAEF2F3A-E7D9-441A-1280-0A08B7E7886A}"/>
               </a:ext>
             </a:extLst>
           </p:cNvPr>
@@ -19382,7 +19382,7 @@
     </p:spTree>
     <p:extLst>
       <p:ext uri="{BB962C8B-B14F-4D97-AF65-F5344CB8AC3E}">
-        <p14:creationId xmlns:p14="http://schemas.microsoft.com/office/powerpoint/2010/main" val="35028064"/>
+        <p14:creationId xmlns:p14="http://schemas.microsoft.com/office/powerpoint/2010/main" val="2361985126"/>
       </p:ext>
     </p:extLst>
   </p:cSld>

</xml_diff>